<commit_message>
Legg inn Skatteetaten ICO-rapport og fyll Q-for-Q for skatt og cookies
Offisiell Word-rapport lå bare i opplasting. Slide 12 og arbeidsnotatet bruker nå personvernerklæringen (hjemmel i lov, navngitte lover) og cookie-siden (Ja/Nei).

Co-authored-by: Karina <kasa031@users.noreply.github.com>
</commit_message>
<xml_diff>
--- a/ACIT4280_1A_presentation.pptx
+++ b/ACIT4280_1A_presentation.pptx
@@ -729,7 +729,7 @@
           <a:lstStyle/>
           <a:p>
             <a:r>
-              <a:t>SPEAKER: Karina. Named acts include skatteforvaltningsloven and folkeregisterloven. Nei test on 24 August 2026.</a:t>
+              <a:t>SPEAKER: Karina. Two purposes. Do not treat the cookie banner as the basis for tax. Nei test 24 August 2026 on skatteetaten.no/person/.</a:t>
             </a:r>
           </a:p>
         </p:txBody>
@@ -8476,13 +8476,13 @@
               </a:spcAft>
             </a:pPr>
             <a:r>
-              <a:rPr sz="1800" b="0" i="0">
+              <a:rPr sz="1600" b="0" i="0">
                 <a:solidFill>
                   <a:srgbClr val="1A1A1A"/>
                 </a:solidFill>
                 <a:latin typeface="Calibri"/>
               </a:rPr>
-              <a:t>Purpose 1: identity, income, tax data for tax and folkeregister.</a:t>
+              <a:t>Purpose 1: identity, income and tax data for tax and folkeregister.</a:t>
             </a:r>
           </a:p>
           <a:p>
@@ -8495,13 +8495,13 @@
               </a:spcAft>
             </a:pPr>
             <a:r>
-              <a:rPr sz="1800" b="0" i="0">
+              <a:rPr sz="1600" b="0" i="0">
                 <a:solidFill>
                   <a:srgbClr val="1A1A1A"/>
                 </a:solidFill>
                 <a:latin typeface="Calibri"/>
               </a:rPr>
-              <a:t>Notice: processing required by law; opt-out generally not possible.</a:t>
+              <a:t>Notice: first and foremost laid down in law. Opt-out generally not possible.</a:t>
             </a:r>
           </a:p>
           <a:p>
@@ -8514,13 +8514,13 @@
               </a:spcAft>
             </a:pPr>
             <a:r>
-              <a:rPr sz="1800" b="0" i="0">
+              <a:rPr sz="1600" b="0" i="0">
                 <a:solidFill>
                   <a:srgbClr val="1A1A1A"/>
                 </a:solidFill>
                 <a:latin typeface="Calibri"/>
               </a:rPr>
-              <a:t>ICO: legal obligation APPROPRIATE, public task APPROPRIATE.</a:t>
+              <a:t>Named acts: skatteforvaltningsloven, folkeregisterloven, skattebetalingsloven.</a:t>
             </a:r>
           </a:p>
           <a:p>
@@ -8533,13 +8533,13 @@
               </a:spcAft>
             </a:pPr>
             <a:r>
-              <a:rPr sz="1800" b="0" i="0">
+              <a:rPr sz="1600" b="0" i="0">
                 <a:solidFill>
                   <a:srgbClr val="1A1A1A"/>
                 </a:solidFill>
                 <a:latin typeface="Calibri"/>
               </a:rPr>
-              <a:t>Consent INCONCLUSIVE for core tax. Contract and LI NOT APPROPRIATE.</a:t>
+              <a:t>Controller: the Director General of Taxation (Skattedirektøren).</a:t>
             </a:r>
           </a:p>
           <a:p>
@@ -8552,13 +8552,13 @@
               </a:spcAft>
             </a:pPr>
             <a:r>
-              <a:rPr sz="1800" b="0" i="0">
+              <a:rPr sz="1600" b="0" i="0">
                 <a:solidFill>
                   <a:srgbClr val="1A1A1A"/>
                 </a:solidFill>
                 <a:latin typeface="Calibri"/>
               </a:rPr>
-              <a:t>Purpose 2: optional stats cookies (Skyra, Matomo, GA, Siteimprove).</a:t>
+              <a:t>ICO: legal obligation APPROPRIATE, public task APPROPRIATE.</a:t>
             </a:r>
           </a:p>
           <a:p>
@@ -8571,13 +8571,32 @@
               </a:spcAft>
             </a:pPr>
             <a:r>
-              <a:rPr sz="1800" b="0" i="0">
+              <a:rPr sz="1600" b="0" i="0">
                 <a:solidFill>
                   <a:srgbClr val="1A1A1A"/>
                 </a:solidFill>
                 <a:latin typeface="Calibri"/>
               </a:rPr>
-              <a:t>Ja/Nei banner. Dedicated ICO run: consent. Match: yes.</a:t>
+              <a:t>Consent INCONCLUSIVE for core tax. Contract and LI NOT APPROPRIATE.</a:t>
+            </a:r>
+          </a:p>
+          <a:p>
+            <a:pPr algn="l">
+              <a:spcBef>
+                <a:spcPts val="0"/>
+              </a:spcBef>
+              <a:spcAft>
+                <a:spcPts val="1000"/>
+              </a:spcAft>
+            </a:pPr>
+            <a:r>
+              <a:rPr sz="1600" b="0" i="0">
+                <a:solidFill>
+                  <a:srgbClr val="1A1A1A"/>
+                </a:solidFill>
+                <a:latin typeface="Calibri"/>
+              </a:rPr>
+              <a:t>Purpose 2: optional stats cookies (Skyra, Matomo, GA, Siteimprove). Ja/Nei. ICO: consent.</a:t>
             </a:r>
           </a:p>
         </p:txBody>

</xml_diff>

<commit_message>
Oppdater Skatteetaten ICO-rapport: samtykke NOT APPROPRIATE for skatt
Ren kjøring (Consent Q1 = No) merker legal obligation og public task som APPROPRIATE, og consent som NOT APPROPRIATE/likely invalid. Tabell 5, worksheet, oversikt og presentasjon synkes.

Co-authored-by: Karina <kasa031@users.noreply.github.com>
</commit_message>
<xml_diff>
--- a/ACIT4280_1A_presentation.pptx
+++ b/ACIT4280_1A_presentation.pptx
@@ -589,7 +589,7 @@
           <a:lstStyle/>
           <a:p>
             <a:r>
-              <a:t>SPEAKER: Karina. Mixing tax processing into a cookie run made consent INCONCLUSIVE. That is why we ran cookies separately.</a:t>
+              <a:t>SPEAKER: Karina. A clean ICO run with Consent Q1 = No marks consent NOT APPROPRIATE for tax. Cookies are a separate purpose and a separate run.</a:t>
             </a:r>
           </a:p>
         </p:txBody>
@@ -8577,7 +8577,7 @@
                 </a:solidFill>
                 <a:latin typeface="Calibri"/>
               </a:rPr>
-              <a:t>Consent INCONCLUSIVE for core tax. Contract and LI NOT APPROPRIATE.</a:t>
+              <a:t>Consent NOT APPROPRIATE for core tax (no genuine free choice). Contract and LI NOT APPROPRIATE.</a:t>
             </a:r>
           </a:p>
           <a:p>

</xml_diff>

<commit_message>
Legg inn Skatteetaten cookie-ICO: samtykke INCONCLUSIVE (Q6)
Egen rapport Skatteetaten_cookies_Lawful basis assessment report.docx. Ingen basis APPROPRIATE. Tabell 5, worksheet, oversikt og presentasjon synkes. Fire kjerneformål matcher; to samtykketester feiler.

Co-authored-by: Karina <kasa031@users.noreply.github.com>
</commit_message>
<xml_diff>
--- a/ACIT4280_1A_presentation.pptx
+++ b/ACIT4280_1A_presentation.pptx
@@ -659,7 +659,7 @@
           <a:lstStyle/>
           <a:p>
             <a:r>
-              <a:t>SPEAKER: Karina. Four of five selected purposes match. document.no is the teaching case: they aim at consent but ICO says the request is not good enough.</a:t>
+              <a:t>SPEAKER: Karina. Four of five core purposes match. Two consent tests fail: skatteetaten cookies (Q6, banner too short) and document.no Signals (request not separate from terms).</a:t>
             </a:r>
           </a:p>
         </p:txBody>
@@ -729,7 +729,7 @@
           <a:lstStyle/>
           <a:p>
             <a:r>
-              <a:t>SPEAKER: Karina. Two purposes. Do not treat the cookie banner as the basis for tax. Nei test 24 August 2026 on skatteetaten.no/person/.</a:t>
+              <a:t>SPEAKER: Karina. Two purposes, two reports. Tax: law. Cookies: they aim at consent, but ICO says name controller, purpose and types more clearly. Nei test 24 August 2026 on skatteetaten.no/person/.</a:t>
             </a:r>
           </a:p>
         </p:txBody>
@@ -6535,7 +6535,7 @@
             <a:avLst/>
           </a:prstGeom>
           <a:solidFill>
-            <a:srgbClr val="F4F6F8"/>
+            <a:srgbClr val="FFF1D1"/>
           </a:solidFill>
           <a:ln>
             <a:noFill/>
@@ -6613,7 +6613,7 @@
             <a:avLst/>
           </a:prstGeom>
           <a:solidFill>
-            <a:srgbClr val="F4F6F8"/>
+            <a:srgbClr val="FFF1D1"/>
           </a:solidFill>
           <a:ln>
             <a:noFill/>
@@ -6691,7 +6691,7 @@
             <a:avLst/>
           </a:prstGeom>
           <a:solidFill>
-            <a:srgbClr val="F4F6F8"/>
+            <a:srgbClr val="FFF1D1"/>
           </a:solidFill>
           <a:ln>
             <a:noFill/>
@@ -6749,7 +6749,7 @@
                 </a:solidFill>
                 <a:latin typeface="Calibri"/>
               </a:rPr>
-              <a:t>Consent</a:t>
+              <a:t>Consent INCONCLUSIVE; none APPROPRIATE</a:t>
             </a:r>
           </a:p>
         </p:txBody>
@@ -6769,7 +6769,7 @@
             <a:avLst/>
           </a:prstGeom>
           <a:solidFill>
-            <a:srgbClr val="F4F6F8"/>
+            <a:srgbClr val="FFF1D1"/>
           </a:solidFill>
           <a:ln>
             <a:noFill/>
@@ -6823,11 +6823,11 @@
             <a:r>
               <a:rPr sz="1300" b="1" i="0">
                 <a:solidFill>
-                  <a:srgbClr val="1B6B3A"/>
-                </a:solidFill>
-                <a:latin typeface="Calibri"/>
-              </a:rPr>
-              <a:t>Yes</a:t>
+                  <a:srgbClr val="9A5B00"/>
+                </a:solidFill>
+                <a:latin typeface="Calibri"/>
+              </a:rPr>
+              <a:t>Partial</a:t>
             </a:r>
           </a:p>
         </p:txBody>
@@ -8596,7 +8596,7 @@
                 </a:solidFill>
                 <a:latin typeface="Calibri"/>
               </a:rPr>
-              <a:t>Purpose 2: optional stats cookies (Skyra, Matomo, GA, Siteimprove). Ja/Nei. ICO: consent.</a:t>
+              <a:t>Purpose 2: optional stats cookies (Skyra, Matomo, GA, Siteimprove). Ja/Nei. ICO: consent INCONCLUSIVE (Q6). No basis APPROPRIATE.</a:t>
             </a:r>
           </a:p>
         </p:txBody>
@@ -11184,7 +11184,7 @@
                 </a:solidFill>
                 <a:latin typeface="Calibri"/>
               </a:rPr>
-              <a:t>Four of five ICO purposes match the notice.</a:t>
+              <a:t>Four of five core ICO purposes match the notice.</a:t>
             </a:r>
           </a:p>
           <a:p>
@@ -11203,7 +11203,7 @@
                 </a:solidFill>
                 <a:latin typeface="Calibri"/>
               </a:rPr>
-              <a:t>document.no does not: Google settings are not a clear Document consent request.</a:t>
+              <a:t>Two consent tests fail: skatteetaten cookies (Q6) and document.no Signals (Q5).</a:t>
             </a:r>
           </a:p>
           <a:p>

</xml_diff>

<commit_message>
Profesjonaliser 1A-innleveringen og fyll inn figurene
Fjerner samtalepreg (1B-avklaringer, interne pekere) fra rapport, oversikt og presentasjon. Legger inn syv figurer: Webbkoll-grafikk fra Tabell 2, metodekort og Skatteetatens personvern-hub.

Co-authored-by: Karina <kasa031@users.noreply.github.com>
</commit_message>
<xml_diff>
--- a/ACIT4280_1A_presentation.pptx
+++ b/ACIT4280_1A_presentation.pptx
@@ -519,7 +519,7 @@
           <a:lstStyle/>
           <a:p>
             <a:r>
-              <a:t>SPEAKER: Humna (open). Welcome the group. State the two parts: Webbkoll on 18 sites, then ICO on five notices. This is 1A, not 1B (no data-subject request test).</a:t>
+              <a:t>SPEAKER: Humna (open). Welcome the audience. State the two parts: Webbkoll on 18 sites, then ICO on five privacy notices.</a:t>
             </a:r>
           </a:p>
         </p:txBody>
@@ -1079,7 +1079,7 @@
           <a:lstStyle/>
           <a:p>
             <a:r>
-              <a:t>SPEAKER: Sumit. Then questions. If asked about 1B: that is the other group's access-request task.</a:t>
+              <a:t>SPEAKER: Sumit. Then questions. If asked about access requests: that is outside the scope of this report.</a:t>
             </a:r>
           </a:p>
         </p:txBody>
@@ -1499,7 +1499,7 @@
           <a:lstStyle/>
           <a:p>
             <a:r>
-              <a:t>SPEAKER: Mithun. Rank is third-party REQUESTS on Table 2, not cookies. Later clock puts babyshop.no at 101; we do not replace the first fill. skatteetaten.no also 14 requests; skiforeningen listed because fewer countries.</a:t>
+              <a:t>SPEAKER: Mithun. Rank is third-party REQUESTS on Table 2, not cookies. The repeat measurement puts babyshop.no at 101; rankings follow the first measurement. skatteetaten.no also 14 requests; skiforeningen listed because fewer countries.</a:t>
             </a:r>
           </a:p>
         </p:txBody>
@@ -1569,7 +1569,7 @@
           <a:lstStyle/>
           <a:p>
             <a:r>
-              <a:t>SPEAKER: Mithun. Point to Figure 2 and Figure 3 in the paper if the projector can show them.</a:t>
+              <a:t>SPEAKER: Mithun. Point to fotball.no at 113 and lanekassen.no at 1. Request volume is not cookie volume.</a:t>
             </a:r>
           </a:p>
         </p:txBody>
@@ -1639,7 +1639,7 @@
           <a:lstStyle/>
           <a:p>
             <a:r>
-              <a:t>SPEAKER: Mithun. This proves request volume is not cookie volume. Hand over to Karina for ICO.</a:t>
+              <a:t>SPEAKER: Mithun. This shows that request volume is not cookie volume. Hand over to Karina for ICO.</a:t>
             </a:r>
           </a:p>
         </p:txBody>
@@ -4831,7 +4831,7 @@
                 </a:solidFill>
                 <a:latin typeface="Calibri"/>
               </a:rPr>
-              <a:t>ACIT4280 Privacy by Design  |  Group assignment 1A</a:t>
+              <a:t>ACIT4280 Privacy by Design</a:t>
             </a:r>
           </a:p>
         </p:txBody>
@@ -5604,7 +5604,7 @@
                 </a:solidFill>
                 <a:latin typeface="Calibri"/>
               </a:rPr>
-              <a:t>ACIT4280 Group 1-A  |  Assignment 1A  |  3 Sep 2026</a:t>
+              <a:t>ACIT4280 Privacy by Design  |  Third-party sharing and lawful basis  |  3 Sep 2026</a:t>
             </a:r>
           </a:p>
         </p:txBody>
@@ -8153,7 +8153,7 @@
                 </a:solidFill>
                 <a:latin typeface="Calibri"/>
               </a:rPr>
-              <a:t>ACIT4280 Group 1-A  |  Assignment 1A  |  3 Sep 2026</a:t>
+              <a:t>ACIT4280 Privacy by Design  |  Third-party sharing and lawful basis  |  3 Sep 2026</a:t>
             </a:r>
           </a:p>
         </p:txBody>
@@ -8674,7 +8674,7 @@
                 </a:solidFill>
                 <a:latin typeface="Calibri"/>
               </a:rPr>
-              <a:t>ACIT4280 Group 1-A  |  Assignment 1A  |  3 Sep 2026</a:t>
+              <a:t>ACIT4280 Privacy by Design  |  Third-party sharing and lawful basis  |  3 Sep 2026</a:t>
             </a:r>
           </a:p>
         </p:txBody>
@@ -9176,7 +9176,7 @@
                 </a:solidFill>
                 <a:latin typeface="Calibri"/>
               </a:rPr>
-              <a:t>ACIT4280 Group 1-A  |  Assignment 1A  |  3 Sep 2026</a:t>
+              <a:t>ACIT4280 Privacy by Design  |  Third-party sharing and lawful basis  |  3 Sep 2026</a:t>
             </a:r>
           </a:p>
         </p:txBody>
@@ -9697,7 +9697,7 @@
                 </a:solidFill>
                 <a:latin typeface="Calibri"/>
               </a:rPr>
-              <a:t>ACIT4280 Group 1-A  |  Assignment 1A  |  3 Sep 2026</a:t>
+              <a:t>ACIT4280 Privacy by Design  |  Third-party sharing and lawful basis  |  3 Sep 2026</a:t>
             </a:r>
           </a:p>
         </p:txBody>
@@ -10296,7 +10296,7 @@
                 </a:solidFill>
                 <a:latin typeface="Calibri"/>
               </a:rPr>
-              <a:t>ACIT4280 Group 1-A  |  Assignment 1A  |  3 Sep 2026</a:t>
+              <a:t>ACIT4280 Privacy by Design  |  Third-party sharing and lawful basis  |  3 Sep 2026</a:t>
             </a:r>
           </a:p>
         </p:txBody>
@@ -10798,7 +10798,7 @@
                 </a:solidFill>
                 <a:latin typeface="Calibri"/>
               </a:rPr>
-              <a:t>ACIT4280 Group 1-A  |  Assignment 1A  |  3 Sep 2026</a:t>
+              <a:t>ACIT4280 Privacy by Design  |  Third-party sharing and lawful basis  |  3 Sep 2026</a:t>
             </a:r>
           </a:p>
         </p:txBody>
@@ -11165,7 +11165,7 @@
                 </a:solidFill>
                 <a:latin typeface="Calibri"/>
               </a:rPr>
-              <a:t>fotball.no is loud on requests and still has zero third-party cookies.</a:t>
+              <a:t>fotball.no has the highest request count and still zero third-party cookies.</a:t>
             </a:r>
           </a:p>
           <a:p>
@@ -11300,7 +11300,7 @@
                 </a:solidFill>
                 <a:latin typeface="Calibri"/>
               </a:rPr>
-              <a:t>ACIT4280 Group 1-A  |  Assignment 1A  |  3 Sep 2026</a:t>
+              <a:t>ACIT4280 Privacy by Design  |  Third-party sharing and lawful basis  |  3 Sep 2026</a:t>
             </a:r>
           </a:p>
         </p:txBody>
@@ -11467,7 +11467,7 @@
                 <a:latin typeface="Calibri"/>
               </a:rPr>
               <a:t>Humna  ·  Mithun  ·  Karina  ·  Sumit
-ACIT4280 Group 1-A</a:t>
+ACIT4280 Privacy by Design</a:t>
             </a:r>
           </a:p>
         </p:txBody>
@@ -12561,7 +12561,7 @@
                 </a:solidFill>
                 <a:latin typeface="Calibri"/>
               </a:rPr>
-              <a:t>ACIT4280 Group 1-A  |  Assignment 1A  |  3 Sep 2026</a:t>
+              <a:t>ACIT4280 Privacy by Design  |  Third-party sharing and lawful basis  |  3 Sep 2026</a:t>
             </a:r>
           </a:p>
         </p:txBody>
@@ -12778,7 +12778,7 @@
                 </a:solidFill>
                 <a:latin typeface="Calibri"/>
               </a:rPr>
-              <a:t>Canvas task</a:t>
+              <a:t>Structure</a:t>
             </a:r>
           </a:p>
         </p:txBody>
@@ -12848,7 +12848,7 @@
                 </a:solidFill>
                 <a:latin typeface="Calibri"/>
               </a:rPr>
-              <a:t>Assignment 1A has two parts</a:t>
+              <a:t>The report has two parts</a:t>
             </a:r>
           </a:p>
         </p:txBody>
@@ -13044,7 +13044,7 @@
                 </a:solidFill>
                 <a:latin typeface="Calibri"/>
               </a:rPr>
-              <a:t>•  Interesting cases (loudest, most globalised, quiet e-gov)</a:t>
+              <a:t>•  Highest and lowest contact; most countries; restrained e-government</a:t>
             </a:r>
           </a:p>
         </p:txBody>
@@ -13122,7 +13122,7 @@
                 </a:solidFill>
                 <a:latin typeface="Calibri"/>
               </a:rPr>
-              <a:t>Part 2  ·  Group 1-A ICO</a:t>
+              <a:t>Part 2  ·  ICO lawful basis</a:t>
             </a:r>
           </a:p>
         </p:txBody>
@@ -13164,7 +13164,7 @@
                 </a:solidFill>
                 <a:latin typeface="Calibri"/>
               </a:rPr>
-              <a:t>•  Five notices we chose</a:t>
+              <a:t>•  Five privacy notices</a:t>
             </a:r>
           </a:p>
           <a:p>
@@ -13240,7 +13240,7 @@
                 </a:solidFill>
                 <a:latin typeface="Calibri"/>
               </a:rPr>
-              <a:t>•  Not 1B: we do not send access requests</a:t>
+              <a:t>•  Cookies, membership and checkout stay separate purposes</a:t>
             </a:r>
           </a:p>
         </p:txBody>
@@ -13318,7 +13318,7 @@
                 </a:solidFill>
                 <a:latin typeface="Calibri"/>
               </a:rPr>
-              <a:t>ACIT4280 Group 1-A  |  Assignment 1A  |  3 Sep 2026</a:t>
+              <a:t>ACIT4280 Privacy by Design  |  Third-party sharing and lawful basis  |  3 Sep 2026</a:t>
             </a:r>
           </a:p>
         </p:txBody>
@@ -13647,7 +13647,7 @@
                 </a:solidFill>
                 <a:latin typeface="Calibri"/>
               </a:rPr>
-              <a:t>English Webbkoll interface named in the brief</a:t>
+              <a:t>English Webbkoll interface</a:t>
             </a:r>
           </a:p>
           <a:p>
@@ -13761,7 +13761,7 @@
                 </a:solidFill>
                 <a:latin typeface="Calibri"/>
               </a:rPr>
-              <a:t>Two tables on purpose: Table 2 first clock, Table 3 later clock (Art. 5(1)(a))</a:t>
+              <a:t>Two tables on purpose: Table 2 first measurement, Table 3 repeat measurement (Art. 5(1)(a))</a:t>
             </a:r>
           </a:p>
         </p:txBody>
@@ -13839,7 +13839,7 @@
                 </a:solidFill>
                 <a:latin typeface="Calibri"/>
               </a:rPr>
-              <a:t>ACIT4280 Group 1-A  |  Assignment 1A  |  3 Sep 2026</a:t>
+              <a:t>ACIT4280 Privacy by Design  |  Third-party sharing and lawful basis  |  3 Sep 2026</a:t>
             </a:r>
           </a:p>
         </p:txBody>
@@ -14225,7 +14225,7 @@
                 </a:solidFill>
                 <a:latin typeface="Calibri"/>
               </a:rPr>
-              <a:t>We never average two clocks. A later visit can differ (24-hour store).</a:t>
+              <a:t>The two measurements are not averaged. A later visit can differ (24-hour store).</a:t>
             </a:r>
           </a:p>
           <a:p>
@@ -14322,7 +14322,7 @@
                 </a:solidFill>
                 <a:latin typeface="Calibri"/>
               </a:rPr>
-              <a:t>ACIT4280 Group 1-A  |  Assignment 1A  |  3 Sep 2026</a:t>
+              <a:t>ACIT4280 Privacy by Design  |  Third-party sharing and lawful basis  |  3 Sep 2026</a:t>
             </a:r>
           </a:p>
         </p:txBody>
@@ -15887,7 +15887,7 @@
                 </a:solidFill>
                 <a:latin typeface="Calibri"/>
               </a:rPr>
-              <a:t>ACIT4280 Group 1-A  |  Assignment 1A  |  3 Sep 2026</a:t>
+              <a:t>ACIT4280 Privacy by Design  |  Third-party sharing and lawful basis  |  3 Sep 2026</a:t>
             </a:r>
           </a:p>
         </p:txBody>
@@ -16104,7 +16104,7 @@
                 </a:solidFill>
                 <a:latin typeface="Calibri"/>
               </a:rPr>
-              <a:t>Part 1</a:t>
+              <a:t>Part 1  ·  Figures 2 and 3</a:t>
             </a:r>
           </a:p>
         </p:txBody>
@@ -16174,21 +16174,69 @@
                 </a:solidFill>
                 <a:latin typeface="Calibri"/>
               </a:rPr>
-              <a:t>Interesting findings</a:t>
-            </a:r>
-          </a:p>
-        </p:txBody>
-      </p:sp>
-      <p:sp>
-        <p:nvSpPr>
-          <p:cNvPr id="8" name="TextBox 7"/>
+              <a:t>Third-party requests by site and sector</a:t>
+            </a:r>
+          </a:p>
+        </p:txBody>
+      </p:sp>
+      <p:pic>
+        <p:nvPicPr>
+          <p:cNvPr id="8" name="Picture 7" descr="fig3_requests_all18.png"/>
+          <p:cNvPicPr>
+            <a:picLocks noChangeAspect="1"/>
+          </p:cNvPicPr>
+          <p:nvPr/>
+        </p:nvPicPr>
+        <p:blipFill>
+          <a:blip r:embed="rId2"/>
+          <a:stretch>
+            <a:fillRect/>
+          </a:stretch>
+        </p:blipFill>
+        <p:spPr>
+          <a:xfrm>
+            <a:off x="320040" y="1280160"/>
+            <a:ext cx="5852160" cy="5029200"/>
+          </a:xfrm>
+          <a:prstGeom prst="rect">
+            <a:avLst/>
+          </a:prstGeom>
+        </p:spPr>
+      </p:pic>
+      <p:pic>
+        <p:nvPicPr>
+          <p:cNvPr id="9" name="Picture 8" descr="fig6_requests_per_sector.png"/>
+          <p:cNvPicPr>
+            <a:picLocks noChangeAspect="1"/>
+          </p:cNvPicPr>
+          <p:nvPr/>
+        </p:nvPicPr>
+        <p:blipFill>
+          <a:blip r:embed="rId3"/>
+          <a:stretch>
+            <a:fillRect/>
+          </a:stretch>
+        </p:blipFill>
+        <p:spPr>
+          <a:xfrm>
+            <a:off x="6263640" y="1417320"/>
+            <a:ext cx="5577840" cy="2926080"/>
+          </a:xfrm>
+          <a:prstGeom prst="rect">
+            <a:avLst/>
+          </a:prstGeom>
+        </p:spPr>
+      </p:pic>
+      <p:sp>
+        <p:nvSpPr>
+          <p:cNvPr id="10" name="TextBox 9"/>
           <p:cNvSpPr txBox="1"/>
           <p:nvPr/>
         </p:nvSpPr>
         <p:spPr>
           <a:xfrm>
-            <a:off x="502920" y="1371600"/>
-            <a:ext cx="11155680" cy="5029200"/>
+            <a:off x="6309360" y="4480560"/>
+            <a:ext cx="5486400" cy="1828800"/>
           </a:xfrm>
           <a:prstGeom prst="rect">
             <a:avLst/>
@@ -16206,17 +16254,17 @@
                 <a:spcPts val="0"/>
               </a:spcBef>
               <a:spcAft>
-                <a:spcPts val="1000"/>
+                <a:spcPts val="600"/>
               </a:spcAft>
             </a:pPr>
             <a:r>
-              <a:rPr sz="1700" b="0" i="0">
+              <a:rPr sz="1500" b="0" i="0">
                 <a:solidFill>
                   <a:srgbClr val="1A1A1A"/>
                 </a:solidFill>
                 <a:latin typeface="Calibri"/>
               </a:rPr>
-              <a:t>Loudest front: fotball.no (113 requests) with still zero third-party cookies.</a:t>
+              <a:t>•  News and media contact the most hosts.</a:t>
             </a:r>
           </a:p>
           <a:p>
@@ -16225,17 +16273,17 @@
                 <a:spcPts val="0"/>
               </a:spcBef>
               <a:spcAft>
-                <a:spcPts val="1000"/>
+                <a:spcPts val="600"/>
               </a:spcAft>
             </a:pPr>
             <a:r>
-              <a:rPr sz="1700" b="0" i="0">
+              <a:rPr sz="1500" b="0" i="0">
                 <a:solidFill>
                   <a:srgbClr val="1A1A1A"/>
                 </a:solidFill>
                 <a:latin typeface="Calibri"/>
               </a:rPr>
-              <a:t>Most globalised first fill: document.no (6 countries excl. Norway).</a:t>
+              <a:t>•  Government contacts the fewest.</a:t>
             </a:r>
           </a:p>
           <a:p>
@@ -16244,17 +16292,17 @@
                 <a:spcPts val="0"/>
               </a:spcBef>
               <a:spcAft>
-                <a:spcPts val="1000"/>
+                <a:spcPts val="600"/>
               </a:spcAft>
             </a:pPr>
             <a:r>
-              <a:rPr sz="1700" b="0" i="0">
+              <a:rPr sz="1500" b="0" i="0">
                 <a:solidFill>
                   <a:srgbClr val="1A1A1A"/>
                 </a:solidFill>
                 <a:latin typeface="Calibri"/>
               </a:rPr>
-              <a:t>Quietest e-government: lanekassen.no (1 request) and altinn.no (5).</a:t>
+              <a:t>•  fotball.no raises the sport total.</a:t>
             </a:r>
           </a:p>
           <a:p>
@@ -16263,81 +16311,24 @@
                 <a:spcPts val="0"/>
               </a:spcBef>
               <a:spcAft>
-                <a:spcPts val="1000"/>
+                <a:spcPts val="600"/>
               </a:spcAft>
             </a:pPr>
             <a:r>
-              <a:rPr sz="1700" b="0" i="0">
+              <a:rPr sz="1500" b="0" i="0">
                 <a:solidFill>
                   <a:srgbClr val="1A1A1A"/>
                 </a:solidFill>
                 <a:latin typeface="Calibri"/>
               </a:rPr>
-              <a:t>Only third-party-cookie site: ikea.no (2 cookies).</a:t>
-            </a:r>
-          </a:p>
-          <a:p>
-            <a:pPr algn="l">
-              <a:spcBef>
-                <a:spcPts val="0"/>
-              </a:spcBef>
-              <a:spcAft>
-                <a:spcPts val="1000"/>
-              </a:spcAft>
-            </a:pPr>
-            <a:r>
-              <a:rPr sz="1700" b="0" i="0">
-                <a:solidFill>
-                  <a:srgbClr val="1A1A1A"/>
-                </a:solidFill>
-                <a:latin typeface="Calibri"/>
-              </a:rPr>
-              <a:t>News/media is the loudest sector; government is the quietest.</a:t>
-            </a:r>
-          </a:p>
-          <a:p>
-            <a:pPr algn="l">
-              <a:spcBef>
-                <a:spcPts val="0"/>
-              </a:spcBef>
-              <a:spcAft>
-                <a:spcPts val="1000"/>
-              </a:spcAft>
-            </a:pPr>
-            <a:r>
-              <a:rPr sz="1700" b="0" i="0">
-                <a:solidFill>
-                  <a:srgbClr val="1A1A1A"/>
-                </a:solidFill>
-                <a:latin typeface="Calibri"/>
-              </a:rPr>
-              <a:t>Shopping sits in the middle; babyshop.no jumps to 101 requests on a later clock.</a:t>
-            </a:r>
-          </a:p>
-          <a:p>
-            <a:pPr algn="l">
-              <a:spcBef>
-                <a:spcPts val="0"/>
-              </a:spcBef>
-              <a:spcAft>
-                <a:spcPts val="1000"/>
-              </a:spcAft>
-            </a:pPr>
-            <a:r>
-              <a:rPr sz="1700" b="0" i="0">
-                <a:solidFill>
-                  <a:srgbClr val="1A1A1A"/>
-                </a:solidFill>
-                <a:latin typeface="Calibri"/>
-              </a:rPr>
-              <a:t>Open item: one Netflix third-party Look up (assets.nflxext.com).</a:t>
-            </a:r>
-          </a:p>
-        </p:txBody>
-      </p:sp>
-      <p:sp>
-        <p:nvSpPr>
-          <p:cNvPr id="9" name="Rectangle 8"/>
+              <a:t>•  ikea.no is the only third-party-cookie site.</a:t>
+            </a:r>
+          </a:p>
+        </p:txBody>
+      </p:sp>
+      <p:sp>
+        <p:nvSpPr>
+          <p:cNvPr id="11" name="Rectangle 10"/>
           <p:cNvSpPr/>
           <p:nvPr/>
         </p:nvSpPr>
@@ -16380,7 +16371,7 @@
       </p:sp>
       <p:sp>
         <p:nvSpPr>
-          <p:cNvPr id="10" name="TextBox 9"/>
+          <p:cNvPr id="12" name="TextBox 11"/>
           <p:cNvSpPr txBox="1"/>
           <p:nvPr/>
         </p:nvSpPr>
@@ -16408,14 +16399,14 @@
                 </a:solidFill>
                 <a:latin typeface="Calibri"/>
               </a:rPr>
-              <a:t>ACIT4280 Group 1-A  |  Assignment 1A  |  3 Sep 2026</a:t>
-            </a:r>
-          </a:p>
-        </p:txBody>
-      </p:sp>
-      <p:sp>
-        <p:nvSpPr>
-          <p:cNvPr id="11" name="TextBox 10"/>
+              <a:t>ACIT4280 Privacy by Design  |  Third-party sharing and lawful basis  |  3 Sep 2026</a:t>
+            </a:r>
+          </a:p>
+        </p:txBody>
+      </p:sp>
+      <p:sp>
+        <p:nvSpPr>
+          <p:cNvPr id="13" name="TextBox 12"/>
           <p:cNvSpPr txBox="1"/>
           <p:nvPr/>
         </p:nvSpPr>
@@ -16700,16 +16691,64 @@
           </a:p>
         </p:txBody>
       </p:sp>
-      <p:sp>
-        <p:nvSpPr>
-          <p:cNvPr id="8" name="TextBox 7"/>
+      <p:pic>
+        <p:nvPicPr>
+          <p:cNvPr id="8" name="Picture 7" descr="fig2_webbkoll_results_klassekampen.png"/>
+          <p:cNvPicPr>
+            <a:picLocks noChangeAspect="1"/>
+          </p:cNvPicPr>
+          <p:nvPr/>
+        </p:nvPicPr>
+        <p:blipFill>
+          <a:blip r:embed="rId2"/>
+          <a:stretch>
+            <a:fillRect/>
+          </a:stretch>
+        </p:blipFill>
+        <p:spPr>
+          <a:xfrm>
+            <a:off x="365760" y="1280160"/>
+            <a:ext cx="5852160" cy="3657600"/>
+          </a:xfrm>
+          <a:prstGeom prst="rect">
+            <a:avLst/>
+          </a:prstGeom>
+        </p:spPr>
+      </p:pic>
+      <p:pic>
+        <p:nvPicPr>
+          <p:cNvPr id="9" name="Picture 8" descr="fig4_keycdn_lookup_klassekampen.png"/>
+          <p:cNvPicPr>
+            <a:picLocks noChangeAspect="1"/>
+          </p:cNvPicPr>
+          <p:nvPr/>
+        </p:nvPicPr>
+        <p:blipFill>
+          <a:blip r:embed="rId3"/>
+          <a:stretch>
+            <a:fillRect/>
+          </a:stretch>
+        </p:blipFill>
+        <p:spPr>
+          <a:xfrm>
+            <a:off x="6309360" y="1280160"/>
+            <a:ext cx="5486400" cy="2926080"/>
+          </a:xfrm>
+          <a:prstGeom prst="rect">
+            <a:avLst/>
+          </a:prstGeom>
+        </p:spPr>
+      </p:pic>
+      <p:sp>
+        <p:nvSpPr>
+          <p:cNvPr id="10" name="TextBox 9"/>
           <p:cNvSpPr txBox="1"/>
           <p:nvPr/>
         </p:nvSpPr>
         <p:spPr>
           <a:xfrm>
-            <a:off x="502920" y="1371600"/>
-            <a:ext cx="11155680" cy="5029200"/>
+            <a:off x="457200" y="5029200"/>
+            <a:ext cx="11247120" cy="1371600"/>
           </a:xfrm>
           <a:prstGeom prst="rect">
             <a:avLst/>
@@ -16727,138 +16766,24 @@
                 <a:spcPts val="0"/>
               </a:spcBef>
               <a:spcAft>
-                <a:spcPts val="1000"/>
+                <a:spcPts val="400"/>
               </a:spcAft>
             </a:pPr>
             <a:r>
-              <a:rPr sz="1700" b="0" i="0">
+              <a:rPr sz="1600" b="0" i="0">
                 <a:solidFill>
                   <a:srgbClr val="1A1A1A"/>
                 </a:solidFill>
                 <a:latin typeface="Calibri"/>
               </a:rPr>
-              <a:t>Highest 5 in Table 4, and our full method walkthrough.</a:t>
-            </a:r>
-          </a:p>
-          <a:p>
-            <a:pPr algn="l">
-              <a:spcBef>
-                <a:spcPts val="0"/>
-              </a:spcBef>
-              <a:spcAft>
-                <a:spcPts val="1000"/>
-              </a:spcAft>
-            </a:pPr>
-            <a:r>
-              <a:rPr sz="1700" b="0" i="0">
-                <a:solidFill>
-                  <a:srgbClr val="1A1A1A"/>
-                </a:solidFill>
-                <a:latin typeface="Calibri"/>
-              </a:rPr>
-              <a:t>Scan 20 August 2026, 12:36:46 UTC.</a:t>
-            </a:r>
-          </a:p>
-          <a:p>
-            <a:pPr algn="l">
-              <a:spcBef>
-                <a:spcPts val="0"/>
-              </a:spcBef>
-              <a:spcAft>
-                <a:spcPts val="1000"/>
-              </a:spcAft>
-            </a:pPr>
-            <a:r>
-              <a:rPr sz="1700" b="0" i="0">
-                <a:solidFill>
-                  <a:srgbClr val="1A1A1A"/>
-                </a:solidFill>
-                <a:latin typeface="Calibri"/>
-              </a:rPr>
-              <a:t>4 first-party cookies, 0 third-party cookies, 56 requests to 13 hosts.</a:t>
-            </a:r>
-          </a:p>
-          <a:p>
-            <a:pPr algn="l">
-              <a:spcBef>
-                <a:spcPts val="0"/>
-              </a:spcBef>
-              <a:spcAft>
-                <a:spcPts val="1000"/>
-              </a:spcAft>
-            </a:pPr>
-            <a:r>
-              <a:rPr sz="1700" b="0" i="0">
-                <a:solidFill>
-                  <a:srgbClr val="1A1A1A"/>
-                </a:solidFill>
-                <a:latin typeface="Calibri"/>
-              </a:rPr>
-              <a:t>Hosts include Google advertising, Meta, Cookiebot.</a:t>
-            </a:r>
-          </a:p>
-          <a:p>
-            <a:pPr algn="l">
-              <a:spcBef>
-                <a:spcPts val="0"/>
-              </a:spcBef>
-              <a:spcAft>
-                <a:spcPts val="1000"/>
-              </a:spcAft>
-            </a:pPr>
-            <a:r>
-              <a:rPr sz="1700" b="0" i="0">
-                <a:solidFill>
-                  <a:srgbClr val="1A1A1A"/>
-                </a:solidFill>
-                <a:latin typeface="Calibri"/>
-              </a:rPr>
-              <a:t>Server KeyCDN: United States (Google). Third-party countries: IE, SE, US.</a:t>
-            </a:r>
-          </a:p>
-          <a:p>
-            <a:pPr algn="l">
-              <a:spcBef>
-                <a:spcPts val="0"/>
-              </a:spcBef>
-              <a:spcAft>
-                <a:spcPts val="1000"/>
-              </a:spcAft>
-            </a:pPr>
-            <a:r>
-              <a:rPr sz="1700" b="0" i="0">
-                <a:solidFill>
-                  <a:srgbClr val="1A1A1A"/>
-                </a:solidFill>
-                <a:latin typeface="Calibri"/>
-              </a:rPr>
-              <a:t>Missing HSTS, CSP, SRI, X-Content-Type-Options, X-Frame-Options.</a:t>
-            </a:r>
-          </a:p>
-          <a:p>
-            <a:pPr algn="l">
-              <a:spcBef>
-                <a:spcPts val="0"/>
-              </a:spcBef>
-              <a:spcAft>
-                <a:spcPts val="1000"/>
-              </a:spcAft>
-            </a:pPr>
-            <a:r>
-              <a:rPr sz="1700" b="0" i="0">
-                <a:solidFill>
-                  <a:srgbClr val="1A1A1A"/>
-                </a:solidFill>
-                <a:latin typeface="Calibri"/>
-              </a:rPr>
-              <a:t>Those gaps are Arts. 5(1)(f), 25 and 32, not Article 6.</a:t>
-            </a:r>
-          </a:p>
-        </p:txBody>
-      </p:sp>
-      <p:sp>
-        <p:nvSpPr>
-          <p:cNvPr id="9" name="Rectangle 8"/>
+              <a:t>Scan 20 August 2026, 12:36:46 UTC. 4 first-party cookies, 0 third-party cookies, 56 requests to 13 hosts (Google advertising, Meta, Cookiebot). Missing HSTS and CSP concern Arts. 5(1)(f), 25 and 32, not Article 6.</a:t>
+            </a:r>
+          </a:p>
+        </p:txBody>
+      </p:sp>
+      <p:sp>
+        <p:nvSpPr>
+          <p:cNvPr id="11" name="Rectangle 10"/>
           <p:cNvSpPr/>
           <p:nvPr/>
         </p:nvSpPr>
@@ -16901,7 +16826,7 @@
       </p:sp>
       <p:sp>
         <p:nvSpPr>
-          <p:cNvPr id="10" name="TextBox 9"/>
+          <p:cNvPr id="12" name="TextBox 11"/>
           <p:cNvSpPr txBox="1"/>
           <p:nvPr/>
         </p:nvSpPr>
@@ -16929,14 +16854,14 @@
                 </a:solidFill>
                 <a:latin typeface="Calibri"/>
               </a:rPr>
-              <a:t>ACIT4280 Group 1-A  |  Assignment 1A  |  3 Sep 2026</a:t>
-            </a:r>
-          </a:p>
-        </p:txBody>
-      </p:sp>
-      <p:sp>
-        <p:nvSpPr>
-          <p:cNvPr id="11" name="TextBox 10"/>
+              <a:t>ACIT4280 Privacy by Design  |  Third-party sharing and lawful basis  |  3 Sep 2026</a:t>
+            </a:r>
+          </a:p>
+        </p:txBody>
+      </p:sp>
+      <p:sp>
+        <p:nvSpPr>
+          <p:cNvPr id="13" name="TextBox 12"/>
           <p:cNvSpPr txBox="1"/>
           <p:nvPr/>
         </p:nvSpPr>
@@ -17146,7 +17071,7 @@
                 </a:solidFill>
                 <a:latin typeface="Calibri"/>
               </a:rPr>
-              <a:t>Part 2  ·  Group 1-A</a:t>
+              <a:t>Part 2</a:t>
             </a:r>
           </a:p>
         </p:txBody>
@@ -17431,7 +17356,7 @@
                 </a:solidFill>
                 <a:latin typeface="Calibri"/>
               </a:rPr>
-              <a:t>ACIT4280 Group 1-A  |  Assignment 1A  |  3 Sep 2026</a:t>
+              <a:t>ACIT4280 Privacy by Design  |  Third-party sharing and lawful basis  |  3 Sep 2026</a:t>
             </a:r>
           </a:p>
         </p:txBody>

</xml_diff>

<commit_message>
Bytt inn gruppens originale Webbkoll- og KeyCDN-figurer
Erstatter rekonstruerte bilder med skjermbilder og diagrammer fra innleveringen: Webbkoll-start og -resultat, stolpediagram, kakediagram, sektoroversikt og KeyCDN-oppslag.

Co-authored-by: Karina <kasa031@users.noreply.github.com>
</commit_message>
<xml_diff>
--- a/ACIT4280_1A_presentation.pptx
+++ b/ACIT4280_1A_presentation.pptx
@@ -16104,7 +16104,7 @@
                 </a:solidFill>
                 <a:latin typeface="Calibri"/>
               </a:rPr>
-              <a:t>Part 1  ·  Figures 2 and 3</a:t>
+              <a:t>Part 1  ·  Figures 2 to 4</a:t>
             </a:r>
           </a:p>
         </p:txBody>
@@ -16195,8 +16195,8 @@
         </p:blipFill>
         <p:spPr>
           <a:xfrm>
-            <a:off x="320040" y="1280160"/>
-            <a:ext cx="5852160" cy="5029200"/>
+            <a:off x="274320" y="1261872"/>
+            <a:ext cx="5943600" cy="5074920"/>
           </a:xfrm>
           <a:prstGeom prst="rect">
             <a:avLst/>
@@ -16205,7 +16205,7 @@
       </p:pic>
       <p:pic>
         <p:nvPicPr>
-          <p:cNvPr id="9" name="Picture 8" descr="fig6_requests_per_sector.png"/>
+          <p:cNvPr id="9" name="Picture 8" descr="fig5_share_requests_pie.png"/>
           <p:cNvPicPr>
             <a:picLocks noChangeAspect="1"/>
           </p:cNvPicPr>
@@ -16219,113 +16219,38 @@
         </p:blipFill>
         <p:spPr>
           <a:xfrm>
-            <a:off x="6263640" y="1417320"/>
-            <a:ext cx="5577840" cy="2926080"/>
+            <a:off x="6355080" y="1261872"/>
+            <a:ext cx="5486400" cy="2468880"/>
           </a:xfrm>
           <a:prstGeom prst="rect">
             <a:avLst/>
           </a:prstGeom>
         </p:spPr>
       </p:pic>
-      <p:sp>
-        <p:nvSpPr>
-          <p:cNvPr id="10" name="TextBox 9"/>
-          <p:cNvSpPr txBox="1"/>
-          <p:nvPr/>
-        </p:nvSpPr>
-        <p:spPr>
-          <a:xfrm>
-            <a:off x="6309360" y="4480560"/>
-            <a:ext cx="5486400" cy="1828800"/>
-          </a:xfrm>
-          <a:prstGeom prst="rect">
-            <a:avLst/>
-          </a:prstGeom>
-          <a:noFill/>
-        </p:spPr>
-        <p:txBody>
-          <a:bodyPr wrap="square">
-            <a:spAutoFit/>
-          </a:bodyPr>
-          <a:lstStyle/>
-          <a:p>
-            <a:pPr algn="l">
-              <a:spcBef>
-                <a:spcPts val="0"/>
-              </a:spcBef>
-              <a:spcAft>
-                <a:spcPts val="600"/>
-              </a:spcAft>
-            </a:pPr>
-            <a:r>
-              <a:rPr sz="1500" b="0" i="0">
-                <a:solidFill>
-                  <a:srgbClr val="1A1A1A"/>
-                </a:solidFill>
-                <a:latin typeface="Calibri"/>
-              </a:rPr>
-              <a:t>•  News and media contact the most hosts.</a:t>
-            </a:r>
-          </a:p>
-          <a:p>
-            <a:pPr algn="l">
-              <a:spcBef>
-                <a:spcPts val="0"/>
-              </a:spcBef>
-              <a:spcAft>
-                <a:spcPts val="600"/>
-              </a:spcAft>
-            </a:pPr>
-            <a:r>
-              <a:rPr sz="1500" b="0" i="0">
-                <a:solidFill>
-                  <a:srgbClr val="1A1A1A"/>
-                </a:solidFill>
-                <a:latin typeface="Calibri"/>
-              </a:rPr>
-              <a:t>•  Government contacts the fewest.</a:t>
-            </a:r>
-          </a:p>
-          <a:p>
-            <a:pPr algn="l">
-              <a:spcBef>
-                <a:spcPts val="0"/>
-              </a:spcBef>
-              <a:spcAft>
-                <a:spcPts val="600"/>
-              </a:spcAft>
-            </a:pPr>
-            <a:r>
-              <a:rPr sz="1500" b="0" i="0">
-                <a:solidFill>
-                  <a:srgbClr val="1A1A1A"/>
-                </a:solidFill>
-                <a:latin typeface="Calibri"/>
-              </a:rPr>
-              <a:t>•  fotball.no raises the sport total.</a:t>
-            </a:r>
-          </a:p>
-          <a:p>
-            <a:pPr algn="l">
-              <a:spcBef>
-                <a:spcPts val="0"/>
-              </a:spcBef>
-              <a:spcAft>
-                <a:spcPts val="600"/>
-              </a:spcAft>
-            </a:pPr>
-            <a:r>
-              <a:rPr sz="1500" b="0" i="0">
-                <a:solidFill>
-                  <a:srgbClr val="1A1A1A"/>
-                </a:solidFill>
-                <a:latin typeface="Calibri"/>
-              </a:rPr>
-              <a:t>•  ikea.no is the only third-party-cookie site.</a:t>
-            </a:r>
-          </a:p>
-        </p:txBody>
-      </p:sp>
+      <p:pic>
+        <p:nvPicPr>
+          <p:cNvPr id="10" name="Picture 9" descr="fig6_requests_per_sector.png"/>
+          <p:cNvPicPr>
+            <a:picLocks noChangeAspect="1"/>
+          </p:cNvPicPr>
+          <p:nvPr/>
+        </p:nvPicPr>
+        <p:blipFill>
+          <a:blip r:embed="rId4"/>
+          <a:stretch>
+            <a:fillRect/>
+          </a:stretch>
+        </p:blipFill>
+        <p:spPr>
+          <a:xfrm>
+            <a:off x="6355080" y="3794760"/>
+            <a:ext cx="5486400" cy="2514600"/>
+          </a:xfrm>
+          <a:prstGeom prst="rect">
+            <a:avLst/>
+          </a:prstGeom>
+        </p:spPr>
+      </p:pic>
       <p:sp>
         <p:nvSpPr>
           <p:cNvPr id="11" name="Rectangle 10"/>
@@ -16707,8 +16632,8 @@
         </p:blipFill>
         <p:spPr>
           <a:xfrm>
-            <a:off x="365760" y="1280160"/>
-            <a:ext cx="5852160" cy="3657600"/>
+            <a:off x="365760" y="1234440"/>
+            <a:ext cx="11430000" cy="2331720"/>
           </a:xfrm>
           <a:prstGeom prst="rect">
             <a:avLst/>
@@ -16731,8 +16656,8 @@
         </p:blipFill>
         <p:spPr>
           <a:xfrm>
-            <a:off x="6309360" y="1280160"/>
-            <a:ext cx="5486400" cy="2926080"/>
+            <a:off x="2194560" y="3657600"/>
+            <a:ext cx="7772400" cy="2788920"/>
           </a:xfrm>
           <a:prstGeom prst="rect">
             <a:avLst/>
@@ -16741,49 +16666,7 @@
       </p:pic>
       <p:sp>
         <p:nvSpPr>
-          <p:cNvPr id="10" name="TextBox 9"/>
-          <p:cNvSpPr txBox="1"/>
-          <p:nvPr/>
-        </p:nvSpPr>
-        <p:spPr>
-          <a:xfrm>
-            <a:off x="457200" y="5029200"/>
-            <a:ext cx="11247120" cy="1371600"/>
-          </a:xfrm>
-          <a:prstGeom prst="rect">
-            <a:avLst/>
-          </a:prstGeom>
-          <a:noFill/>
-        </p:spPr>
-        <p:txBody>
-          <a:bodyPr wrap="square">
-            <a:spAutoFit/>
-          </a:bodyPr>
-          <a:lstStyle/>
-          <a:p>
-            <a:pPr algn="l">
-              <a:spcBef>
-                <a:spcPts val="0"/>
-              </a:spcBef>
-              <a:spcAft>
-                <a:spcPts val="400"/>
-              </a:spcAft>
-            </a:pPr>
-            <a:r>
-              <a:rPr sz="1600" b="0" i="0">
-                <a:solidFill>
-                  <a:srgbClr val="1A1A1A"/>
-                </a:solidFill>
-                <a:latin typeface="Calibri"/>
-              </a:rPr>
-              <a:t>Scan 20 August 2026, 12:36:46 UTC. 4 first-party cookies, 0 third-party cookies, 56 requests to 13 hosts (Google advertising, Meta, Cookiebot). Missing HSTS and CSP concern Arts. 5(1)(f), 25 and 32, not Article 6.</a:t>
-            </a:r>
-          </a:p>
-        </p:txBody>
-      </p:sp>
-      <p:sp>
-        <p:nvSpPr>
-          <p:cNvPr id="11" name="Rectangle 10"/>
+          <p:cNvPr id="10" name="Rectangle 9"/>
           <p:cNvSpPr/>
           <p:nvPr/>
         </p:nvSpPr>
@@ -16826,7 +16709,7 @@
       </p:sp>
       <p:sp>
         <p:nvSpPr>
-          <p:cNvPr id="12" name="TextBox 11"/>
+          <p:cNvPr id="11" name="TextBox 10"/>
           <p:cNvSpPr txBox="1"/>
           <p:nvPr/>
         </p:nvSpPr>
@@ -16861,7 +16744,7 @@
       </p:sp>
       <p:sp>
         <p:nvSpPr>
-          <p:cNvPr id="13" name="TextBox 12"/>
+          <p:cNvPr id="12" name="TextBox 11"/>
           <p:cNvSpPr txBox="1"/>
           <p:nvPr/>
         </p:nvSpPr>

</xml_diff>

<commit_message>
Lag nettleser-PDF av 1A-presentasjonen og rett APA 7-kilder
Office Online åpner ikke PPTX. Slides finnes nå som HTML og PDF til Ctrl+P.
Rapporten bruker innleveringsdato på tittelbladet og Kildekompasset-APA for GDPR/ePrivacy.

Co-authored-by: Karina <kasa031@users.noreply.github.com>
</commit_message>
<xml_diff>
--- a/ACIT4280_1A_presentation.pptx
+++ b/ACIT4280_1A_presentation.pptx
@@ -13704,7 +13704,7 @@
                 </a:solidFill>
                 <a:latin typeface="Calibri"/>
               </a:rPr>
-              <a:t>Server country: KeyCDN Country field for the IP (company name is not a country)</a:t>
+              <a:t>Server country: KeyCDN Country field for the IP</a:t>
             </a:r>
           </a:p>
           <a:p>
@@ -13742,7 +13742,7 @@
                 </a:solidFill>
                 <a:latin typeface="Calibri"/>
               </a:rPr>
-              <a:t>Cloudflare with no Country field: none returned, not counted</a:t>
+              <a:t>If KeyCDN returns no country: recorded as not available</a:t>
             </a:r>
           </a:p>
           <a:p>
@@ -13761,7 +13761,7 @@
                 </a:solidFill>
                 <a:latin typeface="Calibri"/>
               </a:rPr>
-              <a:t>Two tables on purpose: Table 2 first measurement, Table 3 repeat measurement (Art. 5(1)(a))</a:t>
+              <a:t>Two tables: Table 2 first measurement, Table 3 repeat measurement</a:t>
             </a:r>
           </a:p>
         </p:txBody>

</xml_diff>

<commit_message>
Bytt Ja/Nei til Yes/No i engelske 1A-dokumenter
Cookie-banner og overskrifter i rapport, presentasjon og briefing bruker Yes/No.

Co-authored-by: Karina <kasa031@users.noreply.github.com>
</commit_message>
<xml_diff>
--- a/ACIT4280_1A_presentation.pptx
+++ b/ACIT4280_1A_presentation.pptx
@@ -729,7 +729,7 @@
           <a:lstStyle/>
           <a:p>
             <a:r>
-              <a:t>SPEAKER: Karina. Two purposes, two reports. Tax: law. Cookies: they aim at consent, but ICO says name controller, purpose and types more clearly. Nei test 24 August 2026 on skatteetaten.no/person/.</a:t>
+              <a:t>SPEAKER: Karina. Two purposes, two reports. Tax: law. Cookies: they aim at consent, but ICO says name controller, purpose and types more clearly. No test 24 August 2026 on skatteetaten.no/person/.</a:t>
             </a:r>
           </a:p>
         </p:txBody>
@@ -5507,7 +5507,7 @@
                 </a:solidFill>
                 <a:latin typeface="Calibri"/>
               </a:rPr>
-              <a:t>•  Analytics and ads: consent (Ja/Nei, Cookiebot)</a:t>
+              <a:t>•  Analytics and ads: consent (Yes/No, Cookiebot)</a:t>
             </a:r>
           </a:p>
           <a:p>
@@ -5526,7 +5526,7 @@
                 </a:solidFill>
                 <a:latin typeface="Calibri"/>
               </a:rPr>
-              <a:t>•  Nei test 24 Aug 2026 on skatteetaten.no/person/</a:t>
+              <a:t>•  No test 24 Aug 2026 on skatteetaten.no/person/</a:t>
             </a:r>
           </a:p>
         </p:txBody>
@@ -8596,7 +8596,7 @@
                 </a:solidFill>
                 <a:latin typeface="Calibri"/>
               </a:rPr>
-              <a:t>Purpose 2: optional stats cookies (Skyra, Matomo, GA, Siteimprove). Ja/Nei. ICO: consent INCONCLUSIVE (Q6). No basis APPROPRIATE.</a:t>
+              <a:t>Purpose 2: optional stats cookies (Skyra, Matomo, GA, Siteimprove). Yes/No. ICO: consent INCONCLUSIVE (Q6). No basis APPROPRIATE.</a:t>
             </a:r>
           </a:p>
         </p:txBody>
@@ -11222,7 +11222,7 @@
                 </a:solidFill>
                 <a:latin typeface="Calibri"/>
               </a:rPr>
-              <a:t>Legal obligation (tax) is not the same as cookie consent (Ja/Nei).</a:t>
+              <a:t>Legal obligation (tax) is not the same as cookie consent (Yes/No).</a:t>
             </a:r>
           </a:p>
         </p:txBody>
@@ -14168,7 +14168,7 @@
                 </a:solidFill>
                 <a:latin typeface="Calibri"/>
               </a:rPr>
-              <a:t>It does not click Ja/Nei or Cookiebot.</a:t>
+              <a:t>It does not click Yes/No or Cookiebot.</a:t>
             </a:r>
           </a:p>
           <a:p>

</xml_diff>

<commit_message>
Gjør Group Assignment 1A synlig på tittelbildet
Tittelen er Analysis of 3rd-party data sharing and data tracking and of GDPR compliance of Norwegian web sites.

Co-authored-by: Karina <kasa031@users.noreply.github.com>
</commit_message>
<xml_diff>
--- a/ACIT4280_1A_presentation.pptx
+++ b/ACIT4280_1A_presentation.pptx
@@ -4738,8 +4738,8 @@
         </p:nvSpPr>
         <p:spPr>
           <a:xfrm>
-            <a:off x="640080" y="1051560"/>
-            <a:ext cx="10972800" cy="365760"/>
+            <a:off x="640080" y="777240"/>
+            <a:ext cx="10972800" cy="320040"/>
           </a:xfrm>
           <a:prstGeom prst="rect">
             <a:avLst/>
@@ -4760,7 +4760,7 @@
                 </a:solidFill>
                 <a:latin typeface="Calibri"/>
               </a:rPr>
-              <a:t>ACIT4280 Privacy by Design  ·  Group Assignment 1A</a:t>
+              <a:t>ACIT4280 Privacy by Design</a:t>
             </a:r>
           </a:p>
         </p:txBody>
@@ -4773,8 +4773,8 @@
         </p:nvSpPr>
         <p:spPr>
           <a:xfrm>
-            <a:off x="640080" y="1508760"/>
-            <a:ext cx="10972800" cy="2011680"/>
+            <a:off x="640080" y="1115568"/>
+            <a:ext cx="10972800" cy="347472"/>
           </a:xfrm>
           <a:prstGeom prst="rect">
             <a:avLst/>
@@ -4789,6 +4789,41 @@
           <a:p>
             <a:pPr algn="l"/>
             <a:r>
+              <a:rPr sz="2200" b="1" i="0">
+                <a:solidFill>
+                  <a:srgbClr val="FFF1D1"/>
+                </a:solidFill>
+                <a:latin typeface="Calibri"/>
+              </a:rPr>
+              <a:t>Group Assignment 1A</a:t>
+            </a:r>
+          </a:p>
+        </p:txBody>
+      </p:sp>
+      <p:sp>
+        <p:nvSpPr>
+          <p:cNvPr id="6" name="TextBox 5"/>
+          <p:cNvSpPr txBox="1"/>
+          <p:nvPr/>
+        </p:nvSpPr>
+        <p:spPr>
+          <a:xfrm>
+            <a:off x="640080" y="1554480"/>
+            <a:ext cx="10972800" cy="1965960"/>
+          </a:xfrm>
+          <a:prstGeom prst="rect">
+            <a:avLst/>
+          </a:prstGeom>
+          <a:noFill/>
+        </p:spPr>
+        <p:txBody>
+          <a:bodyPr wrap="square">
+            <a:spAutoFit/>
+          </a:bodyPr>
+          <a:lstStyle/>
+          <a:p>
+            <a:pPr algn="l"/>
+            <a:r>
               <a:rPr sz="2800" b="1" i="0">
                 <a:solidFill>
                   <a:srgbClr val="FFFFFF"/>
@@ -4804,7 +4839,7 @@
       </p:sp>
       <p:sp>
         <p:nvSpPr>
-          <p:cNvPr id="6" name="TextBox 5"/>
+          <p:cNvPr id="7" name="TextBox 6"/>
           <p:cNvSpPr txBox="1"/>
           <p:nvPr/>
         </p:nvSpPr>
@@ -4840,7 +4875,7 @@
       </p:sp>
       <p:sp>
         <p:nvSpPr>
-          <p:cNvPr id="7" name="TextBox 6"/>
+          <p:cNvPr id="8" name="TextBox 7"/>
           <p:cNvSpPr txBox="1"/>
           <p:nvPr/>
         </p:nvSpPr>

</xml_diff>

<commit_message>
Forklar tabeller og KeyCDN-grenser i 1A-presentasjonen
Samme poeng som i rapporten: Table 2 vs Table 3, klassekampen 46/56, Match Yes/Partial, og at KeyCDN ikke er GDPR kapittel V.

Co-authored-by: Karina <kasa031@users.noreply.github.com>
</commit_message>
<xml_diff>
--- a/ACIT4280_1A_presentation.pptx
+++ b/ACIT4280_1A_presentation.pptx
@@ -588,7 +588,7 @@
           <a:lstStyle/>
           <a:p>
             <a:r>
-              <a:t>Four of five core purposes match. Two consent tests fail: skatteetaten cookies (Q6, banner too short) and document.no Signals (request not separate from terms).</a:t>
+              <a:t>Four of five core purposes match. Two consent tests fail: skatteetaten cookies (Q6, banner too short) and document.no Signals (request not separate from terms). Webbkoll 0 external cookies on skatteetaten is not a conflict with the cookie ICO row.</a:t>
             </a:r>
           </a:p>
         </p:txBody>
@@ -658,7 +658,7 @@
           <a:lstStyle/>
           <a:p>
             <a:r>
-              <a:t>Two purposes, two reports. Tax: law. Cookies: they aim at consent, but ICO says name controller, purpose and types more clearly. No test 24 August 2026 on skatteetaten.no/person/.</a:t>
+              <a:t>Two purposes, two reports. Tax: law. Cookies: they aim at consent, but ICO says name controller, purpose and types more clearly. No test 24 August 2026 on skatteetaten.no/person/. Table 5 cookie row tests the notice, not the Webbkoll count.</a:t>
             </a:r>
           </a:p>
         </p:txBody>
@@ -1148,7 +1148,7 @@
           <a:lstStyle/>
           <a:p>
             <a:r>
-              <a:t>Stress one purpose at a time. Cookie clicks are not the lawful basis for tax or checkout.</a:t>
+              <a:t>Table 1 is the 18 Canvas names. Table 1a is why we picked the five. Stress one purpose at a time. Cookie clicks are not the lawful basis for tax or checkout.</a:t>
             </a:r>
           </a:p>
         </p:txBody>
@@ -1218,7 +1218,7 @@
           <a:lstStyle/>
           <a:p>
             <a:r>
-              <a:t>Webbkoll does not read a privacy notice and does not decide Article 6. Request volume is not cookie volume.</a:t>
+              <a:t>Webbkoll does not read a privacy notice and does not decide Article 6. Request volume is not cookie volume and is not proof that personal data left Norway.</a:t>
             </a:r>
           </a:p>
         </p:txBody>
@@ -1288,7 +1288,7 @@
           <a:lstStyle/>
           <a:p>
             <a:r>
-              <a:t>Hand over to Mithun for the numbers.</a:t>
+              <a:t>skatteetaten.no shows five internal cookies and zero external cookies because we never clicked Yes. The ICO cookie row tests the notice, not that Webbkoll count.</a:t>
             </a:r>
           </a:p>
         </p:txBody>
@@ -1428,7 +1428,7 @@
           <a:lstStyle/>
           <a:p>
             <a:r>
-              <a:t>Point to fotball.no at 113 and lanekassen.no at 1. Request volume is not cookie volume.</a:t>
+              <a:t>Point to fotball.no at 113 and lanekassen.no at 1. Request volume is not cookie volume. Do not read the pie as cookies.</a:t>
             </a:r>
           </a:p>
         </p:txBody>
@@ -1498,7 +1498,7 @@
           <a:lstStyle/>
           <a:p>
             <a:r>
-              <a:t>This shows that request volume is not cookie volume. Continue with the ICO tool.</a:t>
+              <a:t>Say the number on the screenshot is 56 because that is the later scan. The ranking in Table 4 is 46 from Table 2. Zero third-party cookies either way.</a:t>
             </a:r>
           </a:p>
         </p:txBody>
@@ -5134,8 +5134,8 @@
         </p:nvSpPr>
         <p:spPr>
           <a:xfrm>
-            <a:off x="365760" y="1325880"/>
-            <a:ext cx="2377440" cy="658368"/>
+            <a:off x="365760" y="1280160"/>
+            <a:ext cx="2377440" cy="621792"/>
           </a:xfrm>
           <a:prstGeom prst="rect">
             <a:avLst/>
@@ -5177,7 +5177,7 @@
         </p:nvSpPr>
         <p:spPr>
           <a:xfrm>
-            <a:off x="438912" y="1490472"/>
+            <a:off x="438912" y="1444752"/>
             <a:ext cx="2286000" cy="365760"/>
           </a:xfrm>
           <a:prstGeom prst="rect">
@@ -5212,8 +5212,8 @@
         </p:nvSpPr>
         <p:spPr>
           <a:xfrm>
-            <a:off x="2743200" y="1325880"/>
-            <a:ext cx="2926080" cy="658368"/>
+            <a:off x="2743200" y="1280160"/>
+            <a:ext cx="2926080" cy="621792"/>
           </a:xfrm>
           <a:prstGeom prst="rect">
             <a:avLst/>
@@ -5255,7 +5255,7 @@
         </p:nvSpPr>
         <p:spPr>
           <a:xfrm>
-            <a:off x="2816352" y="1490472"/>
+            <a:off x="2816352" y="1444752"/>
             <a:ext cx="2834640" cy="365760"/>
           </a:xfrm>
           <a:prstGeom prst="rect">
@@ -5290,8 +5290,8 @@
         </p:nvSpPr>
         <p:spPr>
           <a:xfrm>
-            <a:off x="5669280" y="1325880"/>
-            <a:ext cx="4846320" cy="658368"/>
+            <a:off x="5669280" y="1280160"/>
+            <a:ext cx="4846320" cy="621792"/>
           </a:xfrm>
           <a:prstGeom prst="rect">
             <a:avLst/>
@@ -5333,7 +5333,7 @@
         </p:nvSpPr>
         <p:spPr>
           <a:xfrm>
-            <a:off x="5742432" y="1490472"/>
+            <a:off x="5742432" y="1444752"/>
             <a:ext cx="4754880" cy="365760"/>
           </a:xfrm>
           <a:prstGeom prst="rect">
@@ -5368,8 +5368,8 @@
         </p:nvSpPr>
         <p:spPr>
           <a:xfrm>
-            <a:off x="10515600" y="1325880"/>
-            <a:ext cx="1280160" cy="658368"/>
+            <a:off x="10515600" y="1280160"/>
+            <a:ext cx="1280160" cy="621792"/>
           </a:xfrm>
           <a:prstGeom prst="rect">
             <a:avLst/>
@@ -5411,7 +5411,7 @@
         </p:nvSpPr>
         <p:spPr>
           <a:xfrm>
-            <a:off x="10588752" y="1490472"/>
+            <a:off x="10588752" y="1444752"/>
             <a:ext cx="1188720" cy="365760"/>
           </a:xfrm>
           <a:prstGeom prst="rect">
@@ -5446,8 +5446,8 @@
         </p:nvSpPr>
         <p:spPr>
           <a:xfrm>
-            <a:off x="365760" y="1984248"/>
-            <a:ext cx="2377440" cy="658368"/>
+            <a:off x="365760" y="1901952"/>
+            <a:ext cx="2377440" cy="621792"/>
           </a:xfrm>
           <a:prstGeom prst="rect">
             <a:avLst/>
@@ -5489,7 +5489,7 @@
         </p:nvSpPr>
         <p:spPr>
           <a:xfrm>
-            <a:off x="438912" y="2148840"/>
+            <a:off x="438912" y="2066544"/>
             <a:ext cx="2267712" cy="411480"/>
           </a:xfrm>
           <a:prstGeom prst="rect">
@@ -5524,8 +5524,8 @@
         </p:nvSpPr>
         <p:spPr>
           <a:xfrm>
-            <a:off x="2743200" y="1984248"/>
-            <a:ext cx="2926080" cy="658368"/>
+            <a:off x="2743200" y="1901952"/>
+            <a:ext cx="2926080" cy="621792"/>
           </a:xfrm>
           <a:prstGeom prst="rect">
             <a:avLst/>
@@ -5567,7 +5567,7 @@
         </p:nvSpPr>
         <p:spPr>
           <a:xfrm>
-            <a:off x="2816352" y="2148840"/>
+            <a:off x="2816352" y="2066544"/>
             <a:ext cx="2816352" cy="411480"/>
           </a:xfrm>
           <a:prstGeom prst="rect">
@@ -5602,8 +5602,8 @@
         </p:nvSpPr>
         <p:spPr>
           <a:xfrm>
-            <a:off x="5669280" y="1984248"/>
-            <a:ext cx="4846320" cy="658368"/>
+            <a:off x="5669280" y="1901952"/>
+            <a:ext cx="4846320" cy="621792"/>
           </a:xfrm>
           <a:prstGeom prst="rect">
             <a:avLst/>
@@ -5645,7 +5645,7 @@
         </p:nvSpPr>
         <p:spPr>
           <a:xfrm>
-            <a:off x="5742432" y="2148840"/>
+            <a:off x="5742432" y="2066544"/>
             <a:ext cx="4736592" cy="411480"/>
           </a:xfrm>
           <a:prstGeom prst="rect">
@@ -5680,8 +5680,8 @@
         </p:nvSpPr>
         <p:spPr>
           <a:xfrm>
-            <a:off x="10515600" y="1984248"/>
-            <a:ext cx="1280160" cy="658368"/>
+            <a:off x="10515600" y="1901952"/>
+            <a:ext cx="1280160" cy="621792"/>
           </a:xfrm>
           <a:prstGeom prst="rect">
             <a:avLst/>
@@ -5723,7 +5723,7 @@
         </p:nvSpPr>
         <p:spPr>
           <a:xfrm>
-            <a:off x="10588752" y="2148840"/>
+            <a:off x="10588752" y="2066544"/>
             <a:ext cx="1170432" cy="411480"/>
           </a:xfrm>
           <a:prstGeom prst="rect">
@@ -5758,8 +5758,8 @@
         </p:nvSpPr>
         <p:spPr>
           <a:xfrm>
-            <a:off x="365760" y="2642616"/>
-            <a:ext cx="2377440" cy="658368"/>
+            <a:off x="365760" y="2523744"/>
+            <a:ext cx="2377440" cy="621792"/>
           </a:xfrm>
           <a:prstGeom prst="rect">
             <a:avLst/>
@@ -5801,7 +5801,7 @@
         </p:nvSpPr>
         <p:spPr>
           <a:xfrm>
-            <a:off x="438912" y="2807208"/>
+            <a:off x="438912" y="2688336"/>
             <a:ext cx="2267712" cy="411480"/>
           </a:xfrm>
           <a:prstGeom prst="rect">
@@ -5836,8 +5836,8 @@
         </p:nvSpPr>
         <p:spPr>
           <a:xfrm>
-            <a:off x="2743200" y="2642616"/>
-            <a:ext cx="2926080" cy="658368"/>
+            <a:off x="2743200" y="2523744"/>
+            <a:ext cx="2926080" cy="621792"/>
           </a:xfrm>
           <a:prstGeom prst="rect">
             <a:avLst/>
@@ -5879,7 +5879,7 @@
         </p:nvSpPr>
         <p:spPr>
           <a:xfrm>
-            <a:off x="2816352" y="2807208"/>
+            <a:off x="2816352" y="2688336"/>
             <a:ext cx="2816352" cy="411480"/>
           </a:xfrm>
           <a:prstGeom prst="rect">
@@ -5914,8 +5914,8 @@
         </p:nvSpPr>
         <p:spPr>
           <a:xfrm>
-            <a:off x="5669280" y="2642616"/>
-            <a:ext cx="4846320" cy="658368"/>
+            <a:off x="5669280" y="2523744"/>
+            <a:ext cx="4846320" cy="621792"/>
           </a:xfrm>
           <a:prstGeom prst="rect">
             <a:avLst/>
@@ -5957,7 +5957,7 @@
         </p:nvSpPr>
         <p:spPr>
           <a:xfrm>
-            <a:off x="5742432" y="2807208"/>
+            <a:off x="5742432" y="2688336"/>
             <a:ext cx="4736592" cy="411480"/>
           </a:xfrm>
           <a:prstGeom prst="rect">
@@ -5992,8 +5992,8 @@
         </p:nvSpPr>
         <p:spPr>
           <a:xfrm>
-            <a:off x="10515600" y="2642616"/>
-            <a:ext cx="1280160" cy="658368"/>
+            <a:off x="10515600" y="2523744"/>
+            <a:ext cx="1280160" cy="621792"/>
           </a:xfrm>
           <a:prstGeom prst="rect">
             <a:avLst/>
@@ -6035,7 +6035,7 @@
         </p:nvSpPr>
         <p:spPr>
           <a:xfrm>
-            <a:off x="10588752" y="2807208"/>
+            <a:off x="10588752" y="2688336"/>
             <a:ext cx="1170432" cy="411480"/>
           </a:xfrm>
           <a:prstGeom prst="rect">
@@ -6070,8 +6070,8 @@
         </p:nvSpPr>
         <p:spPr>
           <a:xfrm>
-            <a:off x="365760" y="3300984"/>
-            <a:ext cx="2377440" cy="658368"/>
+            <a:off x="365760" y="3145536"/>
+            <a:ext cx="2377440" cy="621792"/>
           </a:xfrm>
           <a:prstGeom prst="rect">
             <a:avLst/>
@@ -6113,7 +6113,7 @@
         </p:nvSpPr>
         <p:spPr>
           <a:xfrm>
-            <a:off x="438912" y="3465576"/>
+            <a:off x="438912" y="3310128"/>
             <a:ext cx="2267712" cy="411480"/>
           </a:xfrm>
           <a:prstGeom prst="rect">
@@ -6148,8 +6148,8 @@
         </p:nvSpPr>
         <p:spPr>
           <a:xfrm>
-            <a:off x="2743200" y="3300984"/>
-            <a:ext cx="2926080" cy="658368"/>
+            <a:off x="2743200" y="3145536"/>
+            <a:ext cx="2926080" cy="621792"/>
           </a:xfrm>
           <a:prstGeom prst="rect">
             <a:avLst/>
@@ -6191,7 +6191,7 @@
         </p:nvSpPr>
         <p:spPr>
           <a:xfrm>
-            <a:off x="2816352" y="3465576"/>
+            <a:off x="2816352" y="3310128"/>
             <a:ext cx="2816352" cy="411480"/>
           </a:xfrm>
           <a:prstGeom prst="rect">
@@ -6226,8 +6226,8 @@
         </p:nvSpPr>
         <p:spPr>
           <a:xfrm>
-            <a:off x="5669280" y="3300984"/>
-            <a:ext cx="4846320" cy="658368"/>
+            <a:off x="5669280" y="3145536"/>
+            <a:ext cx="4846320" cy="621792"/>
           </a:xfrm>
           <a:prstGeom prst="rect">
             <a:avLst/>
@@ -6269,7 +6269,7 @@
         </p:nvSpPr>
         <p:spPr>
           <a:xfrm>
-            <a:off x="5742432" y="3465576"/>
+            <a:off x="5742432" y="3310128"/>
             <a:ext cx="4736592" cy="411480"/>
           </a:xfrm>
           <a:prstGeom prst="rect">
@@ -6304,8 +6304,8 @@
         </p:nvSpPr>
         <p:spPr>
           <a:xfrm>
-            <a:off x="10515600" y="3300984"/>
-            <a:ext cx="1280160" cy="658368"/>
+            <a:off x="10515600" y="3145536"/>
+            <a:ext cx="1280160" cy="621792"/>
           </a:xfrm>
           <a:prstGeom prst="rect">
             <a:avLst/>
@@ -6347,7 +6347,7 @@
         </p:nvSpPr>
         <p:spPr>
           <a:xfrm>
-            <a:off x="10588752" y="3465576"/>
+            <a:off x="10588752" y="3310128"/>
             <a:ext cx="1170432" cy="411480"/>
           </a:xfrm>
           <a:prstGeom prst="rect">
@@ -6382,8 +6382,8 @@
         </p:nvSpPr>
         <p:spPr>
           <a:xfrm>
-            <a:off x="365760" y="3959352"/>
-            <a:ext cx="2377440" cy="658368"/>
+            <a:off x="365760" y="3767328"/>
+            <a:ext cx="2377440" cy="621792"/>
           </a:xfrm>
           <a:prstGeom prst="rect">
             <a:avLst/>
@@ -6425,7 +6425,7 @@
         </p:nvSpPr>
         <p:spPr>
           <a:xfrm>
-            <a:off x="438912" y="4123944"/>
+            <a:off x="438912" y="3931920"/>
             <a:ext cx="2267712" cy="411480"/>
           </a:xfrm>
           <a:prstGeom prst="rect">
@@ -6460,8 +6460,8 @@
         </p:nvSpPr>
         <p:spPr>
           <a:xfrm>
-            <a:off x="2743200" y="3959352"/>
-            <a:ext cx="2926080" cy="658368"/>
+            <a:off x="2743200" y="3767328"/>
+            <a:ext cx="2926080" cy="621792"/>
           </a:xfrm>
           <a:prstGeom prst="rect">
             <a:avLst/>
@@ -6503,7 +6503,7 @@
         </p:nvSpPr>
         <p:spPr>
           <a:xfrm>
-            <a:off x="2816352" y="4123944"/>
+            <a:off x="2816352" y="3931920"/>
             <a:ext cx="2816352" cy="411480"/>
           </a:xfrm>
           <a:prstGeom prst="rect">
@@ -6538,8 +6538,8 @@
         </p:nvSpPr>
         <p:spPr>
           <a:xfrm>
-            <a:off x="5669280" y="3959352"/>
-            <a:ext cx="4846320" cy="658368"/>
+            <a:off x="5669280" y="3767328"/>
+            <a:ext cx="4846320" cy="621792"/>
           </a:xfrm>
           <a:prstGeom prst="rect">
             <a:avLst/>
@@ -6581,7 +6581,7 @@
         </p:nvSpPr>
         <p:spPr>
           <a:xfrm>
-            <a:off x="5742432" y="4123944"/>
+            <a:off x="5742432" y="3931920"/>
             <a:ext cx="4736592" cy="411480"/>
           </a:xfrm>
           <a:prstGeom prst="rect">
@@ -6616,8 +6616,8 @@
         </p:nvSpPr>
         <p:spPr>
           <a:xfrm>
-            <a:off x="10515600" y="3959352"/>
-            <a:ext cx="1280160" cy="658368"/>
+            <a:off x="10515600" y="3767328"/>
+            <a:ext cx="1280160" cy="621792"/>
           </a:xfrm>
           <a:prstGeom prst="rect">
             <a:avLst/>
@@ -6659,7 +6659,7 @@
         </p:nvSpPr>
         <p:spPr>
           <a:xfrm>
-            <a:off x="10588752" y="4123944"/>
+            <a:off x="10588752" y="3931920"/>
             <a:ext cx="1170432" cy="411480"/>
           </a:xfrm>
           <a:prstGeom prst="rect">
@@ -6694,8 +6694,8 @@
         </p:nvSpPr>
         <p:spPr>
           <a:xfrm>
-            <a:off x="365760" y="4617720"/>
-            <a:ext cx="2377440" cy="658368"/>
+            <a:off x="365760" y="4389120"/>
+            <a:ext cx="2377440" cy="621792"/>
           </a:xfrm>
           <a:prstGeom prst="rect">
             <a:avLst/>
@@ -6737,7 +6737,7 @@
         </p:nvSpPr>
         <p:spPr>
           <a:xfrm>
-            <a:off x="438912" y="4782312"/>
+            <a:off x="438912" y="4553712"/>
             <a:ext cx="2267712" cy="411480"/>
           </a:xfrm>
           <a:prstGeom prst="rect">
@@ -6772,8 +6772,8 @@
         </p:nvSpPr>
         <p:spPr>
           <a:xfrm>
-            <a:off x="2743200" y="4617720"/>
-            <a:ext cx="2926080" cy="658368"/>
+            <a:off x="2743200" y="4389120"/>
+            <a:ext cx="2926080" cy="621792"/>
           </a:xfrm>
           <a:prstGeom prst="rect">
             <a:avLst/>
@@ -6815,7 +6815,7 @@
         </p:nvSpPr>
         <p:spPr>
           <a:xfrm>
-            <a:off x="2816352" y="4782312"/>
+            <a:off x="2816352" y="4553712"/>
             <a:ext cx="2816352" cy="411480"/>
           </a:xfrm>
           <a:prstGeom prst="rect">
@@ -6850,8 +6850,8 @@
         </p:nvSpPr>
         <p:spPr>
           <a:xfrm>
-            <a:off x="5669280" y="4617720"/>
-            <a:ext cx="4846320" cy="658368"/>
+            <a:off x="5669280" y="4389120"/>
+            <a:ext cx="4846320" cy="621792"/>
           </a:xfrm>
           <a:prstGeom prst="rect">
             <a:avLst/>
@@ -6893,7 +6893,7 @@
         </p:nvSpPr>
         <p:spPr>
           <a:xfrm>
-            <a:off x="5742432" y="4782312"/>
+            <a:off x="5742432" y="4553712"/>
             <a:ext cx="4736592" cy="411480"/>
           </a:xfrm>
           <a:prstGeom prst="rect">
@@ -6928,8 +6928,8 @@
         </p:nvSpPr>
         <p:spPr>
           <a:xfrm>
-            <a:off x="10515600" y="4617720"/>
-            <a:ext cx="1280160" cy="658368"/>
+            <a:off x="10515600" y="4389120"/>
+            <a:ext cx="1280160" cy="621792"/>
           </a:xfrm>
           <a:prstGeom prst="rect">
             <a:avLst/>
@@ -6971,7 +6971,7 @@
         </p:nvSpPr>
         <p:spPr>
           <a:xfrm>
-            <a:off x="10588752" y="4782312"/>
+            <a:off x="10588752" y="4553712"/>
             <a:ext cx="1170432" cy="411480"/>
           </a:xfrm>
           <a:prstGeom prst="rect">
@@ -7006,8 +7006,8 @@
         </p:nvSpPr>
         <p:spPr>
           <a:xfrm>
-            <a:off x="365760" y="5276088"/>
-            <a:ext cx="2377440" cy="658368"/>
+            <a:off x="365760" y="5010912"/>
+            <a:ext cx="2377440" cy="621792"/>
           </a:xfrm>
           <a:prstGeom prst="rect">
             <a:avLst/>
@@ -7049,7 +7049,7 @@
         </p:nvSpPr>
         <p:spPr>
           <a:xfrm>
-            <a:off x="438912" y="5440680"/>
+            <a:off x="438912" y="5175504"/>
             <a:ext cx="2267712" cy="411480"/>
           </a:xfrm>
           <a:prstGeom prst="rect">
@@ -7084,8 +7084,8 @@
         </p:nvSpPr>
         <p:spPr>
           <a:xfrm>
-            <a:off x="2743200" y="5276088"/>
-            <a:ext cx="2926080" cy="658368"/>
+            <a:off x="2743200" y="5010912"/>
+            <a:ext cx="2926080" cy="621792"/>
           </a:xfrm>
           <a:prstGeom prst="rect">
             <a:avLst/>
@@ -7127,7 +7127,7 @@
         </p:nvSpPr>
         <p:spPr>
           <a:xfrm>
-            <a:off x="2816352" y="5440680"/>
+            <a:off x="2816352" y="5175504"/>
             <a:ext cx="2816352" cy="411480"/>
           </a:xfrm>
           <a:prstGeom prst="rect">
@@ -7162,8 +7162,8 @@
         </p:nvSpPr>
         <p:spPr>
           <a:xfrm>
-            <a:off x="5669280" y="5276088"/>
-            <a:ext cx="4846320" cy="658368"/>
+            <a:off x="5669280" y="5010912"/>
+            <a:ext cx="4846320" cy="621792"/>
           </a:xfrm>
           <a:prstGeom prst="rect">
             <a:avLst/>
@@ -7205,7 +7205,7 @@
         </p:nvSpPr>
         <p:spPr>
           <a:xfrm>
-            <a:off x="5742432" y="5440680"/>
+            <a:off x="5742432" y="5175504"/>
             <a:ext cx="4736592" cy="411480"/>
           </a:xfrm>
           <a:prstGeom prst="rect">
@@ -7240,8 +7240,8 @@
         </p:nvSpPr>
         <p:spPr>
           <a:xfrm>
-            <a:off x="10515600" y="5276088"/>
-            <a:ext cx="1280160" cy="658368"/>
+            <a:off x="10515600" y="5010912"/>
+            <a:ext cx="1280160" cy="621792"/>
           </a:xfrm>
           <a:prstGeom prst="rect">
             <a:avLst/>
@@ -7283,7 +7283,7 @@
         </p:nvSpPr>
         <p:spPr>
           <a:xfrm>
-            <a:off x="10588752" y="5440680"/>
+            <a:off x="10588752" y="5175504"/>
             <a:ext cx="1170432" cy="411480"/>
           </a:xfrm>
           <a:prstGeom prst="rect">
@@ -7312,7 +7312,42 @@
       </p:sp>
       <p:sp>
         <p:nvSpPr>
-          <p:cNvPr id="63" name="Rectangle 62"/>
+          <p:cNvPr id="63" name="TextBox 62"/>
+          <p:cNvSpPr txBox="1"/>
+          <p:nvPr/>
+        </p:nvSpPr>
+        <p:spPr>
+          <a:xfrm>
+            <a:off x="365760" y="6144768"/>
+            <a:ext cx="11430000" cy="457200"/>
+          </a:xfrm>
+          <a:prstGeom prst="rect">
+            <a:avLst/>
+          </a:prstGeom>
+          <a:noFill/>
+        </p:spPr>
+        <p:txBody>
+          <a:bodyPr wrap="square">
+            <a:spAutoFit/>
+          </a:bodyPr>
+          <a:lstStyle/>
+          <a:p>
+            <a:pPr algn="l"/>
+            <a:r>
+              <a:rPr sz="1300" b="0" i="0">
+                <a:solidFill>
+                  <a:srgbClr val="4A5568"/>
+                </a:solidFill>
+                <a:latin typeface="Calibri"/>
+              </a:rPr>
+              <a:t>Each row is one purpose. Yes = notice and ICO line up. Partial = they aim at consent, but ICO marks consent INCONCLUSIVE and no basis APPROPRIATE.</a:t>
+            </a:r>
+          </a:p>
+        </p:txBody>
+      </p:sp>
+      <p:sp>
+        <p:nvSpPr>
+          <p:cNvPr id="64" name="Rectangle 63"/>
           <p:cNvSpPr/>
           <p:nvPr/>
         </p:nvSpPr>
@@ -7355,7 +7390,7 @@
       </p:sp>
       <p:sp>
         <p:nvSpPr>
-          <p:cNvPr id="64" name="TextBox 63"/>
+          <p:cNvPr id="65" name="TextBox 64"/>
           <p:cNvSpPr txBox="1"/>
           <p:nvPr/>
         </p:nvSpPr>
@@ -7390,7 +7425,7 @@
       </p:sp>
       <p:sp>
         <p:nvSpPr>
-          <p:cNvPr id="65" name="TextBox 64"/>
+          <p:cNvPr id="66" name="TextBox 65"/>
           <p:cNvSpPr txBox="1"/>
           <p:nvPr/>
         </p:nvSpPr>
@@ -7791,7 +7826,7 @@
                 </a:solidFill>
                 <a:latin typeface="Calibri"/>
               </a:rPr>
-              <a:t>Purpose 2: optional stats cookies (Skyra, Matomo, GA, Siteimprove). Yes/No. ICO: consent INCONCLUSIVE (Q6). No basis APPROPRIATE.</a:t>
+              <a:t>Purpose 2: optional stats cookies. Notice: Yes/No. Webbkoll: 0 external cookies (no click). ICO: consent INCONCLUSIVE (Q6). No basis APPROPRIATE.</a:t>
             </a:r>
           </a:p>
         </p:txBody>
@@ -10147,7 +10182,7 @@
                 </a:solidFill>
                 <a:latin typeface="Calibri"/>
               </a:rPr>
-              <a:t>Webbkoll measures contact, not lawfulness.</a:t>
+              <a:t>Webbkoll measures contact, not lawfulness and not a Chapter V export.</a:t>
             </a:r>
           </a:p>
           <a:p>
@@ -10166,7 +10201,7 @@
                 </a:solidFill>
                 <a:latin typeface="Calibri"/>
               </a:rPr>
-              <a:t>One purpose per ICO run, or the tool mixes bases.</a:t>
+              <a:t>Rankings follow Table 2. Table 3 is a check. Do not average them.</a:t>
             </a:r>
           </a:p>
           <a:p>
@@ -10185,7 +10220,7 @@
                 </a:solidFill>
                 <a:latin typeface="Calibri"/>
               </a:rPr>
-              <a:t>fotball.no has the highest request count and still zero third-party cookies.</a:t>
+              <a:t>fotball.no has the highest request count (113) and still zero third-party cookies.</a:t>
             </a:r>
           </a:p>
           <a:p>
@@ -10204,7 +10239,7 @@
                 </a:solidFill>
                 <a:latin typeface="Calibri"/>
               </a:rPr>
-              <a:t>Four of five core ICO purposes match the notice.</a:t>
+              <a:t>Four of five core ICO purposes match the notice (Table 5).</a:t>
             </a:r>
           </a:p>
           <a:p>
@@ -10823,7 +10858,7 @@
                 </a:solidFill>
                 <a:latin typeface="Calibri"/>
               </a:rPr>
-              <a:t>•  18 Norwegian-facing sites</a:t>
+              <a:t>•  18 course-listed sites (Table 1)</a:t>
             </a:r>
           </a:p>
           <a:p>
@@ -10842,7 +10877,7 @@
                 </a:solidFill>
                 <a:latin typeface="Calibri"/>
               </a:rPr>
-              <a:t>•  Shopping, government, news/media, sport</a:t>
+              <a:t>•  Shopping, government, news/media/entertainment, spare time/sports</a:t>
             </a:r>
           </a:p>
           <a:p>
@@ -10861,7 +10896,7 @@
                 </a:solidFill>
                 <a:latin typeface="Calibri"/>
               </a:rPr>
-              <a:t>•  Server location, cookies, 3rd-party requests, countries excl. Norway</a:t>
+              <a:t>•  Columns: server country, internal/external cookies, 3rd-party requests, countries excl. Norway</a:t>
             </a:r>
           </a:p>
           <a:p>
@@ -10880,7 +10915,7 @@
                 </a:solidFill>
                 <a:latin typeface="Calibri"/>
               </a:rPr>
-              <a:t>•  Graphics per sector</a:t>
+              <a:t>•  Figures 2-4: all 18 sites, share, sector totals</a:t>
             </a:r>
           </a:p>
           <a:p>
@@ -10899,7 +10934,7 @@
                 </a:solidFill>
                 <a:latin typeface="Calibri"/>
               </a:rPr>
-              <a:t>•  Highest and lowest contact; most countries; restrained e-government</a:t>
+              <a:t>•  Rank on Table 2 requests, not cookies</a:t>
             </a:r>
           </a:p>
         </p:txBody>
@@ -11019,7 +11054,7 @@
                 </a:solidFill>
                 <a:latin typeface="Calibri"/>
               </a:rPr>
-              <a:t>•  Five privacy notices</a:t>
+              <a:t>•  Five notices from Table 1a (one shopping, one government, two news, one sport)</a:t>
             </a:r>
           </a:p>
           <a:p>
@@ -11038,7 +11073,7 @@
                 </a:solidFill>
                 <a:latin typeface="Calibri"/>
               </a:rPr>
-              <a:t>•  skatteetaten, Netflix, fotball.no, document.no, babyshop.no</a:t>
+              <a:t>•  babyshop, skatteetaten, Netflix, document.no, fotball.no</a:t>
             </a:r>
           </a:p>
           <a:p>
@@ -11076,7 +11111,7 @@
                 </a:solidFill>
                 <a:latin typeface="Calibri"/>
               </a:rPr>
-              <a:t>•  Compare notice vs official ICO report</a:t>
+              <a:t>•  Compare notice vs official ICO Word report (26 Aug 2026)</a:t>
             </a:r>
           </a:p>
           <a:p>
@@ -11467,7 +11502,7 @@
                 </a:solidFill>
                 <a:latin typeface="Calibri"/>
               </a:rPr>
-              <a:t>English Webbkoll interface</a:t>
+              <a:t>English Webbkoll; one live Chromium visit: no add-ons, no Do Not Track, no consent click</a:t>
             </a:r>
           </a:p>
           <a:p>
@@ -11486,7 +11521,7 @@
                 </a:solidFill>
                 <a:latin typeface="Calibri"/>
               </a:rPr>
-              <a:t>One live Chromium visit: no add-ons, no Do Not Track, no consent click</a:t>
+              <a:t>Server country = KeyCDN of the site IP; country list = KeyCDN of third-party IPs</a:t>
             </a:r>
           </a:p>
           <a:p>
@@ -11505,7 +11540,7 @@
                 </a:solidFill>
                 <a:latin typeface="Calibri"/>
               </a:rPr>
-              <a:t>Scan clock on the result page is part of the measurement</a:t>
+              <a:t>Norway dropped from the country count (the list may still print NO)</a:t>
             </a:r>
           </a:p>
           <a:p>
@@ -11524,7 +11559,7 @@
                 </a:solidFill>
                 <a:latin typeface="Calibri"/>
               </a:rPr>
-              <a:t>Server country: KeyCDN Country field for the IP</a:t>
+              <a:t>n/a = KeyCDN returned no country (dnt.no, babyshop.no, altinn.no on Table 3)</a:t>
             </a:r>
           </a:p>
           <a:p>
@@ -11543,7 +11578,7 @@
                 </a:solidFill>
                 <a:latin typeface="Calibri"/>
               </a:rPr>
-              <a:t>Norway dropped from the shared-country list</a:t>
+              <a:t>Table 2 = first scan and ranking base; Table 3 = later check, not averaged</a:t>
             </a:r>
           </a:p>
           <a:p>
@@ -11562,26 +11597,7 @@
                 </a:solidFill>
                 <a:latin typeface="Calibri"/>
               </a:rPr>
-              <a:t>If KeyCDN returns no country: recorded as not available</a:t>
-            </a:r>
-          </a:p>
-          <a:p>
-            <a:pPr algn="l">
-              <a:spcBef>
-                <a:spcPts val="0"/>
-              </a:spcBef>
-              <a:spcAft>
-                <a:spcPts val="1000"/>
-              </a:spcAft>
-            </a:pPr>
-            <a:r>
-              <a:rPr sz="1800" b="0" i="0">
-                <a:solidFill>
-                  <a:srgbClr val="1A1A1A"/>
-                </a:solidFill>
-                <a:latin typeface="Calibri"/>
-              </a:rPr>
-              <a:t>Two tables: Table 2 first measurement, Table 3 repeat measurement</a:t>
+              <a:t>KeyCDN countries are not a GDPR Chapter V transfer record (arts. 44-47)</a:t>
             </a:r>
           </a:p>
         </p:txBody>
@@ -11953,7 +11969,7 @@
                 </a:solidFill>
                 <a:latin typeface="Calibri"/>
               </a:rPr>
-              <a:t>It does not click Yes/No or Cookiebot.</a:t>
+              <a:t>It does not click Yes/No or Cookiebot, so optional analytics cookies may not appear.</a:t>
             </a:r>
           </a:p>
           <a:p>
@@ -11972,7 +11988,7 @@
                 </a:solidFill>
                 <a:latin typeface="Calibri"/>
               </a:rPr>
-              <a:t>Zero third-party cookies can still mean many third-party requests.</a:t>
+              <a:t>A high request count is not a cookie count, and it is not personal data leaving Norway.</a:t>
             </a:r>
           </a:p>
           <a:p>
@@ -12010,7 +12026,7 @@
                 </a:solidFill>
                 <a:latin typeface="Calibri"/>
               </a:rPr>
-              <a:t>The two measurements are not averaged. A later visit can differ (24-hour store).</a:t>
+              <a:t>babyshop.no is 101 requests on Table 3, but 45 on Table 2. Rankings stay on Table 2.</a:t>
             </a:r>
           </a:p>
           <a:p>
@@ -12442,8 +12458,8 @@
         </p:nvSpPr>
         <p:spPr>
           <a:xfrm>
-            <a:off x="457200" y="1691640"/>
-            <a:ext cx="5394960" cy="822960"/>
+            <a:off x="457200" y="1627632"/>
+            <a:ext cx="5394960" cy="749808"/>
           </a:xfrm>
           <a:prstGeom prst="rect">
             <a:avLst/>
@@ -12485,8 +12501,8 @@
         </p:nvSpPr>
         <p:spPr>
           <a:xfrm>
-            <a:off x="640080" y="1764792"/>
-            <a:ext cx="5029200" cy="320040"/>
+            <a:off x="640080" y="1682496"/>
+            <a:ext cx="5029200" cy="292608"/>
           </a:xfrm>
           <a:prstGeom prst="rect">
             <a:avLst/>
@@ -12520,8 +12536,8 @@
         </p:nvSpPr>
         <p:spPr>
           <a:xfrm>
-            <a:off x="640080" y="2075688"/>
-            <a:ext cx="5029200" cy="320040"/>
+            <a:off x="640080" y="1975104"/>
+            <a:ext cx="5029200" cy="292608"/>
           </a:xfrm>
           <a:prstGeom prst="rect">
             <a:avLst/>
@@ -12555,8 +12571,8 @@
         </p:nvSpPr>
         <p:spPr>
           <a:xfrm>
-            <a:off x="6400800" y="1691640"/>
-            <a:ext cx="5303520" cy="822960"/>
+            <a:off x="6400800" y="1627632"/>
+            <a:ext cx="5303520" cy="749808"/>
           </a:xfrm>
           <a:prstGeom prst="rect">
             <a:avLst/>
@@ -12598,8 +12614,8 @@
         </p:nvSpPr>
         <p:spPr>
           <a:xfrm>
-            <a:off x="6583680" y="1764792"/>
-            <a:ext cx="4937760" cy="320040"/>
+            <a:off x="6583680" y="1682496"/>
+            <a:ext cx="4937760" cy="292608"/>
           </a:xfrm>
           <a:prstGeom prst="rect">
             <a:avLst/>
@@ -12633,8 +12649,8 @@
         </p:nvSpPr>
         <p:spPr>
           <a:xfrm>
-            <a:off x="6583680" y="2075688"/>
-            <a:ext cx="4937760" cy="320040"/>
+            <a:off x="6583680" y="1975104"/>
+            <a:ext cx="4937760" cy="292608"/>
           </a:xfrm>
           <a:prstGeom prst="rect">
             <a:avLst/>
@@ -12668,8 +12684,8 @@
         </p:nvSpPr>
         <p:spPr>
           <a:xfrm>
-            <a:off x="457200" y="2606040"/>
-            <a:ext cx="5394960" cy="822960"/>
+            <a:off x="457200" y="2450592"/>
+            <a:ext cx="5394960" cy="749808"/>
           </a:xfrm>
           <a:prstGeom prst="rect">
             <a:avLst/>
@@ -12711,8 +12727,8 @@
         </p:nvSpPr>
         <p:spPr>
           <a:xfrm>
-            <a:off x="640080" y="2679192"/>
-            <a:ext cx="5029200" cy="320040"/>
+            <a:off x="640080" y="2505456"/>
+            <a:ext cx="5029200" cy="292608"/>
           </a:xfrm>
           <a:prstGeom prst="rect">
             <a:avLst/>
@@ -12746,8 +12762,8 @@
         </p:nvSpPr>
         <p:spPr>
           <a:xfrm>
-            <a:off x="640080" y="2990088"/>
-            <a:ext cx="5029200" cy="320040"/>
+            <a:off x="640080" y="2798064"/>
+            <a:ext cx="5029200" cy="292608"/>
           </a:xfrm>
           <a:prstGeom prst="rect">
             <a:avLst/>
@@ -12781,8 +12797,8 @@
         </p:nvSpPr>
         <p:spPr>
           <a:xfrm>
-            <a:off x="6400800" y="2606040"/>
-            <a:ext cx="5303520" cy="822960"/>
+            <a:off x="6400800" y="2450592"/>
+            <a:ext cx="5303520" cy="749808"/>
           </a:xfrm>
           <a:prstGeom prst="rect">
             <a:avLst/>
@@ -12824,8 +12840,8 @@
         </p:nvSpPr>
         <p:spPr>
           <a:xfrm>
-            <a:off x="6583680" y="2679192"/>
-            <a:ext cx="4937760" cy="320040"/>
+            <a:off x="6583680" y="2505456"/>
+            <a:ext cx="4937760" cy="292608"/>
           </a:xfrm>
           <a:prstGeom prst="rect">
             <a:avLst/>
@@ -12859,8 +12875,8 @@
         </p:nvSpPr>
         <p:spPr>
           <a:xfrm>
-            <a:off x="6583680" y="2990088"/>
-            <a:ext cx="4937760" cy="320040"/>
+            <a:off x="6583680" y="2798064"/>
+            <a:ext cx="4937760" cy="292608"/>
           </a:xfrm>
           <a:prstGeom prst="rect">
             <a:avLst/>
@@ -12894,8 +12910,8 @@
         </p:nvSpPr>
         <p:spPr>
           <a:xfrm>
-            <a:off x="457200" y="3520440"/>
-            <a:ext cx="5394960" cy="822960"/>
+            <a:off x="457200" y="3273552"/>
+            <a:ext cx="5394960" cy="749808"/>
           </a:xfrm>
           <a:prstGeom prst="rect">
             <a:avLst/>
@@ -12937,8 +12953,8 @@
         </p:nvSpPr>
         <p:spPr>
           <a:xfrm>
-            <a:off x="640080" y="3593592"/>
-            <a:ext cx="5029200" cy="320040"/>
+            <a:off x="640080" y="3328416"/>
+            <a:ext cx="5029200" cy="292608"/>
           </a:xfrm>
           <a:prstGeom prst="rect">
             <a:avLst/>
@@ -12972,8 +12988,8 @@
         </p:nvSpPr>
         <p:spPr>
           <a:xfrm>
-            <a:off x="640080" y="3904488"/>
-            <a:ext cx="5029200" cy="320040"/>
+            <a:off x="640080" y="3621024"/>
+            <a:ext cx="5029200" cy="292608"/>
           </a:xfrm>
           <a:prstGeom prst="rect">
             <a:avLst/>
@@ -13007,8 +13023,8 @@
         </p:nvSpPr>
         <p:spPr>
           <a:xfrm>
-            <a:off x="6400800" y="3520440"/>
-            <a:ext cx="5303520" cy="822960"/>
+            <a:off x="6400800" y="3273552"/>
+            <a:ext cx="5303520" cy="749808"/>
           </a:xfrm>
           <a:prstGeom prst="rect">
             <a:avLst/>
@@ -13050,8 +13066,8 @@
         </p:nvSpPr>
         <p:spPr>
           <a:xfrm>
-            <a:off x="6583680" y="3593592"/>
-            <a:ext cx="4937760" cy="320040"/>
+            <a:off x="6583680" y="3328416"/>
+            <a:ext cx="4937760" cy="292608"/>
           </a:xfrm>
           <a:prstGeom prst="rect">
             <a:avLst/>
@@ -13085,8 +13101,8 @@
         </p:nvSpPr>
         <p:spPr>
           <a:xfrm>
-            <a:off x="6583680" y="3904488"/>
-            <a:ext cx="4937760" cy="320040"/>
+            <a:off x="6583680" y="3621024"/>
+            <a:ext cx="4937760" cy="292608"/>
           </a:xfrm>
           <a:prstGeom prst="rect">
             <a:avLst/>
@@ -13120,8 +13136,8 @@
         </p:nvSpPr>
         <p:spPr>
           <a:xfrm>
-            <a:off x="457200" y="4434840"/>
-            <a:ext cx="5394960" cy="822960"/>
+            <a:off x="457200" y="4096512"/>
+            <a:ext cx="5394960" cy="749808"/>
           </a:xfrm>
           <a:prstGeom prst="rect">
             <a:avLst/>
@@ -13163,8 +13179,8 @@
         </p:nvSpPr>
         <p:spPr>
           <a:xfrm>
-            <a:off x="640080" y="4507992"/>
-            <a:ext cx="5029200" cy="320040"/>
+            <a:off x="640080" y="4151376"/>
+            <a:ext cx="5029200" cy="292608"/>
           </a:xfrm>
           <a:prstGeom prst="rect">
             <a:avLst/>
@@ -13198,8 +13214,8 @@
         </p:nvSpPr>
         <p:spPr>
           <a:xfrm>
-            <a:off x="640080" y="4818888"/>
-            <a:ext cx="5029200" cy="320040"/>
+            <a:off x="640080" y="4443984"/>
+            <a:ext cx="5029200" cy="292608"/>
           </a:xfrm>
           <a:prstGeom prst="rect">
             <a:avLst/>
@@ -13233,8 +13249,8 @@
         </p:nvSpPr>
         <p:spPr>
           <a:xfrm>
-            <a:off x="6400800" y="4434840"/>
-            <a:ext cx="5303520" cy="822960"/>
+            <a:off x="6400800" y="4096512"/>
+            <a:ext cx="5303520" cy="749808"/>
           </a:xfrm>
           <a:prstGeom prst="rect">
             <a:avLst/>
@@ -13276,8 +13292,8 @@
         </p:nvSpPr>
         <p:spPr>
           <a:xfrm>
-            <a:off x="6583680" y="4507992"/>
-            <a:ext cx="4937760" cy="320040"/>
+            <a:off x="6583680" y="4151376"/>
+            <a:ext cx="4937760" cy="292608"/>
           </a:xfrm>
           <a:prstGeom prst="rect">
             <a:avLst/>
@@ -13311,8 +13327,8 @@
         </p:nvSpPr>
         <p:spPr>
           <a:xfrm>
-            <a:off x="6583680" y="4818888"/>
-            <a:ext cx="4937760" cy="320040"/>
+            <a:off x="6583680" y="4443984"/>
+            <a:ext cx="4937760" cy="292608"/>
           </a:xfrm>
           <a:prstGeom prst="rect">
             <a:avLst/>
@@ -13346,8 +13362,8 @@
         </p:nvSpPr>
         <p:spPr>
           <a:xfrm>
-            <a:off x="457200" y="5349240"/>
-            <a:ext cx="5394960" cy="822960"/>
+            <a:off x="457200" y="4919472"/>
+            <a:ext cx="5394960" cy="749808"/>
           </a:xfrm>
           <a:prstGeom prst="rect">
             <a:avLst/>
@@ -13389,8 +13405,8 @@
         </p:nvSpPr>
         <p:spPr>
           <a:xfrm>
-            <a:off x="640080" y="5422392"/>
-            <a:ext cx="5029200" cy="320040"/>
+            <a:off x="640080" y="4974336"/>
+            <a:ext cx="5029200" cy="292608"/>
           </a:xfrm>
           <a:prstGeom prst="rect">
             <a:avLst/>
@@ -13424,8 +13440,8 @@
         </p:nvSpPr>
         <p:spPr>
           <a:xfrm>
-            <a:off x="640080" y="5733288"/>
-            <a:ext cx="5029200" cy="320040"/>
+            <a:off x="640080" y="5266944"/>
+            <a:ext cx="5029200" cy="292608"/>
           </a:xfrm>
           <a:prstGeom prst="rect">
             <a:avLst/>
@@ -13459,8 +13475,8 @@
         </p:nvSpPr>
         <p:spPr>
           <a:xfrm>
-            <a:off x="6400800" y="5349240"/>
-            <a:ext cx="5303520" cy="822960"/>
+            <a:off x="6400800" y="4919472"/>
+            <a:ext cx="5303520" cy="749808"/>
           </a:xfrm>
           <a:prstGeom prst="rect">
             <a:avLst/>
@@ -13502,8 +13518,8 @@
         </p:nvSpPr>
         <p:spPr>
           <a:xfrm>
-            <a:off x="6583680" y="5422392"/>
-            <a:ext cx="4937760" cy="320040"/>
+            <a:off x="6583680" y="4974336"/>
+            <a:ext cx="4937760" cy="292608"/>
           </a:xfrm>
           <a:prstGeom prst="rect">
             <a:avLst/>
@@ -13537,8 +13553,8 @@
         </p:nvSpPr>
         <p:spPr>
           <a:xfrm>
-            <a:off x="6583680" y="5733288"/>
-            <a:ext cx="4937760" cy="320040"/>
+            <a:off x="6583680" y="5266944"/>
+            <a:ext cx="4937760" cy="292608"/>
           </a:xfrm>
           <a:prstGeom prst="rect">
             <a:avLst/>
@@ -13566,7 +13582,42 @@
       </p:sp>
       <p:sp>
         <p:nvSpPr>
-          <p:cNvPr id="39" name="Rectangle 38"/>
+          <p:cNvPr id="39" name="TextBox 38"/>
+          <p:cNvSpPr txBox="1"/>
+          <p:nvPr/>
+        </p:nvSpPr>
+        <p:spPr>
+          <a:xfrm>
+            <a:off x="457200" y="6263640"/>
+            <a:ext cx="11247120" cy="347472"/>
+          </a:xfrm>
+          <a:prstGeom prst="rect">
+            <a:avLst/>
+          </a:prstGeom>
+          <a:noFill/>
+        </p:spPr>
+        <p:txBody>
+          <a:bodyPr wrap="square">
+            <a:spAutoFit/>
+          </a:bodyPr>
+          <a:lstStyle/>
+          <a:p>
+            <a:pPr algn="l"/>
+            <a:r>
+              <a:rPr sz="1300" b="0" i="0">
+                <a:solidFill>
+                  <a:srgbClr val="4A5568"/>
+                </a:solidFill>
+                <a:latin typeface="Calibri"/>
+              </a:rPr>
+              <a:t>Table 2 request column. Highest 1 = worst sharer. Lowest 1 = most restrained. babyshop 101 is Table 3 only.</a:t>
+            </a:r>
+          </a:p>
+        </p:txBody>
+      </p:sp>
+      <p:sp>
+        <p:nvSpPr>
+          <p:cNvPr id="40" name="Rectangle 39"/>
           <p:cNvSpPr/>
           <p:nvPr/>
         </p:nvSpPr>
@@ -13609,7 +13660,7 @@
       </p:sp>
       <p:sp>
         <p:nvSpPr>
-          <p:cNvPr id="40" name="TextBox 39"/>
+          <p:cNvPr id="41" name="TextBox 40"/>
           <p:cNvSpPr txBox="1"/>
           <p:nvPr/>
         </p:nvSpPr>
@@ -13644,7 +13695,7 @@
       </p:sp>
       <p:sp>
         <p:nvSpPr>
-          <p:cNvPr id="41" name="TextBox 40"/>
+          <p:cNvPr id="42" name="TextBox 41"/>
           <p:cNvSpPr txBox="1"/>
           <p:nvPr/>
         </p:nvSpPr>
@@ -13910,8 +13961,8 @@
         </p:blipFill>
         <p:spPr>
           <a:xfrm>
-            <a:off x="274320" y="1261872"/>
-            <a:ext cx="5943600" cy="5074920"/>
+            <a:off x="274320" y="1207008"/>
+            <a:ext cx="5943600" cy="4709160"/>
           </a:xfrm>
           <a:prstGeom prst="rect">
             <a:avLst/>
@@ -13934,8 +13985,8 @@
         </p:blipFill>
         <p:spPr>
           <a:xfrm>
-            <a:off x="6355080" y="1261872"/>
-            <a:ext cx="5486400" cy="2468880"/>
+            <a:off x="6355080" y="1207008"/>
+            <a:ext cx="5486400" cy="2286000"/>
           </a:xfrm>
           <a:prstGeom prst="rect">
             <a:avLst/>
@@ -13958,8 +14009,8 @@
         </p:blipFill>
         <p:spPr>
           <a:xfrm>
-            <a:off x="6355080" y="3794760"/>
-            <a:ext cx="5486400" cy="2514600"/>
+            <a:off x="6355080" y="3566160"/>
+            <a:ext cx="5486400" cy="2331720"/>
           </a:xfrm>
           <a:prstGeom prst="rect">
             <a:avLst/>
@@ -13968,7 +14019,42 @@
       </p:pic>
       <p:sp>
         <p:nvSpPr>
-          <p:cNvPr id="10" name="Rectangle 9"/>
+          <p:cNvPr id="10" name="TextBox 9"/>
+          <p:cNvSpPr txBox="1"/>
+          <p:nvPr/>
+        </p:nvSpPr>
+        <p:spPr>
+          <a:xfrm>
+            <a:off x="365760" y="6263640"/>
+            <a:ext cx="11430000" cy="347472"/>
+          </a:xfrm>
+          <a:prstGeom prst="rect">
+            <a:avLst/>
+          </a:prstGeom>
+          <a:noFill/>
+        </p:spPr>
+        <p:txBody>
+          <a:bodyPr wrap="square">
+            <a:spAutoFit/>
+          </a:bodyPr>
+          <a:lstStyle/>
+          <a:p>
+            <a:pPr algn="l"/>
+            <a:r>
+              <a:rPr sz="1300" b="0" i="0">
+                <a:solidFill>
+                  <a:srgbClr val="4A5568"/>
+                </a:solidFill>
+                <a:latin typeface="Calibri"/>
+              </a:rPr>
+              <a:t>All three charts use Table 2. News/media is the largest sector total; government is the smallest; sport is high because of fotball.no.</a:t>
+            </a:r>
+          </a:p>
+        </p:txBody>
+      </p:sp>
+      <p:sp>
+        <p:nvSpPr>
+          <p:cNvPr id="11" name="Rectangle 10"/>
           <p:cNvSpPr/>
           <p:nvPr/>
         </p:nvSpPr>
@@ -14011,7 +14097,7 @@
       </p:sp>
       <p:sp>
         <p:nvSpPr>
-          <p:cNvPr id="11" name="TextBox 10"/>
+          <p:cNvPr id="12" name="TextBox 11"/>
           <p:cNvSpPr txBox="1"/>
           <p:nvPr/>
         </p:nvSpPr>
@@ -14046,7 +14132,7 @@
       </p:sp>
       <p:sp>
         <p:nvSpPr>
-          <p:cNvPr id="12" name="TextBox 11"/>
+          <p:cNvPr id="13" name="TextBox 12"/>
           <p:cNvSpPr txBox="1"/>
           <p:nvPr/>
         </p:nvSpPr>
@@ -14291,7 +14377,7 @@
                 </a:solidFill>
                 <a:latin typeface="Calibri"/>
               </a:rPr>
-              <a:t>klassekampen.no: requests without third-party cookies</a:t>
+              <a:t>klassekampen.no: 46 on the ranking, 56 on the screenshot</a:t>
             </a:r>
           </a:p>
         </p:txBody>
@@ -14312,8 +14398,8 @@
         </p:blipFill>
         <p:spPr>
           <a:xfrm>
-            <a:off x="365760" y="1234440"/>
-            <a:ext cx="11430000" cy="2331720"/>
+            <a:off x="365760" y="1207008"/>
+            <a:ext cx="11430000" cy="2148840"/>
           </a:xfrm>
           <a:prstGeom prst="rect">
             <a:avLst/>
@@ -14336,8 +14422,8 @@
         </p:blipFill>
         <p:spPr>
           <a:xfrm>
-            <a:off x="2194560" y="3657600"/>
-            <a:ext cx="7772400" cy="2788920"/>
+            <a:off x="2194560" y="3456432"/>
+            <a:ext cx="7772400" cy="2606040"/>
           </a:xfrm>
           <a:prstGeom prst="rect">
             <a:avLst/>
@@ -14346,7 +14432,42 @@
       </p:pic>
       <p:sp>
         <p:nvSpPr>
-          <p:cNvPr id="9" name="Rectangle 8"/>
+          <p:cNvPr id="9" name="TextBox 8"/>
+          <p:cNvSpPr txBox="1"/>
+          <p:nvPr/>
+        </p:nvSpPr>
+        <p:spPr>
+          <a:xfrm>
+            <a:off x="365760" y="6126480"/>
+            <a:ext cx="11430000" cy="457200"/>
+          </a:xfrm>
+          <a:prstGeom prst="rect">
+            <a:avLst/>
+          </a:prstGeom>
+          <a:noFill/>
+        </p:spPr>
+        <p:txBody>
+          <a:bodyPr wrap="square">
+            <a:spAutoFit/>
+          </a:bodyPr>
+          <a:lstStyle/>
+          <a:p>
+            <a:pPr algn="l"/>
+            <a:r>
+              <a:rPr sz="1300" b="0" i="0">
+                <a:solidFill>
+                  <a:srgbClr val="4A5568"/>
+                </a:solidFill>
+                <a:latin typeface="Calibri"/>
+              </a:rPr>
+              <a:t>Table 2 rank: 46 requests, 0 third-party cookies. Screenshots = later visit (Table 3: 56 requests to 13 hosts). Server KeyCDN: United States, Google. Not a Chapter V finding.</a:t>
+            </a:r>
+          </a:p>
+        </p:txBody>
+      </p:sp>
+      <p:sp>
+        <p:nvSpPr>
+          <p:cNvPr id="10" name="Rectangle 9"/>
           <p:cNvSpPr/>
           <p:nvPr/>
         </p:nvSpPr>
@@ -14389,7 +14510,7 @@
       </p:sp>
       <p:sp>
         <p:nvSpPr>
-          <p:cNvPr id="10" name="TextBox 9"/>
+          <p:cNvPr id="11" name="TextBox 10"/>
           <p:cNvSpPr txBox="1"/>
           <p:nvPr/>
         </p:nvSpPr>
@@ -14424,7 +14545,7 @@
       </p:sp>
       <p:sp>
         <p:nvSpPr>
-          <p:cNvPr id="11" name="TextBox 10"/>
+          <p:cNvPr id="12" name="TextBox 11"/>
           <p:cNvSpPr txBox="1"/>
           <p:nvPr/>
         </p:nvSpPr>
@@ -14711,7 +14832,7 @@
                 </a:solidFill>
                 <a:latin typeface="Calibri"/>
               </a:rPr>
-              <a:t>Tool: ICO Lawful basis interactive guidance (updated 14 April 2026).</a:t>
+              <a:t>Tool: ICO Lawful basis interactive guidance. Official Word reports dated 26 August 2026.</a:t>
             </a:r>
           </a:p>
           <a:p>
@@ -14730,7 +14851,7 @@
                 </a:solidFill>
                 <a:latin typeface="Calibri"/>
               </a:rPr>
-              <a:t>Five services, one concrete processing activity per run.</a:t>
+              <a:t>Five services from Table 1a. One concrete processing activity per run.</a:t>
             </a:r>
           </a:p>
           <a:p>
@@ -14749,7 +14870,7 @@
                 </a:solidFill>
                 <a:latin typeface="Calibri"/>
               </a:rPr>
-              <a:t>Find the privacy notice, run the tool, save the official Word report.</a:t>
+              <a:t>Compare: what the notice claims vs what ICO marks APPROPRIATE.</a:t>
             </a:r>
           </a:p>
           <a:p>
@@ -14768,7 +14889,7 @@
                 </a:solidFill>
                 <a:latin typeface="Calibri"/>
               </a:rPr>
-              <a:t>Compare: what the notice claims vs what ICO marks APPROPRIATE.</a:t>
+              <a:t>Match Yes = they line up for that purpose. Partial = notice aims at consent, ICO marks INCONCLUSIVE.</a:t>
             </a:r>
           </a:p>
           <a:p>
@@ -14806,7 +14927,7 @@
                 </a:solidFill>
                 <a:latin typeface="Calibri"/>
               </a:rPr>
-              <a:t>UK tool also has recognised legitimate interest (five narrow public purposes). None of our five purposes fitted that list.</a:t>
+              <a:t>UK recognised legitimate interest did not fit any of our five purposes.</a:t>
             </a:r>
           </a:p>
         </p:txBody>

</xml_diff>

<commit_message>
Fjern utenforliggende undersøkelser fra 1A-leveransen
Behold Webbkoll (cookies, tredjepartskall, land) og ICO (ett formål per kjøring).
Ta vekk Accept-banner-testen, HSTS som funn og den pedagogiske cookie-figuren.

Co-authored-by: Karina <kasa031@users.noreply.github.com>
</commit_message>
<xml_diff>
--- a/ACIT4280_1A_presentation.pptx
+++ b/ACIT4280_1A_presentation.pptx
@@ -588,7 +588,7 @@
           <a:lstStyle/>
           <a:p>
             <a:r>
-              <a:t>Four of five core purposes match. Two consent tests fail: skatteetaten cookies (Q6, banner too short) and document.no Signals (request not separate from terms). Webbkoll 0 external cookies on skatteetaten is not a conflict with the cookie ICO row.</a:t>
+              <a:t>Four of five core purposes match. Two consent tests fail: skatteetaten cookies (Q6) and document.no Signals (request not separate from terms).</a:t>
             </a:r>
           </a:p>
         </p:txBody>
@@ -658,7 +658,7 @@
           <a:lstStyle/>
           <a:p>
             <a:r>
-              <a:t>Two purposes, two reports. Tax: law. Cookies: they aim at consent, but ICO says name controller, purpose and types more clearly. No test 24 August 2026 on skatteetaten.no/person/. Table 5 cookie row tests the notice, not the Webbkoll count.</a:t>
+              <a:t>Two purposes, two reports. Table 5 cookie row tests the notice.</a:t>
             </a:r>
           </a:p>
         </p:txBody>
@@ -1148,7 +1148,7 @@
           <a:lstStyle/>
           <a:p>
             <a:r>
-              <a:t>Table 1 is the 18 Canvas names. Table 1a is why we picked the five. Stress one purpose at a time. Cookie clicks are not the lawful basis for tax or checkout.</a:t>
+              <a:t>Table 1 is the 18 Canvas names. Table 1a is why we picked the five. Stress one purpose at a time.</a:t>
             </a:r>
           </a:p>
         </p:txBody>
@@ -1218,7 +1218,7 @@
           <a:lstStyle/>
           <a:p>
             <a:r>
-              <a:t>Webbkoll does not read a privacy notice and does not decide Article 6. Request volume is not cookie volume and is not proof that personal data left Norway.</a:t>
+              <a:t>Webbkoll does not read a privacy notice and does not decide Article 6. Request volume is not cookie volume.</a:t>
             </a:r>
           </a:p>
         </p:txBody>
@@ -1288,7 +1288,7 @@
           <a:lstStyle/>
           <a:p>
             <a:r>
-              <a:t>skatteetaten.no shows five internal cookies and zero external cookies because we never clicked Yes. The ICO cookie row tests the notice, not that Webbkoll count.</a:t>
+              <a:t>skatteetaten.no: 5 internal cookies, 0 external cookies on Table 2. The ICO cookie row tests the notice, not that Webbkoll count.</a:t>
             </a:r>
           </a:p>
         </p:txBody>
@@ -1638,7 +1638,7 @@
           <a:lstStyle/>
           <a:p>
             <a:r>
-              <a:t>A clean ICO run with Consent Q1 = No marks consent NOT APPROPRIATE for tax. Cookies are a separate purpose and a separate run.</a:t>
+              <a:t>skatteetaten has two ICO rows because the notice has two purposes. The 18-site Webbkoll table is Part 1 only.</a:t>
             </a:r>
           </a:p>
         </p:txBody>
@@ -7826,7 +7826,7 @@
                 </a:solidFill>
                 <a:latin typeface="Calibri"/>
               </a:rPr>
-              <a:t>Purpose 2: optional stats cookies. Notice: Yes/No. Webbkoll: 0 external cookies (no click). ICO: consent INCONCLUSIVE (Q6). No basis APPROPRIATE.</a:t>
+              <a:t>Purpose 2: optional stats cookies in the notice. ICO: consent INCONCLUSIVE (Q6). No basis APPROPRIATE.</a:t>
             </a:r>
           </a:p>
         </p:txBody>
@@ -8741,7 +8741,7 @@
                 </a:solidFill>
                 <a:latin typeface="Calibri"/>
               </a:rPr>
-              <a:t>FIKS membership can use contract. That is a different purpose.</a:t>
+              <a:t>FIKS membership can use contract. That is a different purpose and was not this run.</a:t>
             </a:r>
           </a:p>
           <a:p>
@@ -8760,26 +8760,7 @@
                 </a:solidFill>
                 <a:latin typeface="Calibri"/>
               </a:rPr>
-              <a:t>Stamdata 'samtykke om publisering' does not match ICO consent (likely invalid).</a:t>
-            </a:r>
-          </a:p>
-          <a:p>
-            <a:pPr algn="l">
-              <a:spcBef>
-                <a:spcPts val="0"/>
-              </a:spcBef>
-              <a:spcAft>
-                <a:spcPts val="1000"/>
-              </a:spcAft>
-            </a:pPr>
-            <a:r>
-              <a:rPr sz="1700" b="0" i="0">
-                <a:solidFill>
-                  <a:srgbClr val="1A1A1A"/>
-                </a:solidFill>
-                <a:latin typeface="Calibri"/>
-              </a:rPr>
-              <a:t>Cookiebot (Deny on 26 Aug 2026) is also a different purpose.</a:t>
+              <a:t>This ICO run is match-history publication only.</a:t>
             </a:r>
           </a:p>
         </p:txBody>
@@ -9791,26 +9772,7 @@
                 </a:solidFill>
                 <a:latin typeface="Calibri"/>
               </a:rPr>
-              <a:t>Marketing/profiling: consent (separate). Cookie policy: necessary vs measurement vs marketing.</a:t>
-            </a:r>
-          </a:p>
-          <a:p>
-            <a:pPr algn="l">
-              <a:spcBef>
-                <a:spcPts val="0"/>
-              </a:spcBef>
-              <a:spcAft>
-                <a:spcPts val="1000"/>
-              </a:spcAft>
-            </a:pPr>
-            <a:r>
-              <a:rPr sz="1800" b="0" i="0">
-                <a:solidFill>
-                  <a:srgbClr val="1A1A1A"/>
-                </a:solidFill>
-                <a:latin typeface="Calibri"/>
-              </a:rPr>
-              <a:t>Bundled 'consent' to cookies inside the terms is not valid Art. 6 consent.</a:t>
+              <a:t>Marketing/profiling: consent (separate purpose). Cookie categories in the notice stay off this ICO run.</a:t>
             </a:r>
           </a:p>
         </p:txBody>
@@ -10182,7 +10144,7 @@
                 </a:solidFill>
                 <a:latin typeface="Calibri"/>
               </a:rPr>
-              <a:t>Webbkoll measures contact, not lawfulness and not a Chapter V export.</a:t>
+              <a:t>Webbkoll measures contact, not lawfulness.</a:t>
             </a:r>
           </a:p>
           <a:p>
@@ -10277,7 +10239,7 @@
                 </a:solidFill>
                 <a:latin typeface="Calibri"/>
               </a:rPr>
-              <a:t>Legal obligation (tax) is not the same as cookie consent (Yes/No).</a:t>
+              <a:t>Legal obligation (tax) is not the same ICO purpose as optional cookies.</a:t>
             </a:r>
           </a:p>
         </p:txBody>
@@ -11502,7 +11464,7 @@
                 </a:solidFill>
                 <a:latin typeface="Calibri"/>
               </a:rPr>
-              <a:t>English Webbkoll; one live Chromium visit: no add-ons, no Do Not Track, no consent click</a:t>
+              <a:t>English Webbkoll; one live Chromium visit: no add-ons, no Do Not Track</a:t>
             </a:r>
           </a:p>
           <a:p>
@@ -11597,7 +11559,7 @@
                 </a:solidFill>
                 <a:latin typeface="Calibri"/>
               </a:rPr>
-              <a:t>KeyCDN countries are not a GDPR Chapter V transfer record (arts. 44-47)</a:t>
+              <a:t>Request count is not the same as cookie count</a:t>
             </a:r>
           </a:p>
         </p:txBody>
@@ -11969,7 +11931,7 @@
                 </a:solidFill>
                 <a:latin typeface="Calibri"/>
               </a:rPr>
-              <a:t>It does not click Yes/No or Cookiebot, so optional analytics cookies may not appear.</a:t>
+              <a:t>It does not decide Article 6. That is the ICO tool.</a:t>
             </a:r>
           </a:p>
           <a:p>
@@ -11988,7 +11950,7 @@
                 </a:solidFill>
                 <a:latin typeface="Calibri"/>
               </a:rPr>
-              <a:t>A high request count is not a cookie count, and it is not personal data leaving Norway.</a:t>
+              <a:t>A high request count is not a cookie count.</a:t>
             </a:r>
           </a:p>
           <a:p>
@@ -14460,7 +14422,7 @@
                 </a:solidFill>
                 <a:latin typeface="Calibri"/>
               </a:rPr>
-              <a:t>Table 2 rank: 46 requests, 0 third-party cookies. Screenshots = later visit (Table 3: 56 requests to 13 hosts). Server KeyCDN: United States, Google. Not a Chapter V finding.</a:t>
+              <a:t>Table 2 rank: 46 requests, 0 third-party cookies. Screenshots = later visit (Table 3: 56 requests to 13 hosts). Server KeyCDN: United States, Google.</a:t>
             </a:r>
           </a:p>
         </p:txBody>
@@ -15257,7 +15219,7 @@
                 </a:solidFill>
                 <a:latin typeface="Calibri"/>
               </a:rPr>
-              <a:t>Article 6 is not a cookie click</a:t>
+              <a:t>One purpose per ICO run</a:t>
             </a:r>
           </a:p>
         </p:txBody>
@@ -15396,7 +15358,7 @@
                 </a:solidFill>
                 <a:latin typeface="Calibri"/>
               </a:rPr>
-              <a:t>•  Contract, legal obligation, public task, consent, legitimate interests, vital interests</a:t>
+              <a:t>•  Contract, legal obligation, public task, consent, legitimate interests</a:t>
             </a:r>
           </a:p>
           <a:p>
@@ -15493,7 +15455,7 @@
                 </a:solidFill>
                 <a:latin typeface="Calibri"/>
               </a:rPr>
-              <a:t>ePrivacy / cookies</a:t>
+              <a:t>Keep purposes apart</a:t>
             </a:r>
           </a:p>
         </p:txBody>
@@ -15535,7 +15497,7 @@
                 </a:solidFill>
                 <a:latin typeface="Calibri"/>
               </a:rPr>
-              <a:t>•  May we store/read info on the device?</a:t>
+              <a:t>•  Tax data is not optional statistics cookies</a:t>
             </a:r>
           </a:p>
           <a:p>
@@ -15554,7 +15516,7 @@
                 </a:solidFill>
                 <a:latin typeface="Calibri"/>
               </a:rPr>
-              <a:t>•  Necessary cookies: often no extra consent</a:t>
+              <a:t>•  Checkout is not marketing</a:t>
             </a:r>
           </a:p>
           <a:p>
@@ -15573,7 +15535,7 @@
                 </a:solidFill>
                 <a:latin typeface="Calibri"/>
               </a:rPr>
-              <a:t>•  Analytics and ads: consent (Yes/No, Cookiebot)</a:t>
+              <a:t>•  Match lists are not FIKS membership</a:t>
             </a:r>
           </a:p>
           <a:p>
@@ -15592,7 +15554,7 @@
                 </a:solidFill>
                 <a:latin typeface="Calibri"/>
               </a:rPr>
-              <a:t>•  No test 24 Aug 2026 on skatteetaten.no/person/</a:t>
+              <a:t>•  Mix them in one ICO run and the tool mixes the bases</a:t>
             </a:r>
           </a:p>
         </p:txBody>

</xml_diff>

<commit_message>
Kutt fyllord på Webbkoll-strukturen i presentasjonen
Co-authored-by: Karina <kasa031@users.noreply.github.com>
</commit_message>
<xml_diff>
--- a/ACIT4280_1A_presentation.pptx
+++ b/ACIT4280_1A_presentation.pptx
@@ -10819,7 +10819,7 @@
                 </a:solidFill>
                 <a:latin typeface="Calibri"/>
               </a:rPr>
-              <a:t>•  18 course-listed sites (Table 1)</a:t>
+              <a:t>•  18 sites (Table 1)</a:t>
             </a:r>
           </a:p>
           <a:p>
@@ -10838,7 +10838,7 @@
                 </a:solidFill>
                 <a:latin typeface="Calibri"/>
               </a:rPr>
-              <a:t>•  Shopping, government, news/media/entertainment, spare time/sports</a:t>
+              <a:t>•  Shopping, government, news/media, sport</a:t>
             </a:r>
           </a:p>
           <a:p>
@@ -10857,7 +10857,7 @@
                 </a:solidFill>
                 <a:latin typeface="Calibri"/>
               </a:rPr>
-              <a:t>•  Columns: server country, internal/external cookies, 3rd-party requests, countries excl. Norway</a:t>
+              <a:t>•  Server country, cookies, 3rd-party requests, countries excl. Norway</a:t>
             </a:r>
           </a:p>
           <a:p>
@@ -10876,7 +10876,7 @@
                 </a:solidFill>
                 <a:latin typeface="Calibri"/>
               </a:rPr>
-              <a:t>•  Figures 2-4: all 18 sites, share, sector totals</a:t>
+              <a:t>•  Figures 2-4: counts, share, sectors</a:t>
             </a:r>
           </a:p>
           <a:p>
@@ -10895,7 +10895,7 @@
                 </a:solidFill>
                 <a:latin typeface="Calibri"/>
               </a:rPr>
-              <a:t>•  Rank on Table 2 requests, not cookies</a:t>
+              <a:t>•  Rank Table 2 requests, not cookies</a:t>
             </a:r>
           </a:p>
         </p:txBody>

</xml_diff>

<commit_message>
Fjern talerfordeling fra presentasjonen
Lysbildene har ingen per-slide navn. Interne notater om hvem som tar hva er også vekke.

Co-authored-by: Karina <kasa031@users.noreply.github.com>
</commit_message>
<xml_diff>
--- a/ACIT4280_1A_presentation.pptx
+++ b/ACIT4280_1A_presentation.pptx
@@ -5064,7 +5064,7 @@
         <p:spPr>
           <a:xfrm>
             <a:off x="457200" y="109728"/>
-            <a:ext cx="7498079" cy="292608"/>
+            <a:ext cx="11247120" cy="292608"/>
           </a:xfrm>
           <a:prstGeom prst="rect">
             <a:avLst/>
@@ -7613,7 +7613,7 @@
         <p:spPr>
           <a:xfrm>
             <a:off x="457200" y="109728"/>
-            <a:ext cx="7498079" cy="292608"/>
+            <a:ext cx="11247120" cy="292608"/>
           </a:xfrm>
           <a:prstGeom prst="rect">
             <a:avLst/>
@@ -8099,7 +8099,7 @@
         <p:spPr>
           <a:xfrm>
             <a:off x="457200" y="109728"/>
-            <a:ext cx="7498079" cy="292608"/>
+            <a:ext cx="11247120" cy="292608"/>
           </a:xfrm>
           <a:prstGeom prst="rect">
             <a:avLst/>
@@ -8566,7 +8566,7 @@
         <p:spPr>
           <a:xfrm>
             <a:off x="457200" y="109728"/>
-            <a:ext cx="7498079" cy="292608"/>
+            <a:ext cx="11247120" cy="292608"/>
           </a:xfrm>
           <a:prstGeom prst="rect">
             <a:avLst/>
@@ -9033,7 +9033,7 @@
         <p:spPr>
           <a:xfrm>
             <a:off x="457200" y="109728"/>
-            <a:ext cx="7498079" cy="292608"/>
+            <a:ext cx="11247120" cy="292608"/>
           </a:xfrm>
           <a:prstGeom prst="rect">
             <a:avLst/>
@@ -9597,7 +9597,7 @@
         <p:spPr>
           <a:xfrm>
             <a:off x="457200" y="109728"/>
-            <a:ext cx="7498079" cy="292608"/>
+            <a:ext cx="11247120" cy="292608"/>
           </a:xfrm>
           <a:prstGeom prst="rect">
             <a:avLst/>
@@ -10045,7 +10045,7 @@
         <p:spPr>
           <a:xfrm>
             <a:off x="457200" y="109728"/>
-            <a:ext cx="7498079" cy="292608"/>
+            <a:ext cx="11247120" cy="292608"/>
           </a:xfrm>
           <a:prstGeom prst="rect">
             <a:avLst/>
@@ -10643,7 +10643,7 @@
         <p:spPr>
           <a:xfrm>
             <a:off x="457200" y="109728"/>
-            <a:ext cx="7498079" cy="292608"/>
+            <a:ext cx="11247120" cy="292608"/>
           </a:xfrm>
           <a:prstGeom prst="rect">
             <a:avLst/>
@@ -11365,7 +11365,7 @@
         <p:spPr>
           <a:xfrm>
             <a:off x="457200" y="109728"/>
-            <a:ext cx="7498079" cy="292608"/>
+            <a:ext cx="11247120" cy="292608"/>
           </a:xfrm>
           <a:prstGeom prst="rect">
             <a:avLst/>
@@ -11832,7 +11832,7 @@
         <p:spPr>
           <a:xfrm>
             <a:off x="457200" y="109728"/>
-            <a:ext cx="7498079" cy="292608"/>
+            <a:ext cx="11247120" cy="292608"/>
           </a:xfrm>
           <a:prstGeom prst="rect">
             <a:avLst/>
@@ -12280,7 +12280,7 @@
         <p:spPr>
           <a:xfrm>
             <a:off x="457200" y="109728"/>
-            <a:ext cx="7498079" cy="292608"/>
+            <a:ext cx="11247120" cy="292608"/>
           </a:xfrm>
           <a:prstGeom prst="rect">
             <a:avLst/>
@@ -13845,7 +13845,7 @@
         <p:spPr>
           <a:xfrm>
             <a:off x="457200" y="109728"/>
-            <a:ext cx="7498079" cy="292608"/>
+            <a:ext cx="11247120" cy="292608"/>
           </a:xfrm>
           <a:prstGeom prst="rect">
             <a:avLst/>
@@ -14282,7 +14282,7 @@
         <p:spPr>
           <a:xfrm>
             <a:off x="457200" y="109728"/>
-            <a:ext cx="7498079" cy="292608"/>
+            <a:ext cx="11247120" cy="292608"/>
           </a:xfrm>
           <a:prstGeom prst="rect">
             <a:avLst/>
@@ -14695,7 +14695,7 @@
         <p:spPr>
           <a:xfrm>
             <a:off x="457200" y="109728"/>
-            <a:ext cx="7498079" cy="292608"/>
+            <a:ext cx="11247120" cy="292608"/>
           </a:xfrm>
           <a:prstGeom prst="rect">
             <a:avLst/>
@@ -15162,7 +15162,7 @@
         <p:spPr>
           <a:xfrm>
             <a:off x="457200" y="109728"/>
-            <a:ext cx="7498079" cy="292608"/>
+            <a:ext cx="11247120" cy="292608"/>
           </a:xfrm>
           <a:prstGeom prst="rect">
             <a:avLst/>

</xml_diff>

<commit_message>
Oppdater avslutningsslide med kort sammendrag på engelsk
Slide 15 erstattes med fire setninger som oppsummerer både Webbkoll-
målingen og ICO-resultatene for presentasjonen.

Co-authored-by: Karina <kasa031@users.noreply.github.com>
</commit_message>
<xml_diff>
--- a/ACIT4280_1A_presentation.pptx
+++ b/ACIT4280_1A_presentation.pptx
@@ -937,7 +937,7 @@
           <a:lstStyle/>
           <a:p>
             <a:r>
-              <a:t>Together the two parts show how the page loads, and why the controller may use the data.</a:t>
+              <a:t>Part 1 is contact. Part 2 is one purpose and one basis at a time.</a:t>
             </a:r>
           </a:p>
         </p:txBody>
@@ -7336,14 +7336,57 @@
       </p:sp>
       <p:sp>
         <p:nvSpPr>
-          <p:cNvPr id="7" name="TextBox 6"/>
+          <p:cNvPr id="7" name="Rectangle 6"/>
+          <p:cNvSpPr/>
+          <p:nvPr/>
+        </p:nvSpPr>
+        <p:spPr>
+          <a:xfrm>
+            <a:off x="457200" y="1417320"/>
+            <a:ext cx="11247120" cy="4434840"/>
+          </a:xfrm>
+          <a:prstGeom prst="rect">
+            <a:avLst/>
+          </a:prstGeom>
+          <a:solidFill>
+            <a:srgbClr val="FFF1D1"/>
+          </a:solidFill>
+          <a:ln>
+            <a:noFill/>
+          </a:ln>
+        </p:spPr>
+        <p:style>
+          <a:lnRef idx="1">
+            <a:schemeClr val="accent1"/>
+          </a:lnRef>
+          <a:fillRef idx="3">
+            <a:schemeClr val="accent1"/>
+          </a:fillRef>
+          <a:effectRef idx="2">
+            <a:schemeClr val="accent1"/>
+          </a:effectRef>
+          <a:fontRef idx="minor">
+            <a:schemeClr val="lt1"/>
+          </a:fontRef>
+        </p:style>
+        <p:txBody>
+          <a:bodyPr rtlCol="0" anchor="ctr"/>
+          <a:lstStyle/>
+          <a:p>
+            <a:pPr algn="ctr"/>
+          </a:p>
+        </p:txBody>
+      </p:sp>
+      <p:sp>
+        <p:nvSpPr>
+          <p:cNvPr id="8" name="TextBox 7"/>
           <p:cNvSpPr txBox="1"/>
           <p:nvPr/>
         </p:nvSpPr>
         <p:spPr>
           <a:xfrm>
-            <a:off x="502920" y="1371600"/>
-            <a:ext cx="11155680" cy="5029200"/>
+            <a:off x="685800" y="1691640"/>
+            <a:ext cx="10789920" cy="3977639"/>
           </a:xfrm>
           <a:prstGeom prst="rect">
             <a:avLst/>
@@ -7361,17 +7404,17 @@
                 <a:spcPts val="0"/>
               </a:spcBef>
               <a:spcAft>
-                <a:spcPts val="1200"/>
+                <a:spcPts val="1600"/>
               </a:spcAft>
             </a:pPr>
             <a:r>
-              <a:rPr sz="2000" b="0" i="0">
-                <a:solidFill>
-                  <a:srgbClr val="1A1A1A"/>
-                </a:solidFill>
-                <a:latin typeface="Calibri"/>
-              </a:rPr>
-              <a:t>fotball.no has the most requests (113) and zero third-party cookies.</a:t>
+              <a:rPr sz="2200" b="0" i="0">
+                <a:solidFill>
+                  <a:srgbClr val="1B365D"/>
+                </a:solidFill>
+                <a:latin typeface="Calibri"/>
+              </a:rPr>
+              <a:t>We measured how much 18 Norwegian sites contact others when they load, and we checked whether five of them have a valid GDPR basis for one specific purpose.</a:t>
             </a:r>
           </a:p>
           <a:p>
@@ -7380,17 +7423,17 @@
                 <a:spcPts val="0"/>
               </a:spcBef>
               <a:spcAft>
-                <a:spcPts val="1200"/>
+                <a:spcPts val="1600"/>
               </a:spcAft>
             </a:pPr>
             <a:r>
-              <a:rPr sz="2000" b="0" i="0">
-                <a:solidFill>
-                  <a:srgbClr val="1A1A1A"/>
-                </a:solidFill>
-                <a:latin typeface="Calibri"/>
-              </a:rPr>
-              <a:t>document.no maps to the most countries. lanekassen.no and altinn.no have the fewest government requests.</a:t>
+              <a:rPr sz="2200" b="0" i="0">
+                <a:solidFill>
+                  <a:srgbClr val="1B365D"/>
+                </a:solidFill>
+                <a:latin typeface="Calibri"/>
+              </a:rPr>
+              <a:t>Many sites reach out to many others without setting cookies.</a:t>
             </a:r>
           </a:p>
           <a:p>
@@ -7399,17 +7442,17 @@
                 <a:spcPts val="0"/>
               </a:spcBef>
               <a:spcAft>
-                <a:spcPts val="1200"/>
+                <a:spcPts val="1600"/>
               </a:spcAft>
             </a:pPr>
             <a:r>
-              <a:rPr sz="2000" b="0" i="0">
-                <a:solidFill>
-                  <a:srgbClr val="1A1A1A"/>
-                </a:solidFill>
-                <a:latin typeface="Calibri"/>
-              </a:rPr>
-              <a:t>News and media is the highest sector total. Government is the lowest.</a:t>
+              <a:rPr sz="2200" b="0" i="0">
+                <a:solidFill>
+                  <a:srgbClr val="1B365D"/>
+                </a:solidFill>
+                <a:latin typeface="Calibri"/>
+              </a:rPr>
+              <a:t>Four of five ICO purposes match the notice.</a:t>
             </a:r>
           </a:p>
           <a:p>
@@ -7418,43 +7461,24 @@
                 <a:spcPts val="0"/>
               </a:spcBef>
               <a:spcAft>
-                <a:spcPts val="1200"/>
+                <a:spcPts val="0"/>
               </a:spcAft>
             </a:pPr>
             <a:r>
-              <a:rPr sz="2000" b="0" i="0">
-                <a:solidFill>
-                  <a:srgbClr val="1A1A1A"/>
-                </a:solidFill>
-                <a:latin typeface="Calibri"/>
-              </a:rPr>
-              <a:t>Four core ICO purposes match the notice. Two consent claims are INCONCLUSIVE in the ICO reports.</a:t>
-            </a:r>
-          </a:p>
-          <a:p>
-            <a:pPr algn="l">
-              <a:spcBef>
-                <a:spcPts val="0"/>
-              </a:spcBef>
-              <a:spcAft>
-                <a:spcPts val="1200"/>
-              </a:spcAft>
-            </a:pPr>
-            <a:r>
-              <a:rPr sz="2000" b="0" i="0">
-                <a:solidFill>
-                  <a:srgbClr val="1A1A1A"/>
-                </a:solidFill>
-                <a:latin typeface="Calibri"/>
-              </a:rPr>
-              <a:t>One purpose needs one basis. Contact and lawfulness are different questions.</a:t>
-            </a:r>
-          </a:p>
-        </p:txBody>
-      </p:sp>
-      <p:sp>
-        <p:nvSpPr>
-          <p:cNvPr id="8" name="Rectangle 7"/>
+              <a:rPr sz="2200" b="0" i="0">
+                <a:solidFill>
+                  <a:srgbClr val="1B365D"/>
+                </a:solidFill>
+                <a:latin typeface="Calibri"/>
+              </a:rPr>
+              <a:t>In two places where the site claims consent, the ICO is not satisfied with how consent is formulated.</a:t>
+            </a:r>
+          </a:p>
+        </p:txBody>
+      </p:sp>
+      <p:sp>
+        <p:nvSpPr>
+          <p:cNvPr id="9" name="Rectangle 8"/>
           <p:cNvSpPr/>
           <p:nvPr/>
         </p:nvSpPr>
@@ -7497,7 +7521,7 @@
       </p:sp>
       <p:sp>
         <p:nvSpPr>
-          <p:cNvPr id="9" name="TextBox 8"/>
+          <p:cNvPr id="10" name="TextBox 9"/>
           <p:cNvSpPr txBox="1"/>
           <p:nvPr/>
         </p:nvSpPr>
@@ -7532,7 +7556,7 @@
       </p:sp>
       <p:sp>
         <p:nvSpPr>
-          <p:cNvPr id="10" name="TextBox 9"/>
+          <p:cNvPr id="11" name="TextBox 10"/>
           <p:cNvSpPr txBox="1"/>
           <p:nvPr/>
         </p:nvSpPr>

</xml_diff>

<commit_message>
Legg til ICO-sammendrag med enkel forklaring av Partial
Ny slide 10 etter Table 5 forklarer at fire formål stemmer og hvorfor
to samtykketester (Skatteetaten og document.no) er Partial.

Co-authored-by: Karina <kasa031@users.noreply.github.com>
</commit_message>
<xml_diff>
--- a/ACIT4280_1A_presentation.pptx
+++ b/ACIT4280_1A_presentation.pptx
@@ -21,6 +21,7 @@
     <p:sldId id="269" r:id="rId21"/>
     <p:sldId id="270" r:id="rId22"/>
     <p:sldId id="271" r:id="rId23"/>
+    <p:sldId id="272" r:id="rId24"/>
   </p:sldIdLst>
   <p:sldSz cx="12191695" cy="6858000" type="screen4x3"/>
   <p:notesSz cx="6858000" cy="9144000"/>
@@ -587,7 +588,7 @@
           <a:lstStyle/>
           <a:p>
             <a:r>
-              <a:t>Two purposes in the notice, two ICO runs. Figure 7 in the report is the hub that splits those pages.</a:t>
+              <a:t>Partial is not a court finding. It means the consent wording did not pass the ICO checklist.</a:t>
             </a:r>
           </a:p>
         </p:txBody>
@@ -657,7 +658,7 @@
           <a:lstStyle/>
           <a:p>
             <a:r>
-              <a:t>Same split as elsewhere: one purpose, one basis.</a:t>
+              <a:t>Two purposes in the notice, two ICO runs. Figure 7 in the report is the hub that splits those pages.</a:t>
             </a:r>
           </a:p>
         </p:txBody>
@@ -727,7 +728,7 @@
           <a:lstStyle/>
           <a:p>
             <a:r>
-              <a:t>fotball.no also has the highest Webbkoll request count. That does not decide Article 6.</a:t>
+              <a:t>Same split as elsewhere: one purpose, one basis.</a:t>
             </a:r>
           </a:p>
         </p:txBody>
@@ -797,7 +798,7 @@
           <a:lstStyle/>
           <a:p>
             <a:r>
-              <a:t>Contract and legitimate interests do not fit this advertising purpose.</a:t>
+              <a:t>fotball.no also has the highest Webbkoll request count. That does not decide Article 6.</a:t>
             </a:r>
           </a:p>
         </p:txBody>
@@ -867,7 +868,7 @@
           <a:lstStyle/>
           <a:p>
             <a:r>
-              <a:t>Same pattern as Netflix: contract for the core service.</a:t>
+              <a:t>Contract and legitimate interests do not fit this advertising purpose.</a:t>
             </a:r>
           </a:p>
         </p:txBody>
@@ -937,7 +938,7 @@
           <a:lstStyle/>
           <a:p>
             <a:r>
-              <a:t>Part 1 is contact. Part 2 is one purpose and one basis at a time.</a:t>
+              <a:t>Same pattern as Netflix: contract for the core service.</a:t>
             </a:r>
           </a:p>
         </p:txBody>
@@ -963,6 +964,76 @@
 </file>
 
 <file path=ppt/notesSlides/notesSlide16.xml><?xml version="1.0" encoding="utf-8"?>
+<p:notes xmlns:a="http://schemas.openxmlformats.org/drawingml/2006/main" xmlns:p="http://schemas.openxmlformats.org/presentationml/2006/main" xmlns:r="http://schemas.openxmlformats.org/officeDocument/2006/relationships">
+  <p:cSld>
+    <p:spTree>
+      <p:nvGrpSpPr>
+        <p:cNvPr id="1" name=""/>
+        <p:cNvGrpSpPr/>
+        <p:nvPr/>
+      </p:nvGrpSpPr>
+      <p:grpSpPr>
+        <a:xfrm>
+          <a:off x="0" y="0"/>
+          <a:ext cx="0" cy="0"/>
+          <a:chOff x="0" y="0"/>
+          <a:chExt cx="0" cy="0"/>
+        </a:xfrm>
+      </p:grpSpPr>
+      <p:sp>
+        <p:nvSpPr>
+          <p:cNvPr id="2" name="Slide Image Placeholder 1"/>
+          <p:cNvSpPr>
+            <a:spLocks noGrp="1"/>
+          </p:cNvSpPr>
+          <p:nvPr>
+            <p:ph type="sldImg" idx="2"/>
+          </p:nvPr>
+        </p:nvSpPr>
+        <p:spPr/>
+      </p:sp>
+      <p:sp>
+        <p:nvSpPr>
+          <p:cNvPr id="3" name="Notes Placeholder 2"/>
+          <p:cNvSpPr>
+            <a:spLocks noGrp="1"/>
+          </p:cNvSpPr>
+          <p:nvPr>
+            <p:ph type="body" idx="3" sz="quarter"/>
+          </p:nvPr>
+        </p:nvSpPr>
+        <p:spPr/>
+        <p:txBody>
+          <a:bodyPr/>
+          <a:lstStyle/>
+          <a:p>
+            <a:r>
+              <a:t>Part 1 is contact. Part 2 is one purpose and one basis at a time.</a:t>
+            </a:r>
+          </a:p>
+        </p:txBody>
+      </p:sp>
+      <p:sp>
+        <p:nvSpPr>
+          <p:cNvPr id="4" name="Slide Number Placeholder 3"/>
+          <p:cNvSpPr>
+            <a:spLocks noGrp="1"/>
+          </p:cNvSpPr>
+          <p:nvPr>
+            <p:ph type="sldNum" idx="5" sz="quarter"/>
+          </p:nvPr>
+        </p:nvSpPr>
+        <p:spPr/>
+      </p:sp>
+    </p:spTree>
+  </p:cSld>
+  <p:clrMapOvr>
+    <a:masterClrMapping/>
+  </p:clrMapOvr>
+</p:notes>
+</file>
+
+<file path=ppt/notesSlides/notesSlide17.xml><?xml version="1.0" encoding="utf-8"?>
 <p:notes xmlns:a="http://schemas.openxmlformats.org/drawingml/2006/main" xmlns:p="http://schemas.openxmlformats.org/presentationml/2006/main" xmlns:r="http://schemas.openxmlformats.org/officeDocument/2006/relationships">
   <p:cSld>
     <p:spTree>
@@ -5071,7 +5142,7 @@
                 </a:solidFill>
                 <a:latin typeface="Calibri"/>
               </a:rPr>
-              <a:t>Part 2</a:t>
+              <a:t>Part 2  ·  Table 5</a:t>
             </a:r>
           </a:p>
         </p:txBody>
@@ -5106,21 +5177,64 @@
                 </a:solidFill>
                 <a:latin typeface="Calibri"/>
               </a:rPr>
-              <a:t>skatteetaten.no: two purposes</a:t>
-            </a:r>
-          </a:p>
-        </p:txBody>
-      </p:sp>
-      <p:sp>
-        <p:nvSpPr>
-          <p:cNvPr id="7" name="TextBox 6"/>
+              <a:t>Four match, two consent tests Partial</a:t>
+            </a:r>
+          </a:p>
+        </p:txBody>
+      </p:sp>
+      <p:sp>
+        <p:nvSpPr>
+          <p:cNvPr id="7" name="Rectangle 6"/>
+          <p:cNvSpPr/>
+          <p:nvPr/>
+        </p:nvSpPr>
+        <p:spPr>
+          <a:xfrm>
+            <a:off x="457200" y="1417320"/>
+            <a:ext cx="11247120" cy="4434840"/>
+          </a:xfrm>
+          <a:prstGeom prst="rect">
+            <a:avLst/>
+          </a:prstGeom>
+          <a:solidFill>
+            <a:srgbClr val="FFF1D1"/>
+          </a:solidFill>
+          <a:ln>
+            <a:noFill/>
+          </a:ln>
+        </p:spPr>
+        <p:style>
+          <a:lnRef idx="1">
+            <a:schemeClr val="accent1"/>
+          </a:lnRef>
+          <a:fillRef idx="3">
+            <a:schemeClr val="accent1"/>
+          </a:fillRef>
+          <a:effectRef idx="2">
+            <a:schemeClr val="accent1"/>
+          </a:effectRef>
+          <a:fontRef idx="minor">
+            <a:schemeClr val="lt1"/>
+          </a:fontRef>
+        </p:style>
+        <p:txBody>
+          <a:bodyPr rtlCol="0" anchor="ctr"/>
+          <a:lstStyle/>
+          <a:p>
+            <a:pPr algn="ctr"/>
+          </a:p>
+        </p:txBody>
+      </p:sp>
+      <p:sp>
+        <p:nvSpPr>
+          <p:cNvPr id="8" name="TextBox 7"/>
           <p:cNvSpPr txBox="1"/>
           <p:nvPr/>
         </p:nvSpPr>
         <p:spPr>
           <a:xfrm>
-            <a:off x="502920" y="1371600"/>
-            <a:ext cx="11155680" cy="5029200"/>
+            <a:off x="685800" y="1691640"/>
+            <a:ext cx="10789920" cy="3977639"/>
           </a:xfrm>
           <a:prstGeom prst="rect">
             <a:avLst/>
@@ -5138,17 +5252,17 @@
                 <a:spcPts val="0"/>
               </a:spcBef>
               <a:spcAft>
-                <a:spcPts val="1200"/>
+                <a:spcPts val="1400"/>
               </a:spcAft>
             </a:pPr>
             <a:r>
-              <a:rPr sz="2000" b="0" i="0">
-                <a:solidFill>
-                  <a:srgbClr val="1A1A1A"/>
-                </a:solidFill>
-                <a:latin typeface="Calibri"/>
-              </a:rPr>
-              <a:t>Tax and registry data: the law requires it. Opt-out is generally not possible.</a:t>
+              <a:rPr sz="2000" b="1" i="0">
+                <a:solidFill>
+                  <a:srgbClr val="1B365D"/>
+                </a:solidFill>
+                <a:latin typeface="Calibri"/>
+              </a:rPr>
+              <a:t>Four core purposes match the notice: tax, paid streaming, match history, checkout.</a:t>
             </a:r>
           </a:p>
           <a:p>
@@ -5157,17 +5271,17 @@
                 <a:spcPts val="0"/>
               </a:spcBef>
               <a:spcAft>
-                <a:spcPts val="1200"/>
+                <a:spcPts val="1400"/>
               </a:spcAft>
             </a:pPr>
             <a:r>
-              <a:rPr sz="2000" b="0" i="0">
-                <a:solidFill>
-                  <a:srgbClr val="1A1A1A"/>
-                </a:solidFill>
-                <a:latin typeface="Calibri"/>
-              </a:rPr>
-              <a:t>ICO: legal obligation and public task APPROPRIATE. Consent NOT APPROPRIATE. Match: Yes.</a:t>
+              <a:rPr sz="2000" b="1" i="0">
+                <a:solidFill>
+                  <a:srgbClr val="1B365D"/>
+                </a:solidFill>
+                <a:latin typeface="Calibri"/>
+              </a:rPr>
+              <a:t>Two consent tests are Partial: Skatteetaten optional cookies and document.no Google Signals.</a:t>
             </a:r>
           </a:p>
           <a:p>
@@ -5176,17 +5290,17 @@
                 <a:spcPts val="0"/>
               </a:spcBef>
               <a:spcAft>
-                <a:spcPts val="1200"/>
+                <a:spcPts val="1400"/>
               </a:spcAft>
             </a:pPr>
             <a:r>
-              <a:rPr sz="2000" b="0" i="0">
-                <a:solidFill>
-                  <a:srgbClr val="1A1A1A"/>
-                </a:solidFill>
-                <a:latin typeface="Calibri"/>
-              </a:rPr>
-              <a:t>Optional statistics cookies: the notice claims consent.</a:t>
+              <a:rPr sz="1800" b="0" i="0">
+                <a:solidFill>
+                  <a:srgbClr val="1B365D"/>
+                </a:solidFill>
+                <a:latin typeface="Calibri"/>
+              </a:rPr>
+              <a:t>In both cases the notice claims consent, but the ICO marks consent INCONCLUSIVE.</a:t>
             </a:r>
           </a:p>
           <a:p>
@@ -5195,24 +5309,24 @@
                 <a:spcPts val="0"/>
               </a:spcBef>
               <a:spcAft>
-                <a:spcPts val="1200"/>
+                <a:spcPts val="0"/>
               </a:spcAft>
             </a:pPr>
             <a:r>
-              <a:rPr sz="2000" b="0" i="0">
-                <a:solidFill>
-                  <a:srgbClr val="1A1A1A"/>
-                </a:solidFill>
-                <a:latin typeface="Calibri"/>
-              </a:rPr>
-              <a:t>ICO: consent INCONCLUSIVE; no basis APPROPRIATE. Match: Partial.</a:t>
-            </a:r>
-          </a:p>
-        </p:txBody>
-      </p:sp>
-      <p:sp>
-        <p:nvSpPr>
-          <p:cNvPr id="8" name="Rectangle 7"/>
+              <a:rPr sz="1800" b="0" i="0">
+                <a:solidFill>
+                  <a:srgbClr val="1B365D"/>
+                </a:solidFill>
+                <a:latin typeface="Calibri"/>
+              </a:rPr>
+              <a:t>Skatteetaten does not spell out clearly enough who processes the optional cookies and how to refuse them. document.no points users to Google ad settings; the ICO says that is not a clear, separate consent request, and Pluss terms bundle the notice.</a:t>
+            </a:r>
+          </a:p>
+        </p:txBody>
+      </p:sp>
+      <p:sp>
+        <p:nvSpPr>
+          <p:cNvPr id="9" name="Rectangle 8"/>
           <p:cNvSpPr/>
           <p:nvPr/>
         </p:nvSpPr>
@@ -5255,7 +5369,7 @@
       </p:sp>
       <p:sp>
         <p:nvSpPr>
-          <p:cNvPr id="9" name="TextBox 8"/>
+          <p:cNvPr id="10" name="TextBox 9"/>
           <p:cNvSpPr txBox="1"/>
           <p:nvPr/>
         </p:nvSpPr>
@@ -5290,7 +5404,7 @@
       </p:sp>
       <p:sp>
         <p:nvSpPr>
-          <p:cNvPr id="10" name="TextBox 9"/>
+          <p:cNvPr id="11" name="TextBox 10"/>
           <p:cNvSpPr txBox="1"/>
           <p:nvPr/>
         </p:nvSpPr>
@@ -5318,7 +5432,7 @@
                 </a:solidFill>
                 <a:latin typeface="Calibri"/>
               </a:rPr>
-              <a:t>10 / 16</a:t>
+              <a:t>10 / 17</a:t>
             </a:r>
           </a:p>
         </p:txBody>
@@ -5535,7 +5649,7 @@
                 </a:solidFill>
                 <a:latin typeface="Calibri"/>
               </a:rPr>
-              <a:t>netflix.no: paid streaming</a:t>
+              <a:t>skatteetaten.no: two purposes</a:t>
             </a:r>
           </a:p>
         </p:txBody>
@@ -5577,7 +5691,7 @@
                 </a:solidFill>
                 <a:latin typeface="Calibri"/>
               </a:rPr>
-              <a:t>Purpose: account and payment data needed to provide the paid service.</a:t>
+              <a:t>Tax and registry data: the law requires it. Opt-out is generally not possible.</a:t>
             </a:r>
           </a:p>
           <a:p>
@@ -5596,7 +5710,7 @@
                 </a:solidFill>
                 <a:latin typeface="Calibri"/>
               </a:rPr>
-              <a:t>Notice (EEA/UK): contractual necessity.</a:t>
+              <a:t>ICO: legal obligation and public task APPROPRIATE. Consent NOT APPROPRIATE. Match: Yes.</a:t>
             </a:r>
           </a:p>
           <a:p>
@@ -5615,7 +5729,7 @@
                 </a:solidFill>
                 <a:latin typeface="Calibri"/>
               </a:rPr>
-              <a:t>ICO: contract APPROPRIATE. Consent marked likely invalid for this purpose.</a:t>
+              <a:t>Optional statistics cookies: the notice claims consent.</a:t>
             </a:r>
           </a:p>
           <a:p>
@@ -5634,7 +5748,7 @@
                 </a:solidFill>
                 <a:latin typeface="Calibri"/>
               </a:rPr>
-              <a:t>Ads and marketing in the same notice were left out.</a:t>
+              <a:t>ICO: consent INCONCLUSIVE; no basis APPROPRIATE. Match: Partial.</a:t>
             </a:r>
           </a:p>
         </p:txBody>
@@ -5747,7 +5861,7 @@
                 </a:solidFill>
                 <a:latin typeface="Calibri"/>
               </a:rPr>
-              <a:t>11 / 16</a:t>
+              <a:t>11 / 17</a:t>
             </a:r>
           </a:p>
         </p:txBody>
@@ -5964,7 +6078,7 @@
                 </a:solidFill>
                 <a:latin typeface="Calibri"/>
               </a:rPr>
-              <a:t>fotball.no: match history</a:t>
+              <a:t>netflix.no: paid streaming</a:t>
             </a:r>
           </a:p>
         </p:txBody>
@@ -6006,7 +6120,7 @@
                 </a:solidFill>
                 <a:latin typeface="Calibri"/>
               </a:rPr>
-              <a:t>Purpose: name and club of active players aged 13+, with club opt-out.</a:t>
+              <a:t>Purpose: account and payment data needed to provide the paid service.</a:t>
             </a:r>
           </a:p>
           <a:p>
@@ -6025,7 +6139,7 @@
                 </a:solidFill>
                 <a:latin typeface="Calibri"/>
               </a:rPr>
-              <a:t>ICO: legitimate interests APPROPRIATE.</a:t>
+              <a:t>Notice (EEA/UK): contractual necessity.</a:t>
             </a:r>
           </a:p>
           <a:p>
@@ -6044,7 +6158,7 @@
                 </a:solidFill>
                 <a:latin typeface="Calibri"/>
               </a:rPr>
-              <a:t>NFF is not a public authority, so public task does not fit.</a:t>
+              <a:t>ICO: contract APPROPRIATE. Consent marked likely invalid for this purpose.</a:t>
             </a:r>
           </a:p>
           <a:p>
@@ -6063,7 +6177,7 @@
                 </a:solidFill>
                 <a:latin typeface="Calibri"/>
               </a:rPr>
-              <a:t>FIKS membership is a different purpose and was not this run.</a:t>
+              <a:t>Ads and marketing in the same notice were left out.</a:t>
             </a:r>
           </a:p>
         </p:txBody>
@@ -6176,7 +6290,7 @@
                 </a:solidFill>
                 <a:latin typeface="Calibri"/>
               </a:rPr>
-              <a:t>12 / 16</a:t>
+              <a:t>12 / 17</a:t>
             </a:r>
           </a:p>
         </p:txBody>
@@ -6393,99 +6507,21 @@
                 </a:solidFill>
                 <a:latin typeface="Calibri"/>
               </a:rPr>
-              <a:t>document.no: Google Signals</a:t>
-            </a:r>
-          </a:p>
-        </p:txBody>
-      </p:sp>
-      <p:sp>
-        <p:nvSpPr>
-          <p:cNvPr id="7" name="Rectangle 6"/>
-          <p:cNvSpPr/>
-          <p:nvPr/>
-        </p:nvSpPr>
-        <p:spPr>
-          <a:xfrm>
-            <a:off x="457200" y="1371600"/>
-            <a:ext cx="11247120" cy="1051560"/>
-          </a:xfrm>
-          <a:prstGeom prst="rect">
-            <a:avLst/>
-          </a:prstGeom>
-          <a:solidFill>
-            <a:srgbClr val="FFF1D1"/>
-          </a:solidFill>
-          <a:ln>
-            <a:noFill/>
-          </a:ln>
-        </p:spPr>
-        <p:style>
-          <a:lnRef idx="1">
-            <a:schemeClr val="accent1"/>
-          </a:lnRef>
-          <a:fillRef idx="3">
-            <a:schemeClr val="accent1"/>
-          </a:fillRef>
-          <a:effectRef idx="2">
-            <a:schemeClr val="accent1"/>
-          </a:effectRef>
-          <a:fontRef idx="minor">
-            <a:schemeClr val="lt1"/>
-          </a:fontRef>
-        </p:style>
-        <p:txBody>
-          <a:bodyPr rtlCol="0" anchor="ctr"/>
-          <a:lstStyle/>
-          <a:p>
-            <a:pPr algn="ctr"/>
-          </a:p>
-        </p:txBody>
-      </p:sp>
-      <p:sp>
-        <p:nvSpPr>
-          <p:cNvPr id="8" name="TextBox 7"/>
+              <a:t>fotball.no: match history</a:t>
+            </a:r>
+          </a:p>
+        </p:txBody>
+      </p:sp>
+      <p:sp>
+        <p:nvSpPr>
+          <p:cNvPr id="7" name="TextBox 6"/>
           <p:cNvSpPr txBox="1"/>
           <p:nvPr/>
         </p:nvSpPr>
         <p:spPr>
           <a:xfrm>
-            <a:off x="640080" y="1554480"/>
-            <a:ext cx="10972800" cy="731520"/>
-          </a:xfrm>
-          <a:prstGeom prst="rect">
-            <a:avLst/>
-          </a:prstGeom>
-          <a:noFill/>
-        </p:spPr>
-        <p:txBody>
-          <a:bodyPr wrap="square">
-            <a:spAutoFit/>
-          </a:bodyPr>
-          <a:lstStyle/>
-          <a:p>
-            <a:pPr algn="l"/>
-            <a:r>
-              <a:rPr sz="2200" b="1" i="0">
-                <a:solidFill>
-                  <a:srgbClr val="1B365D"/>
-                </a:solidFill>
-                <a:latin typeface="Calibri"/>
-              </a:rPr>
-              <a:t>ICO: no basis APPROPRIATE. Consent INCONCLUSIVE. Match: Partial.</a:t>
-            </a:r>
-          </a:p>
-        </p:txBody>
-      </p:sp>
-      <p:sp>
-        <p:nvSpPr>
-          <p:cNvPr id="9" name="TextBox 8"/>
-          <p:cNvSpPr txBox="1"/>
-          <p:nvPr/>
-        </p:nvSpPr>
-        <p:spPr>
-          <a:xfrm>
-            <a:off x="502920" y="2651760"/>
-            <a:ext cx="11155680" cy="3474720"/>
+            <a:off x="502920" y="1371600"/>
+            <a:ext cx="11155680" cy="5029200"/>
           </a:xfrm>
           <a:prstGeom prst="rect">
             <a:avLst/>
@@ -6513,7 +6549,7 @@
                 </a:solidFill>
                 <a:latin typeface="Calibri"/>
               </a:rPr>
-              <a:t>•  Purpose: advertising analytics from site activity.</a:t>
+              <a:t>Purpose: name and club of active players aged 13+, with club opt-out.</a:t>
             </a:r>
           </a:p>
           <a:p>
@@ -6532,7 +6568,7 @@
                 </a:solidFill>
                 <a:latin typeface="Calibri"/>
               </a:rPr>
-              <a:t>•  The notice does not name Article 6. It looks like consent.</a:t>
+              <a:t>ICO: legitimate interests APPROPRIATE.</a:t>
             </a:r>
           </a:p>
           <a:p>
@@ -6551,7 +6587,7 @@
                 </a:solidFill>
                 <a:latin typeface="Calibri"/>
               </a:rPr>
-              <a:t>•  ICO: the request is not clear, prominent and separate from terms.</a:t>
+              <a:t>NFF is not a public authority, so public task does not fit.</a:t>
             </a:r>
           </a:p>
           <a:p>
@@ -6570,14 +6606,14 @@
                 </a:solidFill>
                 <a:latin typeface="Calibri"/>
               </a:rPr>
-              <a:t>•  The choice sits in Google settings. Pluss terms also bundle the notice.</a:t>
-            </a:r>
-          </a:p>
-        </p:txBody>
-      </p:sp>
-      <p:sp>
-        <p:nvSpPr>
-          <p:cNvPr id="10" name="Rectangle 9"/>
+              <a:t>FIKS membership is a different purpose and was not this run.</a:t>
+            </a:r>
+          </a:p>
+        </p:txBody>
+      </p:sp>
+      <p:sp>
+        <p:nvSpPr>
+          <p:cNvPr id="8" name="Rectangle 7"/>
           <p:cNvSpPr/>
           <p:nvPr/>
         </p:nvSpPr>
@@ -6620,7 +6656,7 @@
       </p:sp>
       <p:sp>
         <p:nvSpPr>
-          <p:cNvPr id="11" name="TextBox 10"/>
+          <p:cNvPr id="9" name="TextBox 8"/>
           <p:cNvSpPr txBox="1"/>
           <p:nvPr/>
         </p:nvSpPr>
@@ -6655,7 +6691,7 @@
       </p:sp>
       <p:sp>
         <p:nvSpPr>
-          <p:cNvPr id="12" name="TextBox 11"/>
+          <p:cNvPr id="10" name="TextBox 9"/>
           <p:cNvSpPr txBox="1"/>
           <p:nvPr/>
         </p:nvSpPr>
@@ -6683,7 +6719,7 @@
                 </a:solidFill>
                 <a:latin typeface="Calibri"/>
               </a:rPr>
-              <a:t>13 / 16</a:t>
+              <a:t>13 / 17</a:t>
             </a:r>
           </a:p>
         </p:txBody>
@@ -6900,21 +6936,99 @@
                 </a:solidFill>
                 <a:latin typeface="Calibri"/>
               </a:rPr>
-              <a:t>babyshop.no: checkout</a:t>
-            </a:r>
-          </a:p>
-        </p:txBody>
-      </p:sp>
-      <p:sp>
-        <p:nvSpPr>
-          <p:cNvPr id="7" name="TextBox 6"/>
+              <a:t>document.no: Google Signals</a:t>
+            </a:r>
+          </a:p>
+        </p:txBody>
+      </p:sp>
+      <p:sp>
+        <p:nvSpPr>
+          <p:cNvPr id="7" name="Rectangle 6"/>
+          <p:cNvSpPr/>
+          <p:nvPr/>
+        </p:nvSpPr>
+        <p:spPr>
+          <a:xfrm>
+            <a:off x="457200" y="1371600"/>
+            <a:ext cx="11247120" cy="1051560"/>
+          </a:xfrm>
+          <a:prstGeom prst="rect">
+            <a:avLst/>
+          </a:prstGeom>
+          <a:solidFill>
+            <a:srgbClr val="FFF1D1"/>
+          </a:solidFill>
+          <a:ln>
+            <a:noFill/>
+          </a:ln>
+        </p:spPr>
+        <p:style>
+          <a:lnRef idx="1">
+            <a:schemeClr val="accent1"/>
+          </a:lnRef>
+          <a:fillRef idx="3">
+            <a:schemeClr val="accent1"/>
+          </a:fillRef>
+          <a:effectRef idx="2">
+            <a:schemeClr val="accent1"/>
+          </a:effectRef>
+          <a:fontRef idx="minor">
+            <a:schemeClr val="lt1"/>
+          </a:fontRef>
+        </p:style>
+        <p:txBody>
+          <a:bodyPr rtlCol="0" anchor="ctr"/>
+          <a:lstStyle/>
+          <a:p>
+            <a:pPr algn="ctr"/>
+          </a:p>
+        </p:txBody>
+      </p:sp>
+      <p:sp>
+        <p:nvSpPr>
+          <p:cNvPr id="8" name="TextBox 7"/>
           <p:cNvSpPr txBox="1"/>
           <p:nvPr/>
         </p:nvSpPr>
         <p:spPr>
           <a:xfrm>
-            <a:off x="502920" y="1371600"/>
-            <a:ext cx="11155680" cy="5029200"/>
+            <a:off x="640080" y="1554480"/>
+            <a:ext cx="10972800" cy="731520"/>
+          </a:xfrm>
+          <a:prstGeom prst="rect">
+            <a:avLst/>
+          </a:prstGeom>
+          <a:noFill/>
+        </p:spPr>
+        <p:txBody>
+          <a:bodyPr wrap="square">
+            <a:spAutoFit/>
+          </a:bodyPr>
+          <a:lstStyle/>
+          <a:p>
+            <a:pPr algn="l"/>
+            <a:r>
+              <a:rPr sz="2200" b="1" i="0">
+                <a:solidFill>
+                  <a:srgbClr val="1B365D"/>
+                </a:solidFill>
+                <a:latin typeface="Calibri"/>
+              </a:rPr>
+              <a:t>ICO: no basis APPROPRIATE. Consent INCONCLUSIVE. Match: Partial.</a:t>
+            </a:r>
+          </a:p>
+        </p:txBody>
+      </p:sp>
+      <p:sp>
+        <p:nvSpPr>
+          <p:cNvPr id="9" name="TextBox 8"/>
+          <p:cNvSpPr txBox="1"/>
+          <p:nvPr/>
+        </p:nvSpPr>
+        <p:spPr>
+          <a:xfrm>
+            <a:off x="502920" y="2651760"/>
+            <a:ext cx="11155680" cy="3474720"/>
           </a:xfrm>
           <a:prstGeom prst="rect">
             <a:avLst/>
@@ -6942,7 +7056,7 @@
                 </a:solidFill>
                 <a:latin typeface="Calibri"/>
               </a:rPr>
-              <a:t>Purpose: name, address, contact, order and payment to deliver goods.</a:t>
+              <a:t>•  Purpose: advertising analytics from site activity.</a:t>
             </a:r>
           </a:p>
           <a:p>
@@ -6961,7 +7075,7 @@
                 </a:solidFill>
                 <a:latin typeface="Calibri"/>
               </a:rPr>
-              <a:t>The sales terms are a purchase contract.</a:t>
+              <a:t>•  The notice does not name Article 6. It looks like consent.</a:t>
             </a:r>
           </a:p>
           <a:p>
@@ -6980,7 +7094,7 @@
                 </a:solidFill>
                 <a:latin typeface="Calibri"/>
               </a:rPr>
-              <a:t>ICO: contract APPROPRIATE. Match: Yes for checkout.</a:t>
+              <a:t>•  ICO: the request is not clear, prominent and separate from terms.</a:t>
             </a:r>
           </a:p>
           <a:p>
@@ -6999,14 +7113,14 @@
                 </a:solidFill>
                 <a:latin typeface="Calibri"/>
               </a:rPr>
-              <a:t>The notice does not label Article 6(1)(b). Marketing is a separate purpose.</a:t>
-            </a:r>
-          </a:p>
-        </p:txBody>
-      </p:sp>
-      <p:sp>
-        <p:nvSpPr>
-          <p:cNvPr id="8" name="Rectangle 7"/>
+              <a:t>•  The choice sits in Google settings. Pluss terms also bundle the notice.</a:t>
+            </a:r>
+          </a:p>
+        </p:txBody>
+      </p:sp>
+      <p:sp>
+        <p:nvSpPr>
+          <p:cNvPr id="10" name="Rectangle 9"/>
           <p:cNvSpPr/>
           <p:nvPr/>
         </p:nvSpPr>
@@ -7049,7 +7163,7 @@
       </p:sp>
       <p:sp>
         <p:nvSpPr>
-          <p:cNvPr id="9" name="TextBox 8"/>
+          <p:cNvPr id="11" name="TextBox 10"/>
           <p:cNvSpPr txBox="1"/>
           <p:nvPr/>
         </p:nvSpPr>
@@ -7084,7 +7198,7 @@
       </p:sp>
       <p:sp>
         <p:nvSpPr>
-          <p:cNvPr id="10" name="TextBox 9"/>
+          <p:cNvPr id="12" name="TextBox 11"/>
           <p:cNvSpPr txBox="1"/>
           <p:nvPr/>
         </p:nvSpPr>
@@ -7112,7 +7226,7 @@
                 </a:solidFill>
                 <a:latin typeface="Calibri"/>
               </a:rPr>
-              <a:t>14 / 16</a:t>
+              <a:t>14 / 17</a:t>
             </a:r>
           </a:p>
         </p:txBody>
@@ -7294,7 +7408,7 @@
                 </a:solidFill>
                 <a:latin typeface="Calibri"/>
               </a:rPr>
-              <a:t>Close</a:t>
+              <a:t>Part 2</a:t>
             </a:r>
           </a:p>
         </p:txBody>
@@ -7329,64 +7443,21 @@
                 </a:solidFill>
                 <a:latin typeface="Calibri"/>
               </a:rPr>
-              <a:t>What the report shows</a:t>
-            </a:r>
-          </a:p>
-        </p:txBody>
-      </p:sp>
-      <p:sp>
-        <p:nvSpPr>
-          <p:cNvPr id="7" name="Rectangle 6"/>
-          <p:cNvSpPr/>
-          <p:nvPr/>
-        </p:nvSpPr>
-        <p:spPr>
-          <a:xfrm>
-            <a:off x="457200" y="1417320"/>
-            <a:ext cx="11247120" cy="4434840"/>
-          </a:xfrm>
-          <a:prstGeom prst="rect">
-            <a:avLst/>
-          </a:prstGeom>
-          <a:solidFill>
-            <a:srgbClr val="FFF1D1"/>
-          </a:solidFill>
-          <a:ln>
-            <a:noFill/>
-          </a:ln>
-        </p:spPr>
-        <p:style>
-          <a:lnRef idx="1">
-            <a:schemeClr val="accent1"/>
-          </a:lnRef>
-          <a:fillRef idx="3">
-            <a:schemeClr val="accent1"/>
-          </a:fillRef>
-          <a:effectRef idx="2">
-            <a:schemeClr val="accent1"/>
-          </a:effectRef>
-          <a:fontRef idx="minor">
-            <a:schemeClr val="lt1"/>
-          </a:fontRef>
-        </p:style>
-        <p:txBody>
-          <a:bodyPr rtlCol="0" anchor="ctr"/>
-          <a:lstStyle/>
-          <a:p>
-            <a:pPr algn="ctr"/>
-          </a:p>
-        </p:txBody>
-      </p:sp>
-      <p:sp>
-        <p:nvSpPr>
-          <p:cNvPr id="8" name="TextBox 7"/>
+              <a:t>babyshop.no: checkout</a:t>
+            </a:r>
+          </a:p>
+        </p:txBody>
+      </p:sp>
+      <p:sp>
+        <p:nvSpPr>
+          <p:cNvPr id="7" name="TextBox 6"/>
           <p:cNvSpPr txBox="1"/>
           <p:nvPr/>
         </p:nvSpPr>
         <p:spPr>
           <a:xfrm>
-            <a:off x="685800" y="1691640"/>
-            <a:ext cx="10789920" cy="3977639"/>
+            <a:off x="502920" y="1371600"/>
+            <a:ext cx="11155680" cy="5029200"/>
           </a:xfrm>
           <a:prstGeom prst="rect">
             <a:avLst/>
@@ -7404,17 +7475,17 @@
                 <a:spcPts val="0"/>
               </a:spcBef>
               <a:spcAft>
-                <a:spcPts val="1600"/>
+                <a:spcPts val="1200"/>
               </a:spcAft>
             </a:pPr>
             <a:r>
-              <a:rPr sz="2200" b="0" i="0">
-                <a:solidFill>
-                  <a:srgbClr val="1B365D"/>
-                </a:solidFill>
-                <a:latin typeface="Calibri"/>
-              </a:rPr>
-              <a:t>We measured how much 18 Norwegian sites contact others when they load, and we checked whether five of them have a valid GDPR basis for one specific purpose.</a:t>
+              <a:rPr sz="2000" b="0" i="0">
+                <a:solidFill>
+                  <a:srgbClr val="1A1A1A"/>
+                </a:solidFill>
+                <a:latin typeface="Calibri"/>
+              </a:rPr>
+              <a:t>Purpose: name, address, contact, order and payment to deliver goods.</a:t>
             </a:r>
           </a:p>
           <a:p>
@@ -7423,17 +7494,17 @@
                 <a:spcPts val="0"/>
               </a:spcBef>
               <a:spcAft>
-                <a:spcPts val="1600"/>
+                <a:spcPts val="1200"/>
               </a:spcAft>
             </a:pPr>
             <a:r>
-              <a:rPr sz="2200" b="0" i="0">
-                <a:solidFill>
-                  <a:srgbClr val="1B365D"/>
-                </a:solidFill>
-                <a:latin typeface="Calibri"/>
-              </a:rPr>
-              <a:t>Many sites reach out to many others without setting cookies.</a:t>
+              <a:rPr sz="2000" b="0" i="0">
+                <a:solidFill>
+                  <a:srgbClr val="1A1A1A"/>
+                </a:solidFill>
+                <a:latin typeface="Calibri"/>
+              </a:rPr>
+              <a:t>The sales terms are a purchase contract.</a:t>
             </a:r>
           </a:p>
           <a:p>
@@ -7442,17 +7513,17 @@
                 <a:spcPts val="0"/>
               </a:spcBef>
               <a:spcAft>
-                <a:spcPts val="1600"/>
+                <a:spcPts val="1200"/>
               </a:spcAft>
             </a:pPr>
             <a:r>
-              <a:rPr sz="2200" b="0" i="0">
-                <a:solidFill>
-                  <a:srgbClr val="1B365D"/>
-                </a:solidFill>
-                <a:latin typeface="Calibri"/>
-              </a:rPr>
-              <a:t>Four of five ICO purposes match the notice.</a:t>
+              <a:rPr sz="2000" b="0" i="0">
+                <a:solidFill>
+                  <a:srgbClr val="1A1A1A"/>
+                </a:solidFill>
+                <a:latin typeface="Calibri"/>
+              </a:rPr>
+              <a:t>ICO: contract APPROPRIATE. Match: Yes for checkout.</a:t>
             </a:r>
           </a:p>
           <a:p>
@@ -7461,24 +7532,24 @@
                 <a:spcPts val="0"/>
               </a:spcBef>
               <a:spcAft>
-                <a:spcPts val="0"/>
+                <a:spcPts val="1200"/>
               </a:spcAft>
             </a:pPr>
             <a:r>
-              <a:rPr sz="2200" b="0" i="0">
-                <a:solidFill>
-                  <a:srgbClr val="1B365D"/>
-                </a:solidFill>
-                <a:latin typeface="Calibri"/>
-              </a:rPr>
-              <a:t>In two places where the site claims consent, the ICO is not satisfied with how consent is formulated.</a:t>
-            </a:r>
-          </a:p>
-        </p:txBody>
-      </p:sp>
-      <p:sp>
-        <p:nvSpPr>
-          <p:cNvPr id="9" name="Rectangle 8"/>
+              <a:rPr sz="2000" b="0" i="0">
+                <a:solidFill>
+                  <a:srgbClr val="1A1A1A"/>
+                </a:solidFill>
+                <a:latin typeface="Calibri"/>
+              </a:rPr>
+              <a:t>The notice does not label Article 6(1)(b). Marketing is a separate purpose.</a:t>
+            </a:r>
+          </a:p>
+        </p:txBody>
+      </p:sp>
+      <p:sp>
+        <p:nvSpPr>
+          <p:cNvPr id="8" name="Rectangle 7"/>
           <p:cNvSpPr/>
           <p:nvPr/>
         </p:nvSpPr>
@@ -7521,7 +7592,7 @@
       </p:sp>
       <p:sp>
         <p:nvSpPr>
-          <p:cNvPr id="10" name="TextBox 9"/>
+          <p:cNvPr id="9" name="TextBox 8"/>
           <p:cNvSpPr txBox="1"/>
           <p:nvPr/>
         </p:nvSpPr>
@@ -7556,7 +7627,7 @@
       </p:sp>
       <p:sp>
         <p:nvSpPr>
-          <p:cNvPr id="11" name="TextBox 10"/>
+          <p:cNvPr id="10" name="TextBox 9"/>
           <p:cNvSpPr txBox="1"/>
           <p:nvPr/>
         </p:nvSpPr>
@@ -7584,7 +7655,7 @@
                 </a:solidFill>
                 <a:latin typeface="Calibri"/>
               </a:rPr>
-              <a:t>15 / 16</a:t>
+              <a:t>15 / 17</a:t>
             </a:r>
           </a:p>
         </p:txBody>
@@ -7622,6 +7693,478 @@
             <a:avLst/>
           </a:prstGeom>
           <a:solidFill>
+            <a:srgbClr val="FFFEFB"/>
+          </a:solidFill>
+          <a:ln>
+            <a:noFill/>
+          </a:ln>
+        </p:spPr>
+        <p:style>
+          <a:lnRef idx="1">
+            <a:schemeClr val="accent1"/>
+          </a:lnRef>
+          <a:fillRef idx="3">
+            <a:schemeClr val="accent1"/>
+          </a:fillRef>
+          <a:effectRef idx="2">
+            <a:schemeClr val="accent1"/>
+          </a:effectRef>
+          <a:fontRef idx="minor">
+            <a:schemeClr val="lt1"/>
+          </a:fontRef>
+        </p:style>
+        <p:txBody>
+          <a:bodyPr rtlCol="0" anchor="ctr"/>
+          <a:lstStyle/>
+          <a:p>
+            <a:pPr algn="ctr"/>
+          </a:p>
+        </p:txBody>
+      </p:sp>
+      <p:sp>
+        <p:nvSpPr>
+          <p:cNvPr id="3" name="Rectangle 2"/>
+          <p:cNvSpPr/>
+          <p:nvPr/>
+        </p:nvSpPr>
+        <p:spPr>
+          <a:xfrm>
+            <a:off x="0" y="0"/>
+            <a:ext cx="12191695" cy="1051560"/>
+          </a:xfrm>
+          <a:prstGeom prst="rect">
+            <a:avLst/>
+          </a:prstGeom>
+          <a:solidFill>
+            <a:srgbClr val="1B365D"/>
+          </a:solidFill>
+          <a:ln>
+            <a:noFill/>
+          </a:ln>
+        </p:spPr>
+        <p:style>
+          <a:lnRef idx="1">
+            <a:schemeClr val="accent1"/>
+          </a:lnRef>
+          <a:fillRef idx="3">
+            <a:schemeClr val="accent1"/>
+          </a:fillRef>
+          <a:effectRef idx="2">
+            <a:schemeClr val="accent1"/>
+          </a:effectRef>
+          <a:fontRef idx="minor">
+            <a:schemeClr val="lt1"/>
+          </a:fontRef>
+        </p:style>
+        <p:txBody>
+          <a:bodyPr rtlCol="0" anchor="ctr"/>
+          <a:lstStyle/>
+          <a:p>
+            <a:pPr algn="ctr"/>
+          </a:p>
+        </p:txBody>
+      </p:sp>
+      <p:sp>
+        <p:nvSpPr>
+          <p:cNvPr id="4" name="Rectangle 3"/>
+          <p:cNvSpPr/>
+          <p:nvPr/>
+        </p:nvSpPr>
+        <p:spPr>
+          <a:xfrm>
+            <a:off x="0" y="1051560"/>
+            <a:ext cx="12191695" cy="73152"/>
+          </a:xfrm>
+          <a:prstGeom prst="rect">
+            <a:avLst/>
+          </a:prstGeom>
+          <a:solidFill>
+            <a:srgbClr val="FFF1D1"/>
+          </a:solidFill>
+          <a:ln>
+            <a:noFill/>
+          </a:ln>
+        </p:spPr>
+        <p:style>
+          <a:lnRef idx="1">
+            <a:schemeClr val="accent1"/>
+          </a:lnRef>
+          <a:fillRef idx="3">
+            <a:schemeClr val="accent1"/>
+          </a:fillRef>
+          <a:effectRef idx="2">
+            <a:schemeClr val="accent1"/>
+          </a:effectRef>
+          <a:fontRef idx="minor">
+            <a:schemeClr val="lt1"/>
+          </a:fontRef>
+        </p:style>
+        <p:txBody>
+          <a:bodyPr rtlCol="0" anchor="ctr"/>
+          <a:lstStyle/>
+          <a:p>
+            <a:pPr algn="ctr"/>
+          </a:p>
+        </p:txBody>
+      </p:sp>
+      <p:sp>
+        <p:nvSpPr>
+          <p:cNvPr id="5" name="TextBox 4"/>
+          <p:cNvSpPr txBox="1"/>
+          <p:nvPr/>
+        </p:nvSpPr>
+        <p:spPr>
+          <a:xfrm>
+            <a:off x="457200" y="109728"/>
+            <a:ext cx="11247120" cy="292608"/>
+          </a:xfrm>
+          <a:prstGeom prst="rect">
+            <a:avLst/>
+          </a:prstGeom>
+          <a:noFill/>
+        </p:spPr>
+        <p:txBody>
+          <a:bodyPr wrap="square">
+            <a:spAutoFit/>
+          </a:bodyPr>
+          <a:lstStyle/>
+          <a:p>
+            <a:pPr algn="l"/>
+            <a:r>
+              <a:rPr sz="1200" b="1" i="0">
+                <a:solidFill>
+                  <a:srgbClr val="FFF1D1"/>
+                </a:solidFill>
+                <a:latin typeface="Calibri"/>
+              </a:rPr>
+              <a:t>Close</a:t>
+            </a:r>
+          </a:p>
+        </p:txBody>
+      </p:sp>
+      <p:sp>
+        <p:nvSpPr>
+          <p:cNvPr id="6" name="TextBox 5"/>
+          <p:cNvSpPr txBox="1"/>
+          <p:nvPr/>
+        </p:nvSpPr>
+        <p:spPr>
+          <a:xfrm>
+            <a:off x="457200" y="384048"/>
+            <a:ext cx="11247120" cy="566928"/>
+          </a:xfrm>
+          <a:prstGeom prst="rect">
+            <a:avLst/>
+          </a:prstGeom>
+          <a:noFill/>
+        </p:spPr>
+        <p:txBody>
+          <a:bodyPr wrap="square">
+            <a:spAutoFit/>
+          </a:bodyPr>
+          <a:lstStyle/>
+          <a:p>
+            <a:pPr algn="l"/>
+            <a:r>
+              <a:rPr sz="2800" b="1" i="0">
+                <a:solidFill>
+                  <a:srgbClr val="FFFFFF"/>
+                </a:solidFill>
+                <a:latin typeface="Calibri"/>
+              </a:rPr>
+              <a:t>What the report shows</a:t>
+            </a:r>
+          </a:p>
+        </p:txBody>
+      </p:sp>
+      <p:sp>
+        <p:nvSpPr>
+          <p:cNvPr id="7" name="Rectangle 6"/>
+          <p:cNvSpPr/>
+          <p:nvPr/>
+        </p:nvSpPr>
+        <p:spPr>
+          <a:xfrm>
+            <a:off x="457200" y="1417320"/>
+            <a:ext cx="11247120" cy="4434840"/>
+          </a:xfrm>
+          <a:prstGeom prst="rect">
+            <a:avLst/>
+          </a:prstGeom>
+          <a:solidFill>
+            <a:srgbClr val="FFF1D1"/>
+          </a:solidFill>
+          <a:ln>
+            <a:noFill/>
+          </a:ln>
+        </p:spPr>
+        <p:style>
+          <a:lnRef idx="1">
+            <a:schemeClr val="accent1"/>
+          </a:lnRef>
+          <a:fillRef idx="3">
+            <a:schemeClr val="accent1"/>
+          </a:fillRef>
+          <a:effectRef idx="2">
+            <a:schemeClr val="accent1"/>
+          </a:effectRef>
+          <a:fontRef idx="minor">
+            <a:schemeClr val="lt1"/>
+          </a:fontRef>
+        </p:style>
+        <p:txBody>
+          <a:bodyPr rtlCol="0" anchor="ctr"/>
+          <a:lstStyle/>
+          <a:p>
+            <a:pPr algn="ctr"/>
+          </a:p>
+        </p:txBody>
+      </p:sp>
+      <p:sp>
+        <p:nvSpPr>
+          <p:cNvPr id="8" name="TextBox 7"/>
+          <p:cNvSpPr txBox="1"/>
+          <p:nvPr/>
+        </p:nvSpPr>
+        <p:spPr>
+          <a:xfrm>
+            <a:off x="685800" y="1691640"/>
+            <a:ext cx="10789920" cy="3977639"/>
+          </a:xfrm>
+          <a:prstGeom prst="rect">
+            <a:avLst/>
+          </a:prstGeom>
+          <a:noFill/>
+        </p:spPr>
+        <p:txBody>
+          <a:bodyPr wrap="square">
+            <a:spAutoFit/>
+          </a:bodyPr>
+          <a:lstStyle/>
+          <a:p>
+            <a:pPr algn="l">
+              <a:spcBef>
+                <a:spcPts val="0"/>
+              </a:spcBef>
+              <a:spcAft>
+                <a:spcPts val="1600"/>
+              </a:spcAft>
+            </a:pPr>
+            <a:r>
+              <a:rPr sz="2200" b="0" i="0">
+                <a:solidFill>
+                  <a:srgbClr val="1B365D"/>
+                </a:solidFill>
+                <a:latin typeface="Calibri"/>
+              </a:rPr>
+              <a:t>We measured how much 18 Norwegian sites contact others when they load, and we checked whether five of them have a valid GDPR basis for one specific purpose.</a:t>
+            </a:r>
+          </a:p>
+          <a:p>
+            <a:pPr algn="l">
+              <a:spcBef>
+                <a:spcPts val="0"/>
+              </a:spcBef>
+              <a:spcAft>
+                <a:spcPts val="1600"/>
+              </a:spcAft>
+            </a:pPr>
+            <a:r>
+              <a:rPr sz="2200" b="0" i="0">
+                <a:solidFill>
+                  <a:srgbClr val="1B365D"/>
+                </a:solidFill>
+                <a:latin typeface="Calibri"/>
+              </a:rPr>
+              <a:t>Many sites reach out to many others without setting cookies.</a:t>
+            </a:r>
+          </a:p>
+          <a:p>
+            <a:pPr algn="l">
+              <a:spcBef>
+                <a:spcPts val="0"/>
+              </a:spcBef>
+              <a:spcAft>
+                <a:spcPts val="1600"/>
+              </a:spcAft>
+            </a:pPr>
+            <a:r>
+              <a:rPr sz="2200" b="0" i="0">
+                <a:solidFill>
+                  <a:srgbClr val="1B365D"/>
+                </a:solidFill>
+                <a:latin typeface="Calibri"/>
+              </a:rPr>
+              <a:t>Four of five ICO purposes match the notice.</a:t>
+            </a:r>
+          </a:p>
+          <a:p>
+            <a:pPr algn="l">
+              <a:spcBef>
+                <a:spcPts val="0"/>
+              </a:spcBef>
+              <a:spcAft>
+                <a:spcPts val="0"/>
+              </a:spcAft>
+            </a:pPr>
+            <a:r>
+              <a:rPr sz="2200" b="0" i="0">
+                <a:solidFill>
+                  <a:srgbClr val="1B365D"/>
+                </a:solidFill>
+                <a:latin typeface="Calibri"/>
+              </a:rPr>
+              <a:t>In two places where the site claims consent, the ICO is not satisfied with how consent is formulated.</a:t>
+            </a:r>
+          </a:p>
+        </p:txBody>
+      </p:sp>
+      <p:sp>
+        <p:nvSpPr>
+          <p:cNvPr id="9" name="Rectangle 8"/>
+          <p:cNvSpPr/>
+          <p:nvPr/>
+        </p:nvSpPr>
+        <p:spPr>
+          <a:xfrm>
+            <a:off x="0" y="6656832"/>
+            <a:ext cx="12191695" cy="201168"/>
+          </a:xfrm>
+          <a:prstGeom prst="rect">
+            <a:avLst/>
+          </a:prstGeom>
+          <a:solidFill>
+            <a:srgbClr val="1B365D"/>
+          </a:solidFill>
+          <a:ln>
+            <a:noFill/>
+          </a:ln>
+        </p:spPr>
+        <p:style>
+          <a:lnRef idx="1">
+            <a:schemeClr val="accent1"/>
+          </a:lnRef>
+          <a:fillRef idx="3">
+            <a:schemeClr val="accent1"/>
+          </a:fillRef>
+          <a:effectRef idx="2">
+            <a:schemeClr val="accent1"/>
+          </a:effectRef>
+          <a:fontRef idx="minor">
+            <a:schemeClr val="lt1"/>
+          </a:fontRef>
+        </p:style>
+        <p:txBody>
+          <a:bodyPr rtlCol="0" anchor="ctr"/>
+          <a:lstStyle/>
+          <a:p>
+            <a:pPr algn="ctr"/>
+          </a:p>
+        </p:txBody>
+      </p:sp>
+      <p:sp>
+        <p:nvSpPr>
+          <p:cNvPr id="10" name="TextBox 9"/>
+          <p:cNvSpPr txBox="1"/>
+          <p:nvPr/>
+        </p:nvSpPr>
+        <p:spPr>
+          <a:xfrm>
+            <a:off x="365760" y="6656832"/>
+            <a:ext cx="9144000" cy="201168"/>
+          </a:xfrm>
+          <a:prstGeom prst="rect">
+            <a:avLst/>
+          </a:prstGeom>
+          <a:noFill/>
+        </p:spPr>
+        <p:txBody>
+          <a:bodyPr wrap="square">
+            <a:spAutoFit/>
+          </a:bodyPr>
+          <a:lstStyle/>
+          <a:p>
+            <a:pPr algn="l"/>
+            <a:r>
+              <a:rPr sz="1000" b="0" i="0">
+                <a:solidFill>
+                  <a:srgbClr val="FFFFFF"/>
+                </a:solidFill>
+                <a:latin typeface="Calibri"/>
+              </a:rPr>
+              <a:t>ACIT4280 Group Assignment 1A  |  3 Sep 2026</a:t>
+            </a:r>
+          </a:p>
+        </p:txBody>
+      </p:sp>
+      <p:sp>
+        <p:nvSpPr>
+          <p:cNvPr id="11" name="TextBox 10"/>
+          <p:cNvSpPr txBox="1"/>
+          <p:nvPr/>
+        </p:nvSpPr>
+        <p:spPr>
+          <a:xfrm>
+            <a:off x="10424160" y="6656832"/>
+            <a:ext cx="1371600" cy="201168"/>
+          </a:xfrm>
+          <a:prstGeom prst="rect">
+            <a:avLst/>
+          </a:prstGeom>
+          <a:noFill/>
+        </p:spPr>
+        <p:txBody>
+          <a:bodyPr wrap="square">
+            <a:spAutoFit/>
+          </a:bodyPr>
+          <a:lstStyle/>
+          <a:p>
+            <a:pPr algn="r"/>
+            <a:r>
+              <a:rPr sz="1000" b="0" i="0">
+                <a:solidFill>
+                  <a:srgbClr val="FFFFFF"/>
+                </a:solidFill>
+                <a:latin typeface="Calibri"/>
+              </a:rPr>
+              <a:t>16 / 17</a:t>
+            </a:r>
+          </a:p>
+        </p:txBody>
+      </p:sp>
+    </p:spTree>
+  </p:cSld>
+  <p:clrMapOvr>
+    <a:masterClrMapping/>
+  </p:clrMapOvr>
+</p:sld>
+</file>
+
+<file path=ppt/slides/slide17.xml><?xml version="1.0" encoding="utf-8"?>
+<p:sld xmlns:a="http://schemas.openxmlformats.org/drawingml/2006/main" xmlns:p="http://schemas.openxmlformats.org/presentationml/2006/main" xmlns:r="http://schemas.openxmlformats.org/officeDocument/2006/relationships">
+  <p:cSld>
+    <p:spTree>
+      <p:nvGrpSpPr>
+        <p:cNvPr id="1" name=""/>
+        <p:cNvGrpSpPr/>
+        <p:nvPr/>
+      </p:nvGrpSpPr>
+      <p:grpSpPr/>
+      <p:sp>
+        <p:nvSpPr>
+          <p:cNvPr id="2" name="Rectangle 1"/>
+          <p:cNvSpPr/>
+          <p:nvPr/>
+        </p:nvSpPr>
+        <p:spPr>
+          <a:xfrm>
+            <a:off x="0" y="0"/>
+            <a:ext cx="12191695" cy="6858000"/>
+          </a:xfrm>
+          <a:prstGeom prst="rect">
+            <a:avLst/>
+          </a:prstGeom>
+          <a:solidFill>
             <a:srgbClr val="1B365D"/>
           </a:solidFill>
           <a:ln>
@@ -8399,7 +8942,7 @@
                 </a:solidFill>
                 <a:latin typeface="Calibri"/>
               </a:rPr>
-              <a:t>2 / 16</a:t>
+              <a:t>2 / 17</a:t>
             </a:r>
           </a:p>
         </p:txBody>
@@ -8828,7 +9371,7 @@
                 </a:solidFill>
                 <a:latin typeface="Calibri"/>
               </a:rPr>
-              <a:t>3 / 16</a:t>
+              <a:t>3 / 17</a:t>
             </a:r>
           </a:p>
         </p:txBody>
@@ -9550,7 +10093,7 @@
                 </a:solidFill>
                 <a:latin typeface="Calibri"/>
               </a:rPr>
-              <a:t>4 / 16</a:t>
+              <a:t>4 / 17</a:t>
             </a:r>
           </a:p>
         </p:txBody>
@@ -11115,7 +11658,7 @@
                 </a:solidFill>
                 <a:latin typeface="Calibri"/>
               </a:rPr>
-              <a:t>5 / 16</a:t>
+              <a:t>5 / 17</a:t>
             </a:r>
           </a:p>
         </p:txBody>
@@ -11552,7 +12095,7 @@
                 </a:solidFill>
                 <a:latin typeface="Calibri"/>
               </a:rPr>
-              <a:t>6 / 16</a:t>
+              <a:t>6 / 17</a:t>
             </a:r>
           </a:p>
         </p:txBody>
@@ -11965,7 +12508,7 @@
                 </a:solidFill>
                 <a:latin typeface="Calibri"/>
               </a:rPr>
-              <a:t>7 / 16</a:t>
+              <a:t>7 / 17</a:t>
             </a:r>
           </a:p>
         </p:txBody>
@@ -12394,7 +12937,7 @@
                 </a:solidFill>
                 <a:latin typeface="Calibri"/>
               </a:rPr>
-              <a:t>8 / 16</a:t>
+              <a:t>8 / 17</a:t>
             </a:r>
           </a:p>
         </p:txBody>
@@ -14943,7 +15486,7 @@
                 </a:solidFill>
                 <a:latin typeface="Calibri"/>
               </a:rPr>
-              <a:t>9 / 16</a:t>
+              <a:t>9 / 17</a:t>
             </a:r>
           </a:p>
         </p:txBody>

</xml_diff>

<commit_message>
Stram inn forskningsspørsmål i presentasjonen
Fjerner unødvendige formuleringer som Norwegian-facing og person
opens; kortere spørsmål på title slide og close slide.

Co-authored-by: Karina <kasa031@users.noreply.github.com>
</commit_message>
<xml_diff>
--- a/ACIT4280_1A_presentation.pptx
+++ b/ACIT4280_1A_presentation.pptx
@@ -4870,7 +4870,7 @@
                 </a:solidFill>
                 <a:latin typeface="Calibri"/>
               </a:rPr>
-              <a:t>When a person opens a Norwegian-facing front page, how many other companies does that page contact, and in which countries do those machines appear to sit?</a:t>
+              <a:t>When a front page loads, how many other companies does it contact, and in which countries do those machines appear to sit?</a:t>
             </a:r>
           </a:p>
           <a:p>
@@ -4889,7 +4889,7 @@
                 </a:solidFill>
                 <a:latin typeface="Calibri"/>
               </a:rPr>
-              <a:t>When a site uses personal data, has it named a GDPR Article 6 basis, and does that basis hold in the ICO tool?</a:t>
+              <a:t>When a site uses personal data, has it named a GDPR Article 6 basis, and does the ICO tool agree?</a:t>
             </a:r>
           </a:p>
         </p:txBody>
@@ -7957,7 +7957,7 @@
                 </a:solidFill>
                 <a:latin typeface="Calibri"/>
               </a:rPr>
-              <a:t>We measured how much 18 Norwegian sites contact others when they load, and we checked whether five of them have a valid GDPR basis for one specific purpose.</a:t>
+              <a:t>We measured how much 18 sites contact others on load, and we checked whether five of them have a valid GDPR basis for one specific purpose.</a:t>
             </a:r>
           </a:p>
           <a:p>

</xml_diff>

<commit_message>
Legg til bulletpoints og luft mellom spørsmål på forsideslide
De to forskningsspørsmålene på title slide er tydeligere markert
som separate punkter.

Co-authored-by: Karina <kasa031@users.noreply.github.com>
</commit_message>
<xml_diff>
--- a/ACIT4280_1A_presentation.pptx
+++ b/ACIT4280_1A_presentation.pptx
@@ -4842,7 +4842,7 @@
         <p:spPr>
           <a:xfrm>
             <a:off x="640080" y="3310128"/>
-            <a:ext cx="10972800" cy="1234440"/>
+            <a:ext cx="10972800" cy="1325880"/>
           </a:xfrm>
           <a:prstGeom prst="rect">
             <a:avLst/>
@@ -4860,7 +4860,7 @@
                 <a:spcPts val="0"/>
               </a:spcBef>
               <a:spcAft>
-                <a:spcPts val="800"/>
+                <a:spcPts val="1400"/>
               </a:spcAft>
             </a:pPr>
             <a:r>
@@ -4870,7 +4870,7 @@
                 </a:solidFill>
                 <a:latin typeface="Calibri"/>
               </a:rPr>
-              <a:t>When a front page loads, how many other companies does it contact, and in which countries do those machines appear to sit?</a:t>
+              <a:t>•  When a front page loads, how many other companies does it contact, and in which countries do those machines appear to sit?</a:t>
             </a:r>
           </a:p>
           <a:p>
@@ -4889,7 +4889,7 @@
                 </a:solidFill>
                 <a:latin typeface="Calibri"/>
               </a:rPr>
-              <a:t>When a site uses personal data, has it named a GDPR Article 6 basis, and does the ICO tool agree?</a:t>
+              <a:t>•  When a site uses personal data, has it named a GDPR Article 6 basis, and does the ICO tool agree?</a:t>
             </a:r>
           </a:p>
         </p:txBody>

</xml_diff>

<commit_message>
Bruk Color Hunt-palett i presentasjonen
Erstatter navy/cream med fire farger (#224248, #325E6A, #44A1A4, #FF9A00)
i PPTX, HTML og PDF.

Co-authored-by: Karina <kasa031@users.noreply.github.com>
</commit_message>
<xml_diff>
--- a/ACIT4280_1A_presentation.pptx
+++ b/ACIT4280_1A_presentation.pptx
@@ -4655,7 +4655,7 @@
             <a:avLst/>
           </a:prstGeom>
           <a:solidFill>
-            <a:srgbClr val="1B365D"/>
+            <a:srgbClr val="224248"/>
           </a:solidFill>
           <a:ln>
             <a:noFill/>
@@ -4698,7 +4698,7 @@
             <a:avLst/>
           </a:prstGeom>
           <a:solidFill>
-            <a:srgbClr val="FFF1D1"/>
+            <a:srgbClr val="FF9A00"/>
           </a:solidFill>
           <a:ln>
             <a:noFill/>
@@ -4752,7 +4752,7 @@
             <a:r>
               <a:rPr sz="1600" b="1" i="0">
                 <a:solidFill>
-                  <a:srgbClr val="FFF1D1"/>
+                  <a:srgbClr val="44A1A4"/>
                 </a:solidFill>
                 <a:latin typeface="Calibri"/>
               </a:rPr>
@@ -4787,7 +4787,7 @@
             <a:r>
               <a:rPr sz="2200" b="1" i="0">
                 <a:solidFill>
-                  <a:srgbClr val="FFF1D1"/>
+                  <a:srgbClr val="44A1A4"/>
                 </a:solidFill>
                 <a:latin typeface="Calibri"/>
               </a:rPr>
@@ -4866,7 +4866,7 @@
             <a:r>
               <a:rPr sz="1500" b="0" i="0">
                 <a:solidFill>
-                  <a:srgbClr val="FFF1D1"/>
+                  <a:srgbClr val="FFFFFF"/>
                 </a:solidFill>
                 <a:latin typeface="Calibri"/>
               </a:rPr>
@@ -4885,7 +4885,7 @@
             <a:r>
               <a:rPr sz="1500" b="0" i="0">
                 <a:solidFill>
-                  <a:srgbClr val="FFF1D1"/>
+                  <a:srgbClr val="FFFFFF"/>
                 </a:solidFill>
                 <a:latin typeface="Calibri"/>
               </a:rPr>
@@ -4955,7 +4955,7 @@
             <a:r>
               <a:rPr sz="1600" b="0" i="0">
                 <a:solidFill>
-                  <a:srgbClr val="1B365D"/>
+                  <a:srgbClr val="224248"/>
                 </a:solidFill>
                 <a:latin typeface="Calibri"/>
               </a:rPr>
@@ -5041,7 +5041,7 @@
             <a:avLst/>
           </a:prstGeom>
           <a:solidFill>
-            <a:srgbClr val="1B365D"/>
+            <a:srgbClr val="224248"/>
           </a:solidFill>
           <a:ln>
             <a:noFill/>
@@ -5084,7 +5084,7 @@
             <a:avLst/>
           </a:prstGeom>
           <a:solidFill>
-            <a:srgbClr val="FFF1D1"/>
+            <a:srgbClr val="FF9A00"/>
           </a:solidFill>
           <a:ln>
             <a:noFill/>
@@ -5138,7 +5138,7 @@
             <a:r>
               <a:rPr sz="1200" b="1" i="0">
                 <a:solidFill>
-                  <a:srgbClr val="FFF1D1"/>
+                  <a:srgbClr val="44A1A4"/>
                 </a:solidFill>
                 <a:latin typeface="Calibri"/>
               </a:rPr>
@@ -5197,7 +5197,7 @@
             <a:avLst/>
           </a:prstGeom>
           <a:solidFill>
-            <a:srgbClr val="FFF1D1"/>
+            <a:srgbClr val="44A1A4"/>
           </a:solidFill>
           <a:ln>
             <a:noFill/>
@@ -5258,7 +5258,7 @@
             <a:r>
               <a:rPr sz="2000" b="1" i="0">
                 <a:solidFill>
-                  <a:srgbClr val="1B365D"/>
+                  <a:srgbClr val="224248"/>
                 </a:solidFill>
                 <a:latin typeface="Calibri"/>
               </a:rPr>
@@ -5277,7 +5277,7 @@
             <a:r>
               <a:rPr sz="2000" b="1" i="0">
                 <a:solidFill>
-                  <a:srgbClr val="1B365D"/>
+                  <a:srgbClr val="FF9A00"/>
                 </a:solidFill>
                 <a:latin typeface="Calibri"/>
               </a:rPr>
@@ -5296,7 +5296,7 @@
             <a:r>
               <a:rPr sz="1800" b="0" i="0">
                 <a:solidFill>
-                  <a:srgbClr val="1B365D"/>
+                  <a:srgbClr val="224248"/>
                 </a:solidFill>
                 <a:latin typeface="Calibri"/>
               </a:rPr>
@@ -5315,7 +5315,7 @@
             <a:r>
               <a:rPr sz="1800" b="0" i="0">
                 <a:solidFill>
-                  <a:srgbClr val="1B365D"/>
+                  <a:srgbClr val="224248"/>
                 </a:solidFill>
                 <a:latin typeface="Calibri"/>
               </a:rPr>
@@ -5339,7 +5339,7 @@
             <a:avLst/>
           </a:prstGeom>
           <a:solidFill>
-            <a:srgbClr val="1B365D"/>
+            <a:srgbClr val="224248"/>
           </a:solidFill>
           <a:ln>
             <a:noFill/>
@@ -5513,7 +5513,7 @@
             <a:avLst/>
           </a:prstGeom>
           <a:solidFill>
-            <a:srgbClr val="1B365D"/>
+            <a:srgbClr val="224248"/>
           </a:solidFill>
           <a:ln>
             <a:noFill/>
@@ -5556,7 +5556,7 @@
             <a:avLst/>
           </a:prstGeom>
           <a:solidFill>
-            <a:srgbClr val="FFF1D1"/>
+            <a:srgbClr val="FF9A00"/>
           </a:solidFill>
           <a:ln>
             <a:noFill/>
@@ -5610,7 +5610,7 @@
             <a:r>
               <a:rPr sz="1200" b="1" i="0">
                 <a:solidFill>
-                  <a:srgbClr val="FFF1D1"/>
+                  <a:srgbClr val="44A1A4"/>
                 </a:solidFill>
                 <a:latin typeface="Calibri"/>
               </a:rPr>
@@ -5768,7 +5768,7 @@
             <a:avLst/>
           </a:prstGeom>
           <a:solidFill>
-            <a:srgbClr val="1B365D"/>
+            <a:srgbClr val="224248"/>
           </a:solidFill>
           <a:ln>
             <a:noFill/>
@@ -5942,7 +5942,7 @@
             <a:avLst/>
           </a:prstGeom>
           <a:solidFill>
-            <a:srgbClr val="1B365D"/>
+            <a:srgbClr val="224248"/>
           </a:solidFill>
           <a:ln>
             <a:noFill/>
@@ -5985,7 +5985,7 @@
             <a:avLst/>
           </a:prstGeom>
           <a:solidFill>
-            <a:srgbClr val="FFF1D1"/>
+            <a:srgbClr val="FF9A00"/>
           </a:solidFill>
           <a:ln>
             <a:noFill/>
@@ -6039,7 +6039,7 @@
             <a:r>
               <a:rPr sz="1200" b="1" i="0">
                 <a:solidFill>
-                  <a:srgbClr val="FFF1D1"/>
+                  <a:srgbClr val="44A1A4"/>
                 </a:solidFill>
                 <a:latin typeface="Calibri"/>
               </a:rPr>
@@ -6197,7 +6197,7 @@
             <a:avLst/>
           </a:prstGeom>
           <a:solidFill>
-            <a:srgbClr val="1B365D"/>
+            <a:srgbClr val="224248"/>
           </a:solidFill>
           <a:ln>
             <a:noFill/>
@@ -6371,7 +6371,7 @@
             <a:avLst/>
           </a:prstGeom>
           <a:solidFill>
-            <a:srgbClr val="1B365D"/>
+            <a:srgbClr val="224248"/>
           </a:solidFill>
           <a:ln>
             <a:noFill/>
@@ -6414,7 +6414,7 @@
             <a:avLst/>
           </a:prstGeom>
           <a:solidFill>
-            <a:srgbClr val="FFF1D1"/>
+            <a:srgbClr val="FF9A00"/>
           </a:solidFill>
           <a:ln>
             <a:noFill/>
@@ -6468,7 +6468,7 @@
             <a:r>
               <a:rPr sz="1200" b="1" i="0">
                 <a:solidFill>
-                  <a:srgbClr val="FFF1D1"/>
+                  <a:srgbClr val="44A1A4"/>
                 </a:solidFill>
                 <a:latin typeface="Calibri"/>
               </a:rPr>
@@ -6626,7 +6626,7 @@
             <a:avLst/>
           </a:prstGeom>
           <a:solidFill>
-            <a:srgbClr val="1B365D"/>
+            <a:srgbClr val="224248"/>
           </a:solidFill>
           <a:ln>
             <a:noFill/>
@@ -6800,7 +6800,7 @@
             <a:avLst/>
           </a:prstGeom>
           <a:solidFill>
-            <a:srgbClr val="1B365D"/>
+            <a:srgbClr val="224248"/>
           </a:solidFill>
           <a:ln>
             <a:noFill/>
@@ -6843,7 +6843,7 @@
             <a:avLst/>
           </a:prstGeom>
           <a:solidFill>
-            <a:srgbClr val="FFF1D1"/>
+            <a:srgbClr val="FF9A00"/>
           </a:solidFill>
           <a:ln>
             <a:noFill/>
@@ -6897,7 +6897,7 @@
             <a:r>
               <a:rPr sz="1200" b="1" i="0">
                 <a:solidFill>
-                  <a:srgbClr val="FFF1D1"/>
+                  <a:srgbClr val="44A1A4"/>
                 </a:solidFill>
                 <a:latin typeface="Calibri"/>
               </a:rPr>
@@ -6956,7 +6956,7 @@
             <a:avLst/>
           </a:prstGeom>
           <a:solidFill>
-            <a:srgbClr val="FFF1D1"/>
+            <a:srgbClr val="FF9A00"/>
           </a:solidFill>
           <a:ln>
             <a:noFill/>
@@ -7010,7 +7010,7 @@
             <a:r>
               <a:rPr sz="2200" b="1" i="0">
                 <a:solidFill>
-                  <a:srgbClr val="1B365D"/>
+                  <a:srgbClr val="224248"/>
                 </a:solidFill>
                 <a:latin typeface="Calibri"/>
               </a:rPr>
@@ -7133,7 +7133,7 @@
             <a:avLst/>
           </a:prstGeom>
           <a:solidFill>
-            <a:srgbClr val="1B365D"/>
+            <a:srgbClr val="224248"/>
           </a:solidFill>
           <a:ln>
             <a:noFill/>
@@ -7307,7 +7307,7 @@
             <a:avLst/>
           </a:prstGeom>
           <a:solidFill>
-            <a:srgbClr val="1B365D"/>
+            <a:srgbClr val="224248"/>
           </a:solidFill>
           <a:ln>
             <a:noFill/>
@@ -7350,7 +7350,7 @@
             <a:avLst/>
           </a:prstGeom>
           <a:solidFill>
-            <a:srgbClr val="FFF1D1"/>
+            <a:srgbClr val="FF9A00"/>
           </a:solidFill>
           <a:ln>
             <a:noFill/>
@@ -7404,7 +7404,7 @@
             <a:r>
               <a:rPr sz="1200" b="1" i="0">
                 <a:solidFill>
-                  <a:srgbClr val="FFF1D1"/>
+                  <a:srgbClr val="44A1A4"/>
                 </a:solidFill>
                 <a:latin typeface="Calibri"/>
               </a:rPr>
@@ -7562,7 +7562,7 @@
             <a:avLst/>
           </a:prstGeom>
           <a:solidFill>
-            <a:srgbClr val="1B365D"/>
+            <a:srgbClr val="224248"/>
           </a:solidFill>
           <a:ln>
             <a:noFill/>
@@ -7736,7 +7736,7 @@
             <a:avLst/>
           </a:prstGeom>
           <a:solidFill>
-            <a:srgbClr val="1B365D"/>
+            <a:srgbClr val="224248"/>
           </a:solidFill>
           <a:ln>
             <a:noFill/>
@@ -7779,7 +7779,7 @@
             <a:avLst/>
           </a:prstGeom>
           <a:solidFill>
-            <a:srgbClr val="FFF1D1"/>
+            <a:srgbClr val="FF9A00"/>
           </a:solidFill>
           <a:ln>
             <a:noFill/>
@@ -7833,7 +7833,7 @@
             <a:r>
               <a:rPr sz="1200" b="1" i="0">
                 <a:solidFill>
-                  <a:srgbClr val="FFF1D1"/>
+                  <a:srgbClr val="44A1A4"/>
                 </a:solidFill>
                 <a:latin typeface="Calibri"/>
               </a:rPr>
@@ -7892,7 +7892,7 @@
             <a:avLst/>
           </a:prstGeom>
           <a:solidFill>
-            <a:srgbClr val="FFF1D1"/>
+            <a:srgbClr val="44A1A4"/>
           </a:solidFill>
           <a:ln>
             <a:noFill/>
@@ -7953,7 +7953,7 @@
             <a:r>
               <a:rPr sz="2200" b="0" i="0">
                 <a:solidFill>
-                  <a:srgbClr val="1B365D"/>
+                  <a:srgbClr val="224248"/>
                 </a:solidFill>
                 <a:latin typeface="Calibri"/>
               </a:rPr>
@@ -7972,7 +7972,7 @@
             <a:r>
               <a:rPr sz="2200" b="0" i="0">
                 <a:solidFill>
-                  <a:srgbClr val="1B365D"/>
+                  <a:srgbClr val="224248"/>
                 </a:solidFill>
                 <a:latin typeface="Calibri"/>
               </a:rPr>
@@ -7991,7 +7991,7 @@
             <a:r>
               <a:rPr sz="2200" b="0" i="0">
                 <a:solidFill>
-                  <a:srgbClr val="1B365D"/>
+                  <a:srgbClr val="224248"/>
                 </a:solidFill>
                 <a:latin typeface="Calibri"/>
               </a:rPr>
@@ -8010,7 +8010,7 @@
             <a:r>
               <a:rPr sz="2200" b="0" i="0">
                 <a:solidFill>
-                  <a:srgbClr val="1B365D"/>
+                  <a:srgbClr val="FF9A00"/>
                 </a:solidFill>
                 <a:latin typeface="Calibri"/>
               </a:rPr>
@@ -8034,7 +8034,7 @@
             <a:avLst/>
           </a:prstGeom>
           <a:solidFill>
-            <a:srgbClr val="1B365D"/>
+            <a:srgbClr val="224248"/>
           </a:solidFill>
           <a:ln>
             <a:noFill/>
@@ -8165,7 +8165,7 @@
             <a:avLst/>
           </a:prstGeom>
           <a:solidFill>
-            <a:srgbClr val="1B365D"/>
+            <a:srgbClr val="224248"/>
           </a:solidFill>
           <a:ln>
             <a:noFill/>
@@ -8254,7 +8254,7 @@
             <a:r>
               <a:rPr sz="2000" b="0" i="0">
                 <a:solidFill>
-                  <a:srgbClr val="FFF1D1"/>
+                  <a:srgbClr val="44A1A4"/>
                 </a:solidFill>
                 <a:latin typeface="Calibri"/>
               </a:rPr>
@@ -8339,7 +8339,7 @@
             <a:avLst/>
           </a:prstGeom>
           <a:solidFill>
-            <a:srgbClr val="1B365D"/>
+            <a:srgbClr val="224248"/>
           </a:solidFill>
           <a:ln>
             <a:noFill/>
@@ -8382,7 +8382,7 @@
             <a:avLst/>
           </a:prstGeom>
           <a:solidFill>
-            <a:srgbClr val="FFF1D1"/>
+            <a:srgbClr val="FF9A00"/>
           </a:solidFill>
           <a:ln>
             <a:noFill/>
@@ -8436,7 +8436,7 @@
             <a:r>
               <a:rPr sz="1200" b="1" i="0">
                 <a:solidFill>
-                  <a:srgbClr val="FFF1D1"/>
+                  <a:srgbClr val="44A1A4"/>
                 </a:solidFill>
                 <a:latin typeface="Calibri"/>
               </a:rPr>
@@ -8495,7 +8495,7 @@
             <a:avLst/>
           </a:prstGeom>
           <a:solidFill>
-            <a:srgbClr val="FFF1D1"/>
+            <a:srgbClr val="44A1A4"/>
           </a:solidFill>
           <a:ln>
             <a:noFill/>
@@ -8549,7 +8549,7 @@
             <a:r>
               <a:rPr sz="2200" b="1" i="0">
                 <a:solidFill>
-                  <a:srgbClr val="1B365D"/>
+                  <a:srgbClr val="224248"/>
                 </a:solidFill>
                 <a:latin typeface="Calibri"/>
               </a:rPr>
@@ -8672,7 +8672,7 @@
             <a:avLst/>
           </a:prstGeom>
           <a:solidFill>
-            <a:srgbClr val="1B365D"/>
+            <a:srgbClr val="325E6A"/>
           </a:solidFill>
           <a:ln>
             <a:noFill/>
@@ -8726,7 +8726,7 @@
             <a:r>
               <a:rPr sz="2200" b="1" i="0">
                 <a:solidFill>
-                  <a:srgbClr val="FFF1D1"/>
+                  <a:srgbClr val="FF9A00"/>
                 </a:solidFill>
                 <a:latin typeface="Calibri"/>
               </a:rPr>
@@ -8849,7 +8849,7 @@
             <a:avLst/>
           </a:prstGeom>
           <a:solidFill>
-            <a:srgbClr val="1B365D"/>
+            <a:srgbClr val="224248"/>
           </a:solidFill>
           <a:ln>
             <a:noFill/>
@@ -9023,7 +9023,7 @@
             <a:avLst/>
           </a:prstGeom>
           <a:solidFill>
-            <a:srgbClr val="1B365D"/>
+            <a:srgbClr val="224248"/>
           </a:solidFill>
           <a:ln>
             <a:noFill/>
@@ -9066,7 +9066,7 @@
             <a:avLst/>
           </a:prstGeom>
           <a:solidFill>
-            <a:srgbClr val="FFF1D1"/>
+            <a:srgbClr val="FF9A00"/>
           </a:solidFill>
           <a:ln>
             <a:noFill/>
@@ -9120,7 +9120,7 @@
             <a:r>
               <a:rPr sz="1200" b="1" i="0">
                 <a:solidFill>
-                  <a:srgbClr val="FFF1D1"/>
+                  <a:srgbClr val="44A1A4"/>
                 </a:solidFill>
                 <a:latin typeface="Calibri"/>
               </a:rPr>
@@ -9278,7 +9278,7 @@
             <a:avLst/>
           </a:prstGeom>
           <a:solidFill>
-            <a:srgbClr val="1B365D"/>
+            <a:srgbClr val="224248"/>
           </a:solidFill>
           <a:ln>
             <a:noFill/>
@@ -9452,7 +9452,7 @@
             <a:avLst/>
           </a:prstGeom>
           <a:solidFill>
-            <a:srgbClr val="1B365D"/>
+            <a:srgbClr val="224248"/>
           </a:solidFill>
           <a:ln>
             <a:noFill/>
@@ -9495,7 +9495,7 @@
             <a:avLst/>
           </a:prstGeom>
           <a:solidFill>
-            <a:srgbClr val="FFF1D1"/>
+            <a:srgbClr val="FF9A00"/>
           </a:solidFill>
           <a:ln>
             <a:noFill/>
@@ -9549,7 +9549,7 @@
             <a:r>
               <a:rPr sz="1200" b="1" i="0">
                 <a:solidFill>
-                  <a:srgbClr val="FFF1D1"/>
+                  <a:srgbClr val="44A1A4"/>
                 </a:solidFill>
                 <a:latin typeface="Calibri"/>
               </a:rPr>
@@ -9608,7 +9608,7 @@
             <a:avLst/>
           </a:prstGeom>
           <a:solidFill>
-            <a:srgbClr val="FFF1D1"/>
+            <a:srgbClr val="44A1A4"/>
           </a:solidFill>
           <a:ln>
             <a:noFill/>
@@ -9662,7 +9662,7 @@
             <a:r>
               <a:rPr sz="2200" b="1" i="0">
                 <a:solidFill>
-                  <a:srgbClr val="1B365D"/>
+                  <a:srgbClr val="224248"/>
                 </a:solidFill>
                 <a:latin typeface="Calibri"/>
               </a:rPr>
@@ -9761,7 +9761,7 @@
             <a:r>
               <a:rPr sz="1800" b="1" i="0">
                 <a:solidFill>
-                  <a:srgbClr val="1B365D"/>
+                  <a:srgbClr val="FF9A00"/>
                 </a:solidFill>
                 <a:latin typeface="Calibri"/>
               </a:rPr>
@@ -9785,7 +9785,7 @@
             <a:avLst/>
           </a:prstGeom>
           <a:solidFill>
-            <a:srgbClr val="1B365D"/>
+            <a:srgbClr val="224248"/>
           </a:solidFill>
           <a:ln>
             <a:noFill/>
@@ -9839,7 +9839,7 @@
             <a:r>
               <a:rPr sz="2200" b="1" i="0">
                 <a:solidFill>
-                  <a:srgbClr val="FFF1D1"/>
+                  <a:srgbClr val="44A1A4"/>
                 </a:solidFill>
                 <a:latin typeface="Calibri"/>
               </a:rPr>
@@ -10000,7 +10000,7 @@
             <a:avLst/>
           </a:prstGeom>
           <a:solidFill>
-            <a:srgbClr val="1B365D"/>
+            <a:srgbClr val="224248"/>
           </a:solidFill>
           <a:ln>
             <a:noFill/>
@@ -10174,7 +10174,7 @@
             <a:avLst/>
           </a:prstGeom>
           <a:solidFill>
-            <a:srgbClr val="1B365D"/>
+            <a:srgbClr val="224248"/>
           </a:solidFill>
           <a:ln>
             <a:noFill/>
@@ -10217,7 +10217,7 @@
             <a:avLst/>
           </a:prstGeom>
           <a:solidFill>
-            <a:srgbClr val="FFF1D1"/>
+            <a:srgbClr val="FF9A00"/>
           </a:solidFill>
           <a:ln>
             <a:noFill/>
@@ -10271,7 +10271,7 @@
             <a:r>
               <a:rPr sz="1200" b="1" i="0">
                 <a:solidFill>
-                  <a:srgbClr val="FFF1D1"/>
+                  <a:srgbClr val="44A1A4"/>
                 </a:solidFill>
                 <a:latin typeface="Calibri"/>
               </a:rPr>
@@ -10341,7 +10341,7 @@
             <a:r>
               <a:rPr sz="1800" b="1" i="0">
                 <a:solidFill>
-                  <a:srgbClr val="1B365D"/>
+                  <a:srgbClr val="224248"/>
                 </a:solidFill>
                 <a:latin typeface="Calibri"/>
               </a:rPr>
@@ -10376,7 +10376,7 @@
             <a:r>
               <a:rPr sz="1800" b="1" i="0">
                 <a:solidFill>
-                  <a:srgbClr val="1B365D"/>
+                  <a:srgbClr val="325E6A"/>
                 </a:solidFill>
                 <a:latin typeface="Calibri"/>
               </a:rPr>
@@ -10400,7 +10400,7 @@
             <a:avLst/>
           </a:prstGeom>
           <a:solidFill>
-            <a:srgbClr val="FFF1D1"/>
+            <a:srgbClr val="44A1A4"/>
           </a:solidFill>
           <a:ln>
             <a:noFill/>
@@ -10454,7 +10454,7 @@
             <a:r>
               <a:rPr sz="1600" b="1" i="0">
                 <a:solidFill>
-                  <a:srgbClr val="1B365D"/>
+                  <a:srgbClr val="224248"/>
                 </a:solidFill>
                 <a:latin typeface="Calibri"/>
               </a:rPr>
@@ -10513,7 +10513,7 @@
             <a:avLst/>
           </a:prstGeom>
           <a:solidFill>
-            <a:srgbClr val="F4F6F8"/>
+            <a:srgbClr val="325E6A"/>
           </a:solidFill>
           <a:ln>
             <a:noFill/>
@@ -10567,7 +10567,7 @@
             <a:r>
               <a:rPr sz="1600" b="1" i="0">
                 <a:solidFill>
-                  <a:srgbClr val="1B365D"/>
+                  <a:srgbClr val="FFFFFF"/>
                 </a:solidFill>
                 <a:latin typeface="Calibri"/>
               </a:rPr>
@@ -10602,7 +10602,7 @@
             <a:r>
               <a:rPr sz="1400" b="0" i="0">
                 <a:solidFill>
-                  <a:srgbClr val="1A1A1A"/>
+                  <a:srgbClr val="FFFFFF"/>
                 </a:solidFill>
                 <a:latin typeface="Calibri"/>
               </a:rPr>
@@ -10626,7 +10626,7 @@
             <a:avLst/>
           </a:prstGeom>
           <a:solidFill>
-            <a:srgbClr val="FFF1D1"/>
+            <a:srgbClr val="44A1A4"/>
           </a:solidFill>
           <a:ln>
             <a:noFill/>
@@ -10680,7 +10680,7 @@
             <a:r>
               <a:rPr sz="1600" b="1" i="0">
                 <a:solidFill>
-                  <a:srgbClr val="1B365D"/>
+                  <a:srgbClr val="224248"/>
                 </a:solidFill>
                 <a:latin typeface="Calibri"/>
               </a:rPr>
@@ -10739,7 +10739,7 @@
             <a:avLst/>
           </a:prstGeom>
           <a:solidFill>
-            <a:srgbClr val="F4F6F8"/>
+            <a:srgbClr val="325E6A"/>
           </a:solidFill>
           <a:ln>
             <a:noFill/>
@@ -10793,7 +10793,7 @@
             <a:r>
               <a:rPr sz="1600" b="1" i="0">
                 <a:solidFill>
-                  <a:srgbClr val="1B365D"/>
+                  <a:srgbClr val="FFFFFF"/>
                 </a:solidFill>
                 <a:latin typeface="Calibri"/>
               </a:rPr>
@@ -10828,7 +10828,7 @@
             <a:r>
               <a:rPr sz="1400" b="0" i="0">
                 <a:solidFill>
-                  <a:srgbClr val="1A1A1A"/>
+                  <a:srgbClr val="FFFFFF"/>
                 </a:solidFill>
                 <a:latin typeface="Calibri"/>
               </a:rPr>
@@ -10852,7 +10852,7 @@
             <a:avLst/>
           </a:prstGeom>
           <a:solidFill>
-            <a:srgbClr val="FFF1D1"/>
+            <a:srgbClr val="44A1A4"/>
           </a:solidFill>
           <a:ln>
             <a:noFill/>
@@ -10906,7 +10906,7 @@
             <a:r>
               <a:rPr sz="1600" b="1" i="0">
                 <a:solidFill>
-                  <a:srgbClr val="1B365D"/>
+                  <a:srgbClr val="224248"/>
                 </a:solidFill>
                 <a:latin typeface="Calibri"/>
               </a:rPr>
@@ -10965,7 +10965,7 @@
             <a:avLst/>
           </a:prstGeom>
           <a:solidFill>
-            <a:srgbClr val="F4F6F8"/>
+            <a:srgbClr val="325E6A"/>
           </a:solidFill>
           <a:ln>
             <a:noFill/>
@@ -11019,7 +11019,7 @@
             <a:r>
               <a:rPr sz="1600" b="1" i="0">
                 <a:solidFill>
-                  <a:srgbClr val="1B365D"/>
+                  <a:srgbClr val="FFFFFF"/>
                 </a:solidFill>
                 <a:latin typeface="Calibri"/>
               </a:rPr>
@@ -11054,7 +11054,7 @@
             <a:r>
               <a:rPr sz="1400" b="0" i="0">
                 <a:solidFill>
-                  <a:srgbClr val="1A1A1A"/>
+                  <a:srgbClr val="FFFFFF"/>
                 </a:solidFill>
                 <a:latin typeface="Calibri"/>
               </a:rPr>
@@ -11078,7 +11078,7 @@
             <a:avLst/>
           </a:prstGeom>
           <a:solidFill>
-            <a:srgbClr val="FFF1D1"/>
+            <a:srgbClr val="44A1A4"/>
           </a:solidFill>
           <a:ln>
             <a:noFill/>
@@ -11132,7 +11132,7 @@
             <a:r>
               <a:rPr sz="1600" b="1" i="0">
                 <a:solidFill>
-                  <a:srgbClr val="1B365D"/>
+                  <a:srgbClr val="224248"/>
                 </a:solidFill>
                 <a:latin typeface="Calibri"/>
               </a:rPr>
@@ -11191,7 +11191,7 @@
             <a:avLst/>
           </a:prstGeom>
           <a:solidFill>
-            <a:srgbClr val="F4F6F8"/>
+            <a:srgbClr val="325E6A"/>
           </a:solidFill>
           <a:ln>
             <a:noFill/>
@@ -11245,7 +11245,7 @@
             <a:r>
               <a:rPr sz="1600" b="1" i="0">
                 <a:solidFill>
-                  <a:srgbClr val="1B365D"/>
+                  <a:srgbClr val="FFFFFF"/>
                 </a:solidFill>
                 <a:latin typeface="Calibri"/>
               </a:rPr>
@@ -11280,7 +11280,7 @@
             <a:r>
               <a:rPr sz="1400" b="0" i="0">
                 <a:solidFill>
-                  <a:srgbClr val="1A1A1A"/>
+                  <a:srgbClr val="FFFFFF"/>
                 </a:solidFill>
                 <a:latin typeface="Calibri"/>
               </a:rPr>
@@ -11304,7 +11304,7 @@
             <a:avLst/>
           </a:prstGeom>
           <a:solidFill>
-            <a:srgbClr val="FFF1D1"/>
+            <a:srgbClr val="44A1A4"/>
           </a:solidFill>
           <a:ln>
             <a:noFill/>
@@ -11358,7 +11358,7 @@
             <a:r>
               <a:rPr sz="1600" b="1" i="0">
                 <a:solidFill>
-                  <a:srgbClr val="1B365D"/>
+                  <a:srgbClr val="224248"/>
                 </a:solidFill>
                 <a:latin typeface="Calibri"/>
               </a:rPr>
@@ -11417,7 +11417,7 @@
             <a:avLst/>
           </a:prstGeom>
           <a:solidFill>
-            <a:srgbClr val="F4F6F8"/>
+            <a:srgbClr val="325E6A"/>
           </a:solidFill>
           <a:ln>
             <a:noFill/>
@@ -11471,7 +11471,7 @@
             <a:r>
               <a:rPr sz="1600" b="1" i="0">
                 <a:solidFill>
-                  <a:srgbClr val="1B365D"/>
+                  <a:srgbClr val="FFFFFF"/>
                 </a:solidFill>
                 <a:latin typeface="Calibri"/>
               </a:rPr>
@@ -11506,7 +11506,7 @@
             <a:r>
               <a:rPr sz="1400" b="0" i="0">
                 <a:solidFill>
-                  <a:srgbClr val="1A1A1A"/>
+                  <a:srgbClr val="FFFFFF"/>
                 </a:solidFill>
                 <a:latin typeface="Calibri"/>
               </a:rPr>
@@ -11565,7 +11565,7 @@
             <a:avLst/>
           </a:prstGeom>
           <a:solidFill>
-            <a:srgbClr val="1B365D"/>
+            <a:srgbClr val="224248"/>
           </a:solidFill>
           <a:ln>
             <a:noFill/>
@@ -11739,7 +11739,7 @@
             <a:avLst/>
           </a:prstGeom>
           <a:solidFill>
-            <a:srgbClr val="1B365D"/>
+            <a:srgbClr val="224248"/>
           </a:solidFill>
           <a:ln>
             <a:noFill/>
@@ -11782,7 +11782,7 @@
             <a:avLst/>
           </a:prstGeom>
           <a:solidFill>
-            <a:srgbClr val="FFF1D1"/>
+            <a:srgbClr val="FF9A00"/>
           </a:solidFill>
           <a:ln>
             <a:noFill/>
@@ -11836,7 +11836,7 @@
             <a:r>
               <a:rPr sz="1200" b="1" i="0">
                 <a:solidFill>
-                  <a:srgbClr val="FFF1D1"/>
+                  <a:srgbClr val="44A1A4"/>
                 </a:solidFill>
                 <a:latin typeface="Calibri"/>
               </a:rPr>
@@ -12002,7 +12002,7 @@
             <a:avLst/>
           </a:prstGeom>
           <a:solidFill>
-            <a:srgbClr val="1B365D"/>
+            <a:srgbClr val="224248"/>
           </a:solidFill>
           <a:ln>
             <a:noFill/>
@@ -12176,7 +12176,7 @@
             <a:avLst/>
           </a:prstGeom>
           <a:solidFill>
-            <a:srgbClr val="1B365D"/>
+            <a:srgbClr val="224248"/>
           </a:solidFill>
           <a:ln>
             <a:noFill/>
@@ -12219,7 +12219,7 @@
             <a:avLst/>
           </a:prstGeom>
           <a:solidFill>
-            <a:srgbClr val="FFF1D1"/>
+            <a:srgbClr val="FF9A00"/>
           </a:solidFill>
           <a:ln>
             <a:noFill/>
@@ -12273,7 +12273,7 @@
             <a:r>
               <a:rPr sz="1200" b="1" i="0">
                 <a:solidFill>
-                  <a:srgbClr val="FFF1D1"/>
+                  <a:srgbClr val="44A1A4"/>
                 </a:solidFill>
                 <a:latin typeface="Calibri"/>
               </a:rPr>
@@ -12415,7 +12415,7 @@
             <a:avLst/>
           </a:prstGeom>
           <a:solidFill>
-            <a:srgbClr val="1B365D"/>
+            <a:srgbClr val="224248"/>
           </a:solidFill>
           <a:ln>
             <a:noFill/>
@@ -12589,7 +12589,7 @@
             <a:avLst/>
           </a:prstGeom>
           <a:solidFill>
-            <a:srgbClr val="1B365D"/>
+            <a:srgbClr val="224248"/>
           </a:solidFill>
           <a:ln>
             <a:noFill/>
@@ -12632,7 +12632,7 @@
             <a:avLst/>
           </a:prstGeom>
           <a:solidFill>
-            <a:srgbClr val="FFF1D1"/>
+            <a:srgbClr val="FF9A00"/>
           </a:solidFill>
           <a:ln>
             <a:noFill/>
@@ -12686,7 +12686,7 @@
             <a:r>
               <a:rPr sz="1200" b="1" i="0">
                 <a:solidFill>
-                  <a:srgbClr val="FFF1D1"/>
+                  <a:srgbClr val="44A1A4"/>
                 </a:solidFill>
                 <a:latin typeface="Calibri"/>
               </a:rPr>
@@ -12844,7 +12844,7 @@
             <a:avLst/>
           </a:prstGeom>
           <a:solidFill>
-            <a:srgbClr val="1B365D"/>
+            <a:srgbClr val="224248"/>
           </a:solidFill>
           <a:ln>
             <a:noFill/>
@@ -13018,7 +13018,7 @@
             <a:avLst/>
           </a:prstGeom>
           <a:solidFill>
-            <a:srgbClr val="1B365D"/>
+            <a:srgbClr val="224248"/>
           </a:solidFill>
           <a:ln>
             <a:noFill/>
@@ -13061,7 +13061,7 @@
             <a:avLst/>
           </a:prstGeom>
           <a:solidFill>
-            <a:srgbClr val="FFF1D1"/>
+            <a:srgbClr val="FF9A00"/>
           </a:solidFill>
           <a:ln>
             <a:noFill/>
@@ -13115,7 +13115,7 @@
             <a:r>
               <a:rPr sz="1200" b="1" i="0">
                 <a:solidFill>
-                  <a:srgbClr val="FFF1D1"/>
+                  <a:srgbClr val="44A1A4"/>
                 </a:solidFill>
                 <a:latin typeface="Calibri"/>
               </a:rPr>
@@ -13174,7 +13174,7 @@
             <a:avLst/>
           </a:prstGeom>
           <a:solidFill>
-            <a:srgbClr val="1B365D"/>
+            <a:srgbClr val="224248"/>
           </a:solidFill>
           <a:ln>
             <a:noFill/>
@@ -13252,7 +13252,7 @@
             <a:avLst/>
           </a:prstGeom>
           <a:solidFill>
-            <a:srgbClr val="1B365D"/>
+            <a:srgbClr val="224248"/>
           </a:solidFill>
           <a:ln>
             <a:noFill/>
@@ -13330,7 +13330,7 @@
             <a:avLst/>
           </a:prstGeom>
           <a:solidFill>
-            <a:srgbClr val="1B365D"/>
+            <a:srgbClr val="224248"/>
           </a:solidFill>
           <a:ln>
             <a:noFill/>
@@ -13408,7 +13408,7 @@
             <a:avLst/>
           </a:prstGeom>
           <a:solidFill>
-            <a:srgbClr val="1B365D"/>
+            <a:srgbClr val="224248"/>
           </a:solidFill>
           <a:ln>
             <a:noFill/>
@@ -13774,7 +13774,7 @@
             <a:r>
               <a:rPr sz="1400" b="1" i="0">
                 <a:solidFill>
-                  <a:srgbClr val="1B365D"/>
+                  <a:srgbClr val="224248"/>
                 </a:solidFill>
                 <a:latin typeface="Calibri"/>
               </a:rPr>
@@ -13798,7 +13798,7 @@
             <a:avLst/>
           </a:prstGeom>
           <a:solidFill>
-            <a:srgbClr val="FFF1D1"/>
+            <a:srgbClr val="44A1A4"/>
           </a:solidFill>
           <a:ln>
             <a:noFill/>
@@ -13876,7 +13876,7 @@
             <a:avLst/>
           </a:prstGeom>
           <a:solidFill>
-            <a:srgbClr val="FFF1D1"/>
+            <a:srgbClr val="44A1A4"/>
           </a:solidFill>
           <a:ln>
             <a:noFill/>
@@ -13954,7 +13954,7 @@
             <a:avLst/>
           </a:prstGeom>
           <a:solidFill>
-            <a:srgbClr val="FFF1D1"/>
+            <a:srgbClr val="44A1A4"/>
           </a:solidFill>
           <a:ln>
             <a:noFill/>
@@ -14032,7 +14032,7 @@
             <a:avLst/>
           </a:prstGeom>
           <a:solidFill>
-            <a:srgbClr val="FFF1D1"/>
+            <a:srgbClr val="44A1A4"/>
           </a:solidFill>
           <a:ln>
             <a:noFill/>
@@ -14086,7 +14086,7 @@
             <a:r>
               <a:rPr sz="1400" b="1" i="0">
                 <a:solidFill>
-                  <a:srgbClr val="9A5B00"/>
+                  <a:srgbClr val="FF9A00"/>
                 </a:solidFill>
                 <a:latin typeface="Calibri"/>
               </a:rPr>
@@ -14398,7 +14398,7 @@
             <a:r>
               <a:rPr sz="1400" b="1" i="0">
                 <a:solidFill>
-                  <a:srgbClr val="1B365D"/>
+                  <a:srgbClr val="224248"/>
                 </a:solidFill>
                 <a:latin typeface="Calibri"/>
               </a:rPr>
@@ -14422,7 +14422,7 @@
             <a:avLst/>
           </a:prstGeom>
           <a:solidFill>
-            <a:srgbClr val="F4F6F8"/>
+            <a:srgbClr val="E8F4F4"/>
           </a:solidFill>
           <a:ln>
             <a:noFill/>
@@ -14500,7 +14500,7 @@
             <a:avLst/>
           </a:prstGeom>
           <a:solidFill>
-            <a:srgbClr val="F4F6F8"/>
+            <a:srgbClr val="E8F4F4"/>
           </a:solidFill>
           <a:ln>
             <a:noFill/>
@@ -14578,7 +14578,7 @@
             <a:avLst/>
           </a:prstGeom>
           <a:solidFill>
-            <a:srgbClr val="F4F6F8"/>
+            <a:srgbClr val="E8F4F4"/>
           </a:solidFill>
           <a:ln>
             <a:noFill/>
@@ -14656,7 +14656,7 @@
             <a:avLst/>
           </a:prstGeom>
           <a:solidFill>
-            <a:srgbClr val="F4F6F8"/>
+            <a:srgbClr val="E8F4F4"/>
           </a:solidFill>
           <a:ln>
             <a:noFill/>
@@ -14710,7 +14710,7 @@
             <a:r>
               <a:rPr sz="1400" b="1" i="0">
                 <a:solidFill>
-                  <a:srgbClr val="1B365D"/>
+                  <a:srgbClr val="224248"/>
                 </a:solidFill>
                 <a:latin typeface="Calibri"/>
               </a:rPr>
@@ -14734,7 +14734,7 @@
             <a:avLst/>
           </a:prstGeom>
           <a:solidFill>
-            <a:srgbClr val="FFF1D1"/>
+            <a:srgbClr val="44A1A4"/>
           </a:solidFill>
           <a:ln>
             <a:noFill/>
@@ -14812,7 +14812,7 @@
             <a:avLst/>
           </a:prstGeom>
           <a:solidFill>
-            <a:srgbClr val="FFF1D1"/>
+            <a:srgbClr val="44A1A4"/>
           </a:solidFill>
           <a:ln>
             <a:noFill/>
@@ -14890,7 +14890,7 @@
             <a:avLst/>
           </a:prstGeom>
           <a:solidFill>
-            <a:srgbClr val="FFF1D1"/>
+            <a:srgbClr val="44A1A4"/>
           </a:solidFill>
           <a:ln>
             <a:noFill/>
@@ -14968,7 +14968,7 @@
             <a:avLst/>
           </a:prstGeom>
           <a:solidFill>
-            <a:srgbClr val="FFF1D1"/>
+            <a:srgbClr val="44A1A4"/>
           </a:solidFill>
           <a:ln>
             <a:noFill/>
@@ -15022,7 +15022,7 @@
             <a:r>
               <a:rPr sz="1400" b="1" i="0">
                 <a:solidFill>
-                  <a:srgbClr val="9A5B00"/>
+                  <a:srgbClr val="FF9A00"/>
                 </a:solidFill>
                 <a:latin typeface="Calibri"/>
               </a:rPr>
@@ -15046,7 +15046,7 @@
             <a:avLst/>
           </a:prstGeom>
           <a:solidFill>
-            <a:srgbClr val="F4F6F8"/>
+            <a:srgbClr val="E8F4F4"/>
           </a:solidFill>
           <a:ln>
             <a:noFill/>
@@ -15124,7 +15124,7 @@
             <a:avLst/>
           </a:prstGeom>
           <a:solidFill>
-            <a:srgbClr val="F4F6F8"/>
+            <a:srgbClr val="E8F4F4"/>
           </a:solidFill>
           <a:ln>
             <a:noFill/>
@@ -15202,7 +15202,7 @@
             <a:avLst/>
           </a:prstGeom>
           <a:solidFill>
-            <a:srgbClr val="F4F6F8"/>
+            <a:srgbClr val="E8F4F4"/>
           </a:solidFill>
           <a:ln>
             <a:noFill/>
@@ -15280,7 +15280,7 @@
             <a:avLst/>
           </a:prstGeom>
           <a:solidFill>
-            <a:srgbClr val="F4F6F8"/>
+            <a:srgbClr val="E8F4F4"/>
           </a:solidFill>
           <a:ln>
             <a:noFill/>
@@ -15334,7 +15334,7 @@
             <a:r>
               <a:rPr sz="1400" b="1" i="0">
                 <a:solidFill>
-                  <a:srgbClr val="1B365D"/>
+                  <a:srgbClr val="224248"/>
                 </a:solidFill>
                 <a:latin typeface="Calibri"/>
               </a:rPr>
@@ -15393,7 +15393,7 @@
             <a:avLst/>
           </a:prstGeom>
           <a:solidFill>
-            <a:srgbClr val="1B365D"/>
+            <a:srgbClr val="224248"/>
           </a:solidFill>
           <a:ln>
             <a:noFill/>

</xml_diff>

<commit_message>
Presiser begge forskningsspørsmål på tittelslide
Bruker third parties og servers appear to be located i spørsmål 1,
og processes personal data og lawful basis i spørsmål 2.

Co-authored-by: Karina <kasa031@users.noreply.github.com>
</commit_message>
<xml_diff>
--- a/ACIT4280_1A_presentation.pptx
+++ b/ACIT4280_1A_presentation.pptx
@@ -4870,7 +4870,7 @@
                 </a:solidFill>
                 <a:latin typeface="Calibri"/>
               </a:rPr>
-              <a:t>•  When a front page loads, how many other companies does it contact, and in which countries do those machines appear to sit?</a:t>
+              <a:t>•  When a front page loads, how many third parties does it contact, and in which countries do those servers appear to be located?</a:t>
             </a:r>
           </a:p>
           <a:p>
@@ -4889,7 +4889,7 @@
                 </a:solidFill>
                 <a:latin typeface="Calibri"/>
               </a:rPr>
-              <a:t>•  When a site uses personal data, has it named a GDPR Article 6 basis, and does the ICO tool agree?</a:t>
+              <a:t>•  When a site processes personal data, has it named a GDPR Article 6 lawful basis, and does the ICO tool agree?</a:t>
             </a:r>
           </a:p>
         </p:txBody>

</xml_diff>

<commit_message>
Forbedre skarphet i presentasjonen
Storre skrift pa tittelslide, fiks tekstboks-autoskalering,
regenerer figurer i hoyere opplosning og eksporterer PDF med 2x skala.

Co-authored-by: Karina <kasa031@users.noreply.github.com>
</commit_message>
<xml_diff>
--- a/ACIT4280_1A_presentation.pptx
+++ b/ACIT4280_1A_presentation.pptx
@@ -4743,14 +4743,14 @@
           <a:noFill/>
         </p:spPr>
         <p:txBody>
-          <a:bodyPr wrap="square">
-            <a:spAutoFit/>
+          <a:bodyPr wrap="square" lIns="0" rIns="0" tIns="0" bIns="0">
+            <a:noAutofit/>
           </a:bodyPr>
           <a:lstStyle/>
           <a:p>
             <a:pPr algn="l"/>
             <a:r>
-              <a:rPr sz="1600" b="1" i="0">
+              <a:rPr sz="1800" b="1" i="0">
                 <a:solidFill>
                   <a:srgbClr val="44A1A4"/>
                 </a:solidFill>
@@ -4778,14 +4778,14 @@
           <a:noFill/>
         </p:spPr>
         <p:txBody>
-          <a:bodyPr wrap="square">
-            <a:spAutoFit/>
+          <a:bodyPr wrap="square" lIns="0" rIns="0" tIns="0" bIns="0">
+            <a:noAutofit/>
           </a:bodyPr>
           <a:lstStyle/>
           <a:p>
             <a:pPr algn="l"/>
             <a:r>
-              <a:rPr sz="2200" b="1" i="0">
+              <a:rPr sz="2400" b="1" i="0">
                 <a:solidFill>
                   <a:srgbClr val="44A1A4"/>
                 </a:solidFill>
@@ -4813,14 +4813,14 @@
           <a:noFill/>
         </p:spPr>
         <p:txBody>
-          <a:bodyPr wrap="square">
-            <a:spAutoFit/>
+          <a:bodyPr wrap="square" lIns="0" rIns="0" tIns="0" bIns="0">
+            <a:noAutofit/>
           </a:bodyPr>
           <a:lstStyle/>
           <a:p>
             <a:pPr algn="l"/>
             <a:r>
-              <a:rPr sz="2600" b="1" i="0">
+              <a:rPr sz="2800" b="1" i="0">
                 <a:solidFill>
                   <a:srgbClr val="FFFFFF"/>
                 </a:solidFill>
@@ -4842,7 +4842,7 @@
         <p:spPr>
           <a:xfrm>
             <a:off x="640080" y="3310128"/>
-            <a:ext cx="10972800" cy="1325880"/>
+            <a:ext cx="10972800" cy="1417320"/>
           </a:xfrm>
           <a:prstGeom prst="rect">
             <a:avLst/>
@@ -4850,8 +4850,8 @@
           <a:noFill/>
         </p:spPr>
         <p:txBody>
-          <a:bodyPr wrap="square">
-            <a:spAutoFit/>
+          <a:bodyPr wrap="square" lIns="0" rIns="0" tIns="0" bIns="0">
+            <a:noAutofit/>
           </a:bodyPr>
           <a:lstStyle/>
           <a:p>
@@ -4864,7 +4864,7 @@
               </a:spcAft>
             </a:pPr>
             <a:r>
-              <a:rPr sz="1500" b="0" i="0">
+              <a:rPr sz="1700" b="0" i="0">
                 <a:solidFill>
                   <a:srgbClr val="FFFFFF"/>
                 </a:solidFill>
@@ -4883,7 +4883,7 @@
               </a:spcAft>
             </a:pPr>
             <a:r>
-              <a:rPr sz="1500" b="0" i="0">
+              <a:rPr sz="1700" b="0" i="0">
                 <a:solidFill>
                   <a:srgbClr val="FFFFFF"/>
                 </a:solidFill>
@@ -4911,8 +4911,8 @@
           <a:noFill/>
         </p:spPr>
         <p:txBody>
-          <a:bodyPr wrap="square">
-            <a:spAutoFit/>
+          <a:bodyPr wrap="square" lIns="0" rIns="0" tIns="0" bIns="0">
+            <a:noAutofit/>
           </a:bodyPr>
           <a:lstStyle/>
           <a:p>
@@ -4946,8 +4946,8 @@
           <a:noFill/>
         </p:spPr>
         <p:txBody>
-          <a:bodyPr wrap="square">
-            <a:spAutoFit/>
+          <a:bodyPr wrap="square" lIns="0" rIns="0" tIns="0" bIns="0">
+            <a:noAutofit/>
           </a:bodyPr>
           <a:lstStyle/>
           <a:p>
@@ -5129,8 +5129,8 @@
           <a:noFill/>
         </p:spPr>
         <p:txBody>
-          <a:bodyPr wrap="square">
-            <a:spAutoFit/>
+          <a:bodyPr wrap="square" lIns="0" rIns="0" tIns="0" bIns="0">
+            <a:noAutofit/>
           </a:bodyPr>
           <a:lstStyle/>
           <a:p>
@@ -5164,8 +5164,8 @@
           <a:noFill/>
         </p:spPr>
         <p:txBody>
-          <a:bodyPr wrap="square">
-            <a:spAutoFit/>
+          <a:bodyPr wrap="square" lIns="0" rIns="0" tIns="0" bIns="0">
+            <a:noAutofit/>
           </a:bodyPr>
           <a:lstStyle/>
           <a:p>
@@ -5242,8 +5242,8 @@
           <a:noFill/>
         </p:spPr>
         <p:txBody>
-          <a:bodyPr wrap="square">
-            <a:spAutoFit/>
+          <a:bodyPr wrap="square" lIns="0" rIns="0" tIns="0" bIns="0">
+            <a:noAutofit/>
           </a:bodyPr>
           <a:lstStyle/>
           <a:p>
@@ -5384,14 +5384,14 @@
           <a:noFill/>
         </p:spPr>
         <p:txBody>
-          <a:bodyPr wrap="square">
-            <a:spAutoFit/>
+          <a:bodyPr wrap="square" lIns="0" rIns="0" tIns="0" bIns="0">
+            <a:noAutofit/>
           </a:bodyPr>
           <a:lstStyle/>
           <a:p>
             <a:pPr algn="l"/>
             <a:r>
-              <a:rPr sz="1000" b="0" i="0">
+              <a:rPr sz="1100" b="0" i="0">
                 <a:solidFill>
                   <a:srgbClr val="FFFFFF"/>
                 </a:solidFill>
@@ -5419,14 +5419,14 @@
           <a:noFill/>
         </p:spPr>
         <p:txBody>
-          <a:bodyPr wrap="square">
-            <a:spAutoFit/>
+          <a:bodyPr wrap="square" lIns="0" rIns="0" tIns="0" bIns="0">
+            <a:noAutofit/>
           </a:bodyPr>
           <a:lstStyle/>
           <a:p>
             <a:pPr algn="r"/>
             <a:r>
-              <a:rPr sz="1000" b="0" i="0">
+              <a:rPr sz="1100" b="0" i="0">
                 <a:solidFill>
                   <a:srgbClr val="FFFFFF"/>
                 </a:solidFill>
@@ -5601,8 +5601,8 @@
           <a:noFill/>
         </p:spPr>
         <p:txBody>
-          <a:bodyPr wrap="square">
-            <a:spAutoFit/>
+          <a:bodyPr wrap="square" lIns="0" rIns="0" tIns="0" bIns="0">
+            <a:noAutofit/>
           </a:bodyPr>
           <a:lstStyle/>
           <a:p>
@@ -5636,8 +5636,8 @@
           <a:noFill/>
         </p:spPr>
         <p:txBody>
-          <a:bodyPr wrap="square">
-            <a:spAutoFit/>
+          <a:bodyPr wrap="square" lIns="0" rIns="0" tIns="0" bIns="0">
+            <a:noAutofit/>
           </a:bodyPr>
           <a:lstStyle/>
           <a:p>
@@ -5671,8 +5671,8 @@
           <a:noFill/>
         </p:spPr>
         <p:txBody>
-          <a:bodyPr wrap="square">
-            <a:spAutoFit/>
+          <a:bodyPr wrap="square" lIns="0" rIns="0" tIns="0" bIns="0">
+            <a:noAutofit/>
           </a:bodyPr>
           <a:lstStyle/>
           <a:p>
@@ -5813,14 +5813,14 @@
           <a:noFill/>
         </p:spPr>
         <p:txBody>
-          <a:bodyPr wrap="square">
-            <a:spAutoFit/>
+          <a:bodyPr wrap="square" lIns="0" rIns="0" tIns="0" bIns="0">
+            <a:noAutofit/>
           </a:bodyPr>
           <a:lstStyle/>
           <a:p>
             <a:pPr algn="l"/>
             <a:r>
-              <a:rPr sz="1000" b="0" i="0">
+              <a:rPr sz="1100" b="0" i="0">
                 <a:solidFill>
                   <a:srgbClr val="FFFFFF"/>
                 </a:solidFill>
@@ -5848,14 +5848,14 @@
           <a:noFill/>
         </p:spPr>
         <p:txBody>
-          <a:bodyPr wrap="square">
-            <a:spAutoFit/>
+          <a:bodyPr wrap="square" lIns="0" rIns="0" tIns="0" bIns="0">
+            <a:noAutofit/>
           </a:bodyPr>
           <a:lstStyle/>
           <a:p>
             <a:pPr algn="r"/>
             <a:r>
-              <a:rPr sz="1000" b="0" i="0">
+              <a:rPr sz="1100" b="0" i="0">
                 <a:solidFill>
                   <a:srgbClr val="FFFFFF"/>
                 </a:solidFill>
@@ -6030,8 +6030,8 @@
           <a:noFill/>
         </p:spPr>
         <p:txBody>
-          <a:bodyPr wrap="square">
-            <a:spAutoFit/>
+          <a:bodyPr wrap="square" lIns="0" rIns="0" tIns="0" bIns="0">
+            <a:noAutofit/>
           </a:bodyPr>
           <a:lstStyle/>
           <a:p>
@@ -6065,8 +6065,8 @@
           <a:noFill/>
         </p:spPr>
         <p:txBody>
-          <a:bodyPr wrap="square">
-            <a:spAutoFit/>
+          <a:bodyPr wrap="square" lIns="0" rIns="0" tIns="0" bIns="0">
+            <a:noAutofit/>
           </a:bodyPr>
           <a:lstStyle/>
           <a:p>
@@ -6100,8 +6100,8 @@
           <a:noFill/>
         </p:spPr>
         <p:txBody>
-          <a:bodyPr wrap="square">
-            <a:spAutoFit/>
+          <a:bodyPr wrap="square" lIns="0" rIns="0" tIns="0" bIns="0">
+            <a:noAutofit/>
           </a:bodyPr>
           <a:lstStyle/>
           <a:p>
@@ -6242,14 +6242,14 @@
           <a:noFill/>
         </p:spPr>
         <p:txBody>
-          <a:bodyPr wrap="square">
-            <a:spAutoFit/>
+          <a:bodyPr wrap="square" lIns="0" rIns="0" tIns="0" bIns="0">
+            <a:noAutofit/>
           </a:bodyPr>
           <a:lstStyle/>
           <a:p>
             <a:pPr algn="l"/>
             <a:r>
-              <a:rPr sz="1000" b="0" i="0">
+              <a:rPr sz="1100" b="0" i="0">
                 <a:solidFill>
                   <a:srgbClr val="FFFFFF"/>
                 </a:solidFill>
@@ -6277,14 +6277,14 @@
           <a:noFill/>
         </p:spPr>
         <p:txBody>
-          <a:bodyPr wrap="square">
-            <a:spAutoFit/>
+          <a:bodyPr wrap="square" lIns="0" rIns="0" tIns="0" bIns="0">
+            <a:noAutofit/>
           </a:bodyPr>
           <a:lstStyle/>
           <a:p>
             <a:pPr algn="r"/>
             <a:r>
-              <a:rPr sz="1000" b="0" i="0">
+              <a:rPr sz="1100" b="0" i="0">
                 <a:solidFill>
                   <a:srgbClr val="FFFFFF"/>
                 </a:solidFill>
@@ -6459,8 +6459,8 @@
           <a:noFill/>
         </p:spPr>
         <p:txBody>
-          <a:bodyPr wrap="square">
-            <a:spAutoFit/>
+          <a:bodyPr wrap="square" lIns="0" rIns="0" tIns="0" bIns="0">
+            <a:noAutofit/>
           </a:bodyPr>
           <a:lstStyle/>
           <a:p>
@@ -6494,8 +6494,8 @@
           <a:noFill/>
         </p:spPr>
         <p:txBody>
-          <a:bodyPr wrap="square">
-            <a:spAutoFit/>
+          <a:bodyPr wrap="square" lIns="0" rIns="0" tIns="0" bIns="0">
+            <a:noAutofit/>
           </a:bodyPr>
           <a:lstStyle/>
           <a:p>
@@ -6529,8 +6529,8 @@
           <a:noFill/>
         </p:spPr>
         <p:txBody>
-          <a:bodyPr wrap="square">
-            <a:spAutoFit/>
+          <a:bodyPr wrap="square" lIns="0" rIns="0" tIns="0" bIns="0">
+            <a:noAutofit/>
           </a:bodyPr>
           <a:lstStyle/>
           <a:p>
@@ -6671,14 +6671,14 @@
           <a:noFill/>
         </p:spPr>
         <p:txBody>
-          <a:bodyPr wrap="square">
-            <a:spAutoFit/>
+          <a:bodyPr wrap="square" lIns="0" rIns="0" tIns="0" bIns="0">
+            <a:noAutofit/>
           </a:bodyPr>
           <a:lstStyle/>
           <a:p>
             <a:pPr algn="l"/>
             <a:r>
-              <a:rPr sz="1000" b="0" i="0">
+              <a:rPr sz="1100" b="0" i="0">
                 <a:solidFill>
                   <a:srgbClr val="FFFFFF"/>
                 </a:solidFill>
@@ -6706,14 +6706,14 @@
           <a:noFill/>
         </p:spPr>
         <p:txBody>
-          <a:bodyPr wrap="square">
-            <a:spAutoFit/>
+          <a:bodyPr wrap="square" lIns="0" rIns="0" tIns="0" bIns="0">
+            <a:noAutofit/>
           </a:bodyPr>
           <a:lstStyle/>
           <a:p>
             <a:pPr algn="r"/>
             <a:r>
-              <a:rPr sz="1000" b="0" i="0">
+              <a:rPr sz="1100" b="0" i="0">
                 <a:solidFill>
                   <a:srgbClr val="FFFFFF"/>
                 </a:solidFill>
@@ -6888,8 +6888,8 @@
           <a:noFill/>
         </p:spPr>
         <p:txBody>
-          <a:bodyPr wrap="square">
-            <a:spAutoFit/>
+          <a:bodyPr wrap="square" lIns="0" rIns="0" tIns="0" bIns="0">
+            <a:noAutofit/>
           </a:bodyPr>
           <a:lstStyle/>
           <a:p>
@@ -6923,8 +6923,8 @@
           <a:noFill/>
         </p:spPr>
         <p:txBody>
-          <a:bodyPr wrap="square">
-            <a:spAutoFit/>
+          <a:bodyPr wrap="square" lIns="0" rIns="0" tIns="0" bIns="0">
+            <a:noAutofit/>
           </a:bodyPr>
           <a:lstStyle/>
           <a:p>
@@ -7001,8 +7001,8 @@
           <a:noFill/>
         </p:spPr>
         <p:txBody>
-          <a:bodyPr wrap="square">
-            <a:spAutoFit/>
+          <a:bodyPr wrap="square" lIns="0" rIns="0" tIns="0" bIns="0">
+            <a:noAutofit/>
           </a:bodyPr>
           <a:lstStyle/>
           <a:p>
@@ -7036,8 +7036,8 @@
           <a:noFill/>
         </p:spPr>
         <p:txBody>
-          <a:bodyPr wrap="square">
-            <a:spAutoFit/>
+          <a:bodyPr wrap="square" lIns="0" rIns="0" tIns="0" bIns="0">
+            <a:noAutofit/>
           </a:bodyPr>
           <a:lstStyle/>
           <a:p>
@@ -7178,14 +7178,14 @@
           <a:noFill/>
         </p:spPr>
         <p:txBody>
-          <a:bodyPr wrap="square">
-            <a:spAutoFit/>
+          <a:bodyPr wrap="square" lIns="0" rIns="0" tIns="0" bIns="0">
+            <a:noAutofit/>
           </a:bodyPr>
           <a:lstStyle/>
           <a:p>
             <a:pPr algn="l"/>
             <a:r>
-              <a:rPr sz="1000" b="0" i="0">
+              <a:rPr sz="1100" b="0" i="0">
                 <a:solidFill>
                   <a:srgbClr val="FFFFFF"/>
                 </a:solidFill>
@@ -7213,14 +7213,14 @@
           <a:noFill/>
         </p:spPr>
         <p:txBody>
-          <a:bodyPr wrap="square">
-            <a:spAutoFit/>
+          <a:bodyPr wrap="square" lIns="0" rIns="0" tIns="0" bIns="0">
+            <a:noAutofit/>
           </a:bodyPr>
           <a:lstStyle/>
           <a:p>
             <a:pPr algn="r"/>
             <a:r>
-              <a:rPr sz="1000" b="0" i="0">
+              <a:rPr sz="1100" b="0" i="0">
                 <a:solidFill>
                   <a:srgbClr val="FFFFFF"/>
                 </a:solidFill>
@@ -7395,8 +7395,8 @@
           <a:noFill/>
         </p:spPr>
         <p:txBody>
-          <a:bodyPr wrap="square">
-            <a:spAutoFit/>
+          <a:bodyPr wrap="square" lIns="0" rIns="0" tIns="0" bIns="0">
+            <a:noAutofit/>
           </a:bodyPr>
           <a:lstStyle/>
           <a:p>
@@ -7430,8 +7430,8 @@
           <a:noFill/>
         </p:spPr>
         <p:txBody>
-          <a:bodyPr wrap="square">
-            <a:spAutoFit/>
+          <a:bodyPr wrap="square" lIns="0" rIns="0" tIns="0" bIns="0">
+            <a:noAutofit/>
           </a:bodyPr>
           <a:lstStyle/>
           <a:p>
@@ -7465,8 +7465,8 @@
           <a:noFill/>
         </p:spPr>
         <p:txBody>
-          <a:bodyPr wrap="square">
-            <a:spAutoFit/>
+          <a:bodyPr wrap="square" lIns="0" rIns="0" tIns="0" bIns="0">
+            <a:noAutofit/>
           </a:bodyPr>
           <a:lstStyle/>
           <a:p>
@@ -7607,14 +7607,14 @@
           <a:noFill/>
         </p:spPr>
         <p:txBody>
-          <a:bodyPr wrap="square">
-            <a:spAutoFit/>
+          <a:bodyPr wrap="square" lIns="0" rIns="0" tIns="0" bIns="0">
+            <a:noAutofit/>
           </a:bodyPr>
           <a:lstStyle/>
           <a:p>
             <a:pPr algn="l"/>
             <a:r>
-              <a:rPr sz="1000" b="0" i="0">
+              <a:rPr sz="1100" b="0" i="0">
                 <a:solidFill>
                   <a:srgbClr val="FFFFFF"/>
                 </a:solidFill>
@@ -7642,14 +7642,14 @@
           <a:noFill/>
         </p:spPr>
         <p:txBody>
-          <a:bodyPr wrap="square">
-            <a:spAutoFit/>
+          <a:bodyPr wrap="square" lIns="0" rIns="0" tIns="0" bIns="0">
+            <a:noAutofit/>
           </a:bodyPr>
           <a:lstStyle/>
           <a:p>
             <a:pPr algn="r"/>
             <a:r>
-              <a:rPr sz="1000" b="0" i="0">
+              <a:rPr sz="1100" b="0" i="0">
                 <a:solidFill>
                   <a:srgbClr val="FFFFFF"/>
                 </a:solidFill>
@@ -7824,8 +7824,8 @@
           <a:noFill/>
         </p:spPr>
         <p:txBody>
-          <a:bodyPr wrap="square">
-            <a:spAutoFit/>
+          <a:bodyPr wrap="square" lIns="0" rIns="0" tIns="0" bIns="0">
+            <a:noAutofit/>
           </a:bodyPr>
           <a:lstStyle/>
           <a:p>
@@ -7859,8 +7859,8 @@
           <a:noFill/>
         </p:spPr>
         <p:txBody>
-          <a:bodyPr wrap="square">
-            <a:spAutoFit/>
+          <a:bodyPr wrap="square" lIns="0" rIns="0" tIns="0" bIns="0">
+            <a:noAutofit/>
           </a:bodyPr>
           <a:lstStyle/>
           <a:p>
@@ -7937,8 +7937,8 @@
           <a:noFill/>
         </p:spPr>
         <p:txBody>
-          <a:bodyPr wrap="square">
-            <a:spAutoFit/>
+          <a:bodyPr wrap="square" lIns="0" rIns="0" tIns="0" bIns="0">
+            <a:noAutofit/>
           </a:bodyPr>
           <a:lstStyle/>
           <a:p>
@@ -8079,14 +8079,14 @@
           <a:noFill/>
         </p:spPr>
         <p:txBody>
-          <a:bodyPr wrap="square">
-            <a:spAutoFit/>
+          <a:bodyPr wrap="square" lIns="0" rIns="0" tIns="0" bIns="0">
+            <a:noAutofit/>
           </a:bodyPr>
           <a:lstStyle/>
           <a:p>
             <a:pPr algn="l"/>
             <a:r>
-              <a:rPr sz="1000" b="0" i="0">
+              <a:rPr sz="1100" b="0" i="0">
                 <a:solidFill>
                   <a:srgbClr val="FFFFFF"/>
                 </a:solidFill>
@@ -8114,14 +8114,14 @@
           <a:noFill/>
         </p:spPr>
         <p:txBody>
-          <a:bodyPr wrap="square">
-            <a:spAutoFit/>
+          <a:bodyPr wrap="square" lIns="0" rIns="0" tIns="0" bIns="0">
+            <a:noAutofit/>
           </a:bodyPr>
           <a:lstStyle/>
           <a:p>
             <a:pPr algn="r"/>
             <a:r>
-              <a:rPr sz="1000" b="0" i="0">
+              <a:rPr sz="1100" b="0" i="0">
                 <a:solidFill>
                   <a:srgbClr val="FFFFFF"/>
                 </a:solidFill>
@@ -8210,8 +8210,8 @@
           <a:noFill/>
         </p:spPr>
         <p:txBody>
-          <a:bodyPr wrap="square">
-            <a:spAutoFit/>
+          <a:bodyPr wrap="square" lIns="0" rIns="0" tIns="0" bIns="0">
+            <a:noAutofit/>
           </a:bodyPr>
           <a:lstStyle/>
           <a:p>
@@ -8245,8 +8245,8 @@
           <a:noFill/>
         </p:spPr>
         <p:txBody>
-          <a:bodyPr wrap="square">
-            <a:spAutoFit/>
+          <a:bodyPr wrap="square" lIns="0" rIns="0" tIns="0" bIns="0">
+            <a:noAutofit/>
           </a:bodyPr>
           <a:lstStyle/>
           <a:p>
@@ -8427,8 +8427,8 @@
           <a:noFill/>
         </p:spPr>
         <p:txBody>
-          <a:bodyPr wrap="square">
-            <a:spAutoFit/>
+          <a:bodyPr wrap="square" lIns="0" rIns="0" tIns="0" bIns="0">
+            <a:noAutofit/>
           </a:bodyPr>
           <a:lstStyle/>
           <a:p>
@@ -8462,8 +8462,8 @@
           <a:noFill/>
         </p:spPr>
         <p:txBody>
-          <a:bodyPr wrap="square">
-            <a:spAutoFit/>
+          <a:bodyPr wrap="square" lIns="0" rIns="0" tIns="0" bIns="0">
+            <a:noAutofit/>
           </a:bodyPr>
           <a:lstStyle/>
           <a:p>
@@ -8540,8 +8540,8 @@
           <a:noFill/>
         </p:spPr>
         <p:txBody>
-          <a:bodyPr wrap="square">
-            <a:spAutoFit/>
+          <a:bodyPr wrap="square" lIns="0" rIns="0" tIns="0" bIns="0">
+            <a:noAutofit/>
           </a:bodyPr>
           <a:lstStyle/>
           <a:p>
@@ -8575,8 +8575,8 @@
           <a:noFill/>
         </p:spPr>
         <p:txBody>
-          <a:bodyPr wrap="square">
-            <a:spAutoFit/>
+          <a:bodyPr wrap="square" lIns="0" rIns="0" tIns="0" bIns="0">
+            <a:noAutofit/>
           </a:bodyPr>
           <a:lstStyle/>
           <a:p>
@@ -8717,8 +8717,8 @@
           <a:noFill/>
         </p:spPr>
         <p:txBody>
-          <a:bodyPr wrap="square">
-            <a:spAutoFit/>
+          <a:bodyPr wrap="square" lIns="0" rIns="0" tIns="0" bIns="0">
+            <a:noAutofit/>
           </a:bodyPr>
           <a:lstStyle/>
           <a:p>
@@ -8752,8 +8752,8 @@
           <a:noFill/>
         </p:spPr>
         <p:txBody>
-          <a:bodyPr wrap="square">
-            <a:spAutoFit/>
+          <a:bodyPr wrap="square" lIns="0" rIns="0" tIns="0" bIns="0">
+            <a:noAutofit/>
           </a:bodyPr>
           <a:lstStyle/>
           <a:p>
@@ -8894,14 +8894,14 @@
           <a:noFill/>
         </p:spPr>
         <p:txBody>
-          <a:bodyPr wrap="square">
-            <a:spAutoFit/>
+          <a:bodyPr wrap="square" lIns="0" rIns="0" tIns="0" bIns="0">
+            <a:noAutofit/>
           </a:bodyPr>
           <a:lstStyle/>
           <a:p>
             <a:pPr algn="l"/>
             <a:r>
-              <a:rPr sz="1000" b="0" i="0">
+              <a:rPr sz="1100" b="0" i="0">
                 <a:solidFill>
                   <a:srgbClr val="FFFFFF"/>
                 </a:solidFill>
@@ -8929,14 +8929,14 @@
           <a:noFill/>
         </p:spPr>
         <p:txBody>
-          <a:bodyPr wrap="square">
-            <a:spAutoFit/>
+          <a:bodyPr wrap="square" lIns="0" rIns="0" tIns="0" bIns="0">
+            <a:noAutofit/>
           </a:bodyPr>
           <a:lstStyle/>
           <a:p>
             <a:pPr algn="r"/>
             <a:r>
-              <a:rPr sz="1000" b="0" i="0">
+              <a:rPr sz="1100" b="0" i="0">
                 <a:solidFill>
                   <a:srgbClr val="FFFFFF"/>
                 </a:solidFill>
@@ -9111,8 +9111,8 @@
           <a:noFill/>
         </p:spPr>
         <p:txBody>
-          <a:bodyPr wrap="square">
-            <a:spAutoFit/>
+          <a:bodyPr wrap="square" lIns="0" rIns="0" tIns="0" bIns="0">
+            <a:noAutofit/>
           </a:bodyPr>
           <a:lstStyle/>
           <a:p>
@@ -9146,8 +9146,8 @@
           <a:noFill/>
         </p:spPr>
         <p:txBody>
-          <a:bodyPr wrap="square">
-            <a:spAutoFit/>
+          <a:bodyPr wrap="square" lIns="0" rIns="0" tIns="0" bIns="0">
+            <a:noAutofit/>
           </a:bodyPr>
           <a:lstStyle/>
           <a:p>
@@ -9181,8 +9181,8 @@
           <a:noFill/>
         </p:spPr>
         <p:txBody>
-          <a:bodyPr wrap="square">
-            <a:spAutoFit/>
+          <a:bodyPr wrap="square" lIns="0" rIns="0" tIns="0" bIns="0">
+            <a:noAutofit/>
           </a:bodyPr>
           <a:lstStyle/>
           <a:p>
@@ -9323,14 +9323,14 @@
           <a:noFill/>
         </p:spPr>
         <p:txBody>
-          <a:bodyPr wrap="square">
-            <a:spAutoFit/>
+          <a:bodyPr wrap="square" lIns="0" rIns="0" tIns="0" bIns="0">
+            <a:noAutofit/>
           </a:bodyPr>
           <a:lstStyle/>
           <a:p>
             <a:pPr algn="l"/>
             <a:r>
-              <a:rPr sz="1000" b="0" i="0">
+              <a:rPr sz="1100" b="0" i="0">
                 <a:solidFill>
                   <a:srgbClr val="FFFFFF"/>
                 </a:solidFill>
@@ -9358,14 +9358,14 @@
           <a:noFill/>
         </p:spPr>
         <p:txBody>
-          <a:bodyPr wrap="square">
-            <a:spAutoFit/>
+          <a:bodyPr wrap="square" lIns="0" rIns="0" tIns="0" bIns="0">
+            <a:noAutofit/>
           </a:bodyPr>
           <a:lstStyle/>
           <a:p>
             <a:pPr algn="r"/>
             <a:r>
-              <a:rPr sz="1000" b="0" i="0">
+              <a:rPr sz="1100" b="0" i="0">
                 <a:solidFill>
                   <a:srgbClr val="FFFFFF"/>
                 </a:solidFill>
@@ -9540,8 +9540,8 @@
           <a:noFill/>
         </p:spPr>
         <p:txBody>
-          <a:bodyPr wrap="square">
-            <a:spAutoFit/>
+          <a:bodyPr wrap="square" lIns="0" rIns="0" tIns="0" bIns="0">
+            <a:noAutofit/>
           </a:bodyPr>
           <a:lstStyle/>
           <a:p>
@@ -9575,8 +9575,8 @@
           <a:noFill/>
         </p:spPr>
         <p:txBody>
-          <a:bodyPr wrap="square">
-            <a:spAutoFit/>
+          <a:bodyPr wrap="square" lIns="0" rIns="0" tIns="0" bIns="0">
+            <a:noAutofit/>
           </a:bodyPr>
           <a:lstStyle/>
           <a:p>
@@ -9653,8 +9653,8 @@
           <a:noFill/>
         </p:spPr>
         <p:txBody>
-          <a:bodyPr wrap="square">
-            <a:spAutoFit/>
+          <a:bodyPr wrap="square" lIns="0" rIns="0" tIns="0" bIns="0">
+            <a:noAutofit/>
           </a:bodyPr>
           <a:lstStyle/>
           <a:p>
@@ -9688,8 +9688,8 @@
           <a:noFill/>
         </p:spPr>
         <p:txBody>
-          <a:bodyPr wrap="square">
-            <a:spAutoFit/>
+          <a:bodyPr wrap="square" lIns="0" rIns="0" tIns="0" bIns="0">
+            <a:noAutofit/>
           </a:bodyPr>
           <a:lstStyle/>
           <a:p>
@@ -9830,8 +9830,8 @@
           <a:noFill/>
         </p:spPr>
         <p:txBody>
-          <a:bodyPr wrap="square">
-            <a:spAutoFit/>
+          <a:bodyPr wrap="square" lIns="0" rIns="0" tIns="0" bIns="0">
+            <a:noAutofit/>
           </a:bodyPr>
           <a:lstStyle/>
           <a:p>
@@ -9865,8 +9865,8 @@
           <a:noFill/>
         </p:spPr>
         <p:txBody>
-          <a:bodyPr wrap="square">
-            <a:spAutoFit/>
+          <a:bodyPr wrap="square" lIns="0" rIns="0" tIns="0" bIns="0">
+            <a:noAutofit/>
           </a:bodyPr>
           <a:lstStyle/>
           <a:p>
@@ -10045,14 +10045,14 @@
           <a:noFill/>
         </p:spPr>
         <p:txBody>
-          <a:bodyPr wrap="square">
-            <a:spAutoFit/>
+          <a:bodyPr wrap="square" lIns="0" rIns="0" tIns="0" bIns="0">
+            <a:noAutofit/>
           </a:bodyPr>
           <a:lstStyle/>
           <a:p>
             <a:pPr algn="l"/>
             <a:r>
-              <a:rPr sz="1000" b="0" i="0">
+              <a:rPr sz="1100" b="0" i="0">
                 <a:solidFill>
                   <a:srgbClr val="FFFFFF"/>
                 </a:solidFill>
@@ -10080,14 +10080,14 @@
           <a:noFill/>
         </p:spPr>
         <p:txBody>
-          <a:bodyPr wrap="square">
-            <a:spAutoFit/>
+          <a:bodyPr wrap="square" lIns="0" rIns="0" tIns="0" bIns="0">
+            <a:noAutofit/>
           </a:bodyPr>
           <a:lstStyle/>
           <a:p>
             <a:pPr algn="r"/>
             <a:r>
-              <a:rPr sz="1000" b="0" i="0">
+              <a:rPr sz="1100" b="0" i="0">
                 <a:solidFill>
                   <a:srgbClr val="FFFFFF"/>
                 </a:solidFill>
@@ -10262,8 +10262,8 @@
           <a:noFill/>
         </p:spPr>
         <p:txBody>
-          <a:bodyPr wrap="square">
-            <a:spAutoFit/>
+          <a:bodyPr wrap="square" lIns="0" rIns="0" tIns="0" bIns="0">
+            <a:noAutofit/>
           </a:bodyPr>
           <a:lstStyle/>
           <a:p>
@@ -10297,8 +10297,8 @@
           <a:noFill/>
         </p:spPr>
         <p:txBody>
-          <a:bodyPr wrap="square">
-            <a:spAutoFit/>
+          <a:bodyPr wrap="square" lIns="0" rIns="0" tIns="0" bIns="0">
+            <a:noAutofit/>
           </a:bodyPr>
           <a:lstStyle/>
           <a:p>
@@ -10332,8 +10332,8 @@
           <a:noFill/>
         </p:spPr>
         <p:txBody>
-          <a:bodyPr wrap="square">
-            <a:spAutoFit/>
+          <a:bodyPr wrap="square" lIns="0" rIns="0" tIns="0" bIns="0">
+            <a:noAutofit/>
           </a:bodyPr>
           <a:lstStyle/>
           <a:p>
@@ -10367,8 +10367,8 @@
           <a:noFill/>
         </p:spPr>
         <p:txBody>
-          <a:bodyPr wrap="square">
-            <a:spAutoFit/>
+          <a:bodyPr wrap="square" lIns="0" rIns="0" tIns="0" bIns="0">
+            <a:noAutofit/>
           </a:bodyPr>
           <a:lstStyle/>
           <a:p>
@@ -10445,8 +10445,8 @@
           <a:noFill/>
         </p:spPr>
         <p:txBody>
-          <a:bodyPr wrap="square">
-            <a:spAutoFit/>
+          <a:bodyPr wrap="square" lIns="0" rIns="0" tIns="0" bIns="0">
+            <a:noAutofit/>
           </a:bodyPr>
           <a:lstStyle/>
           <a:p>
@@ -10480,8 +10480,8 @@
           <a:noFill/>
         </p:spPr>
         <p:txBody>
-          <a:bodyPr wrap="square">
-            <a:spAutoFit/>
+          <a:bodyPr wrap="square" lIns="0" rIns="0" tIns="0" bIns="0">
+            <a:noAutofit/>
           </a:bodyPr>
           <a:lstStyle/>
           <a:p>
@@ -10558,8 +10558,8 @@
           <a:noFill/>
         </p:spPr>
         <p:txBody>
-          <a:bodyPr wrap="square">
-            <a:spAutoFit/>
+          <a:bodyPr wrap="square" lIns="0" rIns="0" tIns="0" bIns="0">
+            <a:noAutofit/>
           </a:bodyPr>
           <a:lstStyle/>
           <a:p>
@@ -10593,8 +10593,8 @@
           <a:noFill/>
         </p:spPr>
         <p:txBody>
-          <a:bodyPr wrap="square">
-            <a:spAutoFit/>
+          <a:bodyPr wrap="square" lIns="0" rIns="0" tIns="0" bIns="0">
+            <a:noAutofit/>
           </a:bodyPr>
           <a:lstStyle/>
           <a:p>
@@ -10671,8 +10671,8 @@
           <a:noFill/>
         </p:spPr>
         <p:txBody>
-          <a:bodyPr wrap="square">
-            <a:spAutoFit/>
+          <a:bodyPr wrap="square" lIns="0" rIns="0" tIns="0" bIns="0">
+            <a:noAutofit/>
           </a:bodyPr>
           <a:lstStyle/>
           <a:p>
@@ -10706,8 +10706,8 @@
           <a:noFill/>
         </p:spPr>
         <p:txBody>
-          <a:bodyPr wrap="square">
-            <a:spAutoFit/>
+          <a:bodyPr wrap="square" lIns="0" rIns="0" tIns="0" bIns="0">
+            <a:noAutofit/>
           </a:bodyPr>
           <a:lstStyle/>
           <a:p>
@@ -10784,8 +10784,8 @@
           <a:noFill/>
         </p:spPr>
         <p:txBody>
-          <a:bodyPr wrap="square">
-            <a:spAutoFit/>
+          <a:bodyPr wrap="square" lIns="0" rIns="0" tIns="0" bIns="0">
+            <a:noAutofit/>
           </a:bodyPr>
           <a:lstStyle/>
           <a:p>
@@ -10819,8 +10819,8 @@
           <a:noFill/>
         </p:spPr>
         <p:txBody>
-          <a:bodyPr wrap="square">
-            <a:spAutoFit/>
+          <a:bodyPr wrap="square" lIns="0" rIns="0" tIns="0" bIns="0">
+            <a:noAutofit/>
           </a:bodyPr>
           <a:lstStyle/>
           <a:p>
@@ -10897,8 +10897,8 @@
           <a:noFill/>
         </p:spPr>
         <p:txBody>
-          <a:bodyPr wrap="square">
-            <a:spAutoFit/>
+          <a:bodyPr wrap="square" lIns="0" rIns="0" tIns="0" bIns="0">
+            <a:noAutofit/>
           </a:bodyPr>
           <a:lstStyle/>
           <a:p>
@@ -10932,8 +10932,8 @@
           <a:noFill/>
         </p:spPr>
         <p:txBody>
-          <a:bodyPr wrap="square">
-            <a:spAutoFit/>
+          <a:bodyPr wrap="square" lIns="0" rIns="0" tIns="0" bIns="0">
+            <a:noAutofit/>
           </a:bodyPr>
           <a:lstStyle/>
           <a:p>
@@ -11010,8 +11010,8 @@
           <a:noFill/>
         </p:spPr>
         <p:txBody>
-          <a:bodyPr wrap="square">
-            <a:spAutoFit/>
+          <a:bodyPr wrap="square" lIns="0" rIns="0" tIns="0" bIns="0">
+            <a:noAutofit/>
           </a:bodyPr>
           <a:lstStyle/>
           <a:p>
@@ -11045,8 +11045,8 @@
           <a:noFill/>
         </p:spPr>
         <p:txBody>
-          <a:bodyPr wrap="square">
-            <a:spAutoFit/>
+          <a:bodyPr wrap="square" lIns="0" rIns="0" tIns="0" bIns="0">
+            <a:noAutofit/>
           </a:bodyPr>
           <a:lstStyle/>
           <a:p>
@@ -11123,8 +11123,8 @@
           <a:noFill/>
         </p:spPr>
         <p:txBody>
-          <a:bodyPr wrap="square">
-            <a:spAutoFit/>
+          <a:bodyPr wrap="square" lIns="0" rIns="0" tIns="0" bIns="0">
+            <a:noAutofit/>
           </a:bodyPr>
           <a:lstStyle/>
           <a:p>
@@ -11158,8 +11158,8 @@
           <a:noFill/>
         </p:spPr>
         <p:txBody>
-          <a:bodyPr wrap="square">
-            <a:spAutoFit/>
+          <a:bodyPr wrap="square" lIns="0" rIns="0" tIns="0" bIns="0">
+            <a:noAutofit/>
           </a:bodyPr>
           <a:lstStyle/>
           <a:p>
@@ -11236,8 +11236,8 @@
           <a:noFill/>
         </p:spPr>
         <p:txBody>
-          <a:bodyPr wrap="square">
-            <a:spAutoFit/>
+          <a:bodyPr wrap="square" lIns="0" rIns="0" tIns="0" bIns="0">
+            <a:noAutofit/>
           </a:bodyPr>
           <a:lstStyle/>
           <a:p>
@@ -11271,8 +11271,8 @@
           <a:noFill/>
         </p:spPr>
         <p:txBody>
-          <a:bodyPr wrap="square">
-            <a:spAutoFit/>
+          <a:bodyPr wrap="square" lIns="0" rIns="0" tIns="0" bIns="0">
+            <a:noAutofit/>
           </a:bodyPr>
           <a:lstStyle/>
           <a:p>
@@ -11349,8 +11349,8 @@
           <a:noFill/>
         </p:spPr>
         <p:txBody>
-          <a:bodyPr wrap="square">
-            <a:spAutoFit/>
+          <a:bodyPr wrap="square" lIns="0" rIns="0" tIns="0" bIns="0">
+            <a:noAutofit/>
           </a:bodyPr>
           <a:lstStyle/>
           <a:p>
@@ -11384,8 +11384,8 @@
           <a:noFill/>
         </p:spPr>
         <p:txBody>
-          <a:bodyPr wrap="square">
-            <a:spAutoFit/>
+          <a:bodyPr wrap="square" lIns="0" rIns="0" tIns="0" bIns="0">
+            <a:noAutofit/>
           </a:bodyPr>
           <a:lstStyle/>
           <a:p>
@@ -11462,8 +11462,8 @@
           <a:noFill/>
         </p:spPr>
         <p:txBody>
-          <a:bodyPr wrap="square">
-            <a:spAutoFit/>
+          <a:bodyPr wrap="square" lIns="0" rIns="0" tIns="0" bIns="0">
+            <a:noAutofit/>
           </a:bodyPr>
           <a:lstStyle/>
           <a:p>
@@ -11497,8 +11497,8 @@
           <a:noFill/>
         </p:spPr>
         <p:txBody>
-          <a:bodyPr wrap="square">
-            <a:spAutoFit/>
+          <a:bodyPr wrap="square" lIns="0" rIns="0" tIns="0" bIns="0">
+            <a:noAutofit/>
           </a:bodyPr>
           <a:lstStyle/>
           <a:p>
@@ -11532,8 +11532,8 @@
           <a:noFill/>
         </p:spPr>
         <p:txBody>
-          <a:bodyPr wrap="square">
-            <a:spAutoFit/>
+          <a:bodyPr wrap="square" lIns="0" rIns="0" tIns="0" bIns="0">
+            <a:noAutofit/>
           </a:bodyPr>
           <a:lstStyle/>
           <a:p>
@@ -11610,14 +11610,14 @@
           <a:noFill/>
         </p:spPr>
         <p:txBody>
-          <a:bodyPr wrap="square">
-            <a:spAutoFit/>
+          <a:bodyPr wrap="square" lIns="0" rIns="0" tIns="0" bIns="0">
+            <a:noAutofit/>
           </a:bodyPr>
           <a:lstStyle/>
           <a:p>
             <a:pPr algn="l"/>
             <a:r>
-              <a:rPr sz="1000" b="0" i="0">
+              <a:rPr sz="1100" b="0" i="0">
                 <a:solidFill>
                   <a:srgbClr val="FFFFFF"/>
                 </a:solidFill>
@@ -11645,14 +11645,14 @@
           <a:noFill/>
         </p:spPr>
         <p:txBody>
-          <a:bodyPr wrap="square">
-            <a:spAutoFit/>
+          <a:bodyPr wrap="square" lIns="0" rIns="0" tIns="0" bIns="0">
+            <a:noAutofit/>
           </a:bodyPr>
           <a:lstStyle/>
           <a:p>
             <a:pPr algn="r"/>
             <a:r>
-              <a:rPr sz="1000" b="0" i="0">
+              <a:rPr sz="1100" b="0" i="0">
                 <a:solidFill>
                   <a:srgbClr val="FFFFFF"/>
                 </a:solidFill>
@@ -11827,8 +11827,8 @@
           <a:noFill/>
         </p:spPr>
         <p:txBody>
-          <a:bodyPr wrap="square">
-            <a:spAutoFit/>
+          <a:bodyPr wrap="square" lIns="0" rIns="0" tIns="0" bIns="0">
+            <a:noAutofit/>
           </a:bodyPr>
           <a:lstStyle/>
           <a:p>
@@ -11862,8 +11862,8 @@
           <a:noFill/>
         </p:spPr>
         <p:txBody>
-          <a:bodyPr wrap="square">
-            <a:spAutoFit/>
+          <a:bodyPr wrap="square" lIns="0" rIns="0" tIns="0" bIns="0">
+            <a:noAutofit/>
           </a:bodyPr>
           <a:lstStyle/>
           <a:p>
@@ -11969,8 +11969,8 @@
           <a:noFill/>
         </p:spPr>
         <p:txBody>
-          <a:bodyPr wrap="square">
-            <a:spAutoFit/>
+          <a:bodyPr wrap="square" lIns="0" rIns="0" tIns="0" bIns="0">
+            <a:noAutofit/>
           </a:bodyPr>
           <a:lstStyle/>
           <a:p>
@@ -12047,14 +12047,14 @@
           <a:noFill/>
         </p:spPr>
         <p:txBody>
-          <a:bodyPr wrap="square">
-            <a:spAutoFit/>
+          <a:bodyPr wrap="square" lIns="0" rIns="0" tIns="0" bIns="0">
+            <a:noAutofit/>
           </a:bodyPr>
           <a:lstStyle/>
           <a:p>
             <a:pPr algn="l"/>
             <a:r>
-              <a:rPr sz="1000" b="0" i="0">
+              <a:rPr sz="1100" b="0" i="0">
                 <a:solidFill>
                   <a:srgbClr val="FFFFFF"/>
                 </a:solidFill>
@@ -12082,14 +12082,14 @@
           <a:noFill/>
         </p:spPr>
         <p:txBody>
-          <a:bodyPr wrap="square">
-            <a:spAutoFit/>
+          <a:bodyPr wrap="square" lIns="0" rIns="0" tIns="0" bIns="0">
+            <a:noAutofit/>
           </a:bodyPr>
           <a:lstStyle/>
           <a:p>
             <a:pPr algn="r"/>
             <a:r>
-              <a:rPr sz="1000" b="0" i="0">
+              <a:rPr sz="1100" b="0" i="0">
                 <a:solidFill>
                   <a:srgbClr val="FFFFFF"/>
                 </a:solidFill>
@@ -12264,8 +12264,8 @@
           <a:noFill/>
         </p:spPr>
         <p:txBody>
-          <a:bodyPr wrap="square">
-            <a:spAutoFit/>
+          <a:bodyPr wrap="square" lIns="0" rIns="0" tIns="0" bIns="0">
+            <a:noAutofit/>
           </a:bodyPr>
           <a:lstStyle/>
           <a:p>
@@ -12299,8 +12299,8 @@
           <a:noFill/>
         </p:spPr>
         <p:txBody>
-          <a:bodyPr wrap="square">
-            <a:spAutoFit/>
+          <a:bodyPr wrap="square" lIns="0" rIns="0" tIns="0" bIns="0">
+            <a:noAutofit/>
           </a:bodyPr>
           <a:lstStyle/>
           <a:p>
@@ -12382,8 +12382,8 @@
           <a:noFill/>
         </p:spPr>
         <p:txBody>
-          <a:bodyPr wrap="square">
-            <a:spAutoFit/>
+          <a:bodyPr wrap="square" lIns="0" rIns="0" tIns="0" bIns="0">
+            <a:noAutofit/>
           </a:bodyPr>
           <a:lstStyle/>
           <a:p>
@@ -12460,14 +12460,14 @@
           <a:noFill/>
         </p:spPr>
         <p:txBody>
-          <a:bodyPr wrap="square">
-            <a:spAutoFit/>
+          <a:bodyPr wrap="square" lIns="0" rIns="0" tIns="0" bIns="0">
+            <a:noAutofit/>
           </a:bodyPr>
           <a:lstStyle/>
           <a:p>
             <a:pPr algn="l"/>
             <a:r>
-              <a:rPr sz="1000" b="0" i="0">
+              <a:rPr sz="1100" b="0" i="0">
                 <a:solidFill>
                   <a:srgbClr val="FFFFFF"/>
                 </a:solidFill>
@@ -12495,14 +12495,14 @@
           <a:noFill/>
         </p:spPr>
         <p:txBody>
-          <a:bodyPr wrap="square">
-            <a:spAutoFit/>
+          <a:bodyPr wrap="square" lIns="0" rIns="0" tIns="0" bIns="0">
+            <a:noAutofit/>
           </a:bodyPr>
           <a:lstStyle/>
           <a:p>
             <a:pPr algn="r"/>
             <a:r>
-              <a:rPr sz="1000" b="0" i="0">
+              <a:rPr sz="1100" b="0" i="0">
                 <a:solidFill>
                   <a:srgbClr val="FFFFFF"/>
                 </a:solidFill>
@@ -12677,8 +12677,8 @@
           <a:noFill/>
         </p:spPr>
         <p:txBody>
-          <a:bodyPr wrap="square">
-            <a:spAutoFit/>
+          <a:bodyPr wrap="square" lIns="0" rIns="0" tIns="0" bIns="0">
+            <a:noAutofit/>
           </a:bodyPr>
           <a:lstStyle/>
           <a:p>
@@ -12712,8 +12712,8 @@
           <a:noFill/>
         </p:spPr>
         <p:txBody>
-          <a:bodyPr wrap="square">
-            <a:spAutoFit/>
+          <a:bodyPr wrap="square" lIns="0" rIns="0" tIns="0" bIns="0">
+            <a:noAutofit/>
           </a:bodyPr>
           <a:lstStyle/>
           <a:p>
@@ -12747,8 +12747,8 @@
           <a:noFill/>
         </p:spPr>
         <p:txBody>
-          <a:bodyPr wrap="square">
-            <a:spAutoFit/>
+          <a:bodyPr wrap="square" lIns="0" rIns="0" tIns="0" bIns="0">
+            <a:noAutofit/>
           </a:bodyPr>
           <a:lstStyle/>
           <a:p>
@@ -12889,14 +12889,14 @@
           <a:noFill/>
         </p:spPr>
         <p:txBody>
-          <a:bodyPr wrap="square">
-            <a:spAutoFit/>
+          <a:bodyPr wrap="square" lIns="0" rIns="0" tIns="0" bIns="0">
+            <a:noAutofit/>
           </a:bodyPr>
           <a:lstStyle/>
           <a:p>
             <a:pPr algn="l"/>
             <a:r>
-              <a:rPr sz="1000" b="0" i="0">
+              <a:rPr sz="1100" b="0" i="0">
                 <a:solidFill>
                   <a:srgbClr val="FFFFFF"/>
                 </a:solidFill>
@@ -12924,14 +12924,14 @@
           <a:noFill/>
         </p:spPr>
         <p:txBody>
-          <a:bodyPr wrap="square">
-            <a:spAutoFit/>
+          <a:bodyPr wrap="square" lIns="0" rIns="0" tIns="0" bIns="0">
+            <a:noAutofit/>
           </a:bodyPr>
           <a:lstStyle/>
           <a:p>
             <a:pPr algn="r"/>
             <a:r>
-              <a:rPr sz="1000" b="0" i="0">
+              <a:rPr sz="1100" b="0" i="0">
                 <a:solidFill>
                   <a:srgbClr val="FFFFFF"/>
                 </a:solidFill>
@@ -13106,8 +13106,8 @@
           <a:noFill/>
         </p:spPr>
         <p:txBody>
-          <a:bodyPr wrap="square">
-            <a:spAutoFit/>
+          <a:bodyPr wrap="square" lIns="0" rIns="0" tIns="0" bIns="0">
+            <a:noAutofit/>
           </a:bodyPr>
           <a:lstStyle/>
           <a:p>
@@ -13141,8 +13141,8 @@
           <a:noFill/>
         </p:spPr>
         <p:txBody>
-          <a:bodyPr wrap="square">
-            <a:spAutoFit/>
+          <a:bodyPr wrap="square" lIns="0" rIns="0" tIns="0" bIns="0">
+            <a:noAutofit/>
           </a:bodyPr>
           <a:lstStyle/>
           <a:p>
@@ -13219,8 +13219,8 @@
           <a:noFill/>
         </p:spPr>
         <p:txBody>
-          <a:bodyPr wrap="square">
-            <a:spAutoFit/>
+          <a:bodyPr wrap="square" lIns="0" rIns="0" tIns="0" bIns="0">
+            <a:noAutofit/>
           </a:bodyPr>
           <a:lstStyle/>
           <a:p>
@@ -13297,8 +13297,8 @@
           <a:noFill/>
         </p:spPr>
         <p:txBody>
-          <a:bodyPr wrap="square">
-            <a:spAutoFit/>
+          <a:bodyPr wrap="square" lIns="0" rIns="0" tIns="0" bIns="0">
+            <a:noAutofit/>
           </a:bodyPr>
           <a:lstStyle/>
           <a:p>
@@ -13375,8 +13375,8 @@
           <a:noFill/>
         </p:spPr>
         <p:txBody>
-          <a:bodyPr wrap="square">
-            <a:spAutoFit/>
+          <a:bodyPr wrap="square" lIns="0" rIns="0" tIns="0" bIns="0">
+            <a:noAutofit/>
           </a:bodyPr>
           <a:lstStyle/>
           <a:p>
@@ -13453,8 +13453,8 @@
           <a:noFill/>
         </p:spPr>
         <p:txBody>
-          <a:bodyPr wrap="square">
-            <a:spAutoFit/>
+          <a:bodyPr wrap="square" lIns="0" rIns="0" tIns="0" bIns="0">
+            <a:noAutofit/>
           </a:bodyPr>
           <a:lstStyle/>
           <a:p>
@@ -13531,8 +13531,8 @@
           <a:noFill/>
         </p:spPr>
         <p:txBody>
-          <a:bodyPr wrap="square">
-            <a:spAutoFit/>
+          <a:bodyPr wrap="square" lIns="0" rIns="0" tIns="0" bIns="0">
+            <a:noAutofit/>
           </a:bodyPr>
           <a:lstStyle/>
           <a:p>
@@ -13609,8 +13609,8 @@
           <a:noFill/>
         </p:spPr>
         <p:txBody>
-          <a:bodyPr wrap="square">
-            <a:spAutoFit/>
+          <a:bodyPr wrap="square" lIns="0" rIns="0" tIns="0" bIns="0">
+            <a:noAutofit/>
           </a:bodyPr>
           <a:lstStyle/>
           <a:p>
@@ -13687,8 +13687,8 @@
           <a:noFill/>
         </p:spPr>
         <p:txBody>
-          <a:bodyPr wrap="square">
-            <a:spAutoFit/>
+          <a:bodyPr wrap="square" lIns="0" rIns="0" tIns="0" bIns="0">
+            <a:noAutofit/>
           </a:bodyPr>
           <a:lstStyle/>
           <a:p>
@@ -13765,8 +13765,8 @@
           <a:noFill/>
         </p:spPr>
         <p:txBody>
-          <a:bodyPr wrap="square">
-            <a:spAutoFit/>
+          <a:bodyPr wrap="square" lIns="0" rIns="0" tIns="0" bIns="0">
+            <a:noAutofit/>
           </a:bodyPr>
           <a:lstStyle/>
           <a:p>
@@ -13843,8 +13843,8 @@
           <a:noFill/>
         </p:spPr>
         <p:txBody>
-          <a:bodyPr wrap="square">
-            <a:spAutoFit/>
+          <a:bodyPr wrap="square" lIns="0" rIns="0" tIns="0" bIns="0">
+            <a:noAutofit/>
           </a:bodyPr>
           <a:lstStyle/>
           <a:p>
@@ -13921,8 +13921,8 @@
           <a:noFill/>
         </p:spPr>
         <p:txBody>
-          <a:bodyPr wrap="square">
-            <a:spAutoFit/>
+          <a:bodyPr wrap="square" lIns="0" rIns="0" tIns="0" bIns="0">
+            <a:noAutofit/>
           </a:bodyPr>
           <a:lstStyle/>
           <a:p>
@@ -13999,8 +13999,8 @@
           <a:noFill/>
         </p:spPr>
         <p:txBody>
-          <a:bodyPr wrap="square">
-            <a:spAutoFit/>
+          <a:bodyPr wrap="square" lIns="0" rIns="0" tIns="0" bIns="0">
+            <a:noAutofit/>
           </a:bodyPr>
           <a:lstStyle/>
           <a:p>
@@ -14077,8 +14077,8 @@
           <a:noFill/>
         </p:spPr>
         <p:txBody>
-          <a:bodyPr wrap="square">
-            <a:spAutoFit/>
+          <a:bodyPr wrap="square" lIns="0" rIns="0" tIns="0" bIns="0">
+            <a:noAutofit/>
           </a:bodyPr>
           <a:lstStyle/>
           <a:p>
@@ -14155,8 +14155,8 @@
           <a:noFill/>
         </p:spPr>
         <p:txBody>
-          <a:bodyPr wrap="square">
-            <a:spAutoFit/>
+          <a:bodyPr wrap="square" lIns="0" rIns="0" tIns="0" bIns="0">
+            <a:noAutofit/>
           </a:bodyPr>
           <a:lstStyle/>
           <a:p>
@@ -14233,8 +14233,8 @@
           <a:noFill/>
         </p:spPr>
         <p:txBody>
-          <a:bodyPr wrap="square">
-            <a:spAutoFit/>
+          <a:bodyPr wrap="square" lIns="0" rIns="0" tIns="0" bIns="0">
+            <a:noAutofit/>
           </a:bodyPr>
           <a:lstStyle/>
           <a:p>
@@ -14311,8 +14311,8 @@
           <a:noFill/>
         </p:spPr>
         <p:txBody>
-          <a:bodyPr wrap="square">
-            <a:spAutoFit/>
+          <a:bodyPr wrap="square" lIns="0" rIns="0" tIns="0" bIns="0">
+            <a:noAutofit/>
           </a:bodyPr>
           <a:lstStyle/>
           <a:p>
@@ -14389,8 +14389,8 @@
           <a:noFill/>
         </p:spPr>
         <p:txBody>
-          <a:bodyPr wrap="square">
-            <a:spAutoFit/>
+          <a:bodyPr wrap="square" lIns="0" rIns="0" tIns="0" bIns="0">
+            <a:noAutofit/>
           </a:bodyPr>
           <a:lstStyle/>
           <a:p>
@@ -14467,8 +14467,8 @@
           <a:noFill/>
         </p:spPr>
         <p:txBody>
-          <a:bodyPr wrap="square">
-            <a:spAutoFit/>
+          <a:bodyPr wrap="square" lIns="0" rIns="0" tIns="0" bIns="0">
+            <a:noAutofit/>
           </a:bodyPr>
           <a:lstStyle/>
           <a:p>
@@ -14545,8 +14545,8 @@
           <a:noFill/>
         </p:spPr>
         <p:txBody>
-          <a:bodyPr wrap="square">
-            <a:spAutoFit/>
+          <a:bodyPr wrap="square" lIns="0" rIns="0" tIns="0" bIns="0">
+            <a:noAutofit/>
           </a:bodyPr>
           <a:lstStyle/>
           <a:p>
@@ -14623,8 +14623,8 @@
           <a:noFill/>
         </p:spPr>
         <p:txBody>
-          <a:bodyPr wrap="square">
-            <a:spAutoFit/>
+          <a:bodyPr wrap="square" lIns="0" rIns="0" tIns="0" bIns="0">
+            <a:noAutofit/>
           </a:bodyPr>
           <a:lstStyle/>
           <a:p>
@@ -14701,8 +14701,8 @@
           <a:noFill/>
         </p:spPr>
         <p:txBody>
-          <a:bodyPr wrap="square">
-            <a:spAutoFit/>
+          <a:bodyPr wrap="square" lIns="0" rIns="0" tIns="0" bIns="0">
+            <a:noAutofit/>
           </a:bodyPr>
           <a:lstStyle/>
           <a:p>
@@ -14779,8 +14779,8 @@
           <a:noFill/>
         </p:spPr>
         <p:txBody>
-          <a:bodyPr wrap="square">
-            <a:spAutoFit/>
+          <a:bodyPr wrap="square" lIns="0" rIns="0" tIns="0" bIns="0">
+            <a:noAutofit/>
           </a:bodyPr>
           <a:lstStyle/>
           <a:p>
@@ -14857,8 +14857,8 @@
           <a:noFill/>
         </p:spPr>
         <p:txBody>
-          <a:bodyPr wrap="square">
-            <a:spAutoFit/>
+          <a:bodyPr wrap="square" lIns="0" rIns="0" tIns="0" bIns="0">
+            <a:noAutofit/>
           </a:bodyPr>
           <a:lstStyle/>
           <a:p>
@@ -14935,8 +14935,8 @@
           <a:noFill/>
         </p:spPr>
         <p:txBody>
-          <a:bodyPr wrap="square">
-            <a:spAutoFit/>
+          <a:bodyPr wrap="square" lIns="0" rIns="0" tIns="0" bIns="0">
+            <a:noAutofit/>
           </a:bodyPr>
           <a:lstStyle/>
           <a:p>
@@ -15013,8 +15013,8 @@
           <a:noFill/>
         </p:spPr>
         <p:txBody>
-          <a:bodyPr wrap="square">
-            <a:spAutoFit/>
+          <a:bodyPr wrap="square" lIns="0" rIns="0" tIns="0" bIns="0">
+            <a:noAutofit/>
           </a:bodyPr>
           <a:lstStyle/>
           <a:p>
@@ -15091,8 +15091,8 @@
           <a:noFill/>
         </p:spPr>
         <p:txBody>
-          <a:bodyPr wrap="square">
-            <a:spAutoFit/>
+          <a:bodyPr wrap="square" lIns="0" rIns="0" tIns="0" bIns="0">
+            <a:noAutofit/>
           </a:bodyPr>
           <a:lstStyle/>
           <a:p>
@@ -15169,8 +15169,8 @@
           <a:noFill/>
         </p:spPr>
         <p:txBody>
-          <a:bodyPr wrap="square">
-            <a:spAutoFit/>
+          <a:bodyPr wrap="square" lIns="0" rIns="0" tIns="0" bIns="0">
+            <a:noAutofit/>
           </a:bodyPr>
           <a:lstStyle/>
           <a:p>
@@ -15247,8 +15247,8 @@
           <a:noFill/>
         </p:spPr>
         <p:txBody>
-          <a:bodyPr wrap="square">
-            <a:spAutoFit/>
+          <a:bodyPr wrap="square" lIns="0" rIns="0" tIns="0" bIns="0">
+            <a:noAutofit/>
           </a:bodyPr>
           <a:lstStyle/>
           <a:p>
@@ -15325,8 +15325,8 @@
           <a:noFill/>
         </p:spPr>
         <p:txBody>
-          <a:bodyPr wrap="square">
-            <a:spAutoFit/>
+          <a:bodyPr wrap="square" lIns="0" rIns="0" tIns="0" bIns="0">
+            <a:noAutofit/>
           </a:bodyPr>
           <a:lstStyle/>
           <a:p>
@@ -15360,8 +15360,8 @@
           <a:noFill/>
         </p:spPr>
         <p:txBody>
-          <a:bodyPr wrap="square">
-            <a:spAutoFit/>
+          <a:bodyPr wrap="square" lIns="0" rIns="0" tIns="0" bIns="0">
+            <a:noAutofit/>
           </a:bodyPr>
           <a:lstStyle/>
           <a:p>
@@ -15438,14 +15438,14 @@
           <a:noFill/>
         </p:spPr>
         <p:txBody>
-          <a:bodyPr wrap="square">
-            <a:spAutoFit/>
+          <a:bodyPr wrap="square" lIns="0" rIns="0" tIns="0" bIns="0">
+            <a:noAutofit/>
           </a:bodyPr>
           <a:lstStyle/>
           <a:p>
             <a:pPr algn="l"/>
             <a:r>
-              <a:rPr sz="1000" b="0" i="0">
+              <a:rPr sz="1100" b="0" i="0">
                 <a:solidFill>
                   <a:srgbClr val="FFFFFF"/>
                 </a:solidFill>
@@ -15473,14 +15473,14 @@
           <a:noFill/>
         </p:spPr>
         <p:txBody>
-          <a:bodyPr wrap="square">
-            <a:spAutoFit/>
+          <a:bodyPr wrap="square" lIns="0" rIns="0" tIns="0" bIns="0">
+            <a:noAutofit/>
           </a:bodyPr>
           <a:lstStyle/>
           <a:p>
             <a:pPr algn="r"/>
             <a:r>
-              <a:rPr sz="1000" b="0" i="0">
+              <a:rPr sz="1100" b="0" i="0">
                 <a:solidFill>
                   <a:srgbClr val="FFFFFF"/>
                 </a:solidFill>

</xml_diff>

<commit_message>
Legg til OsloMet-logo pa tittelslide
Plasserer offisiell logo nederst til hoyre i det oransje feltet
pa forsideslide i PPTX, HTML og PDF.

Co-authored-by: Karina <kasa031@users.noreply.github.com>
</commit_message>
<xml_diff>
--- a/ACIT4280_1A_presentation.pptx
+++ b/ACIT4280_1A_presentation.pptx
@@ -4938,7 +4938,7 @@
         <p:spPr>
           <a:xfrm>
             <a:off x="640080" y="5577840"/>
-            <a:ext cx="10972800" cy="914400"/>
+            <a:ext cx="7680960" cy="914400"/>
           </a:xfrm>
           <a:prstGeom prst="rect">
             <a:avLst/>
@@ -4965,6 +4965,30 @@
           </a:p>
         </p:txBody>
       </p:sp>
+      <p:pic>
+        <p:nvPicPr>
+          <p:cNvPr id="10" name="Picture 9" descr="oslomet_logo.png"/>
+          <p:cNvPicPr>
+            <a:picLocks noChangeAspect="1"/>
+          </p:cNvPicPr>
+          <p:nvPr/>
+        </p:nvPicPr>
+        <p:blipFill>
+          <a:blip r:embed="rId2"/>
+          <a:stretch>
+            <a:fillRect/>
+          </a:stretch>
+        </p:blipFill>
+        <p:spPr>
+          <a:xfrm>
+            <a:off x="8854135" y="5852160"/>
+            <a:ext cx="2834640" cy="502920"/>
+          </a:xfrm>
+          <a:prstGeom prst="rect">
+            <a:avLst/>
+          </a:prstGeom>
+        </p:spPr>
+      </p:pic>
     </p:spTree>
   </p:cSld>
   <p:clrMapOvr>

</xml_diff>

<commit_message>
Forenkle tittelbånd: bare dato til venstre
Fjerner Oslo Metropolitan University-tekst siden logoen viser skolenavnet.
Dato og logo står nå på samme høyde.

Co-authored-by: Karina <kasa031@users.noreply.github.com>
</commit_message>
<xml_diff>
--- a/ACIT4280_1A_presentation.pptx
+++ b/ACIT4280_1A_presentation.pptx
@@ -4937,8 +4937,8 @@
         </p:nvSpPr>
         <p:spPr>
           <a:xfrm>
-            <a:off x="640080" y="5577840"/>
-            <a:ext cx="7680960" cy="914400"/>
+            <a:off x="640080" y="5852160"/>
+            <a:ext cx="5486400" cy="502920"/>
           </a:xfrm>
           <a:prstGeom prst="rect">
             <a:avLst/>
@@ -4959,8 +4959,7 @@
                 </a:solidFill>
                 <a:latin typeface="Calibri"/>
               </a:rPr>
-              <a:t>Oslo Metropolitan University
-3 September 2026</a:t>
+              <a:t>3 September 2026</a:t>
             </a:r>
           </a:p>
         </p:txBody>

</xml_diff>

<commit_message>
Legg til Webbkoll-screenshot under Part 1 pa slide 2
Viser fig1 under Webbkoll-punktene for a gi mer illustrasjon.

Co-authored-by: Karina <kasa031@users.noreply.github.com>
</commit_message>
<xml_diff>
--- a/ACIT4280_1A_presentation.pptx
+++ b/ACIT4280_1A_presentation.pptx
@@ -4946,7 +4946,7 @@
           <a:noFill/>
         </p:spPr>
         <p:txBody>
-          <a:bodyPr wrap="square" lIns="0" rIns="0" tIns="0" bIns="0">
+          <a:bodyPr wrap="square" lIns="0" rIns="0" tIns="0" bIns="0" anchor="ctr">
             <a:noAutofit/>
           </a:bodyPr>
           <a:lstStyle/>
@@ -8589,7 +8589,208 @@
         </p:nvSpPr>
         <p:spPr>
           <a:xfrm>
-            <a:off x="685800" y="2103120"/>
+            <a:off x="685800" y="2029968"/>
+            <a:ext cx="4937760" cy="1234440"/>
+          </a:xfrm>
+          <a:prstGeom prst="rect">
+            <a:avLst/>
+          </a:prstGeom>
+          <a:noFill/>
+        </p:spPr>
+        <p:txBody>
+          <a:bodyPr wrap="square" lIns="0" rIns="0" tIns="0" bIns="0">
+            <a:noAutofit/>
+          </a:bodyPr>
+          <a:lstStyle/>
+          <a:p>
+            <a:pPr algn="l">
+              <a:spcBef>
+                <a:spcPts val="0"/>
+              </a:spcBef>
+              <a:spcAft>
+                <a:spcPts val="600"/>
+              </a:spcAft>
+            </a:pPr>
+            <a:r>
+              <a:rPr sz="1600" b="0" i="0">
+                <a:solidFill>
+                  <a:srgbClr val="1A1A1A"/>
+                </a:solidFill>
+                <a:latin typeface="Calibri"/>
+              </a:rPr>
+              <a:t>•  18 sites in four sectors (Table 1)</a:t>
+            </a:r>
+          </a:p>
+          <a:p>
+            <a:pPr algn="l">
+              <a:spcBef>
+                <a:spcPts val="0"/>
+              </a:spcBef>
+              <a:spcAft>
+                <a:spcPts val="600"/>
+              </a:spcAft>
+            </a:pPr>
+            <a:r>
+              <a:rPr sz="1600" b="0" i="0">
+                <a:solidFill>
+                  <a:srgbClr val="1A1A1A"/>
+                </a:solidFill>
+                <a:latin typeface="Calibri"/>
+              </a:rPr>
+              <a:t>•  Cookies, third-party requests, KeyCDN countries</a:t>
+            </a:r>
+          </a:p>
+          <a:p>
+            <a:pPr algn="l">
+              <a:spcBef>
+                <a:spcPts val="0"/>
+              </a:spcBef>
+              <a:spcAft>
+                <a:spcPts val="600"/>
+              </a:spcAft>
+            </a:pPr>
+            <a:r>
+              <a:rPr sz="1600" b="0" i="0">
+                <a:solidFill>
+                  <a:srgbClr val="1A1A1A"/>
+                </a:solidFill>
+                <a:latin typeface="Calibri"/>
+              </a:rPr>
+              <a:t>•  Rank Table 2 requests, not cookies</a:t>
+            </a:r>
+          </a:p>
+          <a:p>
+            <a:pPr algn="l">
+              <a:spcBef>
+                <a:spcPts val="0"/>
+              </a:spcBef>
+              <a:spcAft>
+                <a:spcPts val="600"/>
+              </a:spcAft>
+            </a:pPr>
+            <a:r>
+              <a:rPr sz="1600" b="0" i="0">
+                <a:solidFill>
+                  <a:srgbClr val="1A1A1A"/>
+                </a:solidFill>
+                <a:latin typeface="Calibri"/>
+              </a:rPr>
+              <a:t>•  Figures 2 to 4: counts, share, sectors</a:t>
+            </a:r>
+          </a:p>
+        </p:txBody>
+      </p:sp>
+      <p:pic>
+        <p:nvPicPr>
+          <p:cNvPr id="10" name="Picture 9" descr="fig1_webbkoll_check_klassekampen.png"/>
+          <p:cNvPicPr>
+            <a:picLocks noChangeAspect="1"/>
+          </p:cNvPicPr>
+          <p:nvPr/>
+        </p:nvPicPr>
+        <p:blipFill>
+          <a:blip r:embed="rId2"/>
+          <a:stretch>
+            <a:fillRect/>
+          </a:stretch>
+        </p:blipFill>
+        <p:spPr>
+          <a:xfrm>
+            <a:off x="685800" y="3310128"/>
+            <a:ext cx="4937760" cy="2441448"/>
+          </a:xfrm>
+          <a:prstGeom prst="rect">
+            <a:avLst/>
+          </a:prstGeom>
+        </p:spPr>
+      </p:pic>
+      <p:sp>
+        <p:nvSpPr>
+          <p:cNvPr id="11" name="Rectangle 10"/>
+          <p:cNvSpPr/>
+          <p:nvPr/>
+        </p:nvSpPr>
+        <p:spPr>
+          <a:xfrm>
+            <a:off x="6309360" y="1417320"/>
+            <a:ext cx="5394960" cy="4572000"/>
+          </a:xfrm>
+          <a:prstGeom prst="rect">
+            <a:avLst/>
+          </a:prstGeom>
+          <a:solidFill>
+            <a:srgbClr val="325E6A"/>
+          </a:solidFill>
+          <a:ln>
+            <a:noFill/>
+          </a:ln>
+        </p:spPr>
+        <p:style>
+          <a:lnRef idx="1">
+            <a:schemeClr val="accent1"/>
+          </a:lnRef>
+          <a:fillRef idx="3">
+            <a:schemeClr val="accent1"/>
+          </a:fillRef>
+          <a:effectRef idx="2">
+            <a:schemeClr val="accent1"/>
+          </a:effectRef>
+          <a:fontRef idx="minor">
+            <a:schemeClr val="lt1"/>
+          </a:fontRef>
+        </p:style>
+        <p:txBody>
+          <a:bodyPr rtlCol="0" anchor="ctr"/>
+          <a:lstStyle/>
+          <a:p>
+            <a:pPr algn="ctr"/>
+          </a:p>
+        </p:txBody>
+      </p:sp>
+      <p:sp>
+        <p:nvSpPr>
+          <p:cNvPr id="12" name="TextBox 11"/>
+          <p:cNvSpPr txBox="1"/>
+          <p:nvPr/>
+        </p:nvSpPr>
+        <p:spPr>
+          <a:xfrm>
+            <a:off x="6537960" y="1600200"/>
+            <a:ext cx="4937760" cy="365760"/>
+          </a:xfrm>
+          <a:prstGeom prst="rect">
+            <a:avLst/>
+          </a:prstGeom>
+          <a:noFill/>
+        </p:spPr>
+        <p:txBody>
+          <a:bodyPr wrap="square" lIns="0" rIns="0" tIns="0" bIns="0">
+            <a:noAutofit/>
+          </a:bodyPr>
+          <a:lstStyle/>
+          <a:p>
+            <a:pPr algn="l"/>
+            <a:r>
+              <a:rPr sz="2200" b="1" i="0">
+                <a:solidFill>
+                  <a:srgbClr val="FF9A00"/>
+                </a:solidFill>
+                <a:latin typeface="Calibri"/>
+              </a:rPr>
+              <a:t>Part 2  ·  ICO</a:t>
+            </a:r>
+          </a:p>
+        </p:txBody>
+      </p:sp>
+      <p:sp>
+        <p:nvSpPr>
+          <p:cNvPr id="13" name="TextBox 12"/>
+          <p:cNvSpPr txBox="1"/>
+          <p:nvPr/>
+        </p:nvSpPr>
+        <p:spPr>
+          <a:xfrm>
+            <a:off x="6537960" y="2103120"/>
             <a:ext cx="4937760" cy="3657600"/>
           </a:xfrm>
           <a:prstGeom prst="rect">
@@ -8614,11 +8815,11 @@
             <a:r>
               <a:rPr sz="1800" b="0" i="0">
                 <a:solidFill>
-                  <a:srgbClr val="1A1A1A"/>
-                </a:solidFill>
-                <a:latin typeface="Calibri"/>
-              </a:rPr>
-              <a:t>•  18 sites in four sectors (Table 1)</a:t>
+                  <a:srgbClr val="FFFFFF"/>
+                </a:solidFill>
+                <a:latin typeface="Calibri"/>
+              </a:rPr>
+              <a:t>•  Five sites from Table 1a</a:t>
             </a:r>
           </a:p>
           <a:p>
@@ -8633,11 +8834,11 @@
             <a:r>
               <a:rPr sz="1800" b="0" i="0">
                 <a:solidFill>
-                  <a:srgbClr val="1A1A1A"/>
-                </a:solidFill>
-                <a:latin typeface="Calibri"/>
-              </a:rPr>
-              <a:t>•  Cookies, third-party requests, KeyCDN countries</a:t>
+                  <a:srgbClr val="FFFFFF"/>
+                </a:solidFill>
+                <a:latin typeface="Calibri"/>
+              </a:rPr>
+              <a:t>•  One purpose per ICO run</a:t>
             </a:r>
           </a:p>
           <a:p>
@@ -8652,11 +8853,11 @@
             <a:r>
               <a:rPr sz="1800" b="0" i="0">
                 <a:solidFill>
-                  <a:srgbClr val="1A1A1A"/>
-                </a:solidFill>
-                <a:latin typeface="Calibri"/>
-              </a:rPr>
-              <a:t>•  Rank Table 2 requests, not cookies</a:t>
+                  <a:srgbClr val="FFFFFF"/>
+                </a:solidFill>
+                <a:latin typeface="Calibri"/>
+              </a:rPr>
+              <a:t>•  Notice versus ICO Word report (26 Aug 2026)</a:t>
             </a:r>
           </a:p>
           <a:p>
@@ -8671,187 +8872,10 @@
             <a:r>
               <a:rPr sz="1800" b="0" i="0">
                 <a:solidFill>
-                  <a:srgbClr val="1A1A1A"/>
-                </a:solidFill>
-                <a:latin typeface="Calibri"/>
-              </a:rPr>
-              <a:t>•  Figures 2 to 4: counts, share, sectors</a:t>
-            </a:r>
-          </a:p>
-        </p:txBody>
-      </p:sp>
-      <p:sp>
-        <p:nvSpPr>
-          <p:cNvPr id="10" name="Rectangle 9"/>
-          <p:cNvSpPr/>
-          <p:nvPr/>
-        </p:nvSpPr>
-        <p:spPr>
-          <a:xfrm>
-            <a:off x="6309360" y="1417320"/>
-            <a:ext cx="5394960" cy="4572000"/>
-          </a:xfrm>
-          <a:prstGeom prst="rect">
-            <a:avLst/>
-          </a:prstGeom>
-          <a:solidFill>
-            <a:srgbClr val="325E6A"/>
-          </a:solidFill>
-          <a:ln>
-            <a:noFill/>
-          </a:ln>
-        </p:spPr>
-        <p:style>
-          <a:lnRef idx="1">
-            <a:schemeClr val="accent1"/>
-          </a:lnRef>
-          <a:fillRef idx="3">
-            <a:schemeClr val="accent1"/>
-          </a:fillRef>
-          <a:effectRef idx="2">
-            <a:schemeClr val="accent1"/>
-          </a:effectRef>
-          <a:fontRef idx="minor">
-            <a:schemeClr val="lt1"/>
-          </a:fontRef>
-        </p:style>
-        <p:txBody>
-          <a:bodyPr rtlCol="0" anchor="ctr"/>
-          <a:lstStyle/>
-          <a:p>
-            <a:pPr algn="ctr"/>
-          </a:p>
-        </p:txBody>
-      </p:sp>
-      <p:sp>
-        <p:nvSpPr>
-          <p:cNvPr id="11" name="TextBox 10"/>
-          <p:cNvSpPr txBox="1"/>
-          <p:nvPr/>
-        </p:nvSpPr>
-        <p:spPr>
-          <a:xfrm>
-            <a:off x="6537960" y="1600200"/>
-            <a:ext cx="4937760" cy="365760"/>
-          </a:xfrm>
-          <a:prstGeom prst="rect">
-            <a:avLst/>
-          </a:prstGeom>
-          <a:noFill/>
-        </p:spPr>
-        <p:txBody>
-          <a:bodyPr wrap="square" lIns="0" rIns="0" tIns="0" bIns="0">
-            <a:noAutofit/>
-          </a:bodyPr>
-          <a:lstStyle/>
-          <a:p>
-            <a:pPr algn="l"/>
-            <a:r>
-              <a:rPr sz="2200" b="1" i="0">
-                <a:solidFill>
-                  <a:srgbClr val="FF9A00"/>
-                </a:solidFill>
-                <a:latin typeface="Calibri"/>
-              </a:rPr>
-              <a:t>Part 2  ·  ICO</a:t>
-            </a:r>
-          </a:p>
-        </p:txBody>
-      </p:sp>
-      <p:sp>
-        <p:nvSpPr>
-          <p:cNvPr id="12" name="TextBox 11"/>
-          <p:cNvSpPr txBox="1"/>
-          <p:nvPr/>
-        </p:nvSpPr>
-        <p:spPr>
-          <a:xfrm>
-            <a:off x="6537960" y="2103120"/>
-            <a:ext cx="4937760" cy="3657600"/>
-          </a:xfrm>
-          <a:prstGeom prst="rect">
-            <a:avLst/>
-          </a:prstGeom>
-          <a:noFill/>
-        </p:spPr>
-        <p:txBody>
-          <a:bodyPr wrap="square" lIns="0" rIns="0" tIns="0" bIns="0">
-            <a:noAutofit/>
-          </a:bodyPr>
-          <a:lstStyle/>
-          <a:p>
-            <a:pPr algn="l">
-              <a:spcBef>
-                <a:spcPts val="0"/>
-              </a:spcBef>
-              <a:spcAft>
-                <a:spcPts val="1000"/>
-              </a:spcAft>
-            </a:pPr>
-            <a:r>
-              <a:rPr sz="1800" b="0" i="0">
-                <a:solidFill>
                   <a:srgbClr val="FFFFFF"/>
                 </a:solidFill>
                 <a:latin typeface="Calibri"/>
               </a:rPr>
-              <a:t>•  Five sites from Table 1a</a:t>
-            </a:r>
-          </a:p>
-          <a:p>
-            <a:pPr algn="l">
-              <a:spcBef>
-                <a:spcPts val="0"/>
-              </a:spcBef>
-              <a:spcAft>
-                <a:spcPts val="1000"/>
-              </a:spcAft>
-            </a:pPr>
-            <a:r>
-              <a:rPr sz="1800" b="0" i="0">
-                <a:solidFill>
-                  <a:srgbClr val="FFFFFF"/>
-                </a:solidFill>
-                <a:latin typeface="Calibri"/>
-              </a:rPr>
-              <a:t>•  One purpose per ICO run</a:t>
-            </a:r>
-          </a:p>
-          <a:p>
-            <a:pPr algn="l">
-              <a:spcBef>
-                <a:spcPts val="0"/>
-              </a:spcBef>
-              <a:spcAft>
-                <a:spcPts val="1000"/>
-              </a:spcAft>
-            </a:pPr>
-            <a:r>
-              <a:rPr sz="1800" b="0" i="0">
-                <a:solidFill>
-                  <a:srgbClr val="FFFFFF"/>
-                </a:solidFill>
-                <a:latin typeface="Calibri"/>
-              </a:rPr>
-              <a:t>•  Notice versus ICO Word report (26 Aug 2026)</a:t>
-            </a:r>
-          </a:p>
-          <a:p>
-            <a:pPr algn="l">
-              <a:spcBef>
-                <a:spcPts val="0"/>
-              </a:spcBef>
-              <a:spcAft>
-                <a:spcPts val="1000"/>
-              </a:spcAft>
-            </a:pPr>
-            <a:r>
-              <a:rPr sz="1800" b="0" i="0">
-                <a:solidFill>
-                  <a:srgbClr val="FFFFFF"/>
-                </a:solidFill>
-                <a:latin typeface="Calibri"/>
-              </a:rPr>
               <a:t>•  Yes if notice and ICO agree; Partial if consent is INCONCLUSIVE</a:t>
             </a:r>
           </a:p>
@@ -8859,7 +8883,7 @@
       </p:sp>
       <p:sp>
         <p:nvSpPr>
-          <p:cNvPr id="13" name="Rectangle 12"/>
+          <p:cNvPr id="14" name="Rectangle 13"/>
           <p:cNvSpPr/>
           <p:nvPr/>
         </p:nvSpPr>
@@ -8902,7 +8926,7 @@
       </p:sp>
       <p:sp>
         <p:nvSpPr>
-          <p:cNvPr id="14" name="TextBox 13"/>
+          <p:cNvPr id="15" name="TextBox 14"/>
           <p:cNvSpPr txBox="1"/>
           <p:nvPr/>
         </p:nvSpPr>
@@ -8937,7 +8961,7 @@
       </p:sp>
       <p:sp>
         <p:nvSpPr>
-          <p:cNvPr id="15" name="TextBox 14"/>
+          <p:cNvPr id="16" name="TextBox 15"/>
           <p:cNvSpPr txBox="1"/>
           <p:nvPr/>
         </p:nvSpPr>

</xml_diff>

<commit_message>
Gjor slide 3 How we measured mer fokusert
Tydeligere metodepunkter om Webbkoll, hva som ble malt,
tabellbruk og KeyCDN-begrensning.

Co-authored-by: Karina <kasa031@users.noreply.github.com>
</commit_message>
<xml_diff>
--- a/ACIT4280_1A_presentation.pptx
+++ b/ACIT4280_1A_presentation.pptx
@@ -9248,7 +9248,7 @@
                 </a:solidFill>
                 <a:latin typeface="Calibri"/>
               </a:rPr>
-              <a:t>English Webbkoll. One load per visit. No add-ons. Do Not Track off.</a:t>
+              <a:t>Webbkoll: one clean browser load per site - no add-ons, no cookie banner click.</a:t>
             </a:r>
           </a:p>
           <a:p>
@@ -9267,7 +9267,7 @@
                 </a:solidFill>
                 <a:latin typeface="Calibri"/>
               </a:rPr>
-              <a:t>Table 2 (20 Aug 2026) is the ranking. Table 3 is a later check, not averaged.</a:t>
+              <a:t>We recorded cookies, third-party requests and server country on 18 front pages.</a:t>
             </a:r>
           </a:p>
           <a:p>
@@ -9286,7 +9286,7 @@
                 </a:solidFill>
                 <a:latin typeface="Calibri"/>
               </a:rPr>
-              <a:t>KeyCDN country is a geolocation guess from the IP, not a legal transfer register.</a:t>
+              <a:t>Table 2 (20 Aug 2026) is the ranking. Table 3 is a repeat check, not averaged in.</a:t>
             </a:r>
           </a:p>
           <a:p>
@@ -9305,7 +9305,7 @@
                 </a:solidFill>
                 <a:latin typeface="Calibri"/>
               </a:rPr>
-              <a:t>Requests are not cookies. 17 of 18 sites had zero external cookies. ikea.no had 2.</a:t>
+              <a:t>KeyCDN country is a geolocation guess from the IP - not a legal transfer register.</a:t>
             </a:r>
           </a:p>
         </p:txBody>

</xml_diff>

<commit_message>
Fjern alle Table X-referanser fra presentasjonen
Erstatter tabellnummer med first scan, repeat scan og
forenkler slide-titler uten Table 4/5.

Co-authored-by: Karina <kasa031@users.noreply.github.com>
</commit_message>
<xml_diff>
--- a/ACIT4280_1A_presentation.pptx
+++ b/ACIT4280_1A_presentation.pptx
@@ -1211,7 +1211,7 @@
           <a:lstStyle/>
           <a:p>
             <a:r>
-              <a:t>Each row is one purpose from Table 1a. Partial means consent INCONCLUSIVE.</a:t>
+              <a:t>Each row is one purpose from the five ICO sites. Partial means consent INCONCLUSIVE.</a:t>
             </a:r>
           </a:p>
         </p:txBody>
@@ -7094,7 +7094,7 @@
                 </a:solidFill>
                 <a:latin typeface="Calibri"/>
               </a:rPr>
-              <a:t>•  One clean load per site; rank on Table 2 (20 Aug)</a:t>
+              <a:t>•  One clean load per site; first scan ranks requests (20 Aug)</a:t>
             </a:r>
           </a:p>
           <a:p>
@@ -8041,7 +8041,7 @@
                 </a:solidFill>
                 <a:latin typeface="Calibri"/>
               </a:rPr>
-              <a:t>•  babyshop.no: 101 on Table 3; ranking stays on Table 2 (45).</a:t>
+              <a:t>•  babyshop.no: 101 on repeat scan; ranking stays on first scan (45).</a:t>
             </a:r>
           </a:p>
         </p:txBody>
@@ -8336,7 +8336,7 @@
                 </a:solidFill>
                 <a:latin typeface="Calibri"/>
               </a:rPr>
-              <a:t>Part 1  ·  Table 4</a:t>
+              <a:t>Part 1</a:t>
             </a:r>
           </a:p>
         </p:txBody>
@@ -9606,7 +9606,7 @@
                 </a:solidFill>
                 <a:latin typeface="Calibri"/>
               </a:rPr>
-              <a:t>Ranked on Table 2 requests. lanekassen.no and altinn.no have the fewest government requests. babyshop.no is 101 on Table 3; rankings stay on Table 2.</a:t>
+              <a:t>Ranked on first Webbkoll scan. lanekassen.no and altinn.no have the fewest government requests. babyshop.no is 101 on the repeat scan; rankings stay on the first scan.</a:t>
             </a:r>
           </a:p>
         </p:txBody>
@@ -10043,7 +10043,7 @@
                 </a:solidFill>
                 <a:latin typeface="Calibri"/>
               </a:rPr>
-              <a:t>Table 2. News/media is the highest sector. Government is the lowest.</a:t>
+              <a:t>News/media is the highest sector. Government is the lowest.</a:t>
             </a:r>
           </a:p>
         </p:txBody>
@@ -12948,7 +12948,7 @@
                 </a:solidFill>
                 <a:latin typeface="Calibri"/>
               </a:rPr>
-              <a:t>Part 2  ·  Table 5</a:t>
+              <a:t>Part 2</a:t>
             </a:r>
           </a:p>
         </p:txBody>

</xml_diff>

<commit_message>
Gjor tittelsporsmal mer engasjerende pa forsideslide
Erstatter teknisk formulering med kortere, mer
inviterende sprak som trekker publikum inn.

Co-authored-by: Karina <kasa031@users.noreply.github.com>
</commit_message>
<xml_diff>
--- a/ACIT4280_1A_presentation.pptx
+++ b/ACIT4280_1A_presentation.pptx
@@ -4657,7 +4657,7 @@
                 </a:solidFill>
                 <a:latin typeface="Calibri"/>
               </a:rPr>
-              <a:t>•  When a front page loads, how many third parties does it contact, and in which countries do those servers appear to be located?</a:t>
+              <a:t>•  When you open a front page, who else does it contact - and where in the world are those servers?</a:t>
             </a:r>
           </a:p>
           <a:p>
@@ -4676,7 +4676,7 @@
                 </a:solidFill>
                 <a:latin typeface="Calibri"/>
               </a:rPr>
-              <a:t>•  When a site processes personal data, has it named a GDPR Article 6 lawful basis, and does the ICO tool agree?</a:t>
+              <a:t>•  When a site uses personal data, does it have a lawful basis - and does that claim hold up?</a:t>
             </a:r>
           </a:p>
         </p:txBody>

</xml_diff>

<commit_message>
Gjor presentasjonen mer engasjerende og filosofisk
Oppdater slide-titler og tekst med mer narrative formuleringer
som Your browser talks to strangers, The loud and the quiet,
Four honest answers, two broken promises og Questions?-hook.
Fakta og tall er uendret.

Co-authored-by: Karina <kasa031@users.noreply.github.com>
</commit_message>
<xml_diff>
--- a/ACIT4280_1A_presentation.pptx
+++ b/ACIT4280_1A_presentation.pptx
@@ -515,7 +515,7 @@
           <a:lstStyle/>
           <a:p>
             <a:r>
-              <a:t>Part 1 measures contact. Part 2 tests one purpose at a time.</a:t>
+              <a:t>Part 1 maps invisible contact. Part 2 asks whether the legal story holds.</a:t>
             </a:r>
           </a:p>
         </p:txBody>
@@ -585,7 +585,7 @@
           <a:lstStyle/>
           <a:p>
             <a:r>
-              <a:t>fotball.no also has the highest Webbkoll request count. That does not decide Article 6.</a:t>
+              <a:t>fotball.no also has the highest Webbkoll request count - contact and lawful basis are separate questions.</a:t>
             </a:r>
           </a:p>
         </p:txBody>
@@ -655,7 +655,7 @@
           <a:lstStyle/>
           <a:p>
             <a:r>
-              <a:t>Contract and legitimate interests do not fit this advertising purpose.</a:t>
+              <a:t>Consent that hides in settings is consent in name only.</a:t>
             </a:r>
           </a:p>
         </p:txBody>
@@ -725,7 +725,7 @@
           <a:lstStyle/>
           <a:p>
             <a:r>
-              <a:t>Same pattern as Netflix: contract for the core service.</a:t>
+              <a:t>Same pattern as Netflix: the core transaction runs on contract, not consent.</a:t>
             </a:r>
           </a:p>
         </p:txBody>
@@ -795,7 +795,7 @@
           <a:lstStyle/>
           <a:p>
             <a:r>
-              <a:t>Part 1 is contact. Part 2 is one purpose and one basis at a time.</a:t>
+              <a:t>Contact is visible. Lawful basis must be argued purpose by purpose.</a:t>
             </a:r>
           </a:p>
         </p:txBody>
@@ -931,7 +931,7 @@
           <a:lstStyle/>
           <a:p>
             <a:r>
-              <a:t>Webbkoll records one load. ICO tests one purpose at a time. Contact and lawful basis are different questions.</a:t>
+              <a:t>Webbkoll maps contact on one load. ICO tests one purpose at a time. Who you meet and why it is legal are different questions.</a:t>
             </a:r>
           </a:p>
         </p:txBody>
@@ -1001,7 +1001,7 @@
           <a:lstStyle/>
           <a:p>
             <a:r>
-              <a:t>Webbkoll counts contact on one load. Cookies and requests are separate measures.</a:t>
+              <a:t>Contact is visible even when cookies are not. Volume and cookies measure different things.</a:t>
             </a:r>
           </a:p>
         </p:txBody>
@@ -1071,7 +1071,7 @@
           <a:lstStyle/>
           <a:p>
             <a:r>
-              <a:t>fotball.no has 113 requests and zero third-party cookies. document.no has the widest country list (6).</a:t>
+              <a:t>Request count is not morality - it is visibility. fotball.no is loud with zero third-party cookies.</a:t>
             </a:r>
           </a:p>
         </p:txBody>
@@ -1141,7 +1141,7 @@
           <a:lstStyle/>
           <a:p>
             <a:r>
-              <a:t>fotball.no 113. lanekassen.no 1. The pie is request share, not cookies.</a:t>
+              <a:t>Sector patterns matter: media is networked, government is restrained. Pie chart = request share, not cookies.</a:t>
             </a:r>
           </a:p>
         </p:txBody>
@@ -1211,7 +1211,7 @@
           <a:lstStyle/>
           <a:p>
             <a:r>
-              <a:t>Each row is one purpose from the five ICO sites. Partial means consent INCONCLUSIVE.</a:t>
+              <a:t>Each row is one purpose. Partial means the consent story did not pass the ICO checklist.</a:t>
             </a:r>
           </a:p>
         </p:txBody>
@@ -1281,7 +1281,7 @@
           <a:lstStyle/>
           <a:p>
             <a:r>
-              <a:t>Partial is not a court finding. It means the consent wording did not pass the ICO checklist.</a:t>
+              <a:t>Partial is not guilt - it means the consent story did not survive scrutiny.</a:t>
             </a:r>
           </a:p>
         </p:txBody>
@@ -1351,7 +1351,7 @@
           <a:lstStyle/>
           <a:p>
             <a:r>
-              <a:t>Two purposes in the notice, two ICO runs. Figure 7 in the report is the hub that splits those pages.</a:t>
+              <a:t>One site, two moral questions: mandatory duty vs optional tracking.</a:t>
             </a:r>
           </a:p>
         </p:txBody>
@@ -1421,7 +1421,7 @@
           <a:lstStyle/>
           <a:p>
             <a:r>
-              <a:t>Same split as elsewhere: one purpose, one basis.</a:t>
+              <a:t>When you pay for a service, contract often fits better than consent.</a:t>
             </a:r>
           </a:p>
         </p:txBody>
@@ -4987,7 +4987,7 @@
                 </a:solidFill>
                 <a:latin typeface="Calibri"/>
               </a:rPr>
-              <a:t>fotball.no: match history</a:t>
+              <a:t>fotball.no: a name on the team sheet</a:t>
             </a:r>
           </a:p>
         </p:txBody>
@@ -5048,7 +5048,7 @@
                 </a:solidFill>
                 <a:latin typeface="Calibri"/>
               </a:rPr>
-              <a:t>ICO: legitimate interests APPROPRIATE.</a:t>
+              <a:t>ICO: legitimate interests APPROPRIATE - sport transparency, not blanket consent.</a:t>
             </a:r>
           </a:p>
           <a:p>
@@ -5416,7 +5416,7 @@
                 </a:solidFill>
                 <a:latin typeface="Calibri"/>
               </a:rPr>
-              <a:t>document.no: Google Signals</a:t>
+              <a:t>document.no: consent without a real choice</a:t>
             </a:r>
           </a:p>
         </p:txBody>
@@ -5536,7 +5536,7 @@
                 </a:solidFill>
                 <a:latin typeface="Calibri"/>
               </a:rPr>
-              <a:t>•  Purpose: advertising analytics from site activity.</a:t>
+              <a:t>•  Purpose: advertising analytics built from what you read and click.</a:t>
             </a:r>
           </a:p>
           <a:p>
@@ -5555,7 +5555,7 @@
                 </a:solidFill>
                 <a:latin typeface="Calibri"/>
               </a:rPr>
-              <a:t>•  The notice does not name Article 6. It looks like consent.</a:t>
+              <a:t>•  The notice never names Article 6 - but it reads like consent.</a:t>
             </a:r>
           </a:p>
           <a:p>
@@ -5593,7 +5593,7 @@
                 </a:solidFill>
                 <a:latin typeface="Calibri"/>
               </a:rPr>
-              <a:t>•  The choice sits in Google settings. Pluss terms also bundle the notice.</a:t>
+              <a:t>•  The choice lives in Google settings. Pluss terms also bundle the notice.</a:t>
             </a:r>
           </a:p>
         </p:txBody>
@@ -5923,7 +5923,7 @@
                 </a:solidFill>
                 <a:latin typeface="Calibri"/>
               </a:rPr>
-              <a:t>babyshop.no: checkout</a:t>
+              <a:t>babyshop.no: pay to receive</a:t>
             </a:r>
           </a:p>
         </p:txBody>
@@ -5984,7 +5984,7 @@
                 </a:solidFill>
                 <a:latin typeface="Calibri"/>
               </a:rPr>
-              <a:t>The sales terms are a purchase contract.</a:t>
+              <a:t>The sales terms are a purchase contract - you pay, they ship.</a:t>
             </a:r>
           </a:p>
           <a:p>
@@ -6352,7 +6352,7 @@
                 </a:solidFill>
                 <a:latin typeface="Calibri"/>
               </a:rPr>
-              <a:t>What the report shows</a:t>
+              <a:t>What we learned</a:t>
             </a:r>
           </a:p>
         </p:txBody>
@@ -6437,7 +6437,7 @@
                 </a:solidFill>
                 <a:latin typeface="Calibri"/>
               </a:rPr>
-              <a:t>We measured how much 18 sites contact others on load, and we checked whether five of them have a valid GDPR basis for one specific purpose.</a:t>
+              <a:t>Opening a Norwegian front page starts a hidden conversation - we mapped 18 of them.</a:t>
             </a:r>
           </a:p>
           <a:p>
@@ -6456,7 +6456,7 @@
                 </a:solidFill>
                 <a:latin typeface="Calibri"/>
               </a:rPr>
-              <a:t>Many sites reach out to many others without setting cookies.</a:t>
+              <a:t>Many sites reach out widely without setting a single third-party cookie.</a:t>
             </a:r>
           </a:p>
           <a:p>
@@ -6475,7 +6475,7 @@
                 </a:solidFill>
                 <a:latin typeface="Calibri"/>
               </a:rPr>
-              <a:t>Four of five ICO purposes match the notice.</a:t>
+              <a:t>Four of five ICO purposes match what the notice claims.</a:t>
             </a:r>
           </a:p>
           <a:p>
@@ -6494,7 +6494,7 @@
                 </a:solidFill>
                 <a:latin typeface="Calibri"/>
               </a:rPr>
-              <a:t>In two places where the site claims consent, the ICO is not satisfied with how consent is formulated.</a:t>
+              <a:t>Where sites say consent, the wording must be real - in two cases, the ICO says it is not.</a:t>
             </a:r>
           </a:p>
         </p:txBody>
@@ -6681,7 +6681,7 @@
         </p:nvSpPr>
         <p:spPr>
           <a:xfrm>
-            <a:off x="640080" y="2194560"/>
+            <a:off x="640080" y="1920240"/>
             <a:ext cx="10972800" cy="1097280"/>
           </a:xfrm>
           <a:prstGeom prst="rect">
@@ -6703,7 +6703,7 @@
                 </a:solidFill>
                 <a:latin typeface="Calibri"/>
               </a:rPr>
-              <a:t>Questions</a:t>
+              <a:t>Questions?</a:t>
             </a:r>
           </a:p>
         </p:txBody>
@@ -6716,8 +6716,8 @@
         </p:nvSpPr>
         <p:spPr>
           <a:xfrm>
-            <a:off x="640080" y="3474720"/>
-            <a:ext cx="10972800" cy="1280160"/>
+            <a:off x="640080" y="3063240"/>
+            <a:ext cx="10972800" cy="822960"/>
           </a:xfrm>
           <a:prstGeom prst="rect">
             <a:avLst/>
@@ -6735,6 +6735,41 @@
               <a:rPr sz="2000" b="0" i="0">
                 <a:solidFill>
                   <a:srgbClr val="44A1A4"/>
+                </a:solidFill>
+                <a:latin typeface="Calibri"/>
+              </a:rPr>
+              <a:t>Who else does your browser meet - and does the privacy notice tell the truth?</a:t>
+            </a:r>
+          </a:p>
+        </p:txBody>
+      </p:sp>
+      <p:sp>
+        <p:nvSpPr>
+          <p:cNvPr id="5" name="TextBox 4"/>
+          <p:cNvSpPr txBox="1"/>
+          <p:nvPr/>
+        </p:nvSpPr>
+        <p:spPr>
+          <a:xfrm>
+            <a:off x="640080" y="3977639"/>
+            <a:ext cx="10972800" cy="548640"/>
+          </a:xfrm>
+          <a:prstGeom prst="rect">
+            <a:avLst/>
+          </a:prstGeom>
+          <a:noFill/>
+        </p:spPr>
+        <p:txBody>
+          <a:bodyPr wrap="square" lIns="0" rIns="0" tIns="0" bIns="0">
+            <a:noAutofit/>
+          </a:bodyPr>
+          <a:lstStyle/>
+          <a:p>
+            <a:pPr algn="ctr"/>
+            <a:r>
+              <a:rPr sz="1800" b="0" i="0">
+                <a:solidFill>
+                  <a:srgbClr val="FFFFFF"/>
                 </a:solidFill>
                 <a:latin typeface="Calibri"/>
               </a:rPr>
@@ -6920,7 +6955,7 @@
                 </a:solidFill>
                 <a:latin typeface="Calibri"/>
               </a:rPr>
-              <a:t>The report</a:t>
+              <a:t>Our approach</a:t>
             </a:r>
           </a:p>
         </p:txBody>
@@ -6955,7 +6990,7 @@
                 </a:solidFill>
                 <a:latin typeface="Calibri"/>
               </a:rPr>
-              <a:t>Two questions and how we measured</a:t>
+              <a:t>Two questions, two tools</a:t>
             </a:r>
           </a:p>
         </p:txBody>
@@ -7075,7 +7110,7 @@
                 </a:solidFill>
                 <a:latin typeface="Calibri"/>
               </a:rPr>
-              <a:t>•  18 sites: cookies, requests, KeyCDN country</a:t>
+              <a:t>•  18 Norwegian front pages - one clean visit each</a:t>
             </a:r>
           </a:p>
           <a:p>
@@ -7094,7 +7129,7 @@
                 </a:solidFill>
                 <a:latin typeface="Calibri"/>
               </a:rPr>
-              <a:t>•  One clean load per site; first scan ranks requests (20 Aug)</a:t>
+              <a:t>•  Who do they call? Cookies, requests, server country (first scan, 20 Aug)</a:t>
             </a:r>
           </a:p>
           <a:p>
@@ -7113,7 +7148,7 @@
                 </a:solidFill>
                 <a:latin typeface="Calibri"/>
               </a:rPr>
-              <a:t>•  KeyCDN = IP geolocation guess, not legal transfer proof</a:t>
+              <a:t>•  KeyCDN shows where servers sit - a guess, not proof of lawful transfer</a:t>
             </a:r>
           </a:p>
         </p:txBody>
@@ -7257,7 +7292,7 @@
                 </a:solidFill>
                 <a:latin typeface="Calibri"/>
               </a:rPr>
-              <a:t>•  Five sites, one purpose per run</a:t>
+              <a:t>•  Five sites - one purpose per run, because mixed questions break the test</a:t>
             </a:r>
           </a:p>
           <a:p>
@@ -7276,7 +7311,7 @@
                 </a:solidFill>
                 <a:latin typeface="Calibri"/>
               </a:rPr>
-              <a:t>•  Notice vs ICO Word report (26 Aug 2026)</a:t>
+              <a:t>•  Does the privacy notice match the ICO report? (26 Aug 2026)</a:t>
             </a:r>
           </a:p>
           <a:p>
@@ -7295,7 +7330,7 @@
                 </a:solidFill>
                 <a:latin typeface="Calibri"/>
               </a:rPr>
-              <a:t>•  Yes if notice and ICO agree</a:t>
+              <a:t>•  Yes when notice and ICO tell the same story</a:t>
             </a:r>
           </a:p>
           <a:p>
@@ -7314,7 +7349,7 @@
                 </a:solidFill>
                 <a:latin typeface="Calibri"/>
               </a:rPr>
-              <a:t>•  Partial if consent is INCONCLUSIVE</a:t>
+              <a:t>•  Partial when consent wording fails the checklist</a:t>
             </a:r>
           </a:p>
           <a:p>
@@ -7333,7 +7368,7 @@
                 </a:solidFill>
                 <a:latin typeface="Calibri"/>
               </a:rPr>
-              <a:t>•  Tax, cookies, checkout and marketing are different purposes</a:t>
+              <a:t>•  Tax, cookies, checkout and ads are not the same question</a:t>
             </a:r>
           </a:p>
         </p:txBody>
@@ -7663,7 +7698,7 @@
                 </a:solidFill>
                 <a:latin typeface="Calibri"/>
               </a:rPr>
-              <a:t>What Webbkoll shows and key findings</a:t>
+              <a:t>Your browser talks to strangers</a:t>
             </a:r>
           </a:p>
         </p:txBody>
@@ -7741,7 +7776,7 @@
                 </a:solidFill>
                 <a:latin typeface="Calibri"/>
               </a:rPr>
-              <a:t>What Webbkoll shows</a:t>
+              <a:t>What Webbkoll reveals</a:t>
             </a:r>
           </a:p>
         </p:txBody>
@@ -7783,7 +7818,7 @@
                 </a:solidFill>
                 <a:latin typeface="Calibri"/>
               </a:rPr>
-              <a:t>Cookies, third-party requests and server country.</a:t>
+              <a:t>Every front page starts a conversation - Webbkoll records who joins it.</a:t>
             </a:r>
           </a:p>
           <a:p>
@@ -7946,7 +7981,7 @@
                 </a:solidFill>
                 <a:latin typeface="Calibri"/>
               </a:rPr>
-              <a:t>•  fotball.no: 113 requests, zero third-party cookies.</a:t>
+              <a:t>•  fotball.no: 113 hosts, zero third-party cookies - loud, but not cookie-heavy.</a:t>
             </a:r>
           </a:p>
           <a:p>
@@ -7965,7 +8000,7 @@
                 </a:solidFill>
                 <a:latin typeface="Calibri"/>
               </a:rPr>
-              <a:t>•  17 of 18 sites: zero third-party cookies. ikea.no had 2.</a:t>
+              <a:t>•  17 of 18 sites: no third-party cookies on load. ikea.no was the exception (2).</a:t>
             </a:r>
           </a:p>
           <a:p>
@@ -7984,7 +8019,7 @@
                 </a:solidFill>
                 <a:latin typeface="Calibri"/>
               </a:rPr>
-              <a:t>•  lanekassen.no (1) and altinn.no (5): quietest e-government pages.</a:t>
+              <a:t>•  lanekassen.no (1) and altinn.no (5): the quietest public-sector doors.</a:t>
             </a:r>
           </a:p>
           <a:p>
@@ -8003,7 +8038,7 @@
                 </a:solidFill>
                 <a:latin typeface="Calibri"/>
               </a:rPr>
-              <a:t>•  document.no: widest country list (6 excluding Norway).</a:t>
+              <a:t>•  document.no: data paths touch 6 countries, excluding Norway.</a:t>
             </a:r>
           </a:p>
           <a:p>
@@ -8022,7 +8057,7 @@
                 </a:solidFill>
                 <a:latin typeface="Calibri"/>
               </a:rPr>
-              <a:t>•  News/media contacted the most. Government the fewest.</a:t>
+              <a:t>•  News and media reach out most. Government pages reach out least.</a:t>
             </a:r>
           </a:p>
           <a:p>
@@ -8041,7 +8076,7 @@
                 </a:solidFill>
                 <a:latin typeface="Calibri"/>
               </a:rPr>
-              <a:t>•  babyshop.no: 101 on repeat scan; ranking stays on first scan (45).</a:t>
+              <a:t>•  babyshop.no doubled on repeat scan (45 to 101) - rankings stay on the first scan.</a:t>
             </a:r>
           </a:p>
         </p:txBody>
@@ -8371,7 +8406,7 @@
                 </a:solidFill>
                 <a:latin typeface="Calibri"/>
               </a:rPr>
-              <a:t>Highest and lowest third-party requests</a:t>
+              <a:t>The loud and the quiet</a:t>
             </a:r>
           </a:p>
         </p:txBody>
@@ -9606,7 +9641,7 @@
                 </a:solidFill>
                 <a:latin typeface="Calibri"/>
               </a:rPr>
-              <a:t>Ranked on first Webbkoll scan. lanekassen.no and altinn.no have the fewest government requests. babyshop.no is 101 on the repeat scan; rankings stay on the first scan.</a:t>
+              <a:t>Same question, different answers: fotball.no shouts (113), lanekassen.no barely whispers (1). Rankings follow the first scan.</a:t>
             </a:r>
           </a:p>
         </p:txBody>
@@ -9936,7 +9971,7 @@
                 </a:solidFill>
                 <a:latin typeface="Calibri"/>
               </a:rPr>
-              <a:t>Third-party requests by site and sector</a:t>
+              <a:t>Where the traffic goes</a:t>
             </a:r>
           </a:p>
         </p:txBody>
@@ -10043,7 +10078,7 @@
                 </a:solidFill>
                 <a:latin typeface="Calibri"/>
               </a:rPr>
-              <a:t>News/media is the highest sector. Government is the lowest.</a:t>
+              <a:t>News and media pull the most strings on load. Government pages keep the fewest.</a:t>
             </a:r>
           </a:p>
         </p:txBody>
@@ -10373,7 +10408,7 @@
                 </a:solidFill>
                 <a:latin typeface="Calibri"/>
               </a:rPr>
-              <a:t>ICO: one purpose at a time</a:t>
+              <a:t>Does the privacy notice mean what it says?</a:t>
             </a:r>
           </a:p>
         </p:txBody>
@@ -10415,7 +10450,7 @@
                 </a:solidFill>
                 <a:latin typeface="Calibri"/>
               </a:rPr>
-              <a:t>One purpose per ICO run (26 Aug 2026). Yes if notice and ICO agree; Partial if consent is INCONCLUSIVE.</a:t>
+              <a:t>One purpose per ICO run (26 Aug 2026). We ask: does the site's legal story hold up?</a:t>
             </a:r>
           </a:p>
           <a:p>
@@ -10434,7 +10469,7 @@
                 </a:solidFill>
                 <a:latin typeface="Calibri"/>
               </a:rPr>
-              <a:t>Tax, cookies, checkout and marketing are different purposes.</a:t>
+              <a:t>Yes when notice and ICO agree. Partial when consent is INCONCLUSIVE.</a:t>
             </a:r>
           </a:p>
         </p:txBody>
@@ -12653,7 +12688,7 @@
                 </a:solidFill>
                 <a:latin typeface="Calibri"/>
               </a:rPr>
-              <a:t>ICO labels are guidance, not a court finding.</a:t>
+              <a:t>ICO guidance is not a court verdict - but it shows where the story breaks.</a:t>
             </a:r>
           </a:p>
         </p:txBody>
@@ -12983,7 +13018,7 @@
                 </a:solidFill>
                 <a:latin typeface="Calibri"/>
               </a:rPr>
-              <a:t>Four match, two consent tests Partial</a:t>
+              <a:t>Four honest answers, two broken promises</a:t>
             </a:r>
           </a:p>
         </p:txBody>
@@ -13068,7 +13103,7 @@
                 </a:solidFill>
                 <a:latin typeface="Calibri"/>
               </a:rPr>
-              <a:t>Four core purposes match the notice: tax, paid streaming, match history, checkout.</a:t>
+              <a:t>Four purposes hold up: tax by law, streaming by contract, match history by interest, checkout by contract.</a:t>
             </a:r>
           </a:p>
           <a:p>
@@ -13087,7 +13122,7 @@
                 </a:solidFill>
                 <a:latin typeface="Calibri"/>
               </a:rPr>
-              <a:t>Two consent tests are Partial: Skatteetaten optional cookies and document.no Google Signals.</a:t>
+              <a:t>Two consent claims fail: Skatteetaten optional cookies and document.no Google Signals.</a:t>
             </a:r>
           </a:p>
           <a:p>
@@ -13106,7 +13141,7 @@
                 </a:solidFill>
                 <a:latin typeface="Calibri"/>
               </a:rPr>
-              <a:t>In both cases the notice claims consent, but the ICO marks consent INCONCLUSIVE.</a:t>
+              <a:t>Both notices say consent - but the ICO marks consent INCONCLUSIVE.</a:t>
             </a:r>
           </a:p>
           <a:p>
@@ -13125,7 +13160,7 @@
                 </a:solidFill>
                 <a:latin typeface="Calibri"/>
               </a:rPr>
-              <a:t>Skatteetaten does not spell out clearly enough who processes the optional cookies and how to refuse them. document.no points users to Google ad settings; the ICO says that is not a clear, separate consent request, and Pluss terms bundle the notice.</a:t>
+              <a:t>Skatteetaten does not say clearly enough who runs the optional cookies or how to refuse. document.no sends you to Google ad settings - not a clear, separate choice - and Pluss terms bundle the notice.</a:t>
             </a:r>
           </a:p>
         </p:txBody>
@@ -13455,7 +13490,7 @@
                 </a:solidFill>
                 <a:latin typeface="Calibri"/>
               </a:rPr>
-              <a:t>skatteetaten.no: two purposes</a:t>
+              <a:t>skatteetaten.no: duty and choice</a:t>
             </a:r>
           </a:p>
         </p:txBody>
@@ -13497,7 +13532,7 @@
                 </a:solidFill>
                 <a:latin typeface="Calibri"/>
               </a:rPr>
-              <a:t>Tax and registry data: the law requires it. Opt-out is generally not possible.</a:t>
+              <a:t>Tax and registry data: the law requires it. You cannot opt out of being counted.</a:t>
             </a:r>
           </a:p>
           <a:p>
@@ -13535,7 +13570,7 @@
                 </a:solidFill>
                 <a:latin typeface="Calibri"/>
               </a:rPr>
-              <a:t>Optional statistics cookies: the notice claims consent.</a:t>
+              <a:t>Optional statistics cookies: the notice says you can choose - but does it explain how?</a:t>
             </a:r>
           </a:p>
           <a:p>
@@ -13884,7 +13919,7 @@
                 </a:solidFill>
                 <a:latin typeface="Calibri"/>
               </a:rPr>
-              <a:t>netflix.no: paid streaming</a:t>
+              <a:t>netflix.no: pay to watch</a:t>
             </a:r>
           </a:p>
         </p:txBody>
@@ -13926,7 +13961,7 @@
                 </a:solidFill>
                 <a:latin typeface="Calibri"/>
               </a:rPr>
-              <a:t>Purpose: account and payment data needed to provide the paid service.</a:t>
+              <a:t>Purpose: account and payment data to deliver what you paid for.</a:t>
             </a:r>
           </a:p>
           <a:p>
@@ -13945,7 +13980,7 @@
                 </a:solidFill>
                 <a:latin typeface="Calibri"/>
               </a:rPr>
-              <a:t>Notice (EEA/UK): contractual necessity.</a:t>
+              <a:t>Notice (EEA/UK): contractual necessity - not consent.</a:t>
             </a:r>
           </a:p>
           <a:p>
@@ -13983,7 +14018,7 @@
                 </a:solidFill>
                 <a:latin typeface="Calibri"/>
               </a:rPr>
-              <a:t>Ads and marketing in the same notice were left out.</a:t>
+              <a:t>Ads and marketing in the same notice were left out - different purpose, different basis.</a:t>
             </a:r>
           </a:p>
         </p:txBody>

</xml_diff>

<commit_message>
Tilbakestill presentasjon til a1a950e-versjonen
Karina foretrekker den versjonen: profesjonell tone, Table-referanser
i slides, uten de filosofiske omskrivingene fra senere commits.
Rapporten er uendret.

Co-authored-by: Karina <kasa031@users.noreply.github.com>
</commit_message>
<xml_diff>
--- a/ACIT4280_1A_presentation.pptx
+++ b/ACIT4280_1A_presentation.pptx
@@ -515,7 +515,7 @@
           <a:lstStyle/>
           <a:p>
             <a:r>
-              <a:t>Part 1 maps invisible contact. Part 2 asks whether the legal story holds.</a:t>
+              <a:t>Part 1 measures contact. Part 2 tests one purpose at a time.</a:t>
             </a:r>
           </a:p>
         </p:txBody>
@@ -585,7 +585,7 @@
           <a:lstStyle/>
           <a:p>
             <a:r>
-              <a:t>fotball.no also has the highest Webbkoll request count - contact and lawful basis are separate questions.</a:t>
+              <a:t>fotball.no also has the highest Webbkoll request count. That does not decide Article 6.</a:t>
             </a:r>
           </a:p>
         </p:txBody>
@@ -655,7 +655,7 @@
           <a:lstStyle/>
           <a:p>
             <a:r>
-              <a:t>Consent that hides in settings is consent in name only.</a:t>
+              <a:t>Contract and legitimate interests do not fit this advertising purpose.</a:t>
             </a:r>
           </a:p>
         </p:txBody>
@@ -725,7 +725,7 @@
           <a:lstStyle/>
           <a:p>
             <a:r>
-              <a:t>Same pattern as Netflix: the core transaction runs on contract, not consent.</a:t>
+              <a:t>Same pattern as Netflix: contract for the core service.</a:t>
             </a:r>
           </a:p>
         </p:txBody>
@@ -795,7 +795,7 @@
           <a:lstStyle/>
           <a:p>
             <a:r>
-              <a:t>Contact is visible. Lawful basis must be argued purpose by purpose.</a:t>
+              <a:t>Part 1 is contact. Part 2 is one purpose and one basis at a time.</a:t>
             </a:r>
           </a:p>
         </p:txBody>
@@ -931,7 +931,7 @@
           <a:lstStyle/>
           <a:p>
             <a:r>
-              <a:t>Webbkoll maps contact on one load. ICO tests one purpose at a time. Who you meet and why it is legal are different questions.</a:t>
+              <a:t>Webbkoll records one load. ICO tests one purpose at a time. Contact and lawful basis are different questions.</a:t>
             </a:r>
           </a:p>
         </p:txBody>
@@ -1001,7 +1001,7 @@
           <a:lstStyle/>
           <a:p>
             <a:r>
-              <a:t>Contact is visible even when cookies are not. Volume and cookies measure different things.</a:t>
+              <a:t>Webbkoll counts contact on one load. Cookies and requests are separate measures.</a:t>
             </a:r>
           </a:p>
         </p:txBody>
@@ -1071,7 +1071,7 @@
           <a:lstStyle/>
           <a:p>
             <a:r>
-              <a:t>Request count is not morality - it is visibility. fotball.no is loud with zero third-party cookies.</a:t>
+              <a:t>fotball.no has 113 requests and zero third-party cookies. document.no has the widest country list (6).</a:t>
             </a:r>
           </a:p>
         </p:txBody>
@@ -1141,7 +1141,7 @@
           <a:lstStyle/>
           <a:p>
             <a:r>
-              <a:t>Sector patterns matter: media is networked, government is restrained. Pie chart = request share, not cookies.</a:t>
+              <a:t>fotball.no 113. lanekassen.no 1. The pie is request share, not cookies.</a:t>
             </a:r>
           </a:p>
         </p:txBody>
@@ -1211,7 +1211,7 @@
           <a:lstStyle/>
           <a:p>
             <a:r>
-              <a:t>Each row is one purpose. Partial means the consent story did not pass the ICO checklist.</a:t>
+              <a:t>Each row is one purpose from Table 1a. Partial means consent INCONCLUSIVE.</a:t>
             </a:r>
           </a:p>
         </p:txBody>
@@ -1281,7 +1281,7 @@
           <a:lstStyle/>
           <a:p>
             <a:r>
-              <a:t>Partial is not guilt - it means the consent story did not survive scrutiny.</a:t>
+              <a:t>Partial is not a court finding. It means the consent wording did not pass the ICO checklist.</a:t>
             </a:r>
           </a:p>
         </p:txBody>
@@ -1351,7 +1351,7 @@
           <a:lstStyle/>
           <a:p>
             <a:r>
-              <a:t>One site, two moral questions: mandatory duty vs optional tracking.</a:t>
+              <a:t>Two purposes in the notice, two ICO runs. Figure 7 in the report is the hub that splits those pages.</a:t>
             </a:r>
           </a:p>
         </p:txBody>
@@ -1421,7 +1421,7 @@
           <a:lstStyle/>
           <a:p>
             <a:r>
-              <a:t>When you pay for a service, contract often fits better than consent.</a:t>
+              <a:t>Same split as elsewhere: one purpose, one basis.</a:t>
             </a:r>
           </a:p>
         </p:txBody>
@@ -4657,7 +4657,7 @@
                 </a:solidFill>
                 <a:latin typeface="Calibri"/>
               </a:rPr>
-              <a:t>•  When you open a front page, who else does it contact - and where in the world are those servers?</a:t>
+              <a:t>•  When a front page loads, how many third parties does it contact, and in which countries do those servers appear to be located?</a:t>
             </a:r>
           </a:p>
           <a:p>
@@ -4676,7 +4676,7 @@
                 </a:solidFill>
                 <a:latin typeface="Calibri"/>
               </a:rPr>
-              <a:t>•  When a site uses personal data, does it have a lawful basis - and does that claim hold up?</a:t>
+              <a:t>•  When a site processes personal data, has it named a GDPR Article 6 lawful basis, and does the ICO tool agree?</a:t>
             </a:r>
           </a:p>
         </p:txBody>
@@ -4987,7 +4987,7 @@
                 </a:solidFill>
                 <a:latin typeface="Calibri"/>
               </a:rPr>
-              <a:t>fotball.no: a name on the team sheet</a:t>
+              <a:t>fotball.no: match history</a:t>
             </a:r>
           </a:p>
         </p:txBody>
@@ -5048,7 +5048,7 @@
                 </a:solidFill>
                 <a:latin typeface="Calibri"/>
               </a:rPr>
-              <a:t>ICO: legitimate interests APPROPRIATE - sport transparency, not blanket consent.</a:t>
+              <a:t>ICO: legitimate interests APPROPRIATE.</a:t>
             </a:r>
           </a:p>
           <a:p>
@@ -5416,7 +5416,7 @@
                 </a:solidFill>
                 <a:latin typeface="Calibri"/>
               </a:rPr>
-              <a:t>document.no: consent without a real choice</a:t>
+              <a:t>document.no: Google Signals</a:t>
             </a:r>
           </a:p>
         </p:txBody>
@@ -5536,7 +5536,7 @@
                 </a:solidFill>
                 <a:latin typeface="Calibri"/>
               </a:rPr>
-              <a:t>•  Purpose: advertising analytics built from what you read and click.</a:t>
+              <a:t>•  Purpose: advertising analytics from site activity.</a:t>
             </a:r>
           </a:p>
           <a:p>
@@ -5555,7 +5555,7 @@
                 </a:solidFill>
                 <a:latin typeface="Calibri"/>
               </a:rPr>
-              <a:t>•  The notice never names Article 6 - but it reads like consent.</a:t>
+              <a:t>•  The notice does not name Article 6. It looks like consent.</a:t>
             </a:r>
           </a:p>
           <a:p>
@@ -5593,7 +5593,7 @@
                 </a:solidFill>
                 <a:latin typeface="Calibri"/>
               </a:rPr>
-              <a:t>•  The choice lives in Google settings. Pluss terms also bundle the notice.</a:t>
+              <a:t>•  The choice sits in Google settings. Pluss terms also bundle the notice.</a:t>
             </a:r>
           </a:p>
         </p:txBody>
@@ -5923,7 +5923,7 @@
                 </a:solidFill>
                 <a:latin typeface="Calibri"/>
               </a:rPr>
-              <a:t>babyshop.no: pay to receive</a:t>
+              <a:t>babyshop.no: checkout</a:t>
             </a:r>
           </a:p>
         </p:txBody>
@@ -5984,7 +5984,7 @@
                 </a:solidFill>
                 <a:latin typeface="Calibri"/>
               </a:rPr>
-              <a:t>The sales terms are a purchase contract - you pay, they ship.</a:t>
+              <a:t>The sales terms are a purchase contract.</a:t>
             </a:r>
           </a:p>
           <a:p>
@@ -6352,7 +6352,7 @@
                 </a:solidFill>
                 <a:latin typeface="Calibri"/>
               </a:rPr>
-              <a:t>What we learned</a:t>
+              <a:t>What the report shows</a:t>
             </a:r>
           </a:p>
         </p:txBody>
@@ -6437,7 +6437,7 @@
                 </a:solidFill>
                 <a:latin typeface="Calibri"/>
               </a:rPr>
-              <a:t>Opening a Norwegian front page starts a hidden conversation - we mapped 18 of them.</a:t>
+              <a:t>We measured how much 18 sites contact others on load, and we checked whether five of them have a valid GDPR basis for one specific purpose.</a:t>
             </a:r>
           </a:p>
           <a:p>
@@ -6456,7 +6456,7 @@
                 </a:solidFill>
                 <a:latin typeface="Calibri"/>
               </a:rPr>
-              <a:t>Many sites reach out widely without setting a single third-party cookie.</a:t>
+              <a:t>Many sites reach out to many others without setting cookies.</a:t>
             </a:r>
           </a:p>
           <a:p>
@@ -6475,7 +6475,7 @@
                 </a:solidFill>
                 <a:latin typeface="Calibri"/>
               </a:rPr>
-              <a:t>Four of five ICO purposes match what the notice claims.</a:t>
+              <a:t>Four of five ICO purposes match the notice.</a:t>
             </a:r>
           </a:p>
           <a:p>
@@ -6494,7 +6494,7 @@
                 </a:solidFill>
                 <a:latin typeface="Calibri"/>
               </a:rPr>
-              <a:t>Where sites say consent, the wording must be real - in two cases, the ICO says it is not.</a:t>
+              <a:t>In two places where the site claims consent, the ICO is not satisfied with how consent is formulated.</a:t>
             </a:r>
           </a:p>
         </p:txBody>
@@ -6681,7 +6681,7 @@
         </p:nvSpPr>
         <p:spPr>
           <a:xfrm>
-            <a:off x="640080" y="1920240"/>
+            <a:off x="640080" y="2194560"/>
             <a:ext cx="10972800" cy="1097280"/>
           </a:xfrm>
           <a:prstGeom prst="rect">
@@ -6703,7 +6703,7 @@
                 </a:solidFill>
                 <a:latin typeface="Calibri"/>
               </a:rPr>
-              <a:t>Questions?</a:t>
+              <a:t>Questions</a:t>
             </a:r>
           </a:p>
         </p:txBody>
@@ -6716,8 +6716,8 @@
         </p:nvSpPr>
         <p:spPr>
           <a:xfrm>
-            <a:off x="640080" y="3063240"/>
-            <a:ext cx="10972800" cy="822960"/>
+            <a:off x="640080" y="3474720"/>
+            <a:ext cx="10972800" cy="1280160"/>
           </a:xfrm>
           <a:prstGeom prst="rect">
             <a:avLst/>
@@ -6735,41 +6735,6 @@
               <a:rPr sz="2000" b="0" i="0">
                 <a:solidFill>
                   <a:srgbClr val="44A1A4"/>
-                </a:solidFill>
-                <a:latin typeface="Calibri"/>
-              </a:rPr>
-              <a:t>Who else does your browser meet - and does the privacy notice tell the truth?</a:t>
-            </a:r>
-          </a:p>
-        </p:txBody>
-      </p:sp>
-      <p:sp>
-        <p:nvSpPr>
-          <p:cNvPr id="5" name="TextBox 4"/>
-          <p:cNvSpPr txBox="1"/>
-          <p:nvPr/>
-        </p:nvSpPr>
-        <p:spPr>
-          <a:xfrm>
-            <a:off x="640080" y="3977639"/>
-            <a:ext cx="10972800" cy="548640"/>
-          </a:xfrm>
-          <a:prstGeom prst="rect">
-            <a:avLst/>
-          </a:prstGeom>
-          <a:noFill/>
-        </p:spPr>
-        <p:txBody>
-          <a:bodyPr wrap="square" lIns="0" rIns="0" tIns="0" bIns="0">
-            <a:noAutofit/>
-          </a:bodyPr>
-          <a:lstStyle/>
-          <a:p>
-            <a:pPr algn="ctr"/>
-            <a:r>
-              <a:rPr sz="1800" b="0" i="0">
-                <a:solidFill>
-                  <a:srgbClr val="FFFFFF"/>
                 </a:solidFill>
                 <a:latin typeface="Calibri"/>
               </a:rPr>
@@ -6955,7 +6920,7 @@
                 </a:solidFill>
                 <a:latin typeface="Calibri"/>
               </a:rPr>
-              <a:t>Our approach</a:t>
+              <a:t>The report</a:t>
             </a:r>
           </a:p>
         </p:txBody>
@@ -6990,7 +6955,7 @@
                 </a:solidFill>
                 <a:latin typeface="Calibri"/>
               </a:rPr>
-              <a:t>Two questions, two tools</a:t>
+              <a:t>Two questions and how we measured</a:t>
             </a:r>
           </a:p>
         </p:txBody>
@@ -7110,7 +7075,7 @@
                 </a:solidFill>
                 <a:latin typeface="Calibri"/>
               </a:rPr>
-              <a:t>•  18 Norwegian front pages - one clean visit each</a:t>
+              <a:t>•  18 sites: cookies, requests, KeyCDN country</a:t>
             </a:r>
           </a:p>
           <a:p>
@@ -7129,7 +7094,7 @@
                 </a:solidFill>
                 <a:latin typeface="Calibri"/>
               </a:rPr>
-              <a:t>•  Who do they call? Cookies, requests, server country (first scan, 20 Aug)</a:t>
+              <a:t>•  One clean load per site; rank on Table 2 (20 Aug)</a:t>
             </a:r>
           </a:p>
           <a:p>
@@ -7148,7 +7113,7 @@
                 </a:solidFill>
                 <a:latin typeface="Calibri"/>
               </a:rPr>
-              <a:t>•  KeyCDN shows where servers sit - a guess, not proof of lawful transfer</a:t>
+              <a:t>•  KeyCDN = IP geolocation guess, not legal transfer proof</a:t>
             </a:r>
           </a:p>
         </p:txBody>
@@ -7292,7 +7257,7 @@
                 </a:solidFill>
                 <a:latin typeface="Calibri"/>
               </a:rPr>
-              <a:t>•  Five sites - one purpose per run, because mixed questions break the test</a:t>
+              <a:t>•  Five sites, one purpose per run</a:t>
             </a:r>
           </a:p>
           <a:p>
@@ -7311,7 +7276,7 @@
                 </a:solidFill>
                 <a:latin typeface="Calibri"/>
               </a:rPr>
-              <a:t>•  Does the privacy notice match the ICO report? (26 Aug 2026)</a:t>
+              <a:t>•  Notice vs ICO Word report (26 Aug 2026)</a:t>
             </a:r>
           </a:p>
           <a:p>
@@ -7330,7 +7295,7 @@
                 </a:solidFill>
                 <a:latin typeface="Calibri"/>
               </a:rPr>
-              <a:t>•  Yes when notice and ICO tell the same story</a:t>
+              <a:t>•  Yes if notice and ICO agree</a:t>
             </a:r>
           </a:p>
           <a:p>
@@ -7349,7 +7314,7 @@
                 </a:solidFill>
                 <a:latin typeface="Calibri"/>
               </a:rPr>
-              <a:t>•  Partial when consent wording fails the checklist</a:t>
+              <a:t>•  Partial if consent is INCONCLUSIVE</a:t>
             </a:r>
           </a:p>
           <a:p>
@@ -7368,7 +7333,7 @@
                 </a:solidFill>
                 <a:latin typeface="Calibri"/>
               </a:rPr>
-              <a:t>•  Tax, cookies, checkout and ads are not the same question</a:t>
+              <a:t>•  Tax, cookies, checkout and marketing are different purposes</a:t>
             </a:r>
           </a:p>
         </p:txBody>
@@ -7698,7 +7663,7 @@
                 </a:solidFill>
                 <a:latin typeface="Calibri"/>
               </a:rPr>
-              <a:t>Your browser talks to strangers</a:t>
+              <a:t>What Webbkoll shows and key findings</a:t>
             </a:r>
           </a:p>
         </p:txBody>
@@ -7776,7 +7741,7 @@
                 </a:solidFill>
                 <a:latin typeface="Calibri"/>
               </a:rPr>
-              <a:t>What Webbkoll reveals</a:t>
+              <a:t>What Webbkoll shows</a:t>
             </a:r>
           </a:p>
         </p:txBody>
@@ -7818,7 +7783,7 @@
                 </a:solidFill>
                 <a:latin typeface="Calibri"/>
               </a:rPr>
-              <a:t>Every front page starts a conversation - Webbkoll records who joins it.</a:t>
+              <a:t>Cookies, third-party requests and server country.</a:t>
             </a:r>
           </a:p>
           <a:p>
@@ -7981,7 +7946,7 @@
                 </a:solidFill>
                 <a:latin typeface="Calibri"/>
               </a:rPr>
-              <a:t>•  fotball.no: 113 hosts, zero third-party cookies - loud, but not cookie-heavy.</a:t>
+              <a:t>•  fotball.no: 113 requests, zero third-party cookies.</a:t>
             </a:r>
           </a:p>
           <a:p>
@@ -8000,7 +7965,7 @@
                 </a:solidFill>
                 <a:latin typeface="Calibri"/>
               </a:rPr>
-              <a:t>•  17 of 18 sites: no third-party cookies on load. ikea.no was the exception (2).</a:t>
+              <a:t>•  17 of 18 sites: zero third-party cookies. ikea.no had 2.</a:t>
             </a:r>
           </a:p>
           <a:p>
@@ -8019,7 +7984,7 @@
                 </a:solidFill>
                 <a:latin typeface="Calibri"/>
               </a:rPr>
-              <a:t>•  lanekassen.no (1) and altinn.no (5): the quietest public-sector doors.</a:t>
+              <a:t>•  lanekassen.no (1) and altinn.no (5): quietest e-government pages.</a:t>
             </a:r>
           </a:p>
           <a:p>
@@ -8038,7 +8003,7 @@
                 </a:solidFill>
                 <a:latin typeface="Calibri"/>
               </a:rPr>
-              <a:t>•  document.no: data paths touch 6 countries, excluding Norway.</a:t>
+              <a:t>•  document.no: widest country list (6 excluding Norway).</a:t>
             </a:r>
           </a:p>
           <a:p>
@@ -8057,7 +8022,7 @@
                 </a:solidFill>
                 <a:latin typeface="Calibri"/>
               </a:rPr>
-              <a:t>•  News and media reach out most. Government pages reach out least.</a:t>
+              <a:t>•  News/media contacted the most. Government the fewest.</a:t>
             </a:r>
           </a:p>
           <a:p>
@@ -8076,7 +8041,7 @@
                 </a:solidFill>
                 <a:latin typeface="Calibri"/>
               </a:rPr>
-              <a:t>•  babyshop.no doubled on repeat scan (45 to 101) - rankings stay on the first scan.</a:t>
+              <a:t>•  babyshop.no: 101 on Table 3; ranking stays on Table 2 (45).</a:t>
             </a:r>
           </a:p>
         </p:txBody>
@@ -8371,7 +8336,7 @@
                 </a:solidFill>
                 <a:latin typeface="Calibri"/>
               </a:rPr>
-              <a:t>Part 1</a:t>
+              <a:t>Part 1  ·  Table 4</a:t>
             </a:r>
           </a:p>
         </p:txBody>
@@ -8406,7 +8371,7 @@
                 </a:solidFill>
                 <a:latin typeface="Calibri"/>
               </a:rPr>
-              <a:t>The loud and the quiet</a:t>
+              <a:t>Highest and lowest third-party requests</a:t>
             </a:r>
           </a:p>
         </p:txBody>
@@ -9641,7 +9606,7 @@
                 </a:solidFill>
                 <a:latin typeface="Calibri"/>
               </a:rPr>
-              <a:t>Same question, different answers: fotball.no shouts (113), lanekassen.no barely whispers (1). Rankings follow the first scan.</a:t>
+              <a:t>Ranked on Table 2 requests. lanekassen.no and altinn.no have the fewest government requests. babyshop.no is 101 on Table 3; rankings stay on Table 2.</a:t>
             </a:r>
           </a:p>
         </p:txBody>
@@ -9971,7 +9936,7 @@
                 </a:solidFill>
                 <a:latin typeface="Calibri"/>
               </a:rPr>
-              <a:t>Where the traffic goes</a:t>
+              <a:t>Third-party requests by site and sector</a:t>
             </a:r>
           </a:p>
         </p:txBody>
@@ -10078,7 +10043,7 @@
                 </a:solidFill>
                 <a:latin typeface="Calibri"/>
               </a:rPr>
-              <a:t>News and media pull the most strings on load. Government pages keep the fewest.</a:t>
+              <a:t>Table 2. News/media is the highest sector. Government is the lowest.</a:t>
             </a:r>
           </a:p>
         </p:txBody>
@@ -10408,7 +10373,7 @@
                 </a:solidFill>
                 <a:latin typeface="Calibri"/>
               </a:rPr>
-              <a:t>Does the privacy notice mean what it says?</a:t>
+              <a:t>ICO: one purpose at a time</a:t>
             </a:r>
           </a:p>
         </p:txBody>
@@ -10450,7 +10415,7 @@
                 </a:solidFill>
                 <a:latin typeface="Calibri"/>
               </a:rPr>
-              <a:t>One purpose per ICO run (26 Aug 2026). We ask: does the site's legal story hold up?</a:t>
+              <a:t>One purpose per ICO run (26 Aug 2026). Yes if notice and ICO agree; Partial if consent is INCONCLUSIVE.</a:t>
             </a:r>
           </a:p>
           <a:p>
@@ -10469,7 +10434,7 @@
                 </a:solidFill>
                 <a:latin typeface="Calibri"/>
               </a:rPr>
-              <a:t>Yes when notice and ICO agree. Partial when consent is INCONCLUSIVE.</a:t>
+              <a:t>Tax, cookies, checkout and marketing are different purposes.</a:t>
             </a:r>
           </a:p>
         </p:txBody>
@@ -12688,7 +12653,7 @@
                 </a:solidFill>
                 <a:latin typeface="Calibri"/>
               </a:rPr>
-              <a:t>ICO guidance is not a court verdict - but it shows where the story breaks.</a:t>
+              <a:t>ICO labels are guidance, not a court finding.</a:t>
             </a:r>
           </a:p>
         </p:txBody>
@@ -12983,7 +12948,7 @@
                 </a:solidFill>
                 <a:latin typeface="Calibri"/>
               </a:rPr>
-              <a:t>Part 2</a:t>
+              <a:t>Part 2  ·  Table 5</a:t>
             </a:r>
           </a:p>
         </p:txBody>
@@ -13018,7 +12983,7 @@
                 </a:solidFill>
                 <a:latin typeface="Calibri"/>
               </a:rPr>
-              <a:t>Four honest answers, two broken promises</a:t>
+              <a:t>Four match, two consent tests Partial</a:t>
             </a:r>
           </a:p>
         </p:txBody>
@@ -13103,7 +13068,7 @@
                 </a:solidFill>
                 <a:latin typeface="Calibri"/>
               </a:rPr>
-              <a:t>Four purposes hold up: tax by law, streaming by contract, match history by interest, checkout by contract.</a:t>
+              <a:t>Four core purposes match the notice: tax, paid streaming, match history, checkout.</a:t>
             </a:r>
           </a:p>
           <a:p>
@@ -13122,7 +13087,7 @@
                 </a:solidFill>
                 <a:latin typeface="Calibri"/>
               </a:rPr>
-              <a:t>Two consent claims fail: Skatteetaten optional cookies and document.no Google Signals.</a:t>
+              <a:t>Two consent tests are Partial: Skatteetaten optional cookies and document.no Google Signals.</a:t>
             </a:r>
           </a:p>
           <a:p>
@@ -13141,7 +13106,7 @@
                 </a:solidFill>
                 <a:latin typeface="Calibri"/>
               </a:rPr>
-              <a:t>Both notices say consent - but the ICO marks consent INCONCLUSIVE.</a:t>
+              <a:t>In both cases the notice claims consent, but the ICO marks consent INCONCLUSIVE.</a:t>
             </a:r>
           </a:p>
           <a:p>
@@ -13160,7 +13125,7 @@
                 </a:solidFill>
                 <a:latin typeface="Calibri"/>
               </a:rPr>
-              <a:t>Skatteetaten does not say clearly enough who runs the optional cookies or how to refuse. document.no sends you to Google ad settings - not a clear, separate choice - and Pluss terms bundle the notice.</a:t>
+              <a:t>Skatteetaten does not spell out clearly enough who processes the optional cookies and how to refuse them. document.no points users to Google ad settings; the ICO says that is not a clear, separate consent request, and Pluss terms bundle the notice.</a:t>
             </a:r>
           </a:p>
         </p:txBody>
@@ -13490,7 +13455,7 @@
                 </a:solidFill>
                 <a:latin typeface="Calibri"/>
               </a:rPr>
-              <a:t>skatteetaten.no: duty and choice</a:t>
+              <a:t>skatteetaten.no: two purposes</a:t>
             </a:r>
           </a:p>
         </p:txBody>
@@ -13532,7 +13497,7 @@
                 </a:solidFill>
                 <a:latin typeface="Calibri"/>
               </a:rPr>
-              <a:t>Tax and registry data: the law requires it. You cannot opt out of being counted.</a:t>
+              <a:t>Tax and registry data: the law requires it. Opt-out is generally not possible.</a:t>
             </a:r>
           </a:p>
           <a:p>
@@ -13570,7 +13535,7 @@
                 </a:solidFill>
                 <a:latin typeface="Calibri"/>
               </a:rPr>
-              <a:t>Optional statistics cookies: the notice says you can choose - but does it explain how?</a:t>
+              <a:t>Optional statistics cookies: the notice claims consent.</a:t>
             </a:r>
           </a:p>
           <a:p>
@@ -13919,7 +13884,7 @@
                 </a:solidFill>
                 <a:latin typeface="Calibri"/>
               </a:rPr>
-              <a:t>netflix.no: pay to watch</a:t>
+              <a:t>netflix.no: paid streaming</a:t>
             </a:r>
           </a:p>
         </p:txBody>
@@ -13961,7 +13926,7 @@
                 </a:solidFill>
                 <a:latin typeface="Calibri"/>
               </a:rPr>
-              <a:t>Purpose: account and payment data to deliver what you paid for.</a:t>
+              <a:t>Purpose: account and payment data needed to provide the paid service.</a:t>
             </a:r>
           </a:p>
           <a:p>
@@ -13980,7 +13945,7 @@
                 </a:solidFill>
                 <a:latin typeface="Calibri"/>
               </a:rPr>
-              <a:t>Notice (EEA/UK): contractual necessity - not consent.</a:t>
+              <a:t>Notice (EEA/UK): contractual necessity.</a:t>
             </a:r>
           </a:p>
           <a:p>
@@ -14018,7 +13983,7 @@
                 </a:solidFill>
                 <a:latin typeface="Calibri"/>
               </a:rPr>
-              <a:t>Ads and marketing in the same notice were left out - different purpose, different basis.</a:t>
+              <a:t>Ads and marketing in the same notice were left out.</a:t>
             </a:r>
           </a:p>
         </p:txBody>

</xml_diff>

<commit_message>
Fjern grå caption-tekst på slide 4 (Table 2/3)
Tabellen er selvforklarende uten fotnote om ranking og babyshop.no.

Co-authored-by: Karina <kasa031@users.noreply.github.com>
</commit_message>
<xml_diff>
--- a/ACIT4280_1A_presentation.pptx
+++ b/ACIT4280_1A_presentation.pptx
@@ -9578,42 +9578,7 @@
       </p:sp>
       <p:sp>
         <p:nvSpPr>
-          <p:cNvPr id="39" name="TextBox 38"/>
-          <p:cNvSpPr txBox="1"/>
-          <p:nvPr/>
-        </p:nvSpPr>
-        <p:spPr>
-          <a:xfrm>
-            <a:off x="457200" y="6263640"/>
-            <a:ext cx="11247120" cy="347472"/>
-          </a:xfrm>
-          <a:prstGeom prst="rect">
-            <a:avLst/>
-          </a:prstGeom>
-          <a:noFill/>
-        </p:spPr>
-        <p:txBody>
-          <a:bodyPr wrap="square" lIns="0" rIns="0" tIns="0" bIns="0">
-            <a:noAutofit/>
-          </a:bodyPr>
-          <a:lstStyle/>
-          <a:p>
-            <a:pPr algn="l"/>
-            <a:r>
-              <a:rPr sz="1300" b="0" i="0">
-                <a:solidFill>
-                  <a:srgbClr val="4A5568"/>
-                </a:solidFill>
-                <a:latin typeface="Calibri"/>
-              </a:rPr>
-              <a:t>Ranked on Table 2 requests. lanekassen.no and altinn.no have the fewest government requests. babyshop.no is 101 on Table 3; rankings stay on Table 2.</a:t>
-            </a:r>
-          </a:p>
-        </p:txBody>
-      </p:sp>
-      <p:sp>
-        <p:nvSpPr>
-          <p:cNvPr id="40" name="Rectangle 39"/>
+          <p:cNvPr id="39" name="Rectangle 38"/>
           <p:cNvSpPr/>
           <p:nvPr/>
         </p:nvSpPr>
@@ -9656,7 +9621,7 @@
       </p:sp>
       <p:sp>
         <p:nvSpPr>
-          <p:cNvPr id="41" name="TextBox 40"/>
+          <p:cNvPr id="40" name="TextBox 39"/>
           <p:cNvSpPr txBox="1"/>
           <p:nvPr/>
         </p:nvSpPr>
@@ -9691,7 +9656,7 @@
       </p:sp>
       <p:sp>
         <p:nvSpPr>
-          <p:cNvPr id="42" name="TextBox 41"/>
+          <p:cNvPr id="41" name="TextBox 40"/>
           <p:cNvSpPr txBox="1"/>
           <p:nvPr/>
         </p:nvSpPr>

</xml_diff>

<commit_message>
Fjern ICO caption-tekst pa slide 6
Ta bort setningen om at ICO labels are guidance, not a court finding.

Co-authored-by: Karina <kasa031@users.noreply.github.com>
</commit_message>
<xml_diff>
--- a/ACIT4280_1A_presentation.pptx
+++ b/ACIT4280_1A_presentation.pptx
@@ -12590,42 +12590,7 @@
       </p:sp>
       <p:sp>
         <p:nvSpPr>
-          <p:cNvPr id="64" name="TextBox 63"/>
-          <p:cNvSpPr txBox="1"/>
-          <p:nvPr/>
-        </p:nvSpPr>
-        <p:spPr>
-          <a:xfrm>
-            <a:off x="365760" y="6199632"/>
-            <a:ext cx="11430000" cy="347472"/>
-          </a:xfrm>
-          <a:prstGeom prst="rect">
-            <a:avLst/>
-          </a:prstGeom>
-          <a:noFill/>
-        </p:spPr>
-        <p:txBody>
-          <a:bodyPr wrap="square" lIns="0" rIns="0" tIns="0" bIns="0">
-            <a:noAutofit/>
-          </a:bodyPr>
-          <a:lstStyle/>
-          <a:p>
-            <a:pPr algn="l"/>
-            <a:r>
-              <a:rPr sz="1300" b="0" i="0">
-                <a:solidFill>
-                  <a:srgbClr val="4A5568"/>
-                </a:solidFill>
-                <a:latin typeface="Calibri"/>
-              </a:rPr>
-              <a:t>ICO labels are guidance, not a court finding.</a:t>
-            </a:r>
-          </a:p>
-        </p:txBody>
-      </p:sp>
-      <p:sp>
-        <p:nvSpPr>
-          <p:cNvPr id="65" name="Rectangle 64"/>
+          <p:cNvPr id="64" name="Rectangle 63"/>
           <p:cNvSpPr/>
           <p:nvPr/>
         </p:nvSpPr>
@@ -12668,7 +12633,7 @@
       </p:sp>
       <p:sp>
         <p:nvSpPr>
-          <p:cNvPr id="66" name="TextBox 65"/>
+          <p:cNvPr id="65" name="TextBox 64"/>
           <p:cNvSpPr txBox="1"/>
           <p:nvPr/>
         </p:nvSpPr>
@@ -12703,7 +12668,7 @@
       </p:sp>
       <p:sp>
         <p:nvSpPr>
-          <p:cNvPr id="67" name="TextBox 66"/>
+          <p:cNvPr id="66" name="TextBox 65"/>
           <p:cNvSpPr txBox="1"/>
           <p:nvPr/>
         </p:nvSpPr>

</xml_diff>

<commit_message>
Redesign ICO nettside-slides med logo og infokort
Slides 8-12 viser na logo, sektor og strukturerte kort med
Purpose, Notice, ICO result og Match for alle fem valgte sider.

Co-authored-by: Karina <kasa031@users.noreply.github.com>
</commit_message>
<xml_diff>
--- a/ACIT4280_1A_presentation.pptx
+++ b/ACIT4280_1A_presentation.pptx
@@ -585,7 +585,7 @@
           <a:lstStyle/>
           <a:p>
             <a:r>
-              <a:t>fotball.no also has the highest Webbkoll request count. That does not decide Article 6.</a:t>
+              <a:t>fotball.no has the highest Webbkoll request count. Contact and lawful basis are separate questions.</a:t>
             </a:r>
           </a:p>
         </p:txBody>
@@ -725,7 +725,7 @@
           <a:lstStyle/>
           <a:p>
             <a:r>
-              <a:t>Same pattern as Netflix: contract for the core service.</a:t>
+              <a:t>Same pattern as Netflix: contract for the core transaction.</a:t>
             </a:r>
           </a:p>
         </p:txBody>
@@ -1351,7 +1351,7 @@
           <a:lstStyle/>
           <a:p>
             <a:r>
-              <a:t>Two purposes in the notice, two ICO runs. Figure 7 in the report is the hub that splits those pages.</a:t>
+              <a:t>Two purposes in the notice, two ICO runs. Figure 7 in the report splits the privacy notice from the cookie page.</a:t>
             </a:r>
           </a:p>
         </p:txBody>
@@ -1421,7 +1421,7 @@
           <a:lstStyle/>
           <a:p>
             <a:r>
-              <a:t>Same split as elsewhere: one purpose, one basis.</a:t>
+              <a:t>One purpose, one basis. Ads and marketing in the same notice were left out.</a:t>
             </a:r>
           </a:p>
         </p:txBody>
@@ -4994,14 +4994,159 @@
       </p:sp>
       <p:sp>
         <p:nvSpPr>
-          <p:cNvPr id="7" name="TextBox 6"/>
+          <p:cNvPr id="7" name="Rectangle 6"/>
+          <p:cNvSpPr/>
+          <p:nvPr/>
+        </p:nvSpPr>
+        <p:spPr>
+          <a:xfrm>
+            <a:off x="457200" y="1298448"/>
+            <a:ext cx="2148840" cy="5230368"/>
+          </a:xfrm>
+          <a:prstGeom prst="rect">
+            <a:avLst/>
+          </a:prstGeom>
+          <a:solidFill>
+            <a:srgbClr val="E8F4F4"/>
+          </a:solidFill>
+          <a:ln>
+            <a:noFill/>
+          </a:ln>
+        </p:spPr>
+        <p:style>
+          <a:lnRef idx="1">
+            <a:schemeClr val="accent1"/>
+          </a:lnRef>
+          <a:fillRef idx="3">
+            <a:schemeClr val="accent1"/>
+          </a:fillRef>
+          <a:effectRef idx="2">
+            <a:schemeClr val="accent1"/>
+          </a:effectRef>
+          <a:fontRef idx="minor">
+            <a:schemeClr val="lt1"/>
+          </a:fontRef>
+        </p:style>
+        <p:txBody>
+          <a:bodyPr rtlCol="0" anchor="ctr"/>
+          <a:lstStyle/>
+          <a:p>
+            <a:pPr algn="ctr"/>
+          </a:p>
+        </p:txBody>
+      </p:sp>
+      <p:pic>
+        <p:nvPicPr>
+          <p:cNvPr id="8" name="Picture 7" descr="logo_fotball_no.png"/>
+          <p:cNvPicPr>
+            <a:picLocks noChangeAspect="1"/>
+          </p:cNvPicPr>
+          <p:nvPr/>
+        </p:nvPicPr>
+        <p:blipFill>
+          <a:blip r:embed="rId2"/>
+          <a:stretch>
+            <a:fillRect/>
+          </a:stretch>
+        </p:blipFill>
+        <p:spPr>
+          <a:xfrm>
+            <a:off x="749808" y="1691640"/>
+            <a:ext cx="1554480" cy="1554480"/>
+          </a:xfrm>
+          <a:prstGeom prst="rect">
+            <a:avLst/>
+          </a:prstGeom>
+        </p:spPr>
+      </p:pic>
+      <p:sp>
+        <p:nvSpPr>
+          <p:cNvPr id="9" name="TextBox 8"/>
           <p:cNvSpPr txBox="1"/>
           <p:nvPr/>
         </p:nvSpPr>
         <p:spPr>
           <a:xfrm>
-            <a:off x="502920" y="1371600"/>
-            <a:ext cx="11155680" cy="5029200"/>
+            <a:off x="502920" y="3429000"/>
+            <a:ext cx="2057400" cy="320040"/>
+          </a:xfrm>
+          <a:prstGeom prst="rect">
+            <a:avLst/>
+          </a:prstGeom>
+          <a:noFill/>
+        </p:spPr>
+        <p:txBody>
+          <a:bodyPr wrap="square" lIns="0" rIns="0" tIns="0" bIns="0">
+            <a:noAutofit/>
+          </a:bodyPr>
+          <a:lstStyle/>
+          <a:p>
+            <a:pPr algn="ctr"/>
+            <a:r>
+              <a:rPr sz="1300" b="1" i="0">
+                <a:solidFill>
+                  <a:srgbClr val="325E6A"/>
+                </a:solidFill>
+                <a:latin typeface="Calibri"/>
+              </a:rPr>
+              <a:t>Sport</a:t>
+            </a:r>
+          </a:p>
+        </p:txBody>
+      </p:sp>
+      <p:sp>
+        <p:nvSpPr>
+          <p:cNvPr id="10" name="Rectangle 9"/>
+          <p:cNvSpPr/>
+          <p:nvPr/>
+        </p:nvSpPr>
+        <p:spPr>
+          <a:xfrm>
+            <a:off x="2788920" y="1298448"/>
+            <a:ext cx="8942832" cy="5230368"/>
+          </a:xfrm>
+          <a:prstGeom prst="rect">
+            <a:avLst/>
+          </a:prstGeom>
+          <a:solidFill>
+            <a:srgbClr val="44A1A4"/>
+          </a:solidFill>
+          <a:ln>
+            <a:noFill/>
+          </a:ln>
+        </p:spPr>
+        <p:style>
+          <a:lnRef idx="1">
+            <a:schemeClr val="accent1"/>
+          </a:lnRef>
+          <a:fillRef idx="3">
+            <a:schemeClr val="accent1"/>
+          </a:fillRef>
+          <a:effectRef idx="2">
+            <a:schemeClr val="accent1"/>
+          </a:effectRef>
+          <a:fontRef idx="minor">
+            <a:schemeClr val="lt1"/>
+          </a:fontRef>
+        </p:style>
+        <p:txBody>
+          <a:bodyPr rtlCol="0" anchor="ctr"/>
+          <a:lstStyle/>
+          <a:p>
+            <a:pPr algn="ctr"/>
+          </a:p>
+        </p:txBody>
+      </p:sp>
+      <p:sp>
+        <p:nvSpPr>
+          <p:cNvPr id="11" name="TextBox 10"/>
+          <p:cNvSpPr txBox="1"/>
+          <p:nvPr/>
+        </p:nvSpPr>
+        <p:spPr>
+          <a:xfrm>
+            <a:off x="3044952" y="1444752"/>
+            <a:ext cx="8485632" cy="4974336"/>
           </a:xfrm>
           <a:prstGeom prst="rect">
             <a:avLst/>
@@ -5019,17 +5164,17 @@
                 <a:spcPts val="0"/>
               </a:spcBef>
               <a:spcAft>
-                <a:spcPts val="1200"/>
+                <a:spcPts val="200"/>
               </a:spcAft>
             </a:pPr>
             <a:r>
-              <a:rPr sz="2000" b="0" i="0">
-                <a:solidFill>
-                  <a:srgbClr val="1A1A1A"/>
-                </a:solidFill>
-                <a:latin typeface="Calibri"/>
-              </a:rPr>
-              <a:t>Purpose: name and club of active players aged 13+, with club opt-out.</a:t>
+              <a:rPr sz="1000" b="1" i="0">
+                <a:solidFill>
+                  <a:srgbClr val="325E6A"/>
+                </a:solidFill>
+                <a:latin typeface="Calibri"/>
+              </a:rPr>
+              <a:t>Purpose</a:t>
             </a:r>
           </a:p>
           <a:p>
@@ -5038,17 +5183,17 @@
                 <a:spcPts val="0"/>
               </a:spcBef>
               <a:spcAft>
-                <a:spcPts val="1200"/>
+                <a:spcPts val="1000"/>
               </a:spcAft>
             </a:pPr>
             <a:r>
-              <a:rPr sz="2000" b="0" i="0">
-                <a:solidFill>
-                  <a:srgbClr val="1A1A1A"/>
-                </a:solidFill>
-                <a:latin typeface="Calibri"/>
-              </a:rPr>
-              <a:t>ICO: legitimate interests APPROPRIATE.</a:t>
+              <a:rPr sz="1800" b="1" i="0">
+                <a:solidFill>
+                  <a:srgbClr val="224248"/>
+                </a:solidFill>
+                <a:latin typeface="Calibri"/>
+              </a:rPr>
+              <a:t>Player name and club on public match history (13+)</a:t>
             </a:r>
           </a:p>
           <a:p>
@@ -5057,17 +5202,17 @@
                 <a:spcPts val="0"/>
               </a:spcBef>
               <a:spcAft>
-                <a:spcPts val="1200"/>
+                <a:spcPts val="200"/>
               </a:spcAft>
             </a:pPr>
             <a:r>
-              <a:rPr sz="2000" b="0" i="0">
-                <a:solidFill>
-                  <a:srgbClr val="1A1A1A"/>
-                </a:solidFill>
-                <a:latin typeface="Calibri"/>
-              </a:rPr>
-              <a:t>NFF is not a public authority, so public task does not fit.</a:t>
+              <a:rPr sz="1000" b="1" i="0">
+                <a:solidFill>
+                  <a:srgbClr val="325E6A"/>
+                </a:solidFill>
+                <a:latin typeface="Calibri"/>
+              </a:rPr>
+              <a:t>Notice</a:t>
             </a:r>
           </a:p>
           <a:p>
@@ -5076,24 +5221,100 @@
                 <a:spcPts val="0"/>
               </a:spcBef>
               <a:spcAft>
-                <a:spcPts val="1200"/>
+                <a:spcPts val="1000"/>
               </a:spcAft>
             </a:pPr>
             <a:r>
-              <a:rPr sz="2000" b="0" i="0">
+              <a:rPr sz="1500" b="0" i="0">
                 <a:solidFill>
                   <a:srgbClr val="1A1A1A"/>
                 </a:solidFill>
                 <a:latin typeface="Calibri"/>
               </a:rPr>
-              <a:t>FIKS membership is a different purpose and was not this run.</a:t>
-            </a:r>
-          </a:p>
-        </p:txBody>
-      </p:sp>
-      <p:sp>
-        <p:nvSpPr>
-          <p:cNvPr id="8" name="Rectangle 7"/>
+              <a:t>NFF publishes active players with club opt-out. Not a public authority.</a:t>
+            </a:r>
+          </a:p>
+          <a:p>
+            <a:pPr algn="l">
+              <a:spcBef>
+                <a:spcPts val="0"/>
+              </a:spcBef>
+              <a:spcAft>
+                <a:spcPts val="200"/>
+              </a:spcAft>
+            </a:pPr>
+            <a:r>
+              <a:rPr sz="1000" b="1" i="0">
+                <a:solidFill>
+                  <a:srgbClr val="325E6A"/>
+                </a:solidFill>
+                <a:latin typeface="Calibri"/>
+              </a:rPr>
+              <a:t>ICO result</a:t>
+            </a:r>
+          </a:p>
+          <a:p>
+            <a:pPr algn="l">
+              <a:spcBef>
+                <a:spcPts val="0"/>
+              </a:spcBef>
+              <a:spcAft>
+                <a:spcPts val="1000"/>
+              </a:spcAft>
+            </a:pPr>
+            <a:r>
+              <a:rPr sz="1500" b="0" i="0">
+                <a:solidFill>
+                  <a:srgbClr val="1A1A1A"/>
+                </a:solidFill>
+                <a:latin typeface="Calibri"/>
+              </a:rPr>
+              <a:t>Legitimate interests APPROPRIATE. Public task does not fit.</a:t>
+            </a:r>
+          </a:p>
+          <a:p>
+            <a:pPr algn="l">
+              <a:spcBef>
+                <a:spcPts val="0"/>
+              </a:spcBef>
+              <a:spcAft>
+                <a:spcPts val="400"/>
+              </a:spcAft>
+            </a:pPr>
+            <a:r>
+              <a:rPr sz="1500" b="1" i="0">
+                <a:solidFill>
+                  <a:srgbClr val="224248"/>
+                </a:solidFill>
+                <a:latin typeface="Calibri"/>
+              </a:rPr>
+              <a:t>Match: Yes</a:t>
+            </a:r>
+          </a:p>
+          <a:p>
+            <a:pPr algn="l">
+              <a:spcBef>
+                <a:spcPts val="0"/>
+              </a:spcBef>
+              <a:spcAft>
+                <a:spcPts val="0"/>
+              </a:spcAft>
+            </a:pPr>
+            <a:r>
+              <a:rPr sz="1200" b="0" i="0">
+                <a:solidFill>
+                  <a:srgbClr val="4A5568"/>
+                </a:solidFill>
+                <a:latin typeface="Calibri"/>
+              </a:rPr>
+              <a:t>FIKS membership is a different purpose and was not this ICO run.</a:t>
+            </a:r>
+          </a:p>
+        </p:txBody>
+      </p:sp>
+      <p:sp>
+        <p:nvSpPr>
+          <p:cNvPr id="12" name="Rectangle 11"/>
           <p:cNvSpPr/>
           <p:nvPr/>
         </p:nvSpPr>
@@ -5136,7 +5357,7 @@
       </p:sp>
       <p:sp>
         <p:nvSpPr>
-          <p:cNvPr id="9" name="TextBox 8"/>
+          <p:cNvPr id="13" name="TextBox 12"/>
           <p:cNvSpPr txBox="1"/>
           <p:nvPr/>
         </p:nvSpPr>
@@ -5171,7 +5392,7 @@
       </p:sp>
       <p:sp>
         <p:nvSpPr>
-          <p:cNvPr id="10" name="TextBox 9"/>
+          <p:cNvPr id="14" name="TextBox 13"/>
           <p:cNvSpPr txBox="1"/>
           <p:nvPr/>
         </p:nvSpPr>
@@ -5429,8 +5650,153 @@
         </p:nvSpPr>
         <p:spPr>
           <a:xfrm>
-            <a:off x="457200" y="1371600"/>
-            <a:ext cx="11247120" cy="1051560"/>
+            <a:off x="457200" y="1298448"/>
+            <a:ext cx="2148840" cy="5230368"/>
+          </a:xfrm>
+          <a:prstGeom prst="rect">
+            <a:avLst/>
+          </a:prstGeom>
+          <a:solidFill>
+            <a:srgbClr val="E8F4F4"/>
+          </a:solidFill>
+          <a:ln>
+            <a:noFill/>
+          </a:ln>
+        </p:spPr>
+        <p:style>
+          <a:lnRef idx="1">
+            <a:schemeClr val="accent1"/>
+          </a:lnRef>
+          <a:fillRef idx="3">
+            <a:schemeClr val="accent1"/>
+          </a:fillRef>
+          <a:effectRef idx="2">
+            <a:schemeClr val="accent1"/>
+          </a:effectRef>
+          <a:fontRef idx="minor">
+            <a:schemeClr val="lt1"/>
+          </a:fontRef>
+        </p:style>
+        <p:txBody>
+          <a:bodyPr rtlCol="0" anchor="ctr"/>
+          <a:lstStyle/>
+          <a:p>
+            <a:pPr algn="ctr"/>
+          </a:p>
+        </p:txBody>
+      </p:sp>
+      <p:pic>
+        <p:nvPicPr>
+          <p:cNvPr id="8" name="Picture 7" descr="logo_document_no.png"/>
+          <p:cNvPicPr>
+            <a:picLocks noChangeAspect="1"/>
+          </p:cNvPicPr>
+          <p:nvPr/>
+        </p:nvPicPr>
+        <p:blipFill>
+          <a:blip r:embed="rId2"/>
+          <a:stretch>
+            <a:fillRect/>
+          </a:stretch>
+        </p:blipFill>
+        <p:spPr>
+          <a:xfrm>
+            <a:off x="749808" y="1691640"/>
+            <a:ext cx="1554480" cy="1554480"/>
+          </a:xfrm>
+          <a:prstGeom prst="rect">
+            <a:avLst/>
+          </a:prstGeom>
+        </p:spPr>
+      </p:pic>
+      <p:sp>
+        <p:nvSpPr>
+          <p:cNvPr id="9" name="TextBox 8"/>
+          <p:cNvSpPr txBox="1"/>
+          <p:nvPr/>
+        </p:nvSpPr>
+        <p:spPr>
+          <a:xfrm>
+            <a:off x="502920" y="3429000"/>
+            <a:ext cx="2057400" cy="320040"/>
+          </a:xfrm>
+          <a:prstGeom prst="rect">
+            <a:avLst/>
+          </a:prstGeom>
+          <a:noFill/>
+        </p:spPr>
+        <p:txBody>
+          <a:bodyPr wrap="square" lIns="0" rIns="0" tIns="0" bIns="0">
+            <a:noAutofit/>
+          </a:bodyPr>
+          <a:lstStyle/>
+          <a:p>
+            <a:pPr algn="ctr"/>
+            <a:r>
+              <a:rPr sz="1300" b="1" i="0">
+                <a:solidFill>
+                  <a:srgbClr val="325E6A"/>
+                </a:solidFill>
+                <a:latin typeface="Calibri"/>
+              </a:rPr>
+              <a:t>News / media</a:t>
+            </a:r>
+          </a:p>
+        </p:txBody>
+      </p:sp>
+      <p:sp>
+        <p:nvSpPr>
+          <p:cNvPr id="10" name="Rectangle 9"/>
+          <p:cNvSpPr/>
+          <p:nvPr/>
+        </p:nvSpPr>
+        <p:spPr>
+          <a:xfrm>
+            <a:off x="2788920" y="1298448"/>
+            <a:ext cx="8942832" cy="5230368"/>
+          </a:xfrm>
+          <a:prstGeom prst="rect">
+            <a:avLst/>
+          </a:prstGeom>
+          <a:solidFill>
+            <a:srgbClr val="E8F4F4"/>
+          </a:solidFill>
+          <a:ln>
+            <a:noFill/>
+          </a:ln>
+        </p:spPr>
+        <p:style>
+          <a:lnRef idx="1">
+            <a:schemeClr val="accent1"/>
+          </a:lnRef>
+          <a:fillRef idx="3">
+            <a:schemeClr val="accent1"/>
+          </a:fillRef>
+          <a:effectRef idx="2">
+            <a:schemeClr val="accent1"/>
+          </a:effectRef>
+          <a:fontRef idx="minor">
+            <a:schemeClr val="lt1"/>
+          </a:fontRef>
+        </p:style>
+        <p:txBody>
+          <a:bodyPr rtlCol="0" anchor="ctr"/>
+          <a:lstStyle/>
+          <a:p>
+            <a:pPr algn="ctr"/>
+          </a:p>
+        </p:txBody>
+      </p:sp>
+      <p:sp>
+        <p:nvSpPr>
+          <p:cNvPr id="11" name="Rectangle 10"/>
+          <p:cNvSpPr/>
+          <p:nvPr/>
+        </p:nvSpPr>
+        <p:spPr>
+          <a:xfrm>
+            <a:off x="2788920" y="1298448"/>
+            <a:ext cx="109728" cy="5230368"/>
           </a:xfrm>
           <a:prstGeom prst="rect">
             <a:avLst/>
@@ -5466,49 +5832,14 @@
       </p:sp>
       <p:sp>
         <p:nvSpPr>
-          <p:cNvPr id="8" name="TextBox 7"/>
+          <p:cNvPr id="12" name="TextBox 11"/>
           <p:cNvSpPr txBox="1"/>
           <p:nvPr/>
         </p:nvSpPr>
         <p:spPr>
           <a:xfrm>
-            <a:off x="640080" y="1554480"/>
-            <a:ext cx="10972800" cy="731520"/>
-          </a:xfrm>
-          <a:prstGeom prst="rect">
-            <a:avLst/>
-          </a:prstGeom>
-          <a:noFill/>
-        </p:spPr>
-        <p:txBody>
-          <a:bodyPr wrap="square" lIns="0" rIns="0" tIns="0" bIns="0">
-            <a:noAutofit/>
-          </a:bodyPr>
-          <a:lstStyle/>
-          <a:p>
-            <a:pPr algn="l"/>
-            <a:r>
-              <a:rPr sz="2200" b="1" i="0">
-                <a:solidFill>
-                  <a:srgbClr val="224248"/>
-                </a:solidFill>
-                <a:latin typeface="Calibri"/>
-              </a:rPr>
-              <a:t>ICO: no basis APPROPRIATE. Consent INCONCLUSIVE. Match: Partial.</a:t>
-            </a:r>
-          </a:p>
-        </p:txBody>
-      </p:sp>
-      <p:sp>
-        <p:nvSpPr>
-          <p:cNvPr id="9" name="TextBox 8"/>
-          <p:cNvSpPr txBox="1"/>
-          <p:nvPr/>
-        </p:nvSpPr>
-        <p:spPr>
-          <a:xfrm>
-            <a:off x="502920" y="2651760"/>
-            <a:ext cx="11155680" cy="3474720"/>
+            <a:off x="3044952" y="1444752"/>
+            <a:ext cx="8485632" cy="4974336"/>
           </a:xfrm>
           <a:prstGeom prst="rect">
             <a:avLst/>
@@ -5526,17 +5857,17 @@
                 <a:spcPts val="0"/>
               </a:spcBef>
               <a:spcAft>
-                <a:spcPts val="1200"/>
+                <a:spcPts val="200"/>
               </a:spcAft>
             </a:pPr>
             <a:r>
-              <a:rPr sz="2000" b="0" i="0">
-                <a:solidFill>
-                  <a:srgbClr val="1A1A1A"/>
-                </a:solidFill>
-                <a:latin typeface="Calibri"/>
-              </a:rPr>
-              <a:t>•  Purpose: advertising analytics from site activity.</a:t>
+              <a:rPr sz="1000" b="1" i="0">
+                <a:solidFill>
+                  <a:srgbClr val="325E6A"/>
+                </a:solidFill>
+                <a:latin typeface="Calibri"/>
+              </a:rPr>
+              <a:t>Purpose</a:t>
             </a:r>
           </a:p>
           <a:p>
@@ -5545,17 +5876,17 @@
                 <a:spcPts val="0"/>
               </a:spcBef>
               <a:spcAft>
-                <a:spcPts val="1200"/>
+                <a:spcPts val="1000"/>
               </a:spcAft>
             </a:pPr>
             <a:r>
-              <a:rPr sz="2000" b="0" i="0">
-                <a:solidFill>
-                  <a:srgbClr val="1A1A1A"/>
-                </a:solidFill>
-                <a:latin typeface="Calibri"/>
-              </a:rPr>
-              <a:t>•  The notice does not name Article 6. It looks like consent.</a:t>
+              <a:rPr sz="1800" b="1" i="0">
+                <a:solidFill>
+                  <a:srgbClr val="224248"/>
+                </a:solidFill>
+                <a:latin typeface="Calibri"/>
+              </a:rPr>
+              <a:t>Google Signals advertising analytics</a:t>
             </a:r>
           </a:p>
           <a:p>
@@ -5564,17 +5895,17 @@
                 <a:spcPts val="0"/>
               </a:spcBef>
               <a:spcAft>
-                <a:spcPts val="1200"/>
+                <a:spcPts val="200"/>
               </a:spcAft>
             </a:pPr>
             <a:r>
-              <a:rPr sz="2000" b="0" i="0">
-                <a:solidFill>
-                  <a:srgbClr val="1A1A1A"/>
-                </a:solidFill>
-                <a:latin typeface="Calibri"/>
-              </a:rPr>
-              <a:t>•  ICO: the request is not clear, prominent and separate from terms.</a:t>
+              <a:rPr sz="1000" b="1" i="0">
+                <a:solidFill>
+                  <a:srgbClr val="325E6A"/>
+                </a:solidFill>
+                <a:latin typeface="Calibri"/>
+              </a:rPr>
+              <a:t>Notice</a:t>
             </a:r>
           </a:p>
           <a:p>
@@ -5583,24 +5914,100 @@
                 <a:spcPts val="0"/>
               </a:spcBef>
               <a:spcAft>
-                <a:spcPts val="1200"/>
+                <a:spcPts val="1000"/>
               </a:spcAft>
             </a:pPr>
             <a:r>
-              <a:rPr sz="2000" b="0" i="0">
+              <a:rPr sz="1500" b="0" i="0">
                 <a:solidFill>
                   <a:srgbClr val="1A1A1A"/>
                 </a:solidFill>
                 <a:latin typeface="Calibri"/>
               </a:rPr>
-              <a:t>•  The choice sits in Google settings. Pluss terms also bundle the notice.</a:t>
-            </a:r>
-          </a:p>
-        </p:txBody>
-      </p:sp>
-      <p:sp>
-        <p:nvSpPr>
-          <p:cNvPr id="10" name="Rectangle 9"/>
+              <a:t>Article 6 is not named. Collection runs with Google login and ad personalization.</a:t>
+            </a:r>
+          </a:p>
+          <a:p>
+            <a:pPr algn="l">
+              <a:spcBef>
+                <a:spcPts val="0"/>
+              </a:spcBef>
+              <a:spcAft>
+                <a:spcPts val="200"/>
+              </a:spcAft>
+            </a:pPr>
+            <a:r>
+              <a:rPr sz="1000" b="1" i="0">
+                <a:solidFill>
+                  <a:srgbClr val="325E6A"/>
+                </a:solidFill>
+                <a:latin typeface="Calibri"/>
+              </a:rPr>
+              <a:t>ICO result</a:t>
+            </a:r>
+          </a:p>
+          <a:p>
+            <a:pPr algn="l">
+              <a:spcBef>
+                <a:spcPts val="0"/>
+              </a:spcBef>
+              <a:spcAft>
+                <a:spcPts val="1000"/>
+              </a:spcAft>
+            </a:pPr>
+            <a:r>
+              <a:rPr sz="1500" b="0" i="0">
+                <a:solidFill>
+                  <a:srgbClr val="1A1A1A"/>
+                </a:solidFill>
+                <a:latin typeface="Calibri"/>
+              </a:rPr>
+              <a:t>Consent INCONCLUSIVE. No basis APPROPRIATE.</a:t>
+            </a:r>
+          </a:p>
+          <a:p>
+            <a:pPr algn="l">
+              <a:spcBef>
+                <a:spcPts val="0"/>
+              </a:spcBef>
+              <a:spcAft>
+                <a:spcPts val="400"/>
+              </a:spcAft>
+            </a:pPr>
+            <a:r>
+              <a:rPr sz="1500" b="1" i="0">
+                <a:solidFill>
+                  <a:srgbClr val="FF9A00"/>
+                </a:solidFill>
+                <a:latin typeface="Calibri"/>
+              </a:rPr>
+              <a:t>Match: Partial</a:t>
+            </a:r>
+          </a:p>
+          <a:p>
+            <a:pPr algn="l">
+              <a:spcBef>
+                <a:spcPts val="0"/>
+              </a:spcBef>
+              <a:spcAft>
+                <a:spcPts val="0"/>
+              </a:spcAft>
+            </a:pPr>
+            <a:r>
+              <a:rPr sz="1200" b="0" i="0">
+                <a:solidFill>
+                  <a:srgbClr val="4A5568"/>
+                </a:solidFill>
+                <a:latin typeface="Calibri"/>
+              </a:rPr>
+              <a:t>The choice sits in Google settings. Document Pluss terms also bundle the notice.</a:t>
+            </a:r>
+          </a:p>
+        </p:txBody>
+      </p:sp>
+      <p:sp>
+        <p:nvSpPr>
+          <p:cNvPr id="13" name="Rectangle 12"/>
           <p:cNvSpPr/>
           <p:nvPr/>
         </p:nvSpPr>
@@ -5643,7 +6050,7 @@
       </p:sp>
       <p:sp>
         <p:nvSpPr>
-          <p:cNvPr id="11" name="TextBox 10"/>
+          <p:cNvPr id="14" name="TextBox 13"/>
           <p:cNvSpPr txBox="1"/>
           <p:nvPr/>
         </p:nvSpPr>
@@ -5678,7 +6085,7 @@
       </p:sp>
       <p:sp>
         <p:nvSpPr>
-          <p:cNvPr id="12" name="TextBox 11"/>
+          <p:cNvPr id="15" name="TextBox 14"/>
           <p:cNvSpPr txBox="1"/>
           <p:nvPr/>
         </p:nvSpPr>
@@ -5930,14 +6337,159 @@
       </p:sp>
       <p:sp>
         <p:nvSpPr>
-          <p:cNvPr id="7" name="TextBox 6"/>
+          <p:cNvPr id="7" name="Rectangle 6"/>
+          <p:cNvSpPr/>
+          <p:nvPr/>
+        </p:nvSpPr>
+        <p:spPr>
+          <a:xfrm>
+            <a:off x="457200" y="1298448"/>
+            <a:ext cx="2148840" cy="5230368"/>
+          </a:xfrm>
+          <a:prstGeom prst="rect">
+            <a:avLst/>
+          </a:prstGeom>
+          <a:solidFill>
+            <a:srgbClr val="E8F4F4"/>
+          </a:solidFill>
+          <a:ln>
+            <a:noFill/>
+          </a:ln>
+        </p:spPr>
+        <p:style>
+          <a:lnRef idx="1">
+            <a:schemeClr val="accent1"/>
+          </a:lnRef>
+          <a:fillRef idx="3">
+            <a:schemeClr val="accent1"/>
+          </a:fillRef>
+          <a:effectRef idx="2">
+            <a:schemeClr val="accent1"/>
+          </a:effectRef>
+          <a:fontRef idx="minor">
+            <a:schemeClr val="lt1"/>
+          </a:fontRef>
+        </p:style>
+        <p:txBody>
+          <a:bodyPr rtlCol="0" anchor="ctr"/>
+          <a:lstStyle/>
+          <a:p>
+            <a:pPr algn="ctr"/>
+          </a:p>
+        </p:txBody>
+      </p:sp>
+      <p:pic>
+        <p:nvPicPr>
+          <p:cNvPr id="8" name="Picture 7" descr="logo_babyshop_no.png"/>
+          <p:cNvPicPr>
+            <a:picLocks noChangeAspect="1"/>
+          </p:cNvPicPr>
+          <p:nvPr/>
+        </p:nvPicPr>
+        <p:blipFill>
+          <a:blip r:embed="rId2"/>
+          <a:stretch>
+            <a:fillRect/>
+          </a:stretch>
+        </p:blipFill>
+        <p:spPr>
+          <a:xfrm>
+            <a:off x="749808" y="1691640"/>
+            <a:ext cx="1554480" cy="1554480"/>
+          </a:xfrm>
+          <a:prstGeom prst="rect">
+            <a:avLst/>
+          </a:prstGeom>
+        </p:spPr>
+      </p:pic>
+      <p:sp>
+        <p:nvSpPr>
+          <p:cNvPr id="9" name="TextBox 8"/>
           <p:cNvSpPr txBox="1"/>
           <p:nvPr/>
         </p:nvSpPr>
         <p:spPr>
           <a:xfrm>
-            <a:off x="502920" y="1371600"/>
-            <a:ext cx="11155680" cy="5029200"/>
+            <a:off x="502920" y="3429000"/>
+            <a:ext cx="2057400" cy="320040"/>
+          </a:xfrm>
+          <a:prstGeom prst="rect">
+            <a:avLst/>
+          </a:prstGeom>
+          <a:noFill/>
+        </p:spPr>
+        <p:txBody>
+          <a:bodyPr wrap="square" lIns="0" rIns="0" tIns="0" bIns="0">
+            <a:noAutofit/>
+          </a:bodyPr>
+          <a:lstStyle/>
+          <a:p>
+            <a:pPr algn="ctr"/>
+            <a:r>
+              <a:rPr sz="1300" b="1" i="0">
+                <a:solidFill>
+                  <a:srgbClr val="325E6A"/>
+                </a:solidFill>
+                <a:latin typeface="Calibri"/>
+              </a:rPr>
+              <a:t>Shopping</a:t>
+            </a:r>
+          </a:p>
+        </p:txBody>
+      </p:sp>
+      <p:sp>
+        <p:nvSpPr>
+          <p:cNvPr id="10" name="Rectangle 9"/>
+          <p:cNvSpPr/>
+          <p:nvPr/>
+        </p:nvSpPr>
+        <p:spPr>
+          <a:xfrm>
+            <a:off x="2788920" y="1298448"/>
+            <a:ext cx="8942832" cy="5230368"/>
+          </a:xfrm>
+          <a:prstGeom prst="rect">
+            <a:avLst/>
+          </a:prstGeom>
+          <a:solidFill>
+            <a:srgbClr val="44A1A4"/>
+          </a:solidFill>
+          <a:ln>
+            <a:noFill/>
+          </a:ln>
+        </p:spPr>
+        <p:style>
+          <a:lnRef idx="1">
+            <a:schemeClr val="accent1"/>
+          </a:lnRef>
+          <a:fillRef idx="3">
+            <a:schemeClr val="accent1"/>
+          </a:fillRef>
+          <a:effectRef idx="2">
+            <a:schemeClr val="accent1"/>
+          </a:effectRef>
+          <a:fontRef idx="minor">
+            <a:schemeClr val="lt1"/>
+          </a:fontRef>
+        </p:style>
+        <p:txBody>
+          <a:bodyPr rtlCol="0" anchor="ctr"/>
+          <a:lstStyle/>
+          <a:p>
+            <a:pPr algn="ctr"/>
+          </a:p>
+        </p:txBody>
+      </p:sp>
+      <p:sp>
+        <p:nvSpPr>
+          <p:cNvPr id="11" name="TextBox 10"/>
+          <p:cNvSpPr txBox="1"/>
+          <p:nvPr/>
+        </p:nvSpPr>
+        <p:spPr>
+          <a:xfrm>
+            <a:off x="3044952" y="1444752"/>
+            <a:ext cx="8485632" cy="4974336"/>
           </a:xfrm>
           <a:prstGeom prst="rect">
             <a:avLst/>
@@ -5955,17 +6507,17 @@
                 <a:spcPts val="0"/>
               </a:spcBef>
               <a:spcAft>
-                <a:spcPts val="1200"/>
+                <a:spcPts val="200"/>
               </a:spcAft>
             </a:pPr>
             <a:r>
-              <a:rPr sz="2000" b="0" i="0">
-                <a:solidFill>
-                  <a:srgbClr val="1A1A1A"/>
-                </a:solidFill>
-                <a:latin typeface="Calibri"/>
-              </a:rPr>
-              <a:t>Purpose: name, address, contact, order and payment to deliver goods.</a:t>
+              <a:rPr sz="1000" b="1" i="0">
+                <a:solidFill>
+                  <a:srgbClr val="325E6A"/>
+                </a:solidFill>
+                <a:latin typeface="Calibri"/>
+              </a:rPr>
+              <a:t>Purpose</a:t>
             </a:r>
           </a:p>
           <a:p>
@@ -5974,17 +6526,17 @@
                 <a:spcPts val="0"/>
               </a:spcBef>
               <a:spcAft>
-                <a:spcPts val="1200"/>
+                <a:spcPts val="1000"/>
               </a:spcAft>
             </a:pPr>
             <a:r>
-              <a:rPr sz="2000" b="0" i="0">
-                <a:solidFill>
-                  <a:srgbClr val="1A1A1A"/>
-                </a:solidFill>
-                <a:latin typeface="Calibri"/>
-              </a:rPr>
-              <a:t>The sales terms are a purchase contract.</a:t>
+              <a:rPr sz="1800" b="1" i="0">
+                <a:solidFill>
+                  <a:srgbClr val="224248"/>
+                </a:solidFill>
+                <a:latin typeface="Calibri"/>
+              </a:rPr>
+              <a:t>Checkout and order fulfilment</a:t>
             </a:r>
           </a:p>
           <a:p>
@@ -5993,17 +6545,17 @@
                 <a:spcPts val="0"/>
               </a:spcBef>
               <a:spcAft>
-                <a:spcPts val="1200"/>
+                <a:spcPts val="200"/>
               </a:spcAft>
             </a:pPr>
             <a:r>
-              <a:rPr sz="2000" b="0" i="0">
-                <a:solidFill>
-                  <a:srgbClr val="1A1A1A"/>
-                </a:solidFill>
-                <a:latin typeface="Calibri"/>
-              </a:rPr>
-              <a:t>ICO: contract APPROPRIATE. Match: Yes for checkout.</a:t>
+              <a:rPr sz="1000" b="1" i="0">
+                <a:solidFill>
+                  <a:srgbClr val="325E6A"/>
+                </a:solidFill>
+                <a:latin typeface="Calibri"/>
+              </a:rPr>
+              <a:t>Notice</a:t>
             </a:r>
           </a:p>
           <a:p>
@@ -6012,24 +6564,100 @@
                 <a:spcPts val="0"/>
               </a:spcBef>
               <a:spcAft>
-                <a:spcPts val="1200"/>
+                <a:spcPts val="1000"/>
               </a:spcAft>
             </a:pPr>
             <a:r>
-              <a:rPr sz="2000" b="0" i="0">
+              <a:rPr sz="1500" b="0" i="0">
                 <a:solidFill>
                   <a:srgbClr val="1A1A1A"/>
                 </a:solidFill>
                 <a:latin typeface="Calibri"/>
               </a:rPr>
-              <a:t>The notice does not label Article 6(1)(b). Marketing is a separate purpose.</a:t>
-            </a:r>
-          </a:p>
-        </p:txBody>
-      </p:sp>
-      <p:sp>
-        <p:nvSpPr>
-          <p:cNvPr id="8" name="Rectangle 7"/>
+              <a:t>Name, address, contact, order and payment to deliver goods. Sales terms = purchase contract.</a:t>
+            </a:r>
+          </a:p>
+          <a:p>
+            <a:pPr algn="l">
+              <a:spcBef>
+                <a:spcPts val="0"/>
+              </a:spcBef>
+              <a:spcAft>
+                <a:spcPts val="200"/>
+              </a:spcAft>
+            </a:pPr>
+            <a:r>
+              <a:rPr sz="1000" b="1" i="0">
+                <a:solidFill>
+                  <a:srgbClr val="325E6A"/>
+                </a:solidFill>
+                <a:latin typeface="Calibri"/>
+              </a:rPr>
+              <a:t>ICO result</a:t>
+            </a:r>
+          </a:p>
+          <a:p>
+            <a:pPr algn="l">
+              <a:spcBef>
+                <a:spcPts val="0"/>
+              </a:spcBef>
+              <a:spcAft>
+                <a:spcPts val="1000"/>
+              </a:spcAft>
+            </a:pPr>
+            <a:r>
+              <a:rPr sz="1500" b="0" i="0">
+                <a:solidFill>
+                  <a:srgbClr val="1A1A1A"/>
+                </a:solidFill>
+                <a:latin typeface="Calibri"/>
+              </a:rPr>
+              <a:t>Contract APPROPRIATE. Article 6(1)(b) is not labeled in the notice.</a:t>
+            </a:r>
+          </a:p>
+          <a:p>
+            <a:pPr algn="l">
+              <a:spcBef>
+                <a:spcPts val="0"/>
+              </a:spcBef>
+              <a:spcAft>
+                <a:spcPts val="400"/>
+              </a:spcAft>
+            </a:pPr>
+            <a:r>
+              <a:rPr sz="1500" b="1" i="0">
+                <a:solidFill>
+                  <a:srgbClr val="224248"/>
+                </a:solidFill>
+                <a:latin typeface="Calibri"/>
+              </a:rPr>
+              <a:t>Match: Yes</a:t>
+            </a:r>
+          </a:p>
+          <a:p>
+            <a:pPr algn="l">
+              <a:spcBef>
+                <a:spcPts val="0"/>
+              </a:spcBef>
+              <a:spcAft>
+                <a:spcPts val="0"/>
+              </a:spcAft>
+            </a:pPr>
+            <a:r>
+              <a:rPr sz="1200" b="0" i="0">
+                <a:solidFill>
+                  <a:srgbClr val="4A5568"/>
+                </a:solidFill>
+                <a:latin typeface="Calibri"/>
+              </a:rPr>
+              <a:t>Marketing and profiling stay a separate purpose.</a:t>
+            </a:r>
+          </a:p>
+        </p:txBody>
+      </p:sp>
+      <p:sp>
+        <p:nvSpPr>
+          <p:cNvPr id="12" name="Rectangle 11"/>
           <p:cNvSpPr/>
           <p:nvPr/>
         </p:nvSpPr>
@@ -6072,7 +6700,7 @@
       </p:sp>
       <p:sp>
         <p:nvSpPr>
-          <p:cNvPr id="9" name="TextBox 8"/>
+          <p:cNvPr id="13" name="TextBox 12"/>
           <p:cNvSpPr txBox="1"/>
           <p:nvPr/>
         </p:nvSpPr>
@@ -6107,7 +6735,7 @@
       </p:sp>
       <p:sp>
         <p:nvSpPr>
-          <p:cNvPr id="10" name="TextBox 9"/>
+          <p:cNvPr id="14" name="TextBox 13"/>
           <p:cNvSpPr txBox="1"/>
           <p:nvPr/>
         </p:nvSpPr>
@@ -13392,14 +14020,159 @@
       </p:sp>
       <p:sp>
         <p:nvSpPr>
-          <p:cNvPr id="7" name="TextBox 6"/>
+          <p:cNvPr id="7" name="Rectangle 6"/>
+          <p:cNvSpPr/>
+          <p:nvPr/>
+        </p:nvSpPr>
+        <p:spPr>
+          <a:xfrm>
+            <a:off x="457200" y="1298448"/>
+            <a:ext cx="2148840" cy="5230368"/>
+          </a:xfrm>
+          <a:prstGeom prst="rect">
+            <a:avLst/>
+          </a:prstGeom>
+          <a:solidFill>
+            <a:srgbClr val="E8F4F4"/>
+          </a:solidFill>
+          <a:ln>
+            <a:noFill/>
+          </a:ln>
+        </p:spPr>
+        <p:style>
+          <a:lnRef idx="1">
+            <a:schemeClr val="accent1"/>
+          </a:lnRef>
+          <a:fillRef idx="3">
+            <a:schemeClr val="accent1"/>
+          </a:fillRef>
+          <a:effectRef idx="2">
+            <a:schemeClr val="accent1"/>
+          </a:effectRef>
+          <a:fontRef idx="minor">
+            <a:schemeClr val="lt1"/>
+          </a:fontRef>
+        </p:style>
+        <p:txBody>
+          <a:bodyPr rtlCol="0" anchor="ctr"/>
+          <a:lstStyle/>
+          <a:p>
+            <a:pPr algn="ctr"/>
+          </a:p>
+        </p:txBody>
+      </p:sp>
+      <p:pic>
+        <p:nvPicPr>
+          <p:cNvPr id="8" name="Picture 7" descr="logo_skatteetaten_no.png"/>
+          <p:cNvPicPr>
+            <a:picLocks noChangeAspect="1"/>
+          </p:cNvPicPr>
+          <p:nvPr/>
+        </p:nvPicPr>
+        <p:blipFill>
+          <a:blip r:embed="rId2"/>
+          <a:stretch>
+            <a:fillRect/>
+          </a:stretch>
+        </p:blipFill>
+        <p:spPr>
+          <a:xfrm>
+            <a:off x="749808" y="1691640"/>
+            <a:ext cx="1554480" cy="1554480"/>
+          </a:xfrm>
+          <a:prstGeom prst="rect">
+            <a:avLst/>
+          </a:prstGeom>
+        </p:spPr>
+      </p:pic>
+      <p:sp>
+        <p:nvSpPr>
+          <p:cNvPr id="9" name="TextBox 8"/>
           <p:cNvSpPr txBox="1"/>
           <p:nvPr/>
         </p:nvSpPr>
         <p:spPr>
           <a:xfrm>
-            <a:off x="502920" y="1371600"/>
-            <a:ext cx="11155680" cy="5029200"/>
+            <a:off x="502920" y="3429000"/>
+            <a:ext cx="2057400" cy="320040"/>
+          </a:xfrm>
+          <a:prstGeom prst="rect">
+            <a:avLst/>
+          </a:prstGeom>
+          <a:noFill/>
+        </p:spPr>
+        <p:txBody>
+          <a:bodyPr wrap="square" lIns="0" rIns="0" tIns="0" bIns="0">
+            <a:noAutofit/>
+          </a:bodyPr>
+          <a:lstStyle/>
+          <a:p>
+            <a:pPr algn="ctr"/>
+            <a:r>
+              <a:rPr sz="1300" b="1" i="0">
+                <a:solidFill>
+                  <a:srgbClr val="325E6A"/>
+                </a:solidFill>
+                <a:latin typeface="Calibri"/>
+              </a:rPr>
+              <a:t>Government</a:t>
+            </a:r>
+          </a:p>
+        </p:txBody>
+      </p:sp>
+      <p:sp>
+        <p:nvSpPr>
+          <p:cNvPr id="10" name="Rectangle 9"/>
+          <p:cNvSpPr/>
+          <p:nvPr/>
+        </p:nvSpPr>
+        <p:spPr>
+          <a:xfrm>
+            <a:off x="2788920" y="1298448"/>
+            <a:ext cx="8942832" cy="2487168"/>
+          </a:xfrm>
+          <a:prstGeom prst="rect">
+            <a:avLst/>
+          </a:prstGeom>
+          <a:solidFill>
+            <a:srgbClr val="44A1A4"/>
+          </a:solidFill>
+          <a:ln>
+            <a:noFill/>
+          </a:ln>
+        </p:spPr>
+        <p:style>
+          <a:lnRef idx="1">
+            <a:schemeClr val="accent1"/>
+          </a:lnRef>
+          <a:fillRef idx="3">
+            <a:schemeClr val="accent1"/>
+          </a:fillRef>
+          <a:effectRef idx="2">
+            <a:schemeClr val="accent1"/>
+          </a:effectRef>
+          <a:fontRef idx="minor">
+            <a:schemeClr val="lt1"/>
+          </a:fontRef>
+        </p:style>
+        <p:txBody>
+          <a:bodyPr rtlCol="0" anchor="ctr"/>
+          <a:lstStyle/>
+          <a:p>
+            <a:pPr algn="ctr"/>
+          </a:p>
+        </p:txBody>
+      </p:sp>
+      <p:sp>
+        <p:nvSpPr>
+          <p:cNvPr id="11" name="TextBox 10"/>
+          <p:cNvSpPr txBox="1"/>
+          <p:nvPr/>
+        </p:nvSpPr>
+        <p:spPr>
+          <a:xfrm>
+            <a:off x="3044952" y="1444752"/>
+            <a:ext cx="8485632" cy="2231136"/>
           </a:xfrm>
           <a:prstGeom prst="rect">
             <a:avLst/>
@@ -13417,17 +14190,17 @@
                 <a:spcPts val="0"/>
               </a:spcBef>
               <a:spcAft>
-                <a:spcPts val="1200"/>
+                <a:spcPts val="200"/>
               </a:spcAft>
             </a:pPr>
             <a:r>
-              <a:rPr sz="2000" b="0" i="0">
-                <a:solidFill>
-                  <a:srgbClr val="1A1A1A"/>
-                </a:solidFill>
-                <a:latin typeface="Calibri"/>
-              </a:rPr>
-              <a:t>Tax and registry data: the law requires it. Opt-out is generally not possible.</a:t>
+              <a:rPr sz="1000" b="1" i="0">
+                <a:solidFill>
+                  <a:srgbClr val="325E6A"/>
+                </a:solidFill>
+                <a:latin typeface="Calibri"/>
+              </a:rPr>
+              <a:t>Purpose</a:t>
             </a:r>
           </a:p>
           <a:p>
@@ -13436,17 +14209,17 @@
                 <a:spcPts val="0"/>
               </a:spcBef>
               <a:spcAft>
-                <a:spcPts val="1200"/>
+                <a:spcPts val="800"/>
               </a:spcAft>
             </a:pPr>
             <a:r>
-              <a:rPr sz="2000" b="0" i="0">
-                <a:solidFill>
-                  <a:srgbClr val="1A1A1A"/>
-                </a:solidFill>
-                <a:latin typeface="Calibri"/>
-              </a:rPr>
-              <a:t>ICO: legal obligation and public task APPROPRIATE. Consent NOT APPROPRIATE. Match: Yes.</a:t>
+              <a:rPr sz="1600" b="1" i="0">
+                <a:solidFill>
+                  <a:srgbClr val="224248"/>
+                </a:solidFill>
+                <a:latin typeface="Calibri"/>
+              </a:rPr>
+              <a:t>Tax and National Population Register data</a:t>
             </a:r>
           </a:p>
           <a:p>
@@ -13455,17 +14228,17 @@
                 <a:spcPts val="0"/>
               </a:spcBef>
               <a:spcAft>
-                <a:spcPts val="1200"/>
+                <a:spcPts val="200"/>
               </a:spcAft>
             </a:pPr>
             <a:r>
-              <a:rPr sz="2000" b="0" i="0">
-                <a:solidFill>
-                  <a:srgbClr val="1A1A1A"/>
-                </a:solidFill>
-                <a:latin typeface="Calibri"/>
-              </a:rPr>
-              <a:t>Optional statistics cookies: the notice claims consent.</a:t>
+              <a:rPr sz="1000" b="1" i="0">
+                <a:solidFill>
+                  <a:srgbClr val="325E6A"/>
+                </a:solidFill>
+                <a:latin typeface="Calibri"/>
+              </a:rPr>
+              <a:t>Notice</a:t>
             </a:r>
           </a:p>
           <a:p>
@@ -13474,24 +14247,323 @@
                 <a:spcPts val="0"/>
               </a:spcBef>
               <a:spcAft>
-                <a:spcPts val="1200"/>
+                <a:spcPts val="800"/>
               </a:spcAft>
             </a:pPr>
             <a:r>
-              <a:rPr sz="2000" b="0" i="0">
+              <a:rPr sz="1400" b="0" i="0">
                 <a:solidFill>
                   <a:srgbClr val="1A1A1A"/>
                 </a:solidFill>
                 <a:latin typeface="Calibri"/>
               </a:rPr>
-              <a:t>ICO: consent INCONCLUSIVE; no basis APPROPRIATE. Match: Partial.</a:t>
-            </a:r>
-          </a:p>
-        </p:txBody>
-      </p:sp>
-      <p:sp>
-        <p:nvSpPr>
-          <p:cNvPr id="8" name="Rectangle 7"/>
+              <a:t>The law requires this processing. Opt-out is generally not possible.</a:t>
+            </a:r>
+          </a:p>
+          <a:p>
+            <a:pPr algn="l">
+              <a:spcBef>
+                <a:spcPts val="0"/>
+              </a:spcBef>
+              <a:spcAft>
+                <a:spcPts val="200"/>
+              </a:spcAft>
+            </a:pPr>
+            <a:r>
+              <a:rPr sz="1000" b="1" i="0">
+                <a:solidFill>
+                  <a:srgbClr val="325E6A"/>
+                </a:solidFill>
+                <a:latin typeface="Calibri"/>
+              </a:rPr>
+              <a:t>ICO result</a:t>
+            </a:r>
+          </a:p>
+          <a:p>
+            <a:pPr algn="l">
+              <a:spcBef>
+                <a:spcPts val="0"/>
+              </a:spcBef>
+              <a:spcAft>
+                <a:spcPts val="800"/>
+              </a:spcAft>
+            </a:pPr>
+            <a:r>
+              <a:rPr sz="1400" b="0" i="0">
+                <a:solidFill>
+                  <a:srgbClr val="1A1A1A"/>
+                </a:solidFill>
+                <a:latin typeface="Calibri"/>
+              </a:rPr>
+              <a:t>Legal obligation and public task APPROPRIATE. Consent NOT APPROPRIATE.</a:t>
+            </a:r>
+          </a:p>
+          <a:p>
+            <a:pPr algn="l">
+              <a:spcBef>
+                <a:spcPts val="0"/>
+              </a:spcBef>
+              <a:spcAft>
+                <a:spcPts val="400"/>
+              </a:spcAft>
+            </a:pPr>
+            <a:r>
+              <a:rPr sz="1500" b="1" i="0">
+                <a:solidFill>
+                  <a:srgbClr val="224248"/>
+                </a:solidFill>
+                <a:latin typeface="Calibri"/>
+              </a:rPr>
+              <a:t>Match: Yes</a:t>
+            </a:r>
+          </a:p>
+        </p:txBody>
+      </p:sp>
+      <p:sp>
+        <p:nvSpPr>
+          <p:cNvPr id="12" name="Rectangle 11"/>
+          <p:cNvSpPr/>
+          <p:nvPr/>
+        </p:nvSpPr>
+        <p:spPr>
+          <a:xfrm>
+            <a:off x="2788920" y="4041648"/>
+            <a:ext cx="8942832" cy="2487168"/>
+          </a:xfrm>
+          <a:prstGeom prst="rect">
+            <a:avLst/>
+          </a:prstGeom>
+          <a:solidFill>
+            <a:srgbClr val="E8F4F4"/>
+          </a:solidFill>
+          <a:ln>
+            <a:noFill/>
+          </a:ln>
+        </p:spPr>
+        <p:style>
+          <a:lnRef idx="1">
+            <a:schemeClr val="accent1"/>
+          </a:lnRef>
+          <a:fillRef idx="3">
+            <a:schemeClr val="accent1"/>
+          </a:fillRef>
+          <a:effectRef idx="2">
+            <a:schemeClr val="accent1"/>
+          </a:effectRef>
+          <a:fontRef idx="minor">
+            <a:schemeClr val="lt1"/>
+          </a:fontRef>
+        </p:style>
+        <p:txBody>
+          <a:bodyPr rtlCol="0" anchor="ctr"/>
+          <a:lstStyle/>
+          <a:p>
+            <a:pPr algn="ctr"/>
+          </a:p>
+        </p:txBody>
+      </p:sp>
+      <p:sp>
+        <p:nvSpPr>
+          <p:cNvPr id="13" name="Rectangle 12"/>
+          <p:cNvSpPr/>
+          <p:nvPr/>
+        </p:nvSpPr>
+        <p:spPr>
+          <a:xfrm>
+            <a:off x="2788920" y="4041648"/>
+            <a:ext cx="109728" cy="2487168"/>
+          </a:xfrm>
+          <a:prstGeom prst="rect">
+            <a:avLst/>
+          </a:prstGeom>
+          <a:solidFill>
+            <a:srgbClr val="FF9A00"/>
+          </a:solidFill>
+          <a:ln>
+            <a:noFill/>
+          </a:ln>
+        </p:spPr>
+        <p:style>
+          <a:lnRef idx="1">
+            <a:schemeClr val="accent1"/>
+          </a:lnRef>
+          <a:fillRef idx="3">
+            <a:schemeClr val="accent1"/>
+          </a:fillRef>
+          <a:effectRef idx="2">
+            <a:schemeClr val="accent1"/>
+          </a:effectRef>
+          <a:fontRef idx="minor">
+            <a:schemeClr val="lt1"/>
+          </a:fontRef>
+        </p:style>
+        <p:txBody>
+          <a:bodyPr rtlCol="0" anchor="ctr"/>
+          <a:lstStyle/>
+          <a:p>
+            <a:pPr algn="ctr"/>
+          </a:p>
+        </p:txBody>
+      </p:sp>
+      <p:sp>
+        <p:nvSpPr>
+          <p:cNvPr id="14" name="TextBox 13"/>
+          <p:cNvSpPr txBox="1"/>
+          <p:nvPr/>
+        </p:nvSpPr>
+        <p:spPr>
+          <a:xfrm>
+            <a:off x="3044952" y="4187952"/>
+            <a:ext cx="8485632" cy="2231136"/>
+          </a:xfrm>
+          <a:prstGeom prst="rect">
+            <a:avLst/>
+          </a:prstGeom>
+          <a:noFill/>
+        </p:spPr>
+        <p:txBody>
+          <a:bodyPr wrap="square" lIns="0" rIns="0" tIns="0" bIns="0">
+            <a:noAutofit/>
+          </a:bodyPr>
+          <a:lstStyle/>
+          <a:p>
+            <a:pPr algn="l">
+              <a:spcBef>
+                <a:spcPts val="0"/>
+              </a:spcBef>
+              <a:spcAft>
+                <a:spcPts val="200"/>
+              </a:spcAft>
+            </a:pPr>
+            <a:r>
+              <a:rPr sz="1000" b="1" i="0">
+                <a:solidFill>
+                  <a:srgbClr val="325E6A"/>
+                </a:solidFill>
+                <a:latin typeface="Calibri"/>
+              </a:rPr>
+              <a:t>Purpose</a:t>
+            </a:r>
+          </a:p>
+          <a:p>
+            <a:pPr algn="l">
+              <a:spcBef>
+                <a:spcPts val="0"/>
+              </a:spcBef>
+              <a:spcAft>
+                <a:spcPts val="800"/>
+              </a:spcAft>
+            </a:pPr>
+            <a:r>
+              <a:rPr sz="1600" b="1" i="0">
+                <a:solidFill>
+                  <a:srgbClr val="224248"/>
+                </a:solidFill>
+                <a:latin typeface="Calibri"/>
+              </a:rPr>
+              <a:t>Optional statistics cookies</a:t>
+            </a:r>
+          </a:p>
+          <a:p>
+            <a:pPr algn="l">
+              <a:spcBef>
+                <a:spcPts val="0"/>
+              </a:spcBef>
+              <a:spcAft>
+                <a:spcPts val="200"/>
+              </a:spcAft>
+            </a:pPr>
+            <a:r>
+              <a:rPr sz="1000" b="1" i="0">
+                <a:solidFill>
+                  <a:srgbClr val="325E6A"/>
+                </a:solidFill>
+                <a:latin typeface="Calibri"/>
+              </a:rPr>
+              <a:t>Notice</a:t>
+            </a:r>
+          </a:p>
+          <a:p>
+            <a:pPr algn="l">
+              <a:spcBef>
+                <a:spcPts val="0"/>
+              </a:spcBef>
+              <a:spcAft>
+                <a:spcPts val="800"/>
+              </a:spcAft>
+            </a:pPr>
+            <a:r>
+              <a:rPr sz="1400" b="0" i="0">
+                <a:solidFill>
+                  <a:srgbClr val="1A1A1A"/>
+                </a:solidFill>
+                <a:latin typeface="Calibri"/>
+              </a:rPr>
+              <a:t>Skyra, Matomo, Google Analytics and Siteimprove. The notice claims consent.</a:t>
+            </a:r>
+          </a:p>
+          <a:p>
+            <a:pPr algn="l">
+              <a:spcBef>
+                <a:spcPts val="0"/>
+              </a:spcBef>
+              <a:spcAft>
+                <a:spcPts val="200"/>
+              </a:spcAft>
+            </a:pPr>
+            <a:r>
+              <a:rPr sz="1000" b="1" i="0">
+                <a:solidFill>
+                  <a:srgbClr val="325E6A"/>
+                </a:solidFill>
+                <a:latin typeface="Calibri"/>
+              </a:rPr>
+              <a:t>ICO result</a:t>
+            </a:r>
+          </a:p>
+          <a:p>
+            <a:pPr algn="l">
+              <a:spcBef>
+                <a:spcPts val="0"/>
+              </a:spcBef>
+              <a:spcAft>
+                <a:spcPts val="800"/>
+              </a:spcAft>
+            </a:pPr>
+            <a:r>
+              <a:rPr sz="1400" b="0" i="0">
+                <a:solidFill>
+                  <a:srgbClr val="1A1A1A"/>
+                </a:solidFill>
+                <a:latin typeface="Calibri"/>
+              </a:rPr>
+              <a:t>Consent INCONCLUSIVE. No basis APPROPRIATE.</a:t>
+            </a:r>
+          </a:p>
+          <a:p>
+            <a:pPr algn="l">
+              <a:spcBef>
+                <a:spcPts val="0"/>
+              </a:spcBef>
+              <a:spcAft>
+                <a:spcPts val="400"/>
+              </a:spcAft>
+            </a:pPr>
+            <a:r>
+              <a:rPr sz="1500" b="1" i="0">
+                <a:solidFill>
+                  <a:srgbClr val="FF9A00"/>
+                </a:solidFill>
+                <a:latin typeface="Calibri"/>
+              </a:rPr>
+              <a:t>Match: Partial</a:t>
+            </a:r>
+          </a:p>
+        </p:txBody>
+      </p:sp>
+      <p:sp>
+        <p:nvSpPr>
+          <p:cNvPr id="15" name="Rectangle 14"/>
           <p:cNvSpPr/>
           <p:nvPr/>
         </p:nvSpPr>
@@ -13534,7 +14606,7 @@
       </p:sp>
       <p:sp>
         <p:nvSpPr>
-          <p:cNvPr id="9" name="TextBox 8"/>
+          <p:cNvPr id="16" name="TextBox 15"/>
           <p:cNvSpPr txBox="1"/>
           <p:nvPr/>
         </p:nvSpPr>
@@ -13569,7 +14641,7 @@
       </p:sp>
       <p:sp>
         <p:nvSpPr>
-          <p:cNvPr id="10" name="TextBox 9"/>
+          <p:cNvPr id="17" name="TextBox 16"/>
           <p:cNvSpPr txBox="1"/>
           <p:nvPr/>
         </p:nvSpPr>
@@ -13821,14 +14893,159 @@
       </p:sp>
       <p:sp>
         <p:nvSpPr>
-          <p:cNvPr id="7" name="TextBox 6"/>
+          <p:cNvPr id="7" name="Rectangle 6"/>
+          <p:cNvSpPr/>
+          <p:nvPr/>
+        </p:nvSpPr>
+        <p:spPr>
+          <a:xfrm>
+            <a:off x="457200" y="1298448"/>
+            <a:ext cx="2148840" cy="5230368"/>
+          </a:xfrm>
+          <a:prstGeom prst="rect">
+            <a:avLst/>
+          </a:prstGeom>
+          <a:solidFill>
+            <a:srgbClr val="E8F4F4"/>
+          </a:solidFill>
+          <a:ln>
+            <a:noFill/>
+          </a:ln>
+        </p:spPr>
+        <p:style>
+          <a:lnRef idx="1">
+            <a:schemeClr val="accent1"/>
+          </a:lnRef>
+          <a:fillRef idx="3">
+            <a:schemeClr val="accent1"/>
+          </a:fillRef>
+          <a:effectRef idx="2">
+            <a:schemeClr val="accent1"/>
+          </a:effectRef>
+          <a:fontRef idx="minor">
+            <a:schemeClr val="lt1"/>
+          </a:fontRef>
+        </p:style>
+        <p:txBody>
+          <a:bodyPr rtlCol="0" anchor="ctr"/>
+          <a:lstStyle/>
+          <a:p>
+            <a:pPr algn="ctr"/>
+          </a:p>
+        </p:txBody>
+      </p:sp>
+      <p:pic>
+        <p:nvPicPr>
+          <p:cNvPr id="8" name="Picture 7" descr="logo_netflix_com.png"/>
+          <p:cNvPicPr>
+            <a:picLocks noChangeAspect="1"/>
+          </p:cNvPicPr>
+          <p:nvPr/>
+        </p:nvPicPr>
+        <p:blipFill>
+          <a:blip r:embed="rId2"/>
+          <a:stretch>
+            <a:fillRect/>
+          </a:stretch>
+        </p:blipFill>
+        <p:spPr>
+          <a:xfrm>
+            <a:off x="749808" y="1691640"/>
+            <a:ext cx="1554480" cy="1554480"/>
+          </a:xfrm>
+          <a:prstGeom prst="rect">
+            <a:avLst/>
+          </a:prstGeom>
+        </p:spPr>
+      </p:pic>
+      <p:sp>
+        <p:nvSpPr>
+          <p:cNvPr id="9" name="TextBox 8"/>
           <p:cNvSpPr txBox="1"/>
           <p:nvPr/>
         </p:nvSpPr>
         <p:spPr>
           <a:xfrm>
-            <a:off x="502920" y="1371600"/>
-            <a:ext cx="11155680" cy="5029200"/>
+            <a:off x="502920" y="3429000"/>
+            <a:ext cx="2057400" cy="320040"/>
+          </a:xfrm>
+          <a:prstGeom prst="rect">
+            <a:avLst/>
+          </a:prstGeom>
+          <a:noFill/>
+        </p:spPr>
+        <p:txBody>
+          <a:bodyPr wrap="square" lIns="0" rIns="0" tIns="0" bIns="0">
+            <a:noAutofit/>
+          </a:bodyPr>
+          <a:lstStyle/>
+          <a:p>
+            <a:pPr algn="ctr"/>
+            <a:r>
+              <a:rPr sz="1300" b="1" i="0">
+                <a:solidFill>
+                  <a:srgbClr val="325E6A"/>
+                </a:solidFill>
+                <a:latin typeface="Calibri"/>
+              </a:rPr>
+              <a:t>News / media</a:t>
+            </a:r>
+          </a:p>
+        </p:txBody>
+      </p:sp>
+      <p:sp>
+        <p:nvSpPr>
+          <p:cNvPr id="10" name="Rectangle 9"/>
+          <p:cNvSpPr/>
+          <p:nvPr/>
+        </p:nvSpPr>
+        <p:spPr>
+          <a:xfrm>
+            <a:off x="2788920" y="1298448"/>
+            <a:ext cx="8942832" cy="5230368"/>
+          </a:xfrm>
+          <a:prstGeom prst="rect">
+            <a:avLst/>
+          </a:prstGeom>
+          <a:solidFill>
+            <a:srgbClr val="44A1A4"/>
+          </a:solidFill>
+          <a:ln>
+            <a:noFill/>
+          </a:ln>
+        </p:spPr>
+        <p:style>
+          <a:lnRef idx="1">
+            <a:schemeClr val="accent1"/>
+          </a:lnRef>
+          <a:fillRef idx="3">
+            <a:schemeClr val="accent1"/>
+          </a:fillRef>
+          <a:effectRef idx="2">
+            <a:schemeClr val="accent1"/>
+          </a:effectRef>
+          <a:fontRef idx="minor">
+            <a:schemeClr val="lt1"/>
+          </a:fontRef>
+        </p:style>
+        <p:txBody>
+          <a:bodyPr rtlCol="0" anchor="ctr"/>
+          <a:lstStyle/>
+          <a:p>
+            <a:pPr algn="ctr"/>
+          </a:p>
+        </p:txBody>
+      </p:sp>
+      <p:sp>
+        <p:nvSpPr>
+          <p:cNvPr id="11" name="TextBox 10"/>
+          <p:cNvSpPr txBox="1"/>
+          <p:nvPr/>
+        </p:nvSpPr>
+        <p:spPr>
+          <a:xfrm>
+            <a:off x="3044952" y="1444752"/>
+            <a:ext cx="8485632" cy="4974336"/>
           </a:xfrm>
           <a:prstGeom prst="rect">
             <a:avLst/>
@@ -13846,17 +15063,17 @@
                 <a:spcPts val="0"/>
               </a:spcBef>
               <a:spcAft>
-                <a:spcPts val="1200"/>
+                <a:spcPts val="200"/>
               </a:spcAft>
             </a:pPr>
             <a:r>
-              <a:rPr sz="2000" b="0" i="0">
-                <a:solidFill>
-                  <a:srgbClr val="1A1A1A"/>
-                </a:solidFill>
-                <a:latin typeface="Calibri"/>
-              </a:rPr>
-              <a:t>Purpose: account and payment data needed to provide the paid service.</a:t>
+              <a:rPr sz="1000" b="1" i="0">
+                <a:solidFill>
+                  <a:srgbClr val="325E6A"/>
+                </a:solidFill>
+                <a:latin typeface="Calibri"/>
+              </a:rPr>
+              <a:t>Purpose</a:t>
             </a:r>
           </a:p>
           <a:p>
@@ -13865,17 +15082,17 @@
                 <a:spcPts val="0"/>
               </a:spcBef>
               <a:spcAft>
-                <a:spcPts val="1200"/>
+                <a:spcPts val="1000"/>
               </a:spcAft>
             </a:pPr>
             <a:r>
-              <a:rPr sz="2000" b="0" i="0">
-                <a:solidFill>
-                  <a:srgbClr val="1A1A1A"/>
-                </a:solidFill>
-                <a:latin typeface="Calibri"/>
-              </a:rPr>
-              <a:t>Notice (EEA/UK): contractual necessity.</a:t>
+              <a:rPr sz="1800" b="1" i="0">
+                <a:solidFill>
+                  <a:srgbClr val="224248"/>
+                </a:solidFill>
+                <a:latin typeface="Calibri"/>
+              </a:rPr>
+              <a:t>Account and payment data for the paid subscription</a:t>
             </a:r>
           </a:p>
           <a:p>
@@ -13884,17 +15101,17 @@
                 <a:spcPts val="0"/>
               </a:spcBef>
               <a:spcAft>
-                <a:spcPts val="1200"/>
+                <a:spcPts val="200"/>
               </a:spcAft>
             </a:pPr>
             <a:r>
-              <a:rPr sz="2000" b="0" i="0">
-                <a:solidFill>
-                  <a:srgbClr val="1A1A1A"/>
-                </a:solidFill>
-                <a:latin typeface="Calibri"/>
-              </a:rPr>
-              <a:t>ICO: contract APPROPRIATE. Consent marked likely invalid for this purpose.</a:t>
+              <a:rPr sz="1000" b="1" i="0">
+                <a:solidFill>
+                  <a:srgbClr val="325E6A"/>
+                </a:solidFill>
+                <a:latin typeface="Calibri"/>
+              </a:rPr>
+              <a:t>Notice</a:t>
             </a:r>
           </a:p>
           <a:p>
@@ -13903,24 +15120,81 @@
                 <a:spcPts val="0"/>
               </a:spcBef>
               <a:spcAft>
-                <a:spcPts val="1200"/>
+                <a:spcPts val="1000"/>
               </a:spcAft>
             </a:pPr>
             <a:r>
-              <a:rPr sz="2000" b="0" i="0">
+              <a:rPr sz="1500" b="0" i="0">
                 <a:solidFill>
                   <a:srgbClr val="1A1A1A"/>
                 </a:solidFill>
                 <a:latin typeface="Calibri"/>
               </a:rPr>
-              <a:t>Ads and marketing in the same notice were left out.</a:t>
-            </a:r>
-          </a:p>
-        </p:txBody>
-      </p:sp>
-      <p:sp>
-        <p:nvSpPr>
-          <p:cNvPr id="8" name="Rectangle 7"/>
+              <a:t>EEA/UK privacy statement: contractual necessity to provide the service.</a:t>
+            </a:r>
+          </a:p>
+          <a:p>
+            <a:pPr algn="l">
+              <a:spcBef>
+                <a:spcPts val="0"/>
+              </a:spcBef>
+              <a:spcAft>
+                <a:spcPts val="200"/>
+              </a:spcAft>
+            </a:pPr>
+            <a:r>
+              <a:rPr sz="1000" b="1" i="0">
+                <a:solidFill>
+                  <a:srgbClr val="325E6A"/>
+                </a:solidFill>
+                <a:latin typeface="Calibri"/>
+              </a:rPr>
+              <a:t>ICO result</a:t>
+            </a:r>
+          </a:p>
+          <a:p>
+            <a:pPr algn="l">
+              <a:spcBef>
+                <a:spcPts val="0"/>
+              </a:spcBef>
+              <a:spcAft>
+                <a:spcPts val="1000"/>
+              </a:spcAft>
+            </a:pPr>
+            <a:r>
+              <a:rPr sz="1500" b="0" i="0">
+                <a:solidFill>
+                  <a:srgbClr val="1A1A1A"/>
+                </a:solidFill>
+                <a:latin typeface="Calibri"/>
+              </a:rPr>
+              <a:t>Contract APPROPRIATE. Consent marked likely invalid for this purpose.</a:t>
+            </a:r>
+          </a:p>
+          <a:p>
+            <a:pPr algn="l">
+              <a:spcBef>
+                <a:spcPts val="0"/>
+              </a:spcBef>
+              <a:spcAft>
+                <a:spcPts val="400"/>
+              </a:spcAft>
+            </a:pPr>
+            <a:r>
+              <a:rPr sz="1500" b="1" i="0">
+                <a:solidFill>
+                  <a:srgbClr val="224248"/>
+                </a:solidFill>
+                <a:latin typeface="Calibri"/>
+              </a:rPr>
+              <a:t>Match: Yes</a:t>
+            </a:r>
+          </a:p>
+        </p:txBody>
+      </p:sp>
+      <p:sp>
+        <p:nvSpPr>
+          <p:cNvPr id="12" name="Rectangle 11"/>
           <p:cNvSpPr/>
           <p:nvPr/>
         </p:nvSpPr>
@@ -13963,7 +15237,7 @@
       </p:sp>
       <p:sp>
         <p:nvSpPr>
-          <p:cNvPr id="9" name="TextBox 8"/>
+          <p:cNvPr id="13" name="TextBox 12"/>
           <p:cNvSpPr txBox="1"/>
           <p:nvPr/>
         </p:nvSpPr>
@@ -13998,7 +15272,7 @@
       </p:sp>
       <p:sp>
         <p:nvSpPr>
-          <p:cNvPr id="10" name="TextBox 9"/>
+          <p:cNvPr id="14" name="TextBox 13"/>
           <p:cNvSpPr txBox="1"/>
           <p:nvPr/>
         </p:nvSpPr>

</xml_diff>

<commit_message>
Svart bold tekst pa avslutningsslide 13
Erstatt mork gronn og oransje med svart fet skrift i oppsummeringsboksen.

Co-authored-by: Karina <kasa031@users.noreply.github.com>
</commit_message>
<xml_diff>
--- a/ACIT4280_1A_presentation.pptx
+++ b/ACIT4280_1A_presentation.pptx
@@ -7059,9 +7059,9 @@
               </a:spcAft>
             </a:pPr>
             <a:r>
-              <a:rPr sz="2200" b="0" i="0">
-                <a:solidFill>
-                  <a:srgbClr val="224248"/>
+              <a:rPr sz="2200" b="1" i="0">
+                <a:solidFill>
+                  <a:srgbClr val="1A1A1A"/>
                 </a:solidFill>
                 <a:latin typeface="Calibri"/>
               </a:rPr>
@@ -7078,9 +7078,9 @@
               </a:spcAft>
             </a:pPr>
             <a:r>
-              <a:rPr sz="2200" b="0" i="0">
-                <a:solidFill>
-                  <a:srgbClr val="224248"/>
+              <a:rPr sz="2200" b="1" i="0">
+                <a:solidFill>
+                  <a:srgbClr val="1A1A1A"/>
                 </a:solidFill>
                 <a:latin typeface="Calibri"/>
               </a:rPr>
@@ -7097,9 +7097,9 @@
               </a:spcAft>
             </a:pPr>
             <a:r>
-              <a:rPr sz="2200" b="0" i="0">
-                <a:solidFill>
-                  <a:srgbClr val="224248"/>
+              <a:rPr sz="2200" b="1" i="0">
+                <a:solidFill>
+                  <a:srgbClr val="1A1A1A"/>
                 </a:solidFill>
                 <a:latin typeface="Calibri"/>
               </a:rPr>
@@ -7116,9 +7116,9 @@
               </a:spcAft>
             </a:pPr>
             <a:r>
-              <a:rPr sz="2200" b="0" i="0">
-                <a:solidFill>
-                  <a:srgbClr val="FF9A00"/>
+              <a:rPr sz="2200" b="1" i="0">
+                <a:solidFill>
+                  <a:srgbClr val="1A1A1A"/>
                 </a:solidFill>
                 <a:latin typeface="Calibri"/>
               </a:rPr>

</xml_diff>

<commit_message>
Legg til ICO-logo pa slide 2, aligned med Webbkoll-bilde
ICO-logo under Part 2-teksten, samme hoyde og bredde som Webbkoll-screenshot.

Co-authored-by: Karina <kasa031@users.noreply.github.com>
</commit_message>
<xml_diff>
--- a/ACIT4280_1A_presentation.pptx
+++ b/ACIT4280_1A_presentation.pptx
@@ -7675,7 +7675,7 @@
         <p:spPr>
           <a:xfrm>
             <a:off x="685800" y="1901952"/>
-            <a:ext cx="4937760" cy="960120"/>
+            <a:ext cx="4937760" cy="841248"/>
           </a:xfrm>
           <a:prstGeom prst="rect">
             <a:avLst/>
@@ -7856,8 +7856,8 @@
         </p:nvSpPr>
         <p:spPr>
           <a:xfrm>
-            <a:off x="6537960" y="1965960"/>
-            <a:ext cx="4937760" cy="3474720"/>
+            <a:off x="6537960" y="1901952"/>
+            <a:ext cx="4937760" cy="841248"/>
           </a:xfrm>
           <a:prstGeom prst="rect">
             <a:avLst/>
@@ -7875,11 +7875,11 @@
                 <a:spcPts val="0"/>
               </a:spcBef>
               <a:spcAft>
-                <a:spcPts val="800"/>
+                <a:spcPts val="300"/>
               </a:spcAft>
             </a:pPr>
             <a:r>
-              <a:rPr sz="1600" b="0" i="0">
+              <a:rPr sz="1300" b="0" i="0">
                 <a:solidFill>
                   <a:srgbClr val="FFFFFF"/>
                 </a:solidFill>
@@ -7894,11 +7894,11 @@
                 <a:spcPts val="0"/>
               </a:spcBef>
               <a:spcAft>
-                <a:spcPts val="800"/>
+                <a:spcPts val="300"/>
               </a:spcAft>
             </a:pPr>
             <a:r>
-              <a:rPr sz="1600" b="0" i="0">
+              <a:rPr sz="1300" b="0" i="0">
                 <a:solidFill>
                   <a:srgbClr val="FFFFFF"/>
                 </a:solidFill>
@@ -7913,11 +7913,11 @@
                 <a:spcPts val="0"/>
               </a:spcBef>
               <a:spcAft>
-                <a:spcPts val="800"/>
+                <a:spcPts val="300"/>
               </a:spcAft>
             </a:pPr>
             <a:r>
-              <a:rPr sz="1600" b="0" i="0">
+              <a:rPr sz="1300" b="0" i="0">
                 <a:solidFill>
                   <a:srgbClr val="FFFFFF"/>
                 </a:solidFill>
@@ -7932,11 +7932,11 @@
                 <a:spcPts val="0"/>
               </a:spcBef>
               <a:spcAft>
-                <a:spcPts val="800"/>
+                <a:spcPts val="300"/>
               </a:spcAft>
             </a:pPr>
             <a:r>
-              <a:rPr sz="1600" b="0" i="0">
+              <a:rPr sz="1300" b="0" i="0">
                 <a:solidFill>
                   <a:srgbClr val="FFFFFF"/>
                 </a:solidFill>
@@ -7951,11 +7951,11 @@
                 <a:spcPts val="0"/>
               </a:spcBef>
               <a:spcAft>
-                <a:spcPts val="800"/>
+                <a:spcPts val="300"/>
               </a:spcAft>
             </a:pPr>
             <a:r>
-              <a:rPr sz="1600" b="0" i="0">
+              <a:rPr sz="1300" b="0" i="0">
                 <a:solidFill>
                   <a:srgbClr val="FFFFFF"/>
                 </a:solidFill>
@@ -7966,9 +7966,33 @@
           </a:p>
         </p:txBody>
       </p:sp>
-      <p:sp>
-        <p:nvSpPr>
-          <p:cNvPr id="14" name="Rectangle 13"/>
+      <p:pic>
+        <p:nvPicPr>
+          <p:cNvPr id="14" name="Picture 13" descr="ico_logo.png"/>
+          <p:cNvPicPr>
+            <a:picLocks noChangeAspect="1"/>
+          </p:cNvPicPr>
+          <p:nvPr/>
+        </p:nvPicPr>
+        <p:blipFill>
+          <a:blip r:embed="rId3"/>
+          <a:stretch>
+            <a:fillRect/>
+          </a:stretch>
+        </p:blipFill>
+        <p:spPr>
+          <a:xfrm>
+            <a:off x="6537960" y="2788920"/>
+            <a:ext cx="4937760" cy="1280160"/>
+          </a:xfrm>
+          <a:prstGeom prst="rect">
+            <a:avLst/>
+          </a:prstGeom>
+        </p:spPr>
+      </p:pic>
+      <p:sp>
+        <p:nvSpPr>
+          <p:cNvPr id="15" name="Rectangle 14"/>
           <p:cNvSpPr/>
           <p:nvPr/>
         </p:nvSpPr>
@@ -8011,7 +8035,7 @@
       </p:sp>
       <p:sp>
         <p:nvSpPr>
-          <p:cNvPr id="15" name="TextBox 14"/>
+          <p:cNvPr id="16" name="TextBox 15"/>
           <p:cNvSpPr txBox="1"/>
           <p:nvPr/>
         </p:nvSpPr>
@@ -8046,7 +8070,7 @@
       </p:sp>
       <p:sp>
         <p:nvSpPr>
-          <p:cNvPr id="16" name="TextBox 15"/>
+          <p:cNvPr id="17" name="TextBox 16"/>
           <p:cNvSpPr txBox="1"/>
           <p:nvPr/>
         </p:nvSpPr>
@@ -10636,7 +10660,7 @@
                 </a:solidFill>
                 <a:latin typeface="Calibri"/>
               </a:rPr>
-              <a:t>Table 2. News/media is the highest sector. Government is the lowest.</a:t>
+              <a:t>News/media is the highest sector. Government is the lowest.</a:t>
             </a:r>
           </a:p>
         </p:txBody>

</xml_diff>

<commit_message>
Flytt Webbkoll-tekst ned pa slide 2 for bedre linje med ICO
Webbkoll-panelet har faerre bullets, sa teksten flyttes ned et hakk
mens bildene fortsatt er aligned nederst.

Co-authored-by: Karina <kasa031@users.noreply.github.com>
</commit_message>
<xml_diff>
--- a/ACIT4280_1A_presentation.pptx
+++ b/ACIT4280_1A_presentation.pptx
@@ -7639,7 +7639,7 @@
         </p:nvSpPr>
         <p:spPr>
           <a:xfrm>
-            <a:off x="685800" y="1572768"/>
+            <a:off x="685800" y="1783080"/>
             <a:ext cx="4937760" cy="320040"/>
           </a:xfrm>
           <a:prstGeom prst="rect">
@@ -7674,8 +7674,8 @@
         </p:nvSpPr>
         <p:spPr>
           <a:xfrm>
-            <a:off x="685800" y="1901952"/>
-            <a:ext cx="4937760" cy="841248"/>
+            <a:off x="685800" y="2121408"/>
+            <a:ext cx="4937760" cy="621792"/>
           </a:xfrm>
           <a:prstGeom prst="rect">
             <a:avLst/>

</xml_diff>

<commit_message>
Legg til Artikkel 6 bulletpoints pa forsideslide
Viser de seks lovlige grunnlagene ved siden av sporsmal 2,
slik publikum forstar hva Article 6 refererer til.

Co-authored-by: Karina <kasa031@users.noreply.github.com>
</commit_message>
<xml_diff>
--- a/ACIT4280_1A_presentation.pptx
+++ b/ACIT4280_1A_presentation.pptx
@@ -4592,7 +4592,7 @@
         <p:spPr>
           <a:xfrm>
             <a:off x="640080" y="1554480"/>
-            <a:ext cx="10972800" cy="1691640"/>
+            <a:ext cx="10972800" cy="1417320"/>
           </a:xfrm>
           <a:prstGeom prst="rect">
             <a:avLst/>
@@ -4607,7 +4607,7 @@
           <a:p>
             <a:pPr algn="l"/>
             <a:r>
-              <a:rPr sz="2800" b="1" i="0">
+              <a:rPr sz="2600" b="1" i="0">
                 <a:solidFill>
                   <a:srgbClr val="FFFFFF"/>
                 </a:solidFill>
@@ -4628,8 +4628,8 @@
         </p:nvSpPr>
         <p:spPr>
           <a:xfrm>
-            <a:off x="640080" y="3310128"/>
-            <a:ext cx="10972800" cy="1417320"/>
+            <a:off x="640080" y="3063240"/>
+            <a:ext cx="5394960" cy="1600200"/>
           </a:xfrm>
           <a:prstGeom prst="rect">
             <a:avLst/>
@@ -4647,11 +4647,11 @@
                 <a:spcPts val="0"/>
               </a:spcBef>
               <a:spcAft>
-                <a:spcPts val="1400"/>
+                <a:spcPts val="1200"/>
               </a:spcAft>
             </a:pPr>
             <a:r>
-              <a:rPr sz="1700" b="0" i="0">
+              <a:rPr sz="1600" b="0" i="0">
                 <a:solidFill>
                   <a:srgbClr val="FFFFFF"/>
                 </a:solidFill>
@@ -4670,7 +4670,7 @@
               </a:spcAft>
             </a:pPr>
             <a:r>
-              <a:rPr sz="1700" b="0" i="0">
+              <a:rPr sz="1600" b="0" i="0">
                 <a:solidFill>
                   <a:srgbClr val="FFFFFF"/>
                 </a:solidFill>
@@ -4689,8 +4689,8 @@
         </p:nvSpPr>
         <p:spPr>
           <a:xfrm>
-            <a:off x="640080" y="4617720"/>
-            <a:ext cx="10972800" cy="502920"/>
+            <a:off x="6263640" y="3063240"/>
+            <a:ext cx="5303520" cy="274320"/>
           </a:xfrm>
           <a:prstGeom prst="rect">
             <a:avLst/>
@@ -4705,12 +4705,219 @@
           <a:p>
             <a:pPr algn="l"/>
             <a:r>
-              <a:rPr sz="1600" b="0" i="0">
+              <a:rPr sz="1400" b="1" i="0">
+                <a:solidFill>
+                  <a:srgbClr val="44A1A4"/>
+                </a:solidFill>
+                <a:latin typeface="Calibri"/>
+              </a:rPr>
+              <a:t>Article 6(1) GDPR</a:t>
+            </a:r>
+          </a:p>
+        </p:txBody>
+      </p:sp>
+      <p:sp>
+        <p:nvSpPr>
+          <p:cNvPr id="9" name="TextBox 8"/>
+          <p:cNvSpPr txBox="1"/>
+          <p:nvPr/>
+        </p:nvSpPr>
+        <p:spPr>
+          <a:xfrm>
+            <a:off x="6263640" y="3310128"/>
+            <a:ext cx="5303520" cy="256032"/>
+          </a:xfrm>
+          <a:prstGeom prst="rect">
+            <a:avLst/>
+          </a:prstGeom>
+          <a:noFill/>
+        </p:spPr>
+        <p:txBody>
+          <a:bodyPr wrap="square" lIns="0" rIns="0" tIns="0" bIns="0">
+            <a:noAutofit/>
+          </a:bodyPr>
+          <a:lstStyle/>
+          <a:p>
+            <a:pPr algn="l"/>
+            <a:r>
+              <a:rPr sz="1100" b="0" i="0">
                 <a:solidFill>
                   <a:srgbClr val="FFFFFF"/>
                 </a:solidFill>
                 <a:latin typeface="Calibri"/>
               </a:rPr>
+              <a:t>Six lawful bases for processing personal data:</a:t>
+            </a:r>
+          </a:p>
+        </p:txBody>
+      </p:sp>
+      <p:sp>
+        <p:nvSpPr>
+          <p:cNvPr id="10" name="TextBox 9"/>
+          <p:cNvSpPr txBox="1"/>
+          <p:nvPr/>
+        </p:nvSpPr>
+        <p:spPr>
+          <a:xfrm>
+            <a:off x="6263640" y="3584448"/>
+            <a:ext cx="5303520" cy="1143000"/>
+          </a:xfrm>
+          <a:prstGeom prst="rect">
+            <a:avLst/>
+          </a:prstGeom>
+          <a:noFill/>
+        </p:spPr>
+        <p:txBody>
+          <a:bodyPr wrap="square" lIns="0" rIns="0" tIns="0" bIns="0">
+            <a:noAutofit/>
+          </a:bodyPr>
+          <a:lstStyle/>
+          <a:p>
+            <a:pPr algn="l">
+              <a:spcBef>
+                <a:spcPts val="0"/>
+              </a:spcBef>
+              <a:spcAft>
+                <a:spcPts val="300"/>
+              </a:spcAft>
+            </a:pPr>
+            <a:r>
+              <a:rPr sz="1200" b="0" i="0">
+                <a:solidFill>
+                  <a:srgbClr val="FFFFFF"/>
+                </a:solidFill>
+                <a:latin typeface="Calibri"/>
+              </a:rPr>
+              <a:t>•  Consent (a)</a:t>
+            </a:r>
+          </a:p>
+          <a:p>
+            <a:pPr algn="l">
+              <a:spcBef>
+                <a:spcPts val="0"/>
+              </a:spcBef>
+              <a:spcAft>
+                <a:spcPts val="300"/>
+              </a:spcAft>
+            </a:pPr>
+            <a:r>
+              <a:rPr sz="1200" b="0" i="0">
+                <a:solidFill>
+                  <a:srgbClr val="FFFFFF"/>
+                </a:solidFill>
+                <a:latin typeface="Calibri"/>
+              </a:rPr>
+              <a:t>•  Contractual necessity (b)</a:t>
+            </a:r>
+          </a:p>
+          <a:p>
+            <a:pPr algn="l">
+              <a:spcBef>
+                <a:spcPts val="0"/>
+              </a:spcBef>
+              <a:spcAft>
+                <a:spcPts val="300"/>
+              </a:spcAft>
+            </a:pPr>
+            <a:r>
+              <a:rPr sz="1200" b="0" i="0">
+                <a:solidFill>
+                  <a:srgbClr val="FFFFFF"/>
+                </a:solidFill>
+                <a:latin typeface="Calibri"/>
+              </a:rPr>
+              <a:t>•  Legal obligation (c)</a:t>
+            </a:r>
+          </a:p>
+          <a:p>
+            <a:pPr algn="l">
+              <a:spcBef>
+                <a:spcPts val="0"/>
+              </a:spcBef>
+              <a:spcAft>
+                <a:spcPts val="300"/>
+              </a:spcAft>
+            </a:pPr>
+            <a:r>
+              <a:rPr sz="1200" b="0" i="0">
+                <a:solidFill>
+                  <a:srgbClr val="FFFFFF"/>
+                </a:solidFill>
+                <a:latin typeface="Calibri"/>
+              </a:rPr>
+              <a:t>•  Vital interests (d)</a:t>
+            </a:r>
+          </a:p>
+          <a:p>
+            <a:pPr algn="l">
+              <a:spcBef>
+                <a:spcPts val="0"/>
+              </a:spcBef>
+              <a:spcAft>
+                <a:spcPts val="300"/>
+              </a:spcAft>
+            </a:pPr>
+            <a:r>
+              <a:rPr sz="1200" b="0" i="0">
+                <a:solidFill>
+                  <a:srgbClr val="FFFFFF"/>
+                </a:solidFill>
+                <a:latin typeface="Calibri"/>
+              </a:rPr>
+              <a:t>•  Public task (e)</a:t>
+            </a:r>
+          </a:p>
+          <a:p>
+            <a:pPr algn="l">
+              <a:spcBef>
+                <a:spcPts val="0"/>
+              </a:spcBef>
+              <a:spcAft>
+                <a:spcPts val="300"/>
+              </a:spcAft>
+            </a:pPr>
+            <a:r>
+              <a:rPr sz="1200" b="0" i="0">
+                <a:solidFill>
+                  <a:srgbClr val="FFFFFF"/>
+                </a:solidFill>
+                <a:latin typeface="Calibri"/>
+              </a:rPr>
+              <a:t>•  Legitimate interests (f)</a:t>
+            </a:r>
+          </a:p>
+        </p:txBody>
+      </p:sp>
+      <p:sp>
+        <p:nvSpPr>
+          <p:cNvPr id="11" name="TextBox 10"/>
+          <p:cNvSpPr txBox="1"/>
+          <p:nvPr/>
+        </p:nvSpPr>
+        <p:spPr>
+          <a:xfrm>
+            <a:off x="640080" y="4754880"/>
+            <a:ext cx="10972800" cy="411480"/>
+          </a:xfrm>
+          <a:prstGeom prst="rect">
+            <a:avLst/>
+          </a:prstGeom>
+          <a:noFill/>
+        </p:spPr>
+        <p:txBody>
+          <a:bodyPr wrap="square" lIns="0" rIns="0" tIns="0" bIns="0">
+            <a:noAutofit/>
+          </a:bodyPr>
+          <a:lstStyle/>
+          <a:p>
+            <a:pPr algn="l"/>
+            <a:r>
+              <a:rPr sz="1500" b="0" i="0">
+                <a:solidFill>
+                  <a:srgbClr val="FFFFFF"/>
+                </a:solidFill>
+                <a:latin typeface="Calibri"/>
+              </a:rPr>
               <a:t>Humna Akhtar  ·  Mithun Chandra Debnath  ·  Karina Sætersdal Nilssen</a:t>
             </a:r>
           </a:p>
@@ -4718,7 +4925,7 @@
       </p:sp>
       <p:sp>
         <p:nvSpPr>
-          <p:cNvPr id="9" name="TextBox 8"/>
+          <p:cNvPr id="12" name="TextBox 11"/>
           <p:cNvSpPr txBox="1"/>
           <p:nvPr/>
         </p:nvSpPr>
@@ -4753,7 +4960,7 @@
       </p:sp>
       <p:pic>
         <p:nvPicPr>
-          <p:cNvPr id="10" name="Picture 9" descr="oslomet_logo.png"/>
+          <p:cNvPr id="13" name="Picture 12" descr="oslomet_logo.png"/>
           <p:cNvPicPr>
             <a:picLocks noChangeAspect="1"/>
           </p:cNvPicPr>

</xml_diff>

<commit_message>
Forbedre visuelt design pa forsideslide
- Legg til oransje skillelinje under tittel
- To paneler: Our questions (MID) og Article 6 (TEAL)
- Nummererte forskningssporsmal og to-kolonne Artikkel 6-liste
- Navnelinje med skille over oransje band

Co-authored-by: Karina <kasa031@users.noreply.github.com>
</commit_message>
<xml_diff>
--- a/ACIT4280_1A_presentation.pptx
+++ b/ACIT4280_1A_presentation.pptx
@@ -4515,14 +4515,57 @@
       </p:sp>
       <p:sp>
         <p:nvSpPr>
-          <p:cNvPr id="4" name="TextBox 3"/>
+          <p:cNvPr id="4" name="Rectangle 3"/>
+          <p:cNvSpPr/>
+          <p:nvPr/>
+        </p:nvSpPr>
+        <p:spPr>
+          <a:xfrm>
+            <a:off x="0" y="2907792"/>
+            <a:ext cx="12191695" cy="54864"/>
+          </a:xfrm>
+          <a:prstGeom prst="rect">
+            <a:avLst/>
+          </a:prstGeom>
+          <a:solidFill>
+            <a:srgbClr val="FF9A00"/>
+          </a:solidFill>
+          <a:ln>
+            <a:noFill/>
+          </a:ln>
+        </p:spPr>
+        <p:style>
+          <a:lnRef idx="1">
+            <a:schemeClr val="accent1"/>
+          </a:lnRef>
+          <a:fillRef idx="3">
+            <a:schemeClr val="accent1"/>
+          </a:fillRef>
+          <a:effectRef idx="2">
+            <a:schemeClr val="accent1"/>
+          </a:effectRef>
+          <a:fontRef idx="minor">
+            <a:schemeClr val="lt1"/>
+          </a:fontRef>
+        </p:style>
+        <p:txBody>
+          <a:bodyPr rtlCol="0" anchor="ctr"/>
+          <a:lstStyle/>
+          <a:p>
+            <a:pPr algn="ctr"/>
+          </a:p>
+        </p:txBody>
+      </p:sp>
+      <p:sp>
+        <p:nvSpPr>
+          <p:cNvPr id="5" name="TextBox 4"/>
           <p:cNvSpPr txBox="1"/>
           <p:nvPr/>
         </p:nvSpPr>
         <p:spPr>
           <a:xfrm>
-            <a:off x="640080" y="777240"/>
-            <a:ext cx="10972800" cy="320040"/>
+            <a:off x="640080" y="713232"/>
+            <a:ext cx="10972800" cy="292608"/>
           </a:xfrm>
           <a:prstGeom prst="rect">
             <a:avLst/>
@@ -4537,7 +4580,7 @@
           <a:p>
             <a:pPr algn="l"/>
             <a:r>
-              <a:rPr sz="1800" b="1" i="0">
+              <a:rPr sz="1600" b="1" i="0">
                 <a:solidFill>
                   <a:srgbClr val="44A1A4"/>
                 </a:solidFill>
@@ -4550,14 +4593,14 @@
       </p:sp>
       <p:sp>
         <p:nvSpPr>
-          <p:cNvPr id="5" name="TextBox 4"/>
+          <p:cNvPr id="6" name="TextBox 5"/>
           <p:cNvSpPr txBox="1"/>
           <p:nvPr/>
         </p:nvSpPr>
         <p:spPr>
           <a:xfrm>
-            <a:off x="640080" y="1115568"/>
-            <a:ext cx="10972800" cy="347472"/>
+            <a:off x="640080" y="987552"/>
+            <a:ext cx="10972800" cy="329184"/>
           </a:xfrm>
           <a:prstGeom prst="rect">
             <a:avLst/>
@@ -4572,7 +4615,7 @@
           <a:p>
             <a:pPr algn="l"/>
             <a:r>
-              <a:rPr sz="2400" b="1" i="0">
+              <a:rPr sz="2200" b="1" i="0">
                 <a:solidFill>
                   <a:srgbClr val="44A1A4"/>
                 </a:solidFill>
@@ -4585,14 +4628,14 @@
       </p:sp>
       <p:sp>
         <p:nvSpPr>
-          <p:cNvPr id="6" name="TextBox 5"/>
+          <p:cNvPr id="7" name="TextBox 6"/>
           <p:cNvSpPr txBox="1"/>
           <p:nvPr/>
         </p:nvSpPr>
         <p:spPr>
           <a:xfrm>
-            <a:off x="640080" y="1554480"/>
-            <a:ext cx="10972800" cy="1417320"/>
+            <a:off x="640080" y="1389888"/>
+            <a:ext cx="10972800" cy="1325880"/>
           </a:xfrm>
           <a:prstGeom prst="rect">
             <a:avLst/>
@@ -4607,7 +4650,7 @@
           <a:p>
             <a:pPr algn="l"/>
             <a:r>
-              <a:rPr sz="2600" b="1" i="0">
+              <a:rPr sz="2500" b="1" i="0">
                 <a:solidFill>
                   <a:srgbClr val="FFFFFF"/>
                 </a:solidFill>
@@ -4622,14 +4665,135 @@
       </p:sp>
       <p:sp>
         <p:nvSpPr>
-          <p:cNvPr id="7" name="TextBox 6"/>
+          <p:cNvPr id="8" name="Rectangle 7"/>
+          <p:cNvSpPr/>
+          <p:nvPr/>
+        </p:nvSpPr>
+        <p:spPr>
+          <a:xfrm>
+            <a:off x="502920" y="3090672"/>
+            <a:ext cx="5349240" cy="1847088"/>
+          </a:xfrm>
+          <a:prstGeom prst="rect">
+            <a:avLst/>
+          </a:prstGeom>
+          <a:solidFill>
+            <a:srgbClr val="325E6A"/>
+          </a:solidFill>
+          <a:ln>
+            <a:noFill/>
+          </a:ln>
+        </p:spPr>
+        <p:style>
+          <a:lnRef idx="1">
+            <a:schemeClr val="accent1"/>
+          </a:lnRef>
+          <a:fillRef idx="3">
+            <a:schemeClr val="accent1"/>
+          </a:fillRef>
+          <a:effectRef idx="2">
+            <a:schemeClr val="accent1"/>
+          </a:effectRef>
+          <a:fontRef idx="minor">
+            <a:schemeClr val="lt1"/>
+          </a:fontRef>
+        </p:style>
+        <p:txBody>
+          <a:bodyPr rtlCol="0" anchor="ctr"/>
+          <a:lstStyle/>
+          <a:p>
+            <a:pPr algn="ctr"/>
+          </a:p>
+        </p:txBody>
+      </p:sp>
+      <p:sp>
+        <p:nvSpPr>
+          <p:cNvPr id="9" name="Rectangle 8"/>
+          <p:cNvSpPr/>
+          <p:nvPr/>
+        </p:nvSpPr>
+        <p:spPr>
+          <a:xfrm>
+            <a:off x="6336792" y="3090672"/>
+            <a:ext cx="5349240" cy="1847088"/>
+          </a:xfrm>
+          <a:prstGeom prst="rect">
+            <a:avLst/>
+          </a:prstGeom>
+          <a:solidFill>
+            <a:srgbClr val="44A1A4"/>
+          </a:solidFill>
+          <a:ln>
+            <a:noFill/>
+          </a:ln>
+        </p:spPr>
+        <p:style>
+          <a:lnRef idx="1">
+            <a:schemeClr val="accent1"/>
+          </a:lnRef>
+          <a:fillRef idx="3">
+            <a:schemeClr val="accent1"/>
+          </a:fillRef>
+          <a:effectRef idx="2">
+            <a:schemeClr val="accent1"/>
+          </a:effectRef>
+          <a:fontRef idx="minor">
+            <a:schemeClr val="lt1"/>
+          </a:fontRef>
+        </p:style>
+        <p:txBody>
+          <a:bodyPr rtlCol="0" anchor="ctr"/>
+          <a:lstStyle/>
+          <a:p>
+            <a:pPr algn="ctr"/>
+          </a:p>
+        </p:txBody>
+      </p:sp>
+      <p:sp>
+        <p:nvSpPr>
+          <p:cNvPr id="10" name="TextBox 9"/>
           <p:cNvSpPr txBox="1"/>
           <p:nvPr/>
         </p:nvSpPr>
         <p:spPr>
           <a:xfrm>
-            <a:off x="640080" y="3063240"/>
-            <a:ext cx="5394960" cy="1600200"/>
+            <a:off x="704088" y="3218688"/>
+            <a:ext cx="4937760" cy="219456"/>
+          </a:xfrm>
+          <a:prstGeom prst="rect">
+            <a:avLst/>
+          </a:prstGeom>
+          <a:noFill/>
+        </p:spPr>
+        <p:txBody>
+          <a:bodyPr wrap="square" lIns="0" rIns="0" tIns="0" bIns="0">
+            <a:noAutofit/>
+          </a:bodyPr>
+          <a:lstStyle/>
+          <a:p>
+            <a:pPr algn="l"/>
+            <a:r>
+              <a:rPr sz="1100" b="1" i="0">
+                <a:solidFill>
+                  <a:srgbClr val="FF9A00"/>
+                </a:solidFill>
+                <a:latin typeface="Calibri"/>
+              </a:rPr>
+              <a:t>Our questions</a:t>
+            </a:r>
+          </a:p>
+        </p:txBody>
+      </p:sp>
+      <p:sp>
+        <p:nvSpPr>
+          <p:cNvPr id="11" name="TextBox 10"/>
+          <p:cNvSpPr txBox="1"/>
+          <p:nvPr/>
+        </p:nvSpPr>
+        <p:spPr>
+          <a:xfrm>
+            <a:off x="704088" y="3456432"/>
+            <a:ext cx="4937760" cy="1325880"/>
           </a:xfrm>
           <a:prstGeom prst="rect">
             <a:avLst/>
@@ -4647,17 +4811,17 @@
                 <a:spcPts val="0"/>
               </a:spcBef>
               <a:spcAft>
-                <a:spcPts val="1200"/>
+                <a:spcPts val="1000"/>
               </a:spcAft>
             </a:pPr>
             <a:r>
-              <a:rPr sz="1600" b="0" i="0">
+              <a:rPr sz="1400" b="0" i="0">
                 <a:solidFill>
                   <a:srgbClr val="FFFFFF"/>
                 </a:solidFill>
                 <a:latin typeface="Calibri"/>
               </a:rPr>
-              <a:t>•  When a front page loads, how many third parties does it contact, and in which countries do those servers appear to be located?</a:t>
+              <a:t>When a front page loads, how many third parties does it contact, and in which countries do those servers appear to be located?</a:t>
             </a:r>
           </a:p>
           <a:p>
@@ -4670,27 +4834,27 @@
               </a:spcAft>
             </a:pPr>
             <a:r>
-              <a:rPr sz="1600" b="0" i="0">
+              <a:rPr sz="1400" b="0" i="0">
                 <a:solidFill>
                   <a:srgbClr val="FFFFFF"/>
                 </a:solidFill>
                 <a:latin typeface="Calibri"/>
               </a:rPr>
-              <a:t>•  When a site processes personal data, has it named a GDPR Article 6 lawful basis, and does the ICO tool agree?</a:t>
-            </a:r>
-          </a:p>
-        </p:txBody>
-      </p:sp>
-      <p:sp>
-        <p:nvSpPr>
-          <p:cNvPr id="8" name="TextBox 7"/>
+              <a:t>When a site processes personal data, has it named a GDPR Article 6 lawful basis, and does the ICO tool agree?</a:t>
+            </a:r>
+          </a:p>
+        </p:txBody>
+      </p:sp>
+      <p:sp>
+        <p:nvSpPr>
+          <p:cNvPr id="12" name="TextBox 11"/>
           <p:cNvSpPr txBox="1"/>
           <p:nvPr/>
         </p:nvSpPr>
         <p:spPr>
           <a:xfrm>
-            <a:off x="6263640" y="3063240"/>
-            <a:ext cx="5303520" cy="274320"/>
+            <a:off x="6537960" y="3218688"/>
+            <a:ext cx="4937760" cy="219456"/>
           </a:xfrm>
           <a:prstGeom prst="rect">
             <a:avLst/>
@@ -4705,9 +4869,9 @@
           <a:p>
             <a:pPr algn="l"/>
             <a:r>
-              <a:rPr sz="1400" b="1" i="0">
-                <a:solidFill>
-                  <a:srgbClr val="44A1A4"/>
+              <a:rPr sz="1200" b="1" i="0">
+                <a:solidFill>
+                  <a:srgbClr val="224248"/>
                 </a:solidFill>
                 <a:latin typeface="Calibri"/>
               </a:rPr>
@@ -4718,14 +4882,14 @@
       </p:sp>
       <p:sp>
         <p:nvSpPr>
-          <p:cNvPr id="9" name="TextBox 8"/>
+          <p:cNvPr id="13" name="TextBox 12"/>
           <p:cNvSpPr txBox="1"/>
           <p:nvPr/>
         </p:nvSpPr>
         <p:spPr>
           <a:xfrm>
-            <a:off x="6263640" y="3310128"/>
-            <a:ext cx="5303520" cy="256032"/>
+            <a:off x="6537960" y="3438144"/>
+            <a:ext cx="4937760" cy="201168"/>
           </a:xfrm>
           <a:prstGeom prst="rect">
             <a:avLst/>
@@ -4740,9 +4904,9 @@
           <a:p>
             <a:pPr algn="l"/>
             <a:r>
-              <a:rPr sz="1100" b="0" i="0">
-                <a:solidFill>
-                  <a:srgbClr val="FFFFFF"/>
+              <a:rPr sz="1000" b="0" i="0">
+                <a:solidFill>
+                  <a:srgbClr val="224248"/>
                 </a:solidFill>
                 <a:latin typeface="Calibri"/>
               </a:rPr>
@@ -4753,14 +4917,14 @@
       </p:sp>
       <p:sp>
         <p:nvSpPr>
-          <p:cNvPr id="10" name="TextBox 9"/>
+          <p:cNvPr id="14" name="TextBox 13"/>
           <p:cNvSpPr txBox="1"/>
           <p:nvPr/>
         </p:nvSpPr>
         <p:spPr>
           <a:xfrm>
-            <a:off x="6263640" y="3584448"/>
-            <a:ext cx="5303520" cy="1143000"/>
+            <a:off x="6537960" y="3657600"/>
+            <a:ext cx="4937760" cy="1143000"/>
           </a:xfrm>
           <a:prstGeom prst="rect">
             <a:avLst/>
@@ -4778,17 +4942,17 @@
                 <a:spcPts val="0"/>
               </a:spcBef>
               <a:spcAft>
-                <a:spcPts val="300"/>
+                <a:spcPts val="200"/>
               </a:spcAft>
             </a:pPr>
             <a:r>
-              <a:rPr sz="1200" b="0" i="0">
-                <a:solidFill>
-                  <a:srgbClr val="FFFFFF"/>
-                </a:solidFill>
-                <a:latin typeface="Calibri"/>
-              </a:rPr>
-              <a:t>•  Consent (a)</a:t>
+              <a:rPr sz="1100" b="0" i="0">
+                <a:solidFill>
+                  <a:srgbClr val="224248"/>
+                </a:solidFill>
+                <a:latin typeface="Calibri"/>
+              </a:rPr>
+              <a:t>Consent (a)</a:t>
             </a:r>
           </a:p>
           <a:p>
@@ -4797,17 +4961,17 @@
                 <a:spcPts val="0"/>
               </a:spcBef>
               <a:spcAft>
-                <a:spcPts val="300"/>
+                <a:spcPts val="200"/>
               </a:spcAft>
             </a:pPr>
             <a:r>
-              <a:rPr sz="1200" b="0" i="0">
-                <a:solidFill>
-                  <a:srgbClr val="FFFFFF"/>
-                </a:solidFill>
-                <a:latin typeface="Calibri"/>
-              </a:rPr>
-              <a:t>•  Contractual necessity (b)</a:t>
+              <a:rPr sz="1100" b="0" i="0">
+                <a:solidFill>
+                  <a:srgbClr val="224248"/>
+                </a:solidFill>
+                <a:latin typeface="Calibri"/>
+              </a:rPr>
+              <a:t>Contractual necessity (b)</a:t>
             </a:r>
           </a:p>
           <a:p>
@@ -4816,17 +4980,17 @@
                 <a:spcPts val="0"/>
               </a:spcBef>
               <a:spcAft>
-                <a:spcPts val="300"/>
+                <a:spcPts val="200"/>
               </a:spcAft>
             </a:pPr>
             <a:r>
-              <a:rPr sz="1200" b="0" i="0">
-                <a:solidFill>
-                  <a:srgbClr val="FFFFFF"/>
-                </a:solidFill>
-                <a:latin typeface="Calibri"/>
-              </a:rPr>
-              <a:t>•  Legal obligation (c)</a:t>
+              <a:rPr sz="1100" b="0" i="0">
+                <a:solidFill>
+                  <a:srgbClr val="224248"/>
+                </a:solidFill>
+                <a:latin typeface="Calibri"/>
+              </a:rPr>
+              <a:t>Legal obligation (c)</a:t>
             </a:r>
           </a:p>
           <a:p>
@@ -4835,17 +4999,17 @@
                 <a:spcPts val="0"/>
               </a:spcBef>
               <a:spcAft>
-                <a:spcPts val="300"/>
+                <a:spcPts val="200"/>
               </a:spcAft>
             </a:pPr>
             <a:r>
-              <a:rPr sz="1200" b="0" i="0">
-                <a:solidFill>
-                  <a:srgbClr val="FFFFFF"/>
-                </a:solidFill>
-                <a:latin typeface="Calibri"/>
-              </a:rPr>
-              <a:t>•  Vital interests (d)</a:t>
+              <a:rPr sz="1100" b="0" i="0">
+                <a:solidFill>
+                  <a:srgbClr val="224248"/>
+                </a:solidFill>
+                <a:latin typeface="Calibri"/>
+              </a:rPr>
+              <a:t>Vital interests (d)</a:t>
             </a:r>
           </a:p>
           <a:p>
@@ -4854,17 +5018,17 @@
                 <a:spcPts val="0"/>
               </a:spcBef>
               <a:spcAft>
-                <a:spcPts val="300"/>
+                <a:spcPts val="200"/>
               </a:spcAft>
             </a:pPr>
             <a:r>
-              <a:rPr sz="1200" b="0" i="0">
-                <a:solidFill>
-                  <a:srgbClr val="FFFFFF"/>
-                </a:solidFill>
-                <a:latin typeface="Calibri"/>
-              </a:rPr>
-              <a:t>•  Public task (e)</a:t>
+              <a:rPr sz="1100" b="0" i="0">
+                <a:solidFill>
+                  <a:srgbClr val="224248"/>
+                </a:solidFill>
+                <a:latin typeface="Calibri"/>
+              </a:rPr>
+              <a:t>Public task (e)</a:t>
             </a:r>
           </a:p>
           <a:p>
@@ -4873,31 +5037,74 @@
                 <a:spcPts val="0"/>
               </a:spcBef>
               <a:spcAft>
-                <a:spcPts val="300"/>
+                <a:spcPts val="200"/>
               </a:spcAft>
             </a:pPr>
             <a:r>
-              <a:rPr sz="1200" b="0" i="0">
-                <a:solidFill>
-                  <a:srgbClr val="FFFFFF"/>
-                </a:solidFill>
-                <a:latin typeface="Calibri"/>
-              </a:rPr>
-              <a:t>•  Legitimate interests (f)</a:t>
-            </a:r>
-          </a:p>
-        </p:txBody>
-      </p:sp>
-      <p:sp>
-        <p:nvSpPr>
-          <p:cNvPr id="11" name="TextBox 10"/>
+              <a:rPr sz="1100" b="0" i="0">
+                <a:solidFill>
+                  <a:srgbClr val="224248"/>
+                </a:solidFill>
+                <a:latin typeface="Calibri"/>
+              </a:rPr>
+              <a:t>Legitimate interests (f)</a:t>
+            </a:r>
+          </a:p>
+        </p:txBody>
+      </p:sp>
+      <p:sp>
+        <p:nvSpPr>
+          <p:cNvPr id="15" name="Rectangle 14"/>
+          <p:cNvSpPr/>
+          <p:nvPr/>
+        </p:nvSpPr>
+        <p:spPr>
+          <a:xfrm>
+            <a:off x="502920" y="5047488"/>
+            <a:ext cx="11183112" cy="18288"/>
+          </a:xfrm>
+          <a:prstGeom prst="rect">
+            <a:avLst/>
+          </a:prstGeom>
+          <a:solidFill>
+            <a:srgbClr val="325E6A"/>
+          </a:solidFill>
+          <a:ln>
+            <a:noFill/>
+          </a:ln>
+        </p:spPr>
+        <p:style>
+          <a:lnRef idx="1">
+            <a:schemeClr val="accent1"/>
+          </a:lnRef>
+          <a:fillRef idx="3">
+            <a:schemeClr val="accent1"/>
+          </a:fillRef>
+          <a:effectRef idx="2">
+            <a:schemeClr val="accent1"/>
+          </a:effectRef>
+          <a:fontRef idx="minor">
+            <a:schemeClr val="lt1"/>
+          </a:fontRef>
+        </p:style>
+        <p:txBody>
+          <a:bodyPr rtlCol="0" anchor="ctr"/>
+          <a:lstStyle/>
+          <a:p>
+            <a:pPr algn="ctr"/>
+          </a:p>
+        </p:txBody>
+      </p:sp>
+      <p:sp>
+        <p:nvSpPr>
+          <p:cNvPr id="16" name="TextBox 15"/>
           <p:cNvSpPr txBox="1"/>
           <p:nvPr/>
         </p:nvSpPr>
         <p:spPr>
           <a:xfrm>
-            <a:off x="640080" y="4754880"/>
-            <a:ext cx="10972800" cy="411480"/>
+            <a:off x="640080" y="5102352"/>
+            <a:ext cx="10972800" cy="201168"/>
           </a:xfrm>
           <a:prstGeom prst="rect">
             <a:avLst/>
@@ -4912,7 +5119,7 @@
           <a:p>
             <a:pPr algn="l"/>
             <a:r>
-              <a:rPr sz="1500" b="0" i="0">
+              <a:rPr sz="1300" b="0" i="0">
                 <a:solidFill>
                   <a:srgbClr val="FFFFFF"/>
                 </a:solidFill>
@@ -4925,7 +5132,7 @@
       </p:sp>
       <p:sp>
         <p:nvSpPr>
-          <p:cNvPr id="12" name="TextBox 11"/>
+          <p:cNvPr id="17" name="TextBox 16"/>
           <p:cNvSpPr txBox="1"/>
           <p:nvPr/>
         </p:nvSpPr>
@@ -4960,7 +5167,7 @@
       </p:sp>
       <p:pic>
         <p:nvPicPr>
-          <p:cNvPr id="13" name="Picture 12" descr="oslomet_logo.png"/>
+          <p:cNvPr id="18" name="Picture 17" descr="oslomet_logo.png"/>
           <p:cNvPicPr>
             <a:picLocks noChangeAspect="1"/>
           </p:cNvPicPr>

</xml_diff>

<commit_message>
Linj opp slide 2 symmetrisk mellom Webbkoll og ICO
- Samme vertikal posisjon for titler og punktlister
- Identiske hvite bildebokser nederst i begge paneler
- Fjern asymmetrisk padding i HTML

Co-authored-by: Karina <kasa031@users.noreply.github.com>
</commit_message>
<xml_diff>
--- a/ACIT4280_1A_presentation.pptx
+++ b/ACIT4280_1A_presentation.pptx
@@ -8047,146 +8047,7 @@
       </p:sp>
       <p:sp>
         <p:nvSpPr>
-          <p:cNvPr id="8" name="TextBox 7"/>
-          <p:cNvSpPr txBox="1"/>
-          <p:nvPr/>
-        </p:nvSpPr>
-        <p:spPr>
-          <a:xfrm>
-            <a:off x="685800" y="1783080"/>
-            <a:ext cx="4937760" cy="320040"/>
-          </a:xfrm>
-          <a:prstGeom prst="rect">
-            <a:avLst/>
-          </a:prstGeom>
-          <a:noFill/>
-        </p:spPr>
-        <p:txBody>
-          <a:bodyPr wrap="square" lIns="0" rIns="0" tIns="0" bIns="0">
-            <a:noAutofit/>
-          </a:bodyPr>
-          <a:lstStyle/>
-          <a:p>
-            <a:pPr algn="l"/>
-            <a:r>
-              <a:rPr sz="2000" b="1" i="0">
-                <a:solidFill>
-                  <a:srgbClr val="224248"/>
-                </a:solidFill>
-                <a:latin typeface="Calibri"/>
-              </a:rPr>
-              <a:t>Part 1  ·  Webbkoll</a:t>
-            </a:r>
-          </a:p>
-        </p:txBody>
-      </p:sp>
-      <p:sp>
-        <p:nvSpPr>
-          <p:cNvPr id="9" name="TextBox 8"/>
-          <p:cNvSpPr txBox="1"/>
-          <p:nvPr/>
-        </p:nvSpPr>
-        <p:spPr>
-          <a:xfrm>
-            <a:off x="685800" y="2121408"/>
-            <a:ext cx="4937760" cy="621792"/>
-          </a:xfrm>
-          <a:prstGeom prst="rect">
-            <a:avLst/>
-          </a:prstGeom>
-          <a:noFill/>
-        </p:spPr>
-        <p:txBody>
-          <a:bodyPr wrap="square" lIns="0" rIns="0" tIns="0" bIns="0">
-            <a:noAutofit/>
-          </a:bodyPr>
-          <a:lstStyle/>
-          <a:p>
-            <a:pPr algn="l">
-              <a:spcBef>
-                <a:spcPts val="0"/>
-              </a:spcBef>
-              <a:spcAft>
-                <a:spcPts val="400"/>
-              </a:spcAft>
-            </a:pPr>
-            <a:r>
-              <a:rPr sz="1400" b="0" i="0">
-                <a:solidFill>
-                  <a:srgbClr val="1A1A1A"/>
-                </a:solidFill>
-                <a:latin typeface="Calibri"/>
-              </a:rPr>
-              <a:t>•  18 sites: cookies, requests, KeyCDN country</a:t>
-            </a:r>
-          </a:p>
-          <a:p>
-            <a:pPr algn="l">
-              <a:spcBef>
-                <a:spcPts val="0"/>
-              </a:spcBef>
-              <a:spcAft>
-                <a:spcPts val="400"/>
-              </a:spcAft>
-            </a:pPr>
-            <a:r>
-              <a:rPr sz="1400" b="0" i="0">
-                <a:solidFill>
-                  <a:srgbClr val="1A1A1A"/>
-                </a:solidFill>
-                <a:latin typeface="Calibri"/>
-              </a:rPr>
-              <a:t>•  One clean load per site; rank on Table 2 (20 Aug)</a:t>
-            </a:r>
-          </a:p>
-          <a:p>
-            <a:pPr algn="l">
-              <a:spcBef>
-                <a:spcPts val="0"/>
-              </a:spcBef>
-              <a:spcAft>
-                <a:spcPts val="400"/>
-              </a:spcAft>
-            </a:pPr>
-            <a:r>
-              <a:rPr sz="1400" b="0" i="0">
-                <a:solidFill>
-                  <a:srgbClr val="1A1A1A"/>
-                </a:solidFill>
-                <a:latin typeface="Calibri"/>
-              </a:rPr>
-              <a:t>•  KeyCDN = IP geolocation guess, not legal transfer proof</a:t>
-            </a:r>
-          </a:p>
-        </p:txBody>
-      </p:sp>
-      <p:pic>
-        <p:nvPicPr>
-          <p:cNvPr id="10" name="Picture 9" descr="fig2_webbkoll_results_klassekampen.png"/>
-          <p:cNvPicPr>
-            <a:picLocks noChangeAspect="1"/>
-          </p:cNvPicPr>
-          <p:nvPr/>
-        </p:nvPicPr>
-        <p:blipFill>
-          <a:blip r:embed="rId2"/>
-          <a:stretch>
-            <a:fillRect/>
-          </a:stretch>
-        </p:blipFill>
-        <p:spPr>
-          <a:xfrm>
-            <a:off x="685800" y="2788920"/>
-            <a:ext cx="4937760" cy="1280160"/>
-          </a:xfrm>
-          <a:prstGeom prst="rect">
-            <a:avLst/>
-          </a:prstGeom>
-        </p:spPr>
-      </p:pic>
-      <p:sp>
-        <p:nvSpPr>
-          <p:cNvPr id="11" name="Rectangle 10"/>
+          <p:cNvPr id="8" name="Rectangle 7"/>
           <p:cNvSpPr/>
           <p:nvPr/>
         </p:nvSpPr>
@@ -8229,13 +8090,13 @@
       </p:sp>
       <p:sp>
         <p:nvSpPr>
-          <p:cNvPr id="12" name="TextBox 11"/>
+          <p:cNvPr id="9" name="TextBox 8"/>
           <p:cNvSpPr txBox="1"/>
           <p:nvPr/>
         </p:nvSpPr>
         <p:spPr>
           <a:xfrm>
-            <a:off x="6537960" y="1572768"/>
+            <a:off x="685800" y="1627632"/>
             <a:ext cx="4937760" cy="320040"/>
           </a:xfrm>
           <a:prstGeom prst="rect">
@@ -8253,6 +8114,41 @@
             <a:r>
               <a:rPr sz="2000" b="1" i="0">
                 <a:solidFill>
+                  <a:srgbClr val="224248"/>
+                </a:solidFill>
+                <a:latin typeface="Calibri"/>
+              </a:rPr>
+              <a:t>Part 1  ·  Webbkoll</a:t>
+            </a:r>
+          </a:p>
+        </p:txBody>
+      </p:sp>
+      <p:sp>
+        <p:nvSpPr>
+          <p:cNvPr id="10" name="TextBox 9"/>
+          <p:cNvSpPr txBox="1"/>
+          <p:nvPr/>
+        </p:nvSpPr>
+        <p:spPr>
+          <a:xfrm>
+            <a:off x="6537960" y="1627632"/>
+            <a:ext cx="4937760" cy="320040"/>
+          </a:xfrm>
+          <a:prstGeom prst="rect">
+            <a:avLst/>
+          </a:prstGeom>
+          <a:noFill/>
+        </p:spPr>
+        <p:txBody>
+          <a:bodyPr wrap="square" lIns="0" rIns="0" tIns="0" bIns="0">
+            <a:noAutofit/>
+          </a:bodyPr>
+          <a:lstStyle/>
+          <a:p>
+            <a:pPr algn="l"/>
+            <a:r>
+              <a:rPr sz="2000" b="1" i="0">
+                <a:solidFill>
                   <a:srgbClr val="FF9A00"/>
                 </a:solidFill>
                 <a:latin typeface="Calibri"/>
@@ -8264,14 +8160,14 @@
       </p:sp>
       <p:sp>
         <p:nvSpPr>
-          <p:cNvPr id="13" name="TextBox 12"/>
+          <p:cNvPr id="11" name="TextBox 10"/>
           <p:cNvSpPr txBox="1"/>
           <p:nvPr/>
         </p:nvSpPr>
         <p:spPr>
           <a:xfrm>
-            <a:off x="6537960" y="1901952"/>
-            <a:ext cx="4937760" cy="841248"/>
+            <a:off x="685800" y="1993392"/>
+            <a:ext cx="4937760" cy="2331720"/>
           </a:xfrm>
           <a:prstGeom prst="rect">
             <a:avLst/>
@@ -8295,11 +8191,11 @@
             <a:r>
               <a:rPr sz="1300" b="0" i="0">
                 <a:solidFill>
-                  <a:srgbClr val="FFFFFF"/>
-                </a:solidFill>
-                <a:latin typeface="Calibri"/>
-              </a:rPr>
-              <a:t>•  Five sites, one purpose per run</a:t>
+                  <a:srgbClr val="1A1A1A"/>
+                </a:solidFill>
+                <a:latin typeface="Calibri"/>
+              </a:rPr>
+              <a:t>•  18 sites: cookies, requests, KeyCDN country</a:t>
             </a:r>
           </a:p>
           <a:p>
@@ -8314,11 +8210,11 @@
             <a:r>
               <a:rPr sz="1300" b="0" i="0">
                 <a:solidFill>
-                  <a:srgbClr val="FFFFFF"/>
-                </a:solidFill>
-                <a:latin typeface="Calibri"/>
-              </a:rPr>
-              <a:t>•  Notice vs ICO Word report (26 Aug 2026)</a:t>
+                  <a:srgbClr val="1A1A1A"/>
+                </a:solidFill>
+                <a:latin typeface="Calibri"/>
+              </a:rPr>
+              <a:t>•  One clean load per site; rank on Table 2 (20 Aug)</a:t>
             </a:r>
           </a:p>
           <a:p>
@@ -8333,13 +8229,36 @@
             <a:r>
               <a:rPr sz="1300" b="0" i="0">
                 <a:solidFill>
-                  <a:srgbClr val="FFFFFF"/>
-                </a:solidFill>
-                <a:latin typeface="Calibri"/>
-              </a:rPr>
-              <a:t>•  Yes if notice and ICO agree</a:t>
-            </a:r>
-          </a:p>
+                  <a:srgbClr val="1A1A1A"/>
+                </a:solidFill>
+                <a:latin typeface="Calibri"/>
+              </a:rPr>
+              <a:t>•  KeyCDN = IP geolocation guess, not legal transfer proof</a:t>
+            </a:r>
+          </a:p>
+        </p:txBody>
+      </p:sp>
+      <p:sp>
+        <p:nvSpPr>
+          <p:cNvPr id="12" name="TextBox 11"/>
+          <p:cNvSpPr txBox="1"/>
+          <p:nvPr/>
+        </p:nvSpPr>
+        <p:spPr>
+          <a:xfrm>
+            <a:off x="6537960" y="1993392"/>
+            <a:ext cx="4937760" cy="2331720"/>
+          </a:xfrm>
+          <a:prstGeom prst="rect">
+            <a:avLst/>
+          </a:prstGeom>
+          <a:noFill/>
+        </p:spPr>
+        <p:txBody>
+          <a:bodyPr wrap="square" lIns="0" rIns="0" tIns="0" bIns="0">
+            <a:noAutofit/>
+          </a:bodyPr>
+          <a:lstStyle/>
           <a:p>
             <a:pPr algn="l">
               <a:spcBef>
@@ -8356,7 +8275,7 @@
                 </a:solidFill>
                 <a:latin typeface="Calibri"/>
               </a:rPr>
-              <a:t>•  Partial if consent is INCONCLUSIVE</a:t>
+              <a:t>•  Five sites, one purpose per run</a:t>
             </a:r>
           </a:p>
           <a:p>
@@ -8375,14 +8294,181 @@
                 </a:solidFill>
                 <a:latin typeface="Calibri"/>
               </a:rPr>
+              <a:t>•  Notice vs ICO Word report (26 Aug 2026)</a:t>
+            </a:r>
+          </a:p>
+          <a:p>
+            <a:pPr algn="l">
+              <a:spcBef>
+                <a:spcPts val="0"/>
+              </a:spcBef>
+              <a:spcAft>
+                <a:spcPts val="300"/>
+              </a:spcAft>
+            </a:pPr>
+            <a:r>
+              <a:rPr sz="1300" b="0" i="0">
+                <a:solidFill>
+                  <a:srgbClr val="FFFFFF"/>
+                </a:solidFill>
+                <a:latin typeface="Calibri"/>
+              </a:rPr>
+              <a:t>•  Yes if notice and ICO agree</a:t>
+            </a:r>
+          </a:p>
+          <a:p>
+            <a:pPr algn="l">
+              <a:spcBef>
+                <a:spcPts val="0"/>
+              </a:spcBef>
+              <a:spcAft>
+                <a:spcPts val="300"/>
+              </a:spcAft>
+            </a:pPr>
+            <a:r>
+              <a:rPr sz="1300" b="0" i="0">
+                <a:solidFill>
+                  <a:srgbClr val="FFFFFF"/>
+                </a:solidFill>
+                <a:latin typeface="Calibri"/>
+              </a:rPr>
+              <a:t>•  Partial if consent is INCONCLUSIVE</a:t>
+            </a:r>
+          </a:p>
+          <a:p>
+            <a:pPr algn="l">
+              <a:spcBef>
+                <a:spcPts val="0"/>
+              </a:spcBef>
+              <a:spcAft>
+                <a:spcPts val="300"/>
+              </a:spcAft>
+            </a:pPr>
+            <a:r>
+              <a:rPr sz="1300" b="0" i="0">
+                <a:solidFill>
+                  <a:srgbClr val="FFFFFF"/>
+                </a:solidFill>
+                <a:latin typeface="Calibri"/>
+              </a:rPr>
               <a:t>•  Tax, cookies, checkout and marketing are different purposes</a:t>
             </a:r>
+          </a:p>
+        </p:txBody>
+      </p:sp>
+      <p:sp>
+        <p:nvSpPr>
+          <p:cNvPr id="13" name="Rectangle 12"/>
+          <p:cNvSpPr/>
+          <p:nvPr/>
+        </p:nvSpPr>
+        <p:spPr>
+          <a:xfrm>
+            <a:off x="685800" y="4572000"/>
+            <a:ext cx="4937760" cy="1280160"/>
+          </a:xfrm>
+          <a:prstGeom prst="rect">
+            <a:avLst/>
+          </a:prstGeom>
+          <a:solidFill>
+            <a:srgbClr val="FFFFFF"/>
+          </a:solidFill>
+          <a:ln>
+            <a:noFill/>
+          </a:ln>
+        </p:spPr>
+        <p:style>
+          <a:lnRef idx="1">
+            <a:schemeClr val="accent1"/>
+          </a:lnRef>
+          <a:fillRef idx="3">
+            <a:schemeClr val="accent1"/>
+          </a:fillRef>
+          <a:effectRef idx="2">
+            <a:schemeClr val="accent1"/>
+          </a:effectRef>
+          <a:fontRef idx="minor">
+            <a:schemeClr val="lt1"/>
+          </a:fontRef>
+        </p:style>
+        <p:txBody>
+          <a:bodyPr rtlCol="0" anchor="ctr"/>
+          <a:lstStyle/>
+          <a:p>
+            <a:pPr algn="ctr"/>
           </a:p>
         </p:txBody>
       </p:sp>
       <p:pic>
         <p:nvPicPr>
-          <p:cNvPr id="14" name="Picture 13" descr="ico_logo.png"/>
+          <p:cNvPr id="14" name="Picture 13" descr="fig2_webbkoll_results_klassekampen.png"/>
+          <p:cNvPicPr>
+            <a:picLocks noChangeAspect="1"/>
+          </p:cNvPicPr>
+          <p:nvPr/>
+        </p:nvPicPr>
+        <p:blipFill>
+          <a:blip r:embed="rId2"/>
+          <a:stretch>
+            <a:fillRect/>
+          </a:stretch>
+        </p:blipFill>
+        <p:spPr>
+          <a:xfrm>
+            <a:off x="685800" y="4572000"/>
+            <a:ext cx="4937760" cy="1280160"/>
+          </a:xfrm>
+          <a:prstGeom prst="rect">
+            <a:avLst/>
+          </a:prstGeom>
+        </p:spPr>
+      </p:pic>
+      <p:sp>
+        <p:nvSpPr>
+          <p:cNvPr id="15" name="Rectangle 14"/>
+          <p:cNvSpPr/>
+          <p:nvPr/>
+        </p:nvSpPr>
+        <p:spPr>
+          <a:xfrm>
+            <a:off x="6537960" y="4572000"/>
+            <a:ext cx="4937760" cy="1280160"/>
+          </a:xfrm>
+          <a:prstGeom prst="rect">
+            <a:avLst/>
+          </a:prstGeom>
+          <a:solidFill>
+            <a:srgbClr val="FFFFFF"/>
+          </a:solidFill>
+          <a:ln>
+            <a:noFill/>
+          </a:ln>
+        </p:spPr>
+        <p:style>
+          <a:lnRef idx="1">
+            <a:schemeClr val="accent1"/>
+          </a:lnRef>
+          <a:fillRef idx="3">
+            <a:schemeClr val="accent1"/>
+          </a:fillRef>
+          <a:effectRef idx="2">
+            <a:schemeClr val="accent1"/>
+          </a:effectRef>
+          <a:fontRef idx="minor">
+            <a:schemeClr val="lt1"/>
+          </a:fontRef>
+        </p:style>
+        <p:txBody>
+          <a:bodyPr rtlCol="0" anchor="ctr"/>
+          <a:lstStyle/>
+          <a:p>
+            <a:pPr algn="ctr"/>
+          </a:p>
+        </p:txBody>
+      </p:sp>
+      <p:pic>
+        <p:nvPicPr>
+          <p:cNvPr id="16" name="Picture 15" descr="ico_logo.png"/>
           <p:cNvPicPr>
             <a:picLocks noChangeAspect="1"/>
           </p:cNvPicPr>
@@ -8396,7 +8482,7 @@
         </p:blipFill>
         <p:spPr>
           <a:xfrm>
-            <a:off x="6537960" y="2788920"/>
+            <a:off x="6537960" y="4572000"/>
             <a:ext cx="4937760" cy="1280160"/>
           </a:xfrm>
           <a:prstGeom prst="rect">
@@ -8406,7 +8492,7 @@
       </p:pic>
       <p:sp>
         <p:nvSpPr>
-          <p:cNvPr id="15" name="Rectangle 14"/>
+          <p:cNvPr id="17" name="Rectangle 16"/>
           <p:cNvSpPr/>
           <p:nvPr/>
         </p:nvSpPr>
@@ -8449,7 +8535,7 @@
       </p:sp>
       <p:sp>
         <p:nvSpPr>
-          <p:cNvPr id="16" name="TextBox 15"/>
+          <p:cNvPr id="18" name="TextBox 17"/>
           <p:cNvSpPr txBox="1"/>
           <p:nvPr/>
         </p:nvSpPr>
@@ -8484,7 +8570,7 @@
       </p:sp>
       <p:sp>
         <p:nvSpPr>
-          <p:cNvPr id="17" name="TextBox 16"/>
+          <p:cNvPr id="19" name="TextBox 18"/>
           <p:cNvSpPr txBox="1"/>
           <p:nvPr/>
         </p:nvSpPr>

</xml_diff>

<commit_message>
Legg til bulletpoints pa oppsummeringsslide 13
Co-authored-by: Karina <kasa031@users.noreply.github.com>
</commit_message>
<xml_diff>
--- a/ACIT4280_1A_presentation.pptx
+++ b/ACIT4280_1A_presentation.pptx
@@ -7479,7 +7479,7 @@
                 </a:solidFill>
                 <a:latin typeface="Calibri"/>
               </a:rPr>
-              <a:t>We measured how much 18 sites contact others on load, and we checked whether five of them have a valid GDPR basis for one specific purpose.</a:t>
+              <a:t>•  We measured how much 18 sites contact others on load, and we checked whether five of them have a valid GDPR basis for one specific purpose.</a:t>
             </a:r>
           </a:p>
           <a:p>
@@ -7498,7 +7498,7 @@
                 </a:solidFill>
                 <a:latin typeface="Calibri"/>
               </a:rPr>
-              <a:t>Many sites reach out to many others without setting cookies.</a:t>
+              <a:t>•  Many sites reach out to many others without setting cookies.</a:t>
             </a:r>
           </a:p>
           <a:p>
@@ -7517,7 +7517,7 @@
                 </a:solidFill>
                 <a:latin typeface="Calibri"/>
               </a:rPr>
-              <a:t>Four of five ICO purposes match the notice.</a:t>
+              <a:t>•  Four of five ICO purposes match the notice.</a:t>
             </a:r>
           </a:p>
           <a:p>
@@ -7536,7 +7536,7 @@
                 </a:solidFill>
                 <a:latin typeface="Calibri"/>
               </a:rPr>
-              <a:t>In two places where the site claims consent, the ICO is not satisfied with how consent is formulated.</a:t>
+              <a:t>•  In two places where the site claims consent, the ICO is not satisfied with how consent is formulated.</a:t>
             </a:r>
           </a:p>
         </p:txBody>

</xml_diff>